<commit_message>
feat: headshot, gmail contact, Anthony Huni as enterprise sales
Co-Authored-By: Claude Fable 5.1 <noreply@anthropic.com>
</commit_message>
<xml_diff>
--- a/docs/deck/AI-Training-For-Companies.pptx
+++ b/docs/deck/AI-Training-For-Companies.pptx
@@ -120,72 +120,72 @@
   <p:extLst>
     <p:ext uri="{521415D9-36F7-43E2-AB2F-B90AF26B5E84}">
       <p14:sectionLst xmlns:p14="http://schemas.microsoft.com/office/powerpoint/2010/main">
-        <p14:section name="Intro" id="{2a7aa2f7-497a-5fa8-fb6e-f23bf476016d}">
+        <p14:section name="Intro" id="{f3ec81f9-41fc-18f0-7473-0333c2262653}">
           <p14:sldIdLst>
             <p14:sldId id="256"/>
           </p14:sldIdLst>
         </p14:section>
-        <p14:section name="Problem" id="{4c0da610-6e27-f7f7-9f7f-3cc0e61b891b}">
+        <p14:section name="Problem" id="{ad0de206-ba68-1783-e77b-3dfabe856918}">
           <p14:sldIdLst>
             <p14:sldId id="257"/>
           </p14:sldIdLst>
         </p14:section>
-        <p14:section name="The fix" id="{313ebe44-c5d9-86bd-e6b8-22681dd6d993}">
+        <p14:section name="The fix" id="{d847ce63-ff55-096d-9ca9-fb8085d28b8e}">
           <p14:sldIdLst>
             <p14:sldId id="258"/>
           </p14:sldIdLst>
         </p14:section>
-        <p14:section name="Who teaches" id="{0a35ac7b-53d4-2782-1c2d-03eaa796641e}">
+        <p14:section name="Who teaches" id="{86f4c364-f878-d9f0-be06-0c0c82780045}">
           <p14:sldIdLst>
             <p14:sldId id="259"/>
           </p14:sldIdLst>
         </p14:section>
-        <p14:section name="Case 01" id="{61cd646e-df4a-200c-2c4f-c46fb971fa7e}">
+        <p14:section name="Case 01" id="{5e929284-5024-2143-b6e3-aafca7782d2d}">
           <p14:sldIdLst>
             <p14:sldId id="260"/>
           </p14:sldIdLst>
         </p14:section>
-        <p14:section name="Case 02" id="{613daeda-dd9a-00a5-4e53-8f0e8f05f46a}">
+        <p14:section name="Case 02" id="{91f92fce-28eb-3383-85da-e6ba59a7c38f}">
           <p14:sldIdLst>
             <p14:sldId id="261"/>
           </p14:sldIdLst>
         </p14:section>
-        <p14:section name="Case 03" id="{9a2ae90e-155f-9832-535d-b7081cf02c01}">
+        <p14:section name="Case 03" id="{d0ac0959-afaa-d1a4-c8e4-3a021226f44e}">
           <p14:sldIdLst>
             <p14:sldId id="262"/>
           </p14:sldIdLst>
         </p14:section>
-        <p14:section name="Case 04" id="{1e0db4ea-a526-7e1f-697b-71fe33da29a6}">
+        <p14:section name="Case 04" id="{fe7194f0-f86b-4b73-2dd9-179438c055f6}">
           <p14:sldIdLst>
             <p14:sldId id="263"/>
           </p14:sldIdLst>
         </p14:section>
-        <p14:section name="Enterprise" id="{d37ec8e7-4fbd-4fb7-873f-c97648b9188b}">
+        <p14:section name="Enterprise" id="{e4356191-d65e-ce34-6231-51bab5f1756c}">
           <p14:sldIdLst>
             <p14:sldId id="264"/>
           </p14:sldIdLst>
         </p14:section>
-        <p14:section name="Program" id="{e2a5b65b-4c2f-d347-b1ab-d154358169bc}">
+        <p14:section name="Program" id="{845c9cd5-a8db-2c84-aae5-f17b6b5181a0}">
           <p14:sldIdLst>
             <p14:sldId id="265"/>
           </p14:sldIdLst>
         </p14:section>
-        <p14:section name="Outcomes" id="{3357ba07-0f95-6959-ef7e-e132f6ded8eb}">
+        <p14:section name="Outcomes" id="{e360782e-a1df-1f62-f3b8-de24972ff67a}">
           <p14:sldIdLst>
             <p14:sldId id="266"/>
           </p14:sldIdLst>
         </p14:section>
-        <p14:section name="Pricing" id="{a8e91ff2-ff11-f698-01b8-04c52fcaf70f}">
+        <p14:section name="Pricing" id="{ff36226b-3daa-11e3-a7de-98f85583775d}">
           <p14:sldIdLst>
             <p14:sldId id="267"/>
           </p14:sldIdLst>
         </p14:section>
-        <p14:section name="Fit" id="{5083d00a-8f97-ffbe-b3fc-d0cfc88604b3}">
+        <p14:section name="Fit" id="{f1116293-c2e4-70d3-13b2-051bbe2a8c07}">
           <p14:sldIdLst>
             <p14:sldId id="268"/>
           </p14:sldIdLst>
         </p14:section>
-        <p14:section name="Next step" id="{4e1275da-0ca1-c623-bedc-873f976ac208}">
+        <p14:section name="Next step" id="{a6fb2e74-2994-38cf-5a7f-eb0ba8bdfc64}">
           <p14:sldIdLst>
             <p14:sldId id="269"/>
           </p14:sldIdLst>
@@ -1955,7 +1955,7 @@
         <p:spPr>
           <a:xfrm>
             <a:off x="457200" y="411480"/>
-            <a:ext cx="8229600" cy="777240"/>
+            <a:ext cx="7040880" cy="777240"/>
           </a:xfrm>
           <a:prstGeom prst="rect">
             <a:avLst/>
@@ -2016,7 +2016,7 @@
                 <a:ea typeface="Courier New" pitchFamily="34" charset="-122"/>
                 <a:cs typeface="Courier New" pitchFamily="34" charset="-120"/>
               </a:rPr>
-              <a:t>jordan@wonderflyathletics.com</a:t>
+              <a:t>millhausenjordan@gmail.com</a:t>
             </a:r>
             <a:endParaRPr lang="en-US" sz="900" dirty="0"/>
           </a:p>
@@ -2608,7 +2608,7 @@
         <p:spPr>
           <a:xfrm>
             <a:off x="457200" y="411480"/>
-            <a:ext cx="8229600" cy="777240"/>
+            <a:ext cx="7040880" cy="777240"/>
           </a:xfrm>
           <a:prstGeom prst="rect">
             <a:avLst/>
@@ -3843,7 +3843,7 @@
         <p:spPr>
           <a:xfrm>
             <a:off x="457200" y="411480"/>
-            <a:ext cx="8229600" cy="777240"/>
+            <a:ext cx="7040880" cy="777240"/>
           </a:xfrm>
           <a:prstGeom prst="rect">
             <a:avLst/>
@@ -4699,7 +4699,7 @@
         <p:spPr>
           <a:xfrm>
             <a:off x="457200" y="411480"/>
-            <a:ext cx="8229600" cy="777240"/>
+            <a:ext cx="7040880" cy="777240"/>
           </a:xfrm>
           <a:prstGeom prst="rect">
             <a:avLst/>
@@ -5345,7 +5345,7 @@
         <p:spPr>
           <a:xfrm>
             <a:off x="457200" y="411480"/>
-            <a:ext cx="8229600" cy="777240"/>
+            <a:ext cx="7040880" cy="777240"/>
           </a:xfrm>
           <a:prstGeom prst="rect">
             <a:avLst/>
@@ -6461,7 +6461,7 @@
                 <a:ea typeface="Courier New" pitchFamily="34" charset="-122"/>
                 <a:cs typeface="Courier New" pitchFamily="34" charset="-120"/>
               </a:rPr>
-              <a:t>jordan@wonderflyathletics.com</a:t>
+              <a:t>millhausenjordan@gmail.com</a:t>
             </a:r>
             <a:endParaRPr lang="en-US" sz="1400" dirty="0"/>
           </a:p>
@@ -6859,7 +6859,7 @@
         <p:spPr>
           <a:xfrm>
             <a:off x="457200" y="411480"/>
-            <a:ext cx="8229600" cy="777240"/>
+            <a:ext cx="7040880" cy="777240"/>
           </a:xfrm>
           <a:prstGeom prst="rect">
             <a:avLst/>
@@ -7378,7 +7378,7 @@
         <p:spPr>
           <a:xfrm>
             <a:off x="457200" y="411480"/>
-            <a:ext cx="8229600" cy="777240"/>
+            <a:ext cx="7040880" cy="777240"/>
           </a:xfrm>
           <a:prstGeom prst="rect">
             <a:avLst/>
@@ -7940,7 +7940,7 @@
         <p:spPr>
           <a:xfrm>
             <a:off x="457200" y="411480"/>
-            <a:ext cx="8229600" cy="777240"/>
+            <a:ext cx="7040880" cy="777240"/>
           </a:xfrm>
           <a:prstGeom prst="rect">
             <a:avLst/>
@@ -7967,16 +7967,39 @@
           </a:p>
         </p:txBody>
       </p:sp>
-      <p:sp>
-        <p:nvSpPr>
-          <p:cNvPr id="3" name="Text 1"/>
+      <p:pic>
+        <p:nvPicPr>
+          <p:cNvPr id="3" name="Image 0" descr="/Users/jordan/consulting/public/images/jordan-millhausen.jpg">    </p:cNvPr>
+          <p:cNvPicPr>
+            <a:picLocks noChangeAspect="1"/>
+          </p:cNvPicPr>
+          <p:nvPr/>
+        </p:nvPicPr>
+        <p:blipFill>
+          <a:blip r:embed="rId1"/>
+          <a:srcRect l="0" r="0" t="0" b="0"/>
+          <a:stretch/>
+        </p:blipFill>
+        <p:spPr>
+          <a:xfrm>
+            <a:off x="7680960" y="365760"/>
+            <a:ext cx="1005840" cy="1234440"/>
+          </a:xfrm>
+          <a:prstGeom prst="rect">
+            <a:avLst/>
+          </a:prstGeom>
+        </p:spPr>
+      </p:pic>
+      <p:sp>
+        <p:nvSpPr>
+          <p:cNvPr id="4" name="Text 1"/>
           <p:cNvSpPr txBox="1"/>
           <p:nvPr/>
         </p:nvSpPr>
         <p:spPr>
           <a:xfrm>
             <a:off x="457200" y="1371600"/>
-            <a:ext cx="8229600" cy="640080"/>
+            <a:ext cx="6949440" cy="640080"/>
           </a:xfrm>
           <a:prstGeom prst="rect">
             <a:avLst/>
@@ -8005,7 +8028,7 @@
       </p:sp>
       <p:sp>
         <p:nvSpPr>
-          <p:cNvPr id="4" name="Shape 2"/>
+          <p:cNvPr id="5" name="Shape 2"/>
           <p:cNvSpPr/>
           <p:nvPr/>
         </p:nvSpPr>
@@ -8030,7 +8053,7 @@
       </p:sp>
       <p:sp>
         <p:nvSpPr>
-          <p:cNvPr id="5" name="Text 3"/>
+          <p:cNvPr id="6" name="Text 3"/>
           <p:cNvSpPr txBox="1"/>
           <p:nvPr/>
         </p:nvSpPr>
@@ -8069,7 +8092,7 @@
       </p:sp>
       <p:sp>
         <p:nvSpPr>
-          <p:cNvPr id="6" name="Text 4"/>
+          <p:cNvPr id="7" name="Text 4"/>
           <p:cNvSpPr txBox="1"/>
           <p:nvPr/>
         </p:nvSpPr>
@@ -8108,7 +8131,7 @@
       </p:sp>
       <p:sp>
         <p:nvSpPr>
-          <p:cNvPr id="7" name="Shape 5"/>
+          <p:cNvPr id="8" name="Shape 5"/>
           <p:cNvSpPr/>
           <p:nvPr/>
         </p:nvSpPr>
@@ -8133,7 +8156,7 @@
       </p:sp>
       <p:sp>
         <p:nvSpPr>
-          <p:cNvPr id="8" name="Text 6"/>
+          <p:cNvPr id="9" name="Text 6"/>
           <p:cNvSpPr txBox="1"/>
           <p:nvPr/>
         </p:nvSpPr>
@@ -8172,7 +8195,7 @@
       </p:sp>
       <p:sp>
         <p:nvSpPr>
-          <p:cNvPr id="9" name="Text 7"/>
+          <p:cNvPr id="10" name="Text 7"/>
           <p:cNvSpPr txBox="1"/>
           <p:nvPr/>
         </p:nvSpPr>
@@ -8211,7 +8234,7 @@
       </p:sp>
       <p:sp>
         <p:nvSpPr>
-          <p:cNvPr id="10" name="Shape 8"/>
+          <p:cNvPr id="11" name="Shape 8"/>
           <p:cNvSpPr/>
           <p:nvPr/>
         </p:nvSpPr>
@@ -8236,7 +8259,7 @@
       </p:sp>
       <p:sp>
         <p:nvSpPr>
-          <p:cNvPr id="11" name="Text 9"/>
+          <p:cNvPr id="12" name="Text 9"/>
           <p:cNvSpPr txBox="1"/>
           <p:nvPr/>
         </p:nvSpPr>
@@ -8275,7 +8298,7 @@
       </p:sp>
       <p:sp>
         <p:nvSpPr>
-          <p:cNvPr id="12" name="Text 10"/>
+          <p:cNvPr id="13" name="Text 10"/>
           <p:cNvSpPr txBox="1"/>
           <p:nvPr/>
         </p:nvSpPr>
@@ -8314,7 +8337,7 @@
       </p:sp>
       <p:sp>
         <p:nvSpPr>
-          <p:cNvPr id="13" name="Shape 11"/>
+          <p:cNvPr id="14" name="Shape 11"/>
           <p:cNvSpPr/>
           <p:nvPr/>
         </p:nvSpPr>
@@ -8339,7 +8362,7 @@
       </p:sp>
       <p:sp>
         <p:nvSpPr>
-          <p:cNvPr id="14" name="Text 12"/>
+          <p:cNvPr id="15" name="Text 12"/>
           <p:cNvSpPr txBox="1"/>
           <p:nvPr/>
         </p:nvSpPr>
@@ -8378,7 +8401,7 @@
       </p:sp>
       <p:sp>
         <p:nvSpPr>
-          <p:cNvPr id="15" name="Text 13"/>
+          <p:cNvPr id="16" name="Text 13"/>
           <p:cNvSpPr txBox="1"/>
           <p:nvPr/>
         </p:nvSpPr>
@@ -9052,7 +9075,7 @@
         <p:spPr>
           <a:xfrm>
             <a:off x="457200" y="411480"/>
-            <a:ext cx="8229600" cy="777240"/>
+            <a:ext cx="7040880" cy="777240"/>
           </a:xfrm>
           <a:prstGeom prst="rect">
             <a:avLst/>
@@ -10106,7 +10129,7 @@
         <p:spPr>
           <a:xfrm>
             <a:off x="457200" y="411480"/>
-            <a:ext cx="8229600" cy="777240"/>
+            <a:ext cx="7040880" cy="777240"/>
           </a:xfrm>
           <a:prstGeom prst="rect">
             <a:avLst/>
@@ -11160,7 +11183,7 @@
         <p:spPr>
           <a:xfrm>
             <a:off x="457200" y="411480"/>
-            <a:ext cx="8229600" cy="777240"/>
+            <a:ext cx="7040880" cy="777240"/>
           </a:xfrm>
           <a:prstGeom prst="rect">
             <a:avLst/>
@@ -12214,7 +12237,7 @@
         <p:spPr>
           <a:xfrm>
             <a:off x="457200" y="411480"/>
-            <a:ext cx="8229600" cy="777240"/>
+            <a:ext cx="7040880" cy="777240"/>
           </a:xfrm>
           <a:prstGeom prst="rect">
             <a:avLst/>
@@ -13229,7 +13252,7 @@
         <p:spPr>
           <a:xfrm>
             <a:off x="457200" y="411480"/>
-            <a:ext cx="8229600" cy="777240"/>
+            <a:ext cx="7040880" cy="777240"/>
           </a:xfrm>
           <a:prstGeom prst="rect">
             <a:avLst/>

</xml_diff>

<commit_message>
content: ten client systems in production; BEO redaction script
Co-Authored-By: Claude Fable 5.1 <noreply@anthropic.com>
</commit_message>
<xml_diff>
--- a/docs/deck/AI-Training-For-Companies.pptx
+++ b/docs/deck/AI-Training-For-Companies.pptx
@@ -120,72 +120,72 @@
   <p:extLst>
     <p:ext uri="{521415D9-36F7-43E2-AB2F-B90AF26B5E84}">
       <p14:sectionLst xmlns:p14="http://schemas.microsoft.com/office/powerpoint/2010/main">
-        <p14:section name="Intro" id="{f3ec81f9-41fc-18f0-7473-0333c2262653}">
+        <p14:section name="Intro" id="{aa56ecaf-2aed-f75d-834a-4f4ffc707fc2}">
           <p14:sldIdLst>
             <p14:sldId id="256"/>
           </p14:sldIdLst>
         </p14:section>
-        <p14:section name="Problem" id="{ad0de206-ba68-1783-e77b-3dfabe856918}">
+        <p14:section name="Problem" id="{95188e88-5fd7-ec99-354e-236c6bcce5e6}">
           <p14:sldIdLst>
             <p14:sldId id="257"/>
           </p14:sldIdLst>
         </p14:section>
-        <p14:section name="The fix" id="{d847ce63-ff55-096d-9ca9-fb8085d28b8e}">
+        <p14:section name="The fix" id="{9a61038e-7393-d4a3-0a7a-c231c1380a46}">
           <p14:sldIdLst>
             <p14:sldId id="258"/>
           </p14:sldIdLst>
         </p14:section>
-        <p14:section name="Who teaches" id="{86f4c364-f878-d9f0-be06-0c0c82780045}">
+        <p14:section name="Who teaches" id="{5894fd26-3115-ee4d-f24c-dcf6e08421f1}">
           <p14:sldIdLst>
             <p14:sldId id="259"/>
           </p14:sldIdLst>
         </p14:section>
-        <p14:section name="Case 01" id="{5e929284-5024-2143-b6e3-aafca7782d2d}">
+        <p14:section name="Case 01" id="{8a852e03-2d85-03fe-9766-510bc3cd176c}">
           <p14:sldIdLst>
             <p14:sldId id="260"/>
           </p14:sldIdLst>
         </p14:section>
-        <p14:section name="Case 02" id="{91f92fce-28eb-3383-85da-e6ba59a7c38f}">
+        <p14:section name="Case 02" id="{9f47814c-8ea8-5fd7-9490-475598397078}">
           <p14:sldIdLst>
             <p14:sldId id="261"/>
           </p14:sldIdLst>
         </p14:section>
-        <p14:section name="Case 03" id="{d0ac0959-afaa-d1a4-c8e4-3a021226f44e}">
+        <p14:section name="Case 03" id="{64a1e3d2-a654-5d01-772f-27950b8fa6ef}">
           <p14:sldIdLst>
             <p14:sldId id="262"/>
           </p14:sldIdLst>
         </p14:section>
-        <p14:section name="Case 04" id="{fe7194f0-f86b-4b73-2dd9-179438c055f6}">
+        <p14:section name="Case 04" id="{3bc520d7-9d6a-11ee-421f-13f14f8c413e}">
           <p14:sldIdLst>
             <p14:sldId id="263"/>
           </p14:sldIdLst>
         </p14:section>
-        <p14:section name="Enterprise" id="{e4356191-d65e-ce34-6231-51bab5f1756c}">
+        <p14:section name="Enterprise" id="{a6e8739e-3f5c-bd83-8178-9731d83d0be7}">
           <p14:sldIdLst>
             <p14:sldId id="264"/>
           </p14:sldIdLst>
         </p14:section>
-        <p14:section name="Program" id="{845c9cd5-a8db-2c84-aae5-f17b6b5181a0}">
+        <p14:section name="Program" id="{3ca00bcd-898f-eca3-f403-78b955b2ffda}">
           <p14:sldIdLst>
             <p14:sldId id="265"/>
           </p14:sldIdLst>
         </p14:section>
-        <p14:section name="Outcomes" id="{e360782e-a1df-1f62-f3b8-de24972ff67a}">
+        <p14:section name="Outcomes" id="{8e0d44b8-cfb6-6a52-102b-5b144fe92cb1}">
           <p14:sldIdLst>
             <p14:sldId id="266"/>
           </p14:sldIdLst>
         </p14:section>
-        <p14:section name="Pricing" id="{ff36226b-3daa-11e3-a7de-98f85583775d}">
+        <p14:section name="Pricing" id="{24e1fa23-2c3c-0751-0542-f7101cd6f88c}">
           <p14:sldIdLst>
             <p14:sldId id="267"/>
           </p14:sldIdLst>
         </p14:section>
-        <p14:section name="Fit" id="{f1116293-c2e4-70d3-13b2-051bbe2a8c07}">
+        <p14:section name="Fit" id="{842101a8-546e-d05f-22eb-c543847f3737}">
           <p14:sldIdLst>
             <p14:sldId id="268"/>
           </p14:sldIdLst>
         </p14:section>
-        <p14:section name="Next step" id="{a6fb2e74-2994-38cf-5a7f-eb0ba8bdfc64}">
+        <p14:section name="Next step" id="{2d597b2c-2951-a3d7-6806-61a0d25293bc}">
           <p14:sldIdLst>
             <p14:sldId id="269"/>
           </p14:sldIdLst>
@@ -8187,7 +8187,7 @@
                 <a:ea typeface="Courier New" pitchFamily="34" charset="-122"/>
                 <a:cs typeface="Courier New" pitchFamily="34" charset="-120"/>
               </a:rPr>
-              <a:t>5</a:t>
+              <a:t>10</a:t>
             </a:r>
             <a:endParaRPr lang="en-US" sz="2000" dirty="0"/>
           </a:p>
@@ -8858,7 +8858,7 @@
                           <a:ea typeface="Arial" pitchFamily="34" charset="-122"/>
                           <a:cs typeface="Arial" pitchFamily="34" charset="-120"/>
                         </a:rPr>
-                        <a:t>Five systems in production</a:t>
+                        <a:t>Ten systems in production</a:t>
                       </a:r>
                       <a:endParaRPr lang="en-US" sz="1100" dirty="0">
                         <a:latin typeface="Arial" charset="0"/>

</xml_diff>

<commit_message>
feat: remove web deck; PowerPoint is the deck, title slide uses event photo
Co-Authored-By: Claude Fable 5.1 <noreply@anthropic.com>
</commit_message>
<xml_diff>
--- a/docs/deck/AI-Training-For-Companies.pptx
+++ b/docs/deck/AI-Training-For-Companies.pptx
@@ -120,72 +120,72 @@
   <p:extLst>
     <p:ext uri="{521415D9-36F7-43E2-AB2F-B90AF26B5E84}">
       <p14:sectionLst xmlns:p14="http://schemas.microsoft.com/office/powerpoint/2010/main">
-        <p14:section name="Intro" id="{aa56ecaf-2aed-f75d-834a-4f4ffc707fc2}">
+        <p14:section name="Intro" id="{150df9f5-729f-2e06-2453-df086e436829}">
           <p14:sldIdLst>
             <p14:sldId id="256"/>
           </p14:sldIdLst>
         </p14:section>
-        <p14:section name="Problem" id="{95188e88-5fd7-ec99-354e-236c6bcce5e6}">
+        <p14:section name="Problem" id="{a90e07fa-49b7-ad82-806f-2bbf8ac05af9}">
           <p14:sldIdLst>
             <p14:sldId id="257"/>
           </p14:sldIdLst>
         </p14:section>
-        <p14:section name="The fix" id="{9a61038e-7393-d4a3-0a7a-c231c1380a46}">
+        <p14:section name="The fix" id="{a3d74ea6-c733-1e3c-0826-c677b110960b}">
           <p14:sldIdLst>
             <p14:sldId id="258"/>
           </p14:sldIdLst>
         </p14:section>
-        <p14:section name="Who teaches" id="{5894fd26-3115-ee4d-f24c-dcf6e08421f1}">
+        <p14:section name="Who teaches" id="{6e469c77-88de-86b0-96d4-5fa745fa1b42}">
           <p14:sldIdLst>
             <p14:sldId id="259"/>
           </p14:sldIdLst>
         </p14:section>
-        <p14:section name="Case 01" id="{8a852e03-2d85-03fe-9766-510bc3cd176c}">
+        <p14:section name="Case 01" id="{21df1986-f3ff-d4d3-f804-b7a11a5b254a}">
           <p14:sldIdLst>
             <p14:sldId id="260"/>
           </p14:sldIdLst>
         </p14:section>
-        <p14:section name="Case 02" id="{9f47814c-8ea8-5fd7-9490-475598397078}">
+        <p14:section name="Case 02" id="{7446479a-939f-1e0d-fb20-96e7cac9369c}">
           <p14:sldIdLst>
             <p14:sldId id="261"/>
           </p14:sldIdLst>
         </p14:section>
-        <p14:section name="Case 03" id="{64a1e3d2-a654-5d01-772f-27950b8fa6ef}">
+        <p14:section name="Case 03" id="{c01fecc9-4f05-3974-806f-3c57b0d31057}">
           <p14:sldIdLst>
             <p14:sldId id="262"/>
           </p14:sldIdLst>
         </p14:section>
-        <p14:section name="Case 04" id="{3bc520d7-9d6a-11ee-421f-13f14f8c413e}">
+        <p14:section name="Case 04" id="{cf20ab66-249d-6593-38d6-1429b0622543}">
           <p14:sldIdLst>
             <p14:sldId id="263"/>
           </p14:sldIdLst>
         </p14:section>
-        <p14:section name="Enterprise" id="{a6e8739e-3f5c-bd83-8178-9731d83d0be7}">
+        <p14:section name="Enterprise" id="{2e855428-2cde-7170-cb42-7fc743ac000f}">
           <p14:sldIdLst>
             <p14:sldId id="264"/>
           </p14:sldIdLst>
         </p14:section>
-        <p14:section name="Program" id="{3ca00bcd-898f-eca3-f403-78b955b2ffda}">
+        <p14:section name="Program" id="{6a44456f-3156-ea2e-299e-7f1d5c6a37dd}">
           <p14:sldIdLst>
             <p14:sldId id="265"/>
           </p14:sldIdLst>
         </p14:section>
-        <p14:section name="Outcomes" id="{8e0d44b8-cfb6-6a52-102b-5b144fe92cb1}">
+        <p14:section name="Outcomes" id="{503ec480-9464-7ad4-fb12-deee064320f1}">
           <p14:sldIdLst>
             <p14:sldId id="266"/>
           </p14:sldIdLst>
         </p14:section>
-        <p14:section name="Pricing" id="{24e1fa23-2c3c-0751-0542-f7101cd6f88c}">
+        <p14:section name="Pricing" id="{b1d64254-90b9-c4b6-bf08-edfe93e2fbd6}">
           <p14:sldIdLst>
             <p14:sldId id="267"/>
           </p14:sldIdLst>
         </p14:section>
-        <p14:section name="Fit" id="{842101a8-546e-d05f-22eb-c543847f3737}">
+        <p14:section name="Fit" id="{beda631f-94b2-41ed-88da-2d29f9eed6a5}">
           <p14:sldIdLst>
             <p14:sldId id="268"/>
           </p14:sldIdLst>
         </p14:section>
-        <p14:section name="Next step" id="{2d597b2c-2951-a3d7-6806-61a0d25293bc}">
+        <p14:section name="Next step" id="{145da5ee-e0c7-803f-c43b-65af9a917dca}">
           <p14:sldIdLst>
             <p14:sldId id="269"/>
           </p14:sldIdLst>
@@ -2461,81 +2461,104 @@
           <a:chExt cx="0" cy="0"/>
         </a:xfrm>
       </p:grpSpPr>
-      <p:sp>
-        <p:nvSpPr>
-          <p:cNvPr id="2" name="Text 0"/>
+      <p:pic>
+        <p:nvPicPr>
+          <p:cNvPr id="2" name="Image 0" descr="/Users/jordan/consulting/public/images/hero-windansea-ldx3.jpg">    </p:cNvPr>
+          <p:cNvPicPr>
+            <a:picLocks noChangeAspect="1"/>
+          </p:cNvPicPr>
+          <p:nvPr/>
+        </p:nvPicPr>
+        <p:blipFill>
+          <a:blip r:embed="rId1"/>
+          <a:srcRect l="0" r="0" t="0" b="0"/>
+          <a:stretch/>
+        </p:blipFill>
+        <p:spPr>
+          <a:xfrm>
+            <a:off x="5852160" y="0"/>
+            <a:ext cx="3291840" cy="4549140"/>
+          </a:xfrm>
+          <a:prstGeom prst="rect">
+            <a:avLst/>
+          </a:prstGeom>
+        </p:spPr>
+      </p:pic>
+      <p:sp>
+        <p:nvSpPr>
+          <p:cNvPr id="3" name="Text 0"/>
           <p:cNvSpPr txBox="1"/>
           <p:nvPr/>
         </p:nvSpPr>
         <p:spPr>
           <a:xfrm>
             <a:off x="457200" y="1188720"/>
-            <a:ext cx="6858000" cy="1463040"/>
-          </a:xfrm>
-          <a:prstGeom prst="rect">
-            <a:avLst/>
-          </a:prstGeom>
-          <a:noFill/>
-          <a:ln/>
-        </p:spPr>
-        <p:txBody>
-          <a:bodyPr wrap="square" lIns="0" tIns="0" rIns="0" bIns="0" rtlCol="0" anchor="t"/>
-          <a:lstStyle/>
-          <a:p>
-            <a:pPr indent="0" marL="0">
-              <a:buNone/>
-            </a:pPr>
-            <a:r>
-              <a:rPr lang="en-US" sz="4000" b="1" dirty="0">
+            <a:ext cx="5029200" cy="1645920"/>
+          </a:xfrm>
+          <a:prstGeom prst="rect">
+            <a:avLst/>
+          </a:prstGeom>
+          <a:noFill/>
+          <a:ln/>
+        </p:spPr>
+        <p:txBody>
+          <a:bodyPr wrap="square" lIns="0" tIns="0" rIns="0" bIns="0" rtlCol="0" anchor="t"/>
+          <a:lstStyle/>
+          <a:p>
+            <a:pPr indent="0" marL="0">
+              <a:buNone/>
+            </a:pPr>
+            <a:r>
+              <a:rPr lang="en-US" sz="3600" b="1" dirty="0">
                 <a:solidFill>
                   <a:srgbClr val="FFFFFF"/>
                 </a:solidFill>
               </a:rPr>
               <a:t>We train your team to build AI systems in-house.</a:t>
             </a:r>
-            <a:endParaRPr lang="en-US" sz="4000" dirty="0"/>
-          </a:p>
-        </p:txBody>
-      </p:sp>
-      <p:sp>
-        <p:nvSpPr>
-          <p:cNvPr id="3" name="Text 1"/>
-          <p:cNvSpPr txBox="1"/>
-          <p:nvPr/>
-        </p:nvSpPr>
-        <p:spPr>
-          <a:xfrm>
-            <a:off x="457200" y="2788920"/>
-            <a:ext cx="6035040" cy="1097280"/>
-          </a:xfrm>
-          <a:prstGeom prst="rect">
-            <a:avLst/>
-          </a:prstGeom>
-          <a:noFill/>
-          <a:ln/>
-        </p:spPr>
-        <p:txBody>
-          <a:bodyPr wrap="square" lIns="0" tIns="0" rIns="0" bIns="0" rtlCol="0" anchor="t"/>
-          <a:lstStyle/>
-          <a:p>
-            <a:pPr indent="0" marL="0">
-              <a:buNone/>
-            </a:pPr>
-            <a:r>
-              <a:rPr lang="en-US" sz="1400" dirty="0">
+            <a:endParaRPr lang="en-US" sz="3600" dirty="0"/>
+          </a:p>
+        </p:txBody>
+      </p:sp>
+      <p:sp>
+        <p:nvSpPr>
+          <p:cNvPr id="4" name="Text 1"/>
+          <p:cNvSpPr txBox="1"/>
+          <p:nvPr/>
+        </p:nvSpPr>
+        <p:spPr>
+          <a:xfrm>
+            <a:off x="457200" y="2926080"/>
+            <a:ext cx="5029200" cy="1097280"/>
+          </a:xfrm>
+          <a:prstGeom prst="rect">
+            <a:avLst/>
+          </a:prstGeom>
+          <a:noFill/>
+          <a:ln/>
+        </p:spPr>
+        <p:txBody>
+          <a:bodyPr wrap="square" lIns="0" tIns="0" rIns="0" bIns="0" rtlCol="0" anchor="t"/>
+          <a:lstStyle/>
+          <a:p>
+            <a:pPr indent="0" marL="0">
+              <a:buNone/>
+            </a:pPr>
+            <a:r>
+              <a:rPr lang="en-US" sz="1300" dirty="0">
                 <a:solidFill>
                   <a:srgbClr val="D9D9D9"/>
                 </a:solidFill>
               </a:rPr>
               <a:t>An eight-week program that trains a small team inside your company to build, deploy, and own AI systems. Taught by consultants who have shipped these systems for clients in events, experiential marketing, real estate, and fitness.</a:t>
             </a:r>
-            <a:endParaRPr lang="en-US" sz="1400" dirty="0"/>
-          </a:p>
-        </p:txBody>
-      </p:sp>
-      <p:sp>
-        <p:nvSpPr>
-          <p:cNvPr id="4" name="Text 2"/>
+            <a:endParaRPr lang="en-US" sz="1300" dirty="0"/>
+          </a:p>
+        </p:txBody>
+      </p:sp>
+      <p:sp>
+        <p:nvSpPr>
+          <p:cNvPr id="5" name="Text 2"/>
           <p:cNvSpPr txBox="1"/>
           <p:nvPr/>
         </p:nvSpPr>

</xml_diff>

<commit_message>
content: drop per-case numbers table from site and PowerPoint
Co-Authored-By: Claude Fable 5.1 <noreply@anthropic.com>
</commit_message>
<xml_diff>
--- a/docs/deck/AI-Training-For-Companies.pptx
+++ b/docs/deck/AI-Training-For-Companies.pptx
@@ -120,72 +120,72 @@
   <p:extLst>
     <p:ext uri="{521415D9-36F7-43E2-AB2F-B90AF26B5E84}">
       <p14:sectionLst xmlns:p14="http://schemas.microsoft.com/office/powerpoint/2010/main">
-        <p14:section name="Intro" id="{150df9f5-729f-2e06-2453-df086e436829}">
+        <p14:section name="Intro" id="{62c008f0-410b-c639-ab08-c7005b85ee1c}">
           <p14:sldIdLst>
             <p14:sldId id="256"/>
           </p14:sldIdLst>
         </p14:section>
-        <p14:section name="Problem" id="{a90e07fa-49b7-ad82-806f-2bbf8ac05af9}">
+        <p14:section name="Problem" id="{40934998-40e8-3bd7-2dad-55854f744226}">
           <p14:sldIdLst>
             <p14:sldId id="257"/>
           </p14:sldIdLst>
         </p14:section>
-        <p14:section name="The fix" id="{a3d74ea6-c733-1e3c-0826-c677b110960b}">
+        <p14:section name="The fix" id="{6245e570-3316-ddd3-94d1-c42be3b27525}">
           <p14:sldIdLst>
             <p14:sldId id="258"/>
           </p14:sldIdLst>
         </p14:section>
-        <p14:section name="Who teaches" id="{6e469c77-88de-86b0-96d4-5fa745fa1b42}">
+        <p14:section name="Who teaches" id="{7e228b61-6c08-63d8-4b72-948d8c8b1614}">
           <p14:sldIdLst>
             <p14:sldId id="259"/>
           </p14:sldIdLst>
         </p14:section>
-        <p14:section name="Case 01" id="{21df1986-f3ff-d4d3-f804-b7a11a5b254a}">
+        <p14:section name="Case 01" id="{637a7eb8-050a-b4d6-2d4b-e31acd1487a2}">
           <p14:sldIdLst>
             <p14:sldId id="260"/>
           </p14:sldIdLst>
         </p14:section>
-        <p14:section name="Case 02" id="{7446479a-939f-1e0d-fb20-96e7cac9369c}">
+        <p14:section name="Case 02" id="{56849993-6a29-c8fd-ae2b-132489ac587d}">
           <p14:sldIdLst>
             <p14:sldId id="261"/>
           </p14:sldIdLst>
         </p14:section>
-        <p14:section name="Case 03" id="{c01fecc9-4f05-3974-806f-3c57b0d31057}">
+        <p14:section name="Case 03" id="{066f8a99-dc0f-0ec0-4448-06a635864540}">
           <p14:sldIdLst>
             <p14:sldId id="262"/>
           </p14:sldIdLst>
         </p14:section>
-        <p14:section name="Case 04" id="{cf20ab66-249d-6593-38d6-1429b0622543}">
+        <p14:section name="Case 04" id="{06a3360e-3567-4230-4a89-0bcacd7fe5a7}">
           <p14:sldIdLst>
             <p14:sldId id="263"/>
           </p14:sldIdLst>
         </p14:section>
-        <p14:section name="Enterprise" id="{2e855428-2cde-7170-cb42-7fc743ac000f}">
+        <p14:section name="Enterprise" id="{9f5a076e-a63d-1dc1-8108-a61f8913ca4a}">
           <p14:sldIdLst>
             <p14:sldId id="264"/>
           </p14:sldIdLst>
         </p14:section>
-        <p14:section name="Program" id="{6a44456f-3156-ea2e-299e-7f1d5c6a37dd}">
+        <p14:section name="Program" id="{35d2539b-91db-bbba-5da6-d801d587b23d}">
           <p14:sldIdLst>
             <p14:sldId id="265"/>
           </p14:sldIdLst>
         </p14:section>
-        <p14:section name="Outcomes" id="{503ec480-9464-7ad4-fb12-deee064320f1}">
+        <p14:section name="Outcomes" id="{a305ae7a-6f27-9c42-2ecd-cf184ce343ff}">
           <p14:sldIdLst>
             <p14:sldId id="266"/>
           </p14:sldIdLst>
         </p14:section>
-        <p14:section name="Pricing" id="{b1d64254-90b9-c4b6-bf08-edfe93e2fbd6}">
+        <p14:section name="Pricing" id="{36448106-7c4a-1dab-9327-8ddc9fa4f21a}">
           <p14:sldIdLst>
             <p14:sldId id="267"/>
           </p14:sldIdLst>
         </p14:section>
-        <p14:section name="Fit" id="{beda631f-94b2-41ed-88da-2d29f9eed6a5}">
+        <p14:section name="Fit" id="{bbfa2d69-7786-1ac9-a27b-fba9330fe04d}">
           <p14:sldIdLst>
             <p14:sldId id="268"/>
           </p14:sldIdLst>
         </p14:section>
-        <p14:section name="Next step" id="{145da5ee-e0c7-803f-c43b-65af9a917dca}">
+        <p14:section name="Next step" id="{905479d8-1d9c-3885-e9f4-22eadd45ffc2}">
           <p14:sldIdLst>
             <p14:sldId id="269"/>
           </p14:sldIdLst>
@@ -9277,53 +9277,30 @@
       </p:sp>
       <p:sp>
         <p:nvSpPr>
-          <p:cNvPr id="8" name="Shape 6"/>
-          <p:cNvSpPr/>
-          <p:nvPr/>
-        </p:nvSpPr>
-        <p:spPr>
-          <a:xfrm>
-            <a:off x="457200" y="3931920"/>
-            <a:ext cx="3931920" cy="0"/>
-          </a:xfrm>
-          <a:prstGeom prst="line">
-            <a:avLst/>
-          </a:prstGeom>
-          <a:noFill/>
-          <a:ln w="12700">
-            <a:solidFill>
-              <a:srgbClr val="161616"/>
-            </a:solidFill>
-            <a:prstDash val="solid"/>
-          </a:ln>
-        </p:spPr>
-      </p:sp>
-      <p:sp>
-        <p:nvSpPr>
-          <p:cNvPr id="9" name="Text 7"/>
-          <p:cNvSpPr txBox="1"/>
-          <p:nvPr/>
-        </p:nvSpPr>
-        <p:spPr>
-          <a:xfrm>
-            <a:off x="457200" y="4005072"/>
-            <a:ext cx="1737360" cy="237744"/>
-          </a:xfrm>
-          <a:prstGeom prst="rect">
-            <a:avLst/>
-          </a:prstGeom>
-          <a:noFill/>
-          <a:ln/>
-        </p:spPr>
-        <p:txBody>
-          <a:bodyPr wrap="square" lIns="0" tIns="0" rIns="0" bIns="0" rtlCol="0" anchor="t"/>
-          <a:lstStyle/>
-          <a:p>
-            <a:pPr indent="0" marL="0">
-              <a:buNone/>
-            </a:pPr>
-            <a:r>
-              <a:rPr lang="en-US" sz="700" spc="100" kern="0" dirty="0">
+          <p:cNvPr id="8" name="Text 6"/>
+          <p:cNvSpPr txBox="1"/>
+          <p:nvPr/>
+        </p:nvSpPr>
+        <p:spPr>
+          <a:xfrm>
+            <a:off x="4754880" y="1325880"/>
+            <a:ext cx="3931920" cy="201168"/>
+          </a:xfrm>
+          <a:prstGeom prst="rect">
+            <a:avLst/>
+          </a:prstGeom>
+          <a:noFill/>
+          <a:ln/>
+        </p:spPr>
+        <p:txBody>
+          <a:bodyPr wrap="square" lIns="0" tIns="0" rIns="0" bIns="0" rtlCol="0" anchor="t"/>
+          <a:lstStyle/>
+          <a:p>
+            <a:pPr indent="0" marL="0">
+              <a:buNone/>
+            </a:pPr>
+            <a:r>
+              <a:rPr lang="en-US" sz="800" spc="200" kern="0" dirty="0">
                 <a:solidFill>
                   <a:schemeClr val="tx2"/>
                 </a:solidFill>
@@ -9331,231 +9308,6 @@
                 <a:ea typeface="Courier New" pitchFamily="34" charset="-122"/>
                 <a:cs typeface="Courier New" pitchFamily="34" charset="-120"/>
               </a:rPr>
-              <a:t>RESPONSE TIME</a:t>
-            </a:r>
-            <a:endParaRPr lang="en-US" sz="700" dirty="0"/>
-          </a:p>
-        </p:txBody>
-      </p:sp>
-      <p:sp>
-        <p:nvSpPr>
-          <p:cNvPr id="10" name="Text 8"/>
-          <p:cNvSpPr txBox="1"/>
-          <p:nvPr/>
-        </p:nvSpPr>
-        <p:spPr>
-          <a:xfrm>
-            <a:off x="2240280" y="4005072"/>
-            <a:ext cx="2148840" cy="237744"/>
-          </a:xfrm>
-          <a:prstGeom prst="rect">
-            <a:avLst/>
-          </a:prstGeom>
-          <a:noFill/>
-          <a:ln/>
-        </p:spPr>
-        <p:txBody>
-          <a:bodyPr wrap="square" lIns="0" tIns="0" rIns="0" bIns="0" rtlCol="0" anchor="t"/>
-          <a:lstStyle/>
-          <a:p>
-            <a:pPr indent="0" marL="0">
-              <a:buNone/>
-            </a:pPr>
-            <a:r>
-              <a:rPr lang="en-US" sz="1000" b="1" dirty="0">
-                <a:solidFill>
-                  <a:schemeClr val="tx1"/>
-                </a:solidFill>
-              </a:rPr>
-              <a:t>Seconds, around the clock</a:t>
-            </a:r>
-            <a:endParaRPr lang="en-US" sz="1000" dirty="0"/>
-          </a:p>
-        </p:txBody>
-      </p:sp>
-      <p:sp>
-        <p:nvSpPr>
-          <p:cNvPr id="11" name="Text 9"/>
-          <p:cNvSpPr txBox="1"/>
-          <p:nvPr/>
-        </p:nvSpPr>
-        <p:spPr>
-          <a:xfrm>
-            <a:off x="457200" y="4279392"/>
-            <a:ext cx="1737360" cy="237744"/>
-          </a:xfrm>
-          <a:prstGeom prst="rect">
-            <a:avLst/>
-          </a:prstGeom>
-          <a:noFill/>
-          <a:ln/>
-        </p:spPr>
-        <p:txBody>
-          <a:bodyPr wrap="square" lIns="0" tIns="0" rIns="0" bIns="0" rtlCol="0" anchor="t"/>
-          <a:lstStyle/>
-          <a:p>
-            <a:pPr indent="0" marL="0">
-              <a:buNone/>
-            </a:pPr>
-            <a:r>
-              <a:rPr lang="en-US" sz="700" spc="100" kern="0" dirty="0">
-                <a:solidFill>
-                  <a:schemeClr val="tx2"/>
-                </a:solidFill>
-                <a:latin typeface="Courier New" pitchFamily="34" charset="0"/>
-                <a:ea typeface="Courier New" pitchFamily="34" charset="-122"/>
-                <a:cs typeface="Courier New" pitchFamily="34" charset="-120"/>
-              </a:rPr>
-              <a:t>BRANDS ON THE CONTENT ENGINE</a:t>
-            </a:r>
-            <a:endParaRPr lang="en-US" sz="700" dirty="0"/>
-          </a:p>
-        </p:txBody>
-      </p:sp>
-      <p:sp>
-        <p:nvSpPr>
-          <p:cNvPr id="12" name="Text 10"/>
-          <p:cNvSpPr txBox="1"/>
-          <p:nvPr/>
-        </p:nvSpPr>
-        <p:spPr>
-          <a:xfrm>
-            <a:off x="2240280" y="4279392"/>
-            <a:ext cx="2148840" cy="237744"/>
-          </a:xfrm>
-          <a:prstGeom prst="rect">
-            <a:avLst/>
-          </a:prstGeom>
-          <a:noFill/>
-          <a:ln/>
-        </p:spPr>
-        <p:txBody>
-          <a:bodyPr wrap="square" lIns="0" tIns="0" rIns="0" bIns="0" rtlCol="0" anchor="t"/>
-          <a:lstStyle/>
-          <a:p>
-            <a:pPr indent="0" marL="0">
-              <a:buNone/>
-            </a:pPr>
-            <a:r>
-              <a:rPr lang="en-US" sz="1000" b="1" dirty="0">
-                <a:solidFill>
-                  <a:schemeClr val="tx1"/>
-                </a:solidFill>
-              </a:rPr>
-              <a:t>3</a:t>
-            </a:r>
-            <a:endParaRPr lang="en-US" sz="1000" dirty="0"/>
-          </a:p>
-        </p:txBody>
-      </p:sp>
-      <p:sp>
-        <p:nvSpPr>
-          <p:cNvPr id="13" name="Text 11"/>
-          <p:cNvSpPr txBox="1"/>
-          <p:nvPr/>
-        </p:nvSpPr>
-        <p:spPr>
-          <a:xfrm>
-            <a:off x="457200" y="4553712"/>
-            <a:ext cx="1737360" cy="237744"/>
-          </a:xfrm>
-          <a:prstGeom prst="rect">
-            <a:avLst/>
-          </a:prstGeom>
-          <a:noFill/>
-          <a:ln/>
-        </p:spPr>
-        <p:txBody>
-          <a:bodyPr wrap="square" lIns="0" tIns="0" rIns="0" bIns="0" rtlCol="0" anchor="t"/>
-          <a:lstStyle/>
-          <a:p>
-            <a:pPr indent="0" marL="0">
-              <a:buNone/>
-            </a:pPr>
-            <a:r>
-              <a:rPr lang="en-US" sz="700" spc="100" kern="0" dirty="0">
-                <a:solidFill>
-                  <a:schemeClr val="tx2"/>
-                </a:solidFill>
-                <a:latin typeface="Courier New" pitchFamily="34" charset="0"/>
-                <a:ea typeface="Courier New" pitchFamily="34" charset="-122"/>
-                <a:cs typeface="Courier New" pitchFamily="34" charset="-120"/>
-              </a:rPr>
-              <a:t>HUMAN HANDOFF</a:t>
-            </a:r>
-            <a:endParaRPr lang="en-US" sz="700" dirty="0"/>
-          </a:p>
-        </p:txBody>
-      </p:sp>
-      <p:sp>
-        <p:nvSpPr>
-          <p:cNvPr id="14" name="Text 12"/>
-          <p:cNvSpPr txBox="1"/>
-          <p:nvPr/>
-        </p:nvSpPr>
-        <p:spPr>
-          <a:xfrm>
-            <a:off x="2240280" y="4553712"/>
-            <a:ext cx="2148840" cy="237744"/>
-          </a:xfrm>
-          <a:prstGeom prst="rect">
-            <a:avLst/>
-          </a:prstGeom>
-          <a:noFill/>
-          <a:ln/>
-        </p:spPr>
-        <p:txBody>
-          <a:bodyPr wrap="square" lIns="0" tIns="0" rIns="0" bIns="0" rtlCol="0" anchor="t"/>
-          <a:lstStyle/>
-          <a:p>
-            <a:pPr indent="0" marL="0">
-              <a:buNone/>
-            </a:pPr>
-            <a:r>
-              <a:rPr lang="en-US" sz="1000" b="1" dirty="0">
-                <a:solidFill>
-                  <a:schemeClr val="tx1"/>
-                </a:solidFill>
-              </a:rPr>
-              <a:t>Confidence threshold to Discord</a:t>
-            </a:r>
-            <a:endParaRPr lang="en-US" sz="1000" dirty="0"/>
-          </a:p>
-        </p:txBody>
-      </p:sp>
-      <p:sp>
-        <p:nvSpPr>
-          <p:cNvPr id="15" name="Text 13"/>
-          <p:cNvSpPr txBox="1"/>
-          <p:nvPr/>
-        </p:nvSpPr>
-        <p:spPr>
-          <a:xfrm>
-            <a:off x="4754880" y="1325880"/>
-            <a:ext cx="3931920" cy="201168"/>
-          </a:xfrm>
-          <a:prstGeom prst="rect">
-            <a:avLst/>
-          </a:prstGeom>
-          <a:noFill/>
-          <a:ln/>
-        </p:spPr>
-        <p:txBody>
-          <a:bodyPr wrap="square" lIns="0" tIns="0" rIns="0" bIns="0" rtlCol="0" anchor="t"/>
-          <a:lstStyle/>
-          <a:p>
-            <a:pPr indent="0" marL="0">
-              <a:buNone/>
-            </a:pPr>
-            <a:r>
-              <a:rPr lang="en-US" sz="800" spc="200" kern="0" dirty="0">
-                <a:solidFill>
-                  <a:schemeClr val="tx2"/>
-                </a:solidFill>
-                <a:latin typeface="Courier New" pitchFamily="34" charset="0"/>
-                <a:ea typeface="Courier New" pitchFamily="34" charset="-122"/>
-                <a:cs typeface="Courier New" pitchFamily="34" charset="-120"/>
-              </a:rPr>
               <a:t>WHAT WAS BUILT</a:t>
             </a:r>
             <a:endParaRPr lang="en-US" sz="800" dirty="0"/>
@@ -9564,7 +9316,7 @@
       </p:sp>
       <p:sp>
         <p:nvSpPr>
-          <p:cNvPr id="16" name="Shape 14"/>
+          <p:cNvPr id="9" name="Shape 7"/>
           <p:cNvSpPr/>
           <p:nvPr/>
         </p:nvSpPr>
@@ -9587,7 +9339,7 @@
       </p:sp>
       <p:sp>
         <p:nvSpPr>
-          <p:cNvPr id="17" name="Text 15"/>
+          <p:cNvPr id="10" name="Text 8"/>
           <p:cNvSpPr txBox="1"/>
           <p:nvPr/>
         </p:nvSpPr>
@@ -9626,7 +9378,7 @@
       </p:sp>
       <p:sp>
         <p:nvSpPr>
-          <p:cNvPr id="18" name="Text 16"/>
+          <p:cNvPr id="11" name="Text 9"/>
           <p:cNvSpPr txBox="1"/>
           <p:nvPr/>
         </p:nvSpPr>
@@ -9662,7 +9414,7 @@
       </p:sp>
       <p:sp>
         <p:nvSpPr>
-          <p:cNvPr id="19" name="Shape 17"/>
+          <p:cNvPr id="12" name="Shape 10"/>
           <p:cNvSpPr/>
           <p:nvPr/>
         </p:nvSpPr>
@@ -9685,7 +9437,7 @@
       </p:sp>
       <p:sp>
         <p:nvSpPr>
-          <p:cNvPr id="20" name="Text 18"/>
+          <p:cNvPr id="13" name="Text 11"/>
           <p:cNvSpPr txBox="1"/>
           <p:nvPr/>
         </p:nvSpPr>
@@ -9724,7 +9476,7 @@
       </p:sp>
       <p:sp>
         <p:nvSpPr>
-          <p:cNvPr id="21" name="Text 19"/>
+          <p:cNvPr id="14" name="Text 12"/>
           <p:cNvSpPr txBox="1"/>
           <p:nvPr/>
         </p:nvSpPr>
@@ -9760,7 +9512,7 @@
       </p:sp>
       <p:sp>
         <p:nvSpPr>
-          <p:cNvPr id="22" name="Shape 20"/>
+          <p:cNvPr id="15" name="Shape 13"/>
           <p:cNvSpPr/>
           <p:nvPr/>
         </p:nvSpPr>
@@ -9783,7 +9535,7 @@
       </p:sp>
       <p:sp>
         <p:nvSpPr>
-          <p:cNvPr id="23" name="Text 21"/>
+          <p:cNvPr id="16" name="Text 14"/>
           <p:cNvSpPr txBox="1"/>
           <p:nvPr/>
         </p:nvSpPr>
@@ -9822,7 +9574,7 @@
       </p:sp>
       <p:sp>
         <p:nvSpPr>
-          <p:cNvPr id="24" name="Text 22"/>
+          <p:cNvPr id="17" name="Text 15"/>
           <p:cNvSpPr txBox="1"/>
           <p:nvPr/>
         </p:nvSpPr>
@@ -9858,7 +9610,7 @@
       </p:sp>
       <p:sp>
         <p:nvSpPr>
-          <p:cNvPr id="25" name="Shape 23"/>
+          <p:cNvPr id="18" name="Shape 16"/>
           <p:cNvSpPr/>
           <p:nvPr/>
         </p:nvSpPr>
@@ -9881,7 +9633,7 @@
       </p:sp>
       <p:sp>
         <p:nvSpPr>
-          <p:cNvPr id="26" name="Text 24"/>
+          <p:cNvPr id="19" name="Text 17"/>
           <p:cNvSpPr txBox="1"/>
           <p:nvPr/>
         </p:nvSpPr>
@@ -9920,7 +9672,7 @@
       </p:sp>
       <p:sp>
         <p:nvSpPr>
-          <p:cNvPr id="27" name="Text 25"/>
+          <p:cNvPr id="20" name="Text 18"/>
           <p:cNvSpPr txBox="1"/>
           <p:nvPr/>
         </p:nvSpPr>
@@ -9957,7 +9709,7 @@
       </p:sp>
       <p:sp>
         <p:nvSpPr>
-          <p:cNvPr id="28" name="Text 26"/>
+          <p:cNvPr id="21" name="Text 19"/>
           <p:cNvSpPr txBox="1"/>
           <p:nvPr/>
         </p:nvSpPr>
@@ -9994,7 +9746,7 @@
       </p:sp>
       <p:sp>
         <p:nvSpPr>
-          <p:cNvPr id="29" name="Text 27"/>
+          <p:cNvPr id="22" name="Text 20"/>
           <p:cNvSpPr txBox="1"/>
           <p:nvPr/>
         </p:nvSpPr>
@@ -10331,53 +10083,30 @@
       </p:sp>
       <p:sp>
         <p:nvSpPr>
-          <p:cNvPr id="8" name="Shape 6"/>
-          <p:cNvSpPr/>
-          <p:nvPr/>
-        </p:nvSpPr>
-        <p:spPr>
-          <a:xfrm>
-            <a:off x="457200" y="3931920"/>
-            <a:ext cx="3931920" cy="0"/>
-          </a:xfrm>
-          <a:prstGeom prst="line">
-            <a:avLst/>
-          </a:prstGeom>
-          <a:noFill/>
-          <a:ln w="12700">
-            <a:solidFill>
-              <a:srgbClr val="161616"/>
-            </a:solidFill>
-            <a:prstDash val="solid"/>
-          </a:ln>
-        </p:spPr>
-      </p:sp>
-      <p:sp>
-        <p:nvSpPr>
-          <p:cNvPr id="9" name="Text 7"/>
-          <p:cNvSpPr txBox="1"/>
-          <p:nvPr/>
-        </p:nvSpPr>
-        <p:spPr>
-          <a:xfrm>
-            <a:off x="457200" y="4005072"/>
-            <a:ext cx="1737360" cy="237744"/>
-          </a:xfrm>
-          <a:prstGeom prst="rect">
-            <a:avLst/>
-          </a:prstGeom>
-          <a:noFill/>
-          <a:ln/>
-        </p:spPr>
-        <p:txBody>
-          <a:bodyPr wrap="square" lIns="0" tIns="0" rIns="0" bIns="0" rtlCol="0" anchor="t"/>
-          <a:lstStyle/>
-          <a:p>
-            <a:pPr indent="0" marL="0">
-              <a:buNone/>
-            </a:pPr>
-            <a:r>
-              <a:rPr lang="en-US" sz="700" spc="100" kern="0" dirty="0">
+          <p:cNvPr id="8" name="Text 6"/>
+          <p:cNvSpPr txBox="1"/>
+          <p:nvPr/>
+        </p:nvSpPr>
+        <p:spPr>
+          <a:xfrm>
+            <a:off x="4754880" y="1325880"/>
+            <a:ext cx="3931920" cy="201168"/>
+          </a:xfrm>
+          <a:prstGeom prst="rect">
+            <a:avLst/>
+          </a:prstGeom>
+          <a:noFill/>
+          <a:ln/>
+        </p:spPr>
+        <p:txBody>
+          <a:bodyPr wrap="square" lIns="0" tIns="0" rIns="0" bIns="0" rtlCol="0" anchor="t"/>
+          <a:lstStyle/>
+          <a:p>
+            <a:pPr indent="0" marL="0">
+              <a:buNone/>
+            </a:pPr>
+            <a:r>
+              <a:rPr lang="en-US" sz="800" spc="200" kern="0" dirty="0">
                 <a:solidFill>
                   <a:schemeClr val="tx2"/>
                 </a:solidFill>
@@ -10385,231 +10114,6 @@
                 <a:ea typeface="Courier New" pitchFamily="34" charset="-122"/>
                 <a:cs typeface="Courier New" pitchFamily="34" charset="-120"/>
               </a:rPr>
-              <a:t>REVENUE</a:t>
-            </a:r>
-            <a:endParaRPr lang="en-US" sz="700" dirty="0"/>
-          </a:p>
-        </p:txBody>
-      </p:sp>
-      <p:sp>
-        <p:nvSpPr>
-          <p:cNvPr id="10" name="Text 8"/>
-          <p:cNvSpPr txBox="1"/>
-          <p:nvPr/>
-        </p:nvSpPr>
-        <p:spPr>
-          <a:xfrm>
-            <a:off x="2240280" y="4005072"/>
-            <a:ext cx="2148840" cy="237744"/>
-          </a:xfrm>
-          <a:prstGeom prst="rect">
-            <a:avLst/>
-          </a:prstGeom>
-          <a:noFill/>
-          <a:ln/>
-        </p:spPr>
-        <p:txBody>
-          <a:bodyPr wrap="square" lIns="0" tIns="0" rIns="0" bIns="0" rtlCol="0" anchor="t"/>
-          <a:lstStyle/>
-          <a:p>
-            <a:pPr indent="0" marL="0">
-              <a:buNone/>
-            </a:pPr>
-            <a:r>
-              <a:rPr lang="en-US" sz="1000" b="1" dirty="0">
-                <a:solidFill>
-                  <a:schemeClr val="tx1"/>
-                </a:solidFill>
-              </a:rPr>
-              <a:t>$1M+</a:t>
-            </a:r>
-            <a:endParaRPr lang="en-US" sz="1000" dirty="0"/>
-          </a:p>
-        </p:txBody>
-      </p:sp>
-      <p:sp>
-        <p:nvSpPr>
-          <p:cNvPr id="11" name="Text 9"/>
-          <p:cNvSpPr txBox="1"/>
-          <p:nvPr/>
-        </p:nvSpPr>
-        <p:spPr>
-          <a:xfrm>
-            <a:off x="457200" y="4279392"/>
-            <a:ext cx="1737360" cy="237744"/>
-          </a:xfrm>
-          <a:prstGeom prst="rect">
-            <a:avLst/>
-          </a:prstGeom>
-          <a:noFill/>
-          <a:ln/>
-        </p:spPr>
-        <p:txBody>
-          <a:bodyPr wrap="square" lIns="0" tIns="0" rIns="0" bIns="0" rtlCol="0" anchor="t"/>
-          <a:lstStyle/>
-          <a:p>
-            <a:pPr indent="0" marL="0">
-              <a:buNone/>
-            </a:pPr>
-            <a:r>
-              <a:rPr lang="en-US" sz="700" spc="100" kern="0" dirty="0">
-                <a:solidFill>
-                  <a:schemeClr val="tx2"/>
-                </a:solidFill>
-                <a:latin typeface="Courier New" pitchFamily="34" charset="0"/>
-                <a:ea typeface="Courier New" pitchFamily="34" charset="-122"/>
-                <a:cs typeface="Courier New" pitchFamily="34" charset="-120"/>
-              </a:rPr>
-              <a:t>SYSTEMS CONNECTED</a:t>
-            </a:r>
-            <a:endParaRPr lang="en-US" sz="700" dirty="0"/>
-          </a:p>
-        </p:txBody>
-      </p:sp>
-      <p:sp>
-        <p:nvSpPr>
-          <p:cNvPr id="12" name="Text 10"/>
-          <p:cNvSpPr txBox="1"/>
-          <p:nvPr/>
-        </p:nvSpPr>
-        <p:spPr>
-          <a:xfrm>
-            <a:off x="2240280" y="4279392"/>
-            <a:ext cx="2148840" cy="237744"/>
-          </a:xfrm>
-          <a:prstGeom prst="rect">
-            <a:avLst/>
-          </a:prstGeom>
-          <a:noFill/>
-          <a:ln/>
-        </p:spPr>
-        <p:txBody>
-          <a:bodyPr wrap="square" lIns="0" tIns="0" rIns="0" bIns="0" rtlCol="0" anchor="t"/>
-          <a:lstStyle/>
-          <a:p>
-            <a:pPr indent="0" marL="0">
-              <a:buNone/>
-            </a:pPr>
-            <a:r>
-              <a:rPr lang="en-US" sz="1000" b="1" dirty="0">
-                <a:solidFill>
-                  <a:schemeClr val="tx1"/>
-                </a:solidFill>
-              </a:rPr>
-              <a:t>4</a:t>
-            </a:r>
-            <a:endParaRPr lang="en-US" sz="1000" dirty="0"/>
-          </a:p>
-        </p:txBody>
-      </p:sp>
-      <p:sp>
-        <p:nvSpPr>
-          <p:cNvPr id="13" name="Text 11"/>
-          <p:cNvSpPr txBox="1"/>
-          <p:nvPr/>
-        </p:nvSpPr>
-        <p:spPr>
-          <a:xfrm>
-            <a:off x="457200" y="4553712"/>
-            <a:ext cx="1737360" cy="237744"/>
-          </a:xfrm>
-          <a:prstGeom prst="rect">
-            <a:avLst/>
-          </a:prstGeom>
-          <a:noFill/>
-          <a:ln/>
-        </p:spPr>
-        <p:txBody>
-          <a:bodyPr wrap="square" lIns="0" tIns="0" rIns="0" bIns="0" rtlCol="0" anchor="t"/>
-          <a:lstStyle/>
-          <a:p>
-            <a:pPr indent="0" marL="0">
-              <a:buNone/>
-            </a:pPr>
-            <a:r>
-              <a:rPr lang="en-US" sz="700" spc="100" kern="0" dirty="0">
-                <a:solidFill>
-                  <a:schemeClr val="tx2"/>
-                </a:solidFill>
-                <a:latin typeface="Courier New" pitchFamily="34" charset="0"/>
-                <a:ea typeface="Courier New" pitchFamily="34" charset="-122"/>
-                <a:cs typeface="Courier New" pitchFamily="34" charset="-120"/>
-              </a:rPr>
-              <a:t>RUN OF SHOW</a:t>
-            </a:r>
-            <a:endParaRPr lang="en-US" sz="700" dirty="0"/>
-          </a:p>
-        </p:txBody>
-      </p:sp>
-      <p:sp>
-        <p:nvSpPr>
-          <p:cNvPr id="14" name="Text 12"/>
-          <p:cNvSpPr txBox="1"/>
-          <p:nvPr/>
-        </p:nvSpPr>
-        <p:spPr>
-          <a:xfrm>
-            <a:off x="2240280" y="4553712"/>
-            <a:ext cx="2148840" cy="237744"/>
-          </a:xfrm>
-          <a:prstGeom prst="rect">
-            <a:avLst/>
-          </a:prstGeom>
-          <a:noFill/>
-          <a:ln/>
-        </p:spPr>
-        <p:txBody>
-          <a:bodyPr wrap="square" lIns="0" tIns="0" rIns="0" bIns="0" rtlCol="0" anchor="t"/>
-          <a:lstStyle/>
-          <a:p>
-            <a:pPr indent="0" marL="0">
-              <a:buNone/>
-            </a:pPr>
-            <a:r>
-              <a:rPr lang="en-US" sz="1000" b="1" dirty="0">
-                <a:solidFill>
-                  <a:schemeClr val="tx1"/>
-                </a:solidFill>
-              </a:rPr>
-              <a:t>Written daily by Claude</a:t>
-            </a:r>
-            <a:endParaRPr lang="en-US" sz="1000" dirty="0"/>
-          </a:p>
-        </p:txBody>
-      </p:sp>
-      <p:sp>
-        <p:nvSpPr>
-          <p:cNvPr id="15" name="Text 13"/>
-          <p:cNvSpPr txBox="1"/>
-          <p:nvPr/>
-        </p:nvSpPr>
-        <p:spPr>
-          <a:xfrm>
-            <a:off x="4754880" y="1325880"/>
-            <a:ext cx="3931920" cy="201168"/>
-          </a:xfrm>
-          <a:prstGeom prst="rect">
-            <a:avLst/>
-          </a:prstGeom>
-          <a:noFill/>
-          <a:ln/>
-        </p:spPr>
-        <p:txBody>
-          <a:bodyPr wrap="square" lIns="0" tIns="0" rIns="0" bIns="0" rtlCol="0" anchor="t"/>
-          <a:lstStyle/>
-          <a:p>
-            <a:pPr indent="0" marL="0">
-              <a:buNone/>
-            </a:pPr>
-            <a:r>
-              <a:rPr lang="en-US" sz="800" spc="200" kern="0" dirty="0">
-                <a:solidFill>
-                  <a:schemeClr val="tx2"/>
-                </a:solidFill>
-                <a:latin typeface="Courier New" pitchFamily="34" charset="0"/>
-                <a:ea typeface="Courier New" pitchFamily="34" charset="-122"/>
-                <a:cs typeface="Courier New" pitchFamily="34" charset="-120"/>
-              </a:rPr>
               <a:t>WHAT WAS BUILT</a:t>
             </a:r>
             <a:endParaRPr lang="en-US" sz="800" dirty="0"/>
@@ -10618,7 +10122,7 @@
       </p:sp>
       <p:sp>
         <p:nvSpPr>
-          <p:cNvPr id="16" name="Shape 14"/>
+          <p:cNvPr id="9" name="Shape 7"/>
           <p:cNvSpPr/>
           <p:nvPr/>
         </p:nvSpPr>
@@ -10641,7 +10145,7 @@
       </p:sp>
       <p:sp>
         <p:nvSpPr>
-          <p:cNvPr id="17" name="Text 15"/>
+          <p:cNvPr id="10" name="Text 8"/>
           <p:cNvSpPr txBox="1"/>
           <p:nvPr/>
         </p:nvSpPr>
@@ -10680,7 +10184,7 @@
       </p:sp>
       <p:sp>
         <p:nvSpPr>
-          <p:cNvPr id="18" name="Text 16"/>
+          <p:cNvPr id="11" name="Text 9"/>
           <p:cNvSpPr txBox="1"/>
           <p:nvPr/>
         </p:nvSpPr>
@@ -10716,7 +10220,7 @@
       </p:sp>
       <p:sp>
         <p:nvSpPr>
-          <p:cNvPr id="19" name="Shape 17"/>
+          <p:cNvPr id="12" name="Shape 10"/>
           <p:cNvSpPr/>
           <p:nvPr/>
         </p:nvSpPr>
@@ -10739,7 +10243,7 @@
       </p:sp>
       <p:sp>
         <p:nvSpPr>
-          <p:cNvPr id="20" name="Text 18"/>
+          <p:cNvPr id="13" name="Text 11"/>
           <p:cNvSpPr txBox="1"/>
           <p:nvPr/>
         </p:nvSpPr>
@@ -10778,7 +10282,7 @@
       </p:sp>
       <p:sp>
         <p:nvSpPr>
-          <p:cNvPr id="21" name="Text 19"/>
+          <p:cNvPr id="14" name="Text 12"/>
           <p:cNvSpPr txBox="1"/>
           <p:nvPr/>
         </p:nvSpPr>
@@ -10814,7 +10318,7 @@
       </p:sp>
       <p:sp>
         <p:nvSpPr>
-          <p:cNvPr id="22" name="Shape 20"/>
+          <p:cNvPr id="15" name="Shape 13"/>
           <p:cNvSpPr/>
           <p:nvPr/>
         </p:nvSpPr>
@@ -10837,7 +10341,7 @@
       </p:sp>
       <p:sp>
         <p:nvSpPr>
-          <p:cNvPr id="23" name="Text 21"/>
+          <p:cNvPr id="16" name="Text 14"/>
           <p:cNvSpPr txBox="1"/>
           <p:nvPr/>
         </p:nvSpPr>
@@ -10876,7 +10380,7 @@
       </p:sp>
       <p:sp>
         <p:nvSpPr>
-          <p:cNvPr id="24" name="Text 22"/>
+          <p:cNvPr id="17" name="Text 15"/>
           <p:cNvSpPr txBox="1"/>
           <p:nvPr/>
         </p:nvSpPr>
@@ -10912,7 +10416,7 @@
       </p:sp>
       <p:sp>
         <p:nvSpPr>
-          <p:cNvPr id="25" name="Shape 23"/>
+          <p:cNvPr id="18" name="Shape 16"/>
           <p:cNvSpPr/>
           <p:nvPr/>
         </p:nvSpPr>
@@ -10935,7 +10439,7 @@
       </p:sp>
       <p:sp>
         <p:nvSpPr>
-          <p:cNvPr id="26" name="Text 24"/>
+          <p:cNvPr id="19" name="Text 17"/>
           <p:cNvSpPr txBox="1"/>
           <p:nvPr/>
         </p:nvSpPr>
@@ -10974,7 +10478,7 @@
       </p:sp>
       <p:sp>
         <p:nvSpPr>
-          <p:cNvPr id="27" name="Text 25"/>
+          <p:cNvPr id="20" name="Text 18"/>
           <p:cNvSpPr txBox="1"/>
           <p:nvPr/>
         </p:nvSpPr>
@@ -11011,7 +10515,7 @@
       </p:sp>
       <p:sp>
         <p:nvSpPr>
-          <p:cNvPr id="28" name="Text 26"/>
+          <p:cNvPr id="21" name="Text 19"/>
           <p:cNvSpPr txBox="1"/>
           <p:nvPr/>
         </p:nvSpPr>
@@ -11048,7 +10552,7 @@
       </p:sp>
       <p:sp>
         <p:nvSpPr>
-          <p:cNvPr id="29" name="Text 27"/>
+          <p:cNvPr id="22" name="Text 20"/>
           <p:cNvSpPr txBox="1"/>
           <p:nvPr/>
         </p:nvSpPr>
@@ -11385,53 +10889,30 @@
       </p:sp>
       <p:sp>
         <p:nvSpPr>
-          <p:cNvPr id="8" name="Shape 6"/>
-          <p:cNvSpPr/>
-          <p:nvPr/>
-        </p:nvSpPr>
-        <p:spPr>
-          <a:xfrm>
-            <a:off x="457200" y="3931920"/>
-            <a:ext cx="3931920" cy="0"/>
-          </a:xfrm>
-          <a:prstGeom prst="line">
-            <a:avLst/>
-          </a:prstGeom>
-          <a:noFill/>
-          <a:ln w="12700">
-            <a:solidFill>
-              <a:srgbClr val="161616"/>
-            </a:solidFill>
-            <a:prstDash val="solid"/>
-          </a:ln>
-        </p:spPr>
-      </p:sp>
-      <p:sp>
-        <p:nvSpPr>
-          <p:cNvPr id="9" name="Text 7"/>
-          <p:cNvSpPr txBox="1"/>
-          <p:nvPr/>
-        </p:nvSpPr>
-        <p:spPr>
-          <a:xfrm>
-            <a:off x="457200" y="4005072"/>
-            <a:ext cx="1737360" cy="237744"/>
-          </a:xfrm>
-          <a:prstGeom prst="rect">
-            <a:avLst/>
-          </a:prstGeom>
-          <a:noFill/>
-          <a:ln/>
-        </p:spPr>
-        <p:txBody>
-          <a:bodyPr wrap="square" lIns="0" tIns="0" rIns="0" bIns="0" rtlCol="0" anchor="t"/>
-          <a:lstStyle/>
-          <a:p>
-            <a:pPr indent="0" marL="0">
-              <a:buNone/>
-            </a:pPr>
-            <a:r>
-              <a:rPr lang="en-US" sz="700" spc="100" kern="0" dirty="0">
+          <p:cNvPr id="8" name="Text 6"/>
+          <p:cNvSpPr txBox="1"/>
+          <p:nvPr/>
+        </p:nvSpPr>
+        <p:spPr>
+          <a:xfrm>
+            <a:off x="4754880" y="1325880"/>
+            <a:ext cx="3931920" cy="201168"/>
+          </a:xfrm>
+          <a:prstGeom prst="rect">
+            <a:avLst/>
+          </a:prstGeom>
+          <a:noFill/>
+          <a:ln/>
+        </p:spPr>
+        <p:txBody>
+          <a:bodyPr wrap="square" lIns="0" tIns="0" rIns="0" bIns="0" rtlCol="0" anchor="t"/>
+          <a:lstStyle/>
+          <a:p>
+            <a:pPr indent="0" marL="0">
+              <a:buNone/>
+            </a:pPr>
+            <a:r>
+              <a:rPr lang="en-US" sz="800" spc="200" kern="0" dirty="0">
                 <a:solidFill>
                   <a:schemeClr val="tx2"/>
                 </a:solidFill>
@@ -11439,231 +10920,6 @@
                 <a:ea typeface="Courier New" pitchFamily="34" charset="-122"/>
                 <a:cs typeface="Courier New" pitchFamily="34" charset="-120"/>
               </a:rPr>
-              <a:t>TRANSACTIONS SERVICED</a:t>
-            </a:r>
-            <a:endParaRPr lang="en-US" sz="700" dirty="0"/>
-          </a:p>
-        </p:txBody>
-      </p:sp>
-      <p:sp>
-        <p:nvSpPr>
-          <p:cNvPr id="10" name="Text 8"/>
-          <p:cNvSpPr txBox="1"/>
-          <p:nvPr/>
-        </p:nvSpPr>
-        <p:spPr>
-          <a:xfrm>
-            <a:off x="2240280" y="4005072"/>
-            <a:ext cx="2148840" cy="237744"/>
-          </a:xfrm>
-          <a:prstGeom prst="rect">
-            <a:avLst/>
-          </a:prstGeom>
-          <a:noFill/>
-          <a:ln/>
-        </p:spPr>
-        <p:txBody>
-          <a:bodyPr wrap="square" lIns="0" tIns="0" rIns="0" bIns="0" rtlCol="0" anchor="t"/>
-          <a:lstStyle/>
-          <a:p>
-            <a:pPr indent="0" marL="0">
-              <a:buNone/>
-            </a:pPr>
-            <a:r>
-              <a:rPr lang="en-US" sz="1000" b="1" dirty="0">
-                <a:solidFill>
-                  <a:schemeClr val="tx1"/>
-                </a:solidFill>
-              </a:rPr>
-              <a:t>Million-dollar</a:t>
-            </a:r>
-            <a:endParaRPr lang="en-US" sz="1000" dirty="0"/>
-          </a:p>
-        </p:txBody>
-      </p:sp>
-      <p:sp>
-        <p:nvSpPr>
-          <p:cNvPr id="11" name="Text 9"/>
-          <p:cNvSpPr txBox="1"/>
-          <p:nvPr/>
-        </p:nvSpPr>
-        <p:spPr>
-          <a:xfrm>
-            <a:off x="457200" y="4279392"/>
-            <a:ext cx="1737360" cy="237744"/>
-          </a:xfrm>
-          <a:prstGeom prst="rect">
-            <a:avLst/>
-          </a:prstGeom>
-          <a:noFill/>
-          <a:ln/>
-        </p:spPr>
-        <p:txBody>
-          <a:bodyPr wrap="square" lIns="0" tIns="0" rIns="0" bIns="0" rtlCol="0" anchor="t"/>
-          <a:lstStyle/>
-          <a:p>
-            <a:pPr indent="0" marL="0">
-              <a:buNone/>
-            </a:pPr>
-            <a:r>
-              <a:rPr lang="en-US" sz="700" spc="100" kern="0" dirty="0">
-                <a:solidFill>
-                  <a:schemeClr val="tx2"/>
-                </a:solidFill>
-                <a:latin typeface="Courier New" pitchFamily="34" charset="0"/>
-                <a:ea typeface="Courier New" pitchFamily="34" charset="-122"/>
-                <a:cs typeface="Courier New" pitchFamily="34" charset="-120"/>
-              </a:rPr>
-              <a:t>ZAPIER STEPS REMAINING</a:t>
-            </a:r>
-            <a:endParaRPr lang="en-US" sz="700" dirty="0"/>
-          </a:p>
-        </p:txBody>
-      </p:sp>
-      <p:sp>
-        <p:nvSpPr>
-          <p:cNvPr id="12" name="Text 10"/>
-          <p:cNvSpPr txBox="1"/>
-          <p:nvPr/>
-        </p:nvSpPr>
-        <p:spPr>
-          <a:xfrm>
-            <a:off x="2240280" y="4279392"/>
-            <a:ext cx="2148840" cy="237744"/>
-          </a:xfrm>
-          <a:prstGeom prst="rect">
-            <a:avLst/>
-          </a:prstGeom>
-          <a:noFill/>
-          <a:ln/>
-        </p:spPr>
-        <p:txBody>
-          <a:bodyPr wrap="square" lIns="0" tIns="0" rIns="0" bIns="0" rtlCol="0" anchor="t"/>
-          <a:lstStyle/>
-          <a:p>
-            <a:pPr indent="0" marL="0">
-              <a:buNone/>
-            </a:pPr>
-            <a:r>
-              <a:rPr lang="en-US" sz="1000" b="1" dirty="0">
-                <a:solidFill>
-                  <a:schemeClr val="tx1"/>
-                </a:solidFill>
-              </a:rPr>
-              <a:t>0</a:t>
-            </a:r>
-            <a:endParaRPr lang="en-US" sz="1000" dirty="0"/>
-          </a:p>
-        </p:txBody>
-      </p:sp>
-      <p:sp>
-        <p:nvSpPr>
-          <p:cNvPr id="13" name="Text 11"/>
-          <p:cNvSpPr txBox="1"/>
-          <p:nvPr/>
-        </p:nvSpPr>
-        <p:spPr>
-          <a:xfrm>
-            <a:off x="457200" y="4553712"/>
-            <a:ext cx="1737360" cy="237744"/>
-          </a:xfrm>
-          <a:prstGeom prst="rect">
-            <a:avLst/>
-          </a:prstGeom>
-          <a:noFill/>
-          <a:ln/>
-        </p:spPr>
-        <p:txBody>
-          <a:bodyPr wrap="square" lIns="0" tIns="0" rIns="0" bIns="0" rtlCol="0" anchor="t"/>
-          <a:lstStyle/>
-          <a:p>
-            <a:pPr indent="0" marL="0">
-              <a:buNone/>
-            </a:pPr>
-            <a:r>
-              <a:rPr lang="en-US" sz="700" spc="100" kern="0" dirty="0">
-                <a:solidFill>
-                  <a:schemeClr val="tx2"/>
-                </a:solidFill>
-                <a:latin typeface="Courier New" pitchFamily="34" charset="0"/>
-                <a:ea typeface="Courier New" pitchFamily="34" charset="-122"/>
-                <a:cs typeface="Courier New" pitchFamily="34" charset="-120"/>
-              </a:rPr>
-              <a:t>SKIP-TRACE STATES</a:t>
-            </a:r>
-            <a:endParaRPr lang="en-US" sz="700" dirty="0"/>
-          </a:p>
-        </p:txBody>
-      </p:sp>
-      <p:sp>
-        <p:nvSpPr>
-          <p:cNvPr id="14" name="Text 12"/>
-          <p:cNvSpPr txBox="1"/>
-          <p:nvPr/>
-        </p:nvSpPr>
-        <p:spPr>
-          <a:xfrm>
-            <a:off x="2240280" y="4553712"/>
-            <a:ext cx="2148840" cy="237744"/>
-          </a:xfrm>
-          <a:prstGeom prst="rect">
-            <a:avLst/>
-          </a:prstGeom>
-          <a:noFill/>
-          <a:ln/>
-        </p:spPr>
-        <p:txBody>
-          <a:bodyPr wrap="square" lIns="0" tIns="0" rIns="0" bIns="0" rtlCol="0" anchor="t"/>
-          <a:lstStyle/>
-          <a:p>
-            <a:pPr indent="0" marL="0">
-              <a:buNone/>
-            </a:pPr>
-            <a:r>
-              <a:rPr lang="en-US" sz="1000" b="1" dirty="0">
-                <a:solidFill>
-                  <a:schemeClr val="tx1"/>
-                </a:solidFill>
-              </a:rPr>
-              <a:t>6</a:t>
-            </a:r>
-            <a:endParaRPr lang="en-US" sz="1000" dirty="0"/>
-          </a:p>
-        </p:txBody>
-      </p:sp>
-      <p:sp>
-        <p:nvSpPr>
-          <p:cNvPr id="15" name="Text 13"/>
-          <p:cNvSpPr txBox="1"/>
-          <p:nvPr/>
-        </p:nvSpPr>
-        <p:spPr>
-          <a:xfrm>
-            <a:off x="4754880" y="1325880"/>
-            <a:ext cx="3931920" cy="201168"/>
-          </a:xfrm>
-          <a:prstGeom prst="rect">
-            <a:avLst/>
-          </a:prstGeom>
-          <a:noFill/>
-          <a:ln/>
-        </p:spPr>
-        <p:txBody>
-          <a:bodyPr wrap="square" lIns="0" tIns="0" rIns="0" bIns="0" rtlCol="0" anchor="t"/>
-          <a:lstStyle/>
-          <a:p>
-            <a:pPr indent="0" marL="0">
-              <a:buNone/>
-            </a:pPr>
-            <a:r>
-              <a:rPr lang="en-US" sz="800" spc="200" kern="0" dirty="0">
-                <a:solidFill>
-                  <a:schemeClr val="tx2"/>
-                </a:solidFill>
-                <a:latin typeface="Courier New" pitchFamily="34" charset="0"/>
-                <a:ea typeface="Courier New" pitchFamily="34" charset="-122"/>
-                <a:cs typeface="Courier New" pitchFamily="34" charset="-120"/>
-              </a:rPr>
               <a:t>WHAT WAS BUILT</a:t>
             </a:r>
             <a:endParaRPr lang="en-US" sz="800" dirty="0"/>
@@ -11672,7 +10928,7 @@
       </p:sp>
       <p:sp>
         <p:nvSpPr>
-          <p:cNvPr id="16" name="Shape 14"/>
+          <p:cNvPr id="9" name="Shape 7"/>
           <p:cNvSpPr/>
           <p:nvPr/>
         </p:nvSpPr>
@@ -11695,7 +10951,7 @@
       </p:sp>
       <p:sp>
         <p:nvSpPr>
-          <p:cNvPr id="17" name="Text 15"/>
+          <p:cNvPr id="10" name="Text 8"/>
           <p:cNvSpPr txBox="1"/>
           <p:nvPr/>
         </p:nvSpPr>
@@ -11734,7 +10990,7 @@
       </p:sp>
       <p:sp>
         <p:nvSpPr>
-          <p:cNvPr id="18" name="Text 16"/>
+          <p:cNvPr id="11" name="Text 9"/>
           <p:cNvSpPr txBox="1"/>
           <p:nvPr/>
         </p:nvSpPr>
@@ -11770,7 +11026,7 @@
       </p:sp>
       <p:sp>
         <p:nvSpPr>
-          <p:cNvPr id="19" name="Shape 17"/>
+          <p:cNvPr id="12" name="Shape 10"/>
           <p:cNvSpPr/>
           <p:nvPr/>
         </p:nvSpPr>
@@ -11793,7 +11049,7 @@
       </p:sp>
       <p:sp>
         <p:nvSpPr>
-          <p:cNvPr id="20" name="Text 18"/>
+          <p:cNvPr id="13" name="Text 11"/>
           <p:cNvSpPr txBox="1"/>
           <p:nvPr/>
         </p:nvSpPr>
@@ -11832,7 +11088,7 @@
       </p:sp>
       <p:sp>
         <p:nvSpPr>
-          <p:cNvPr id="21" name="Text 19"/>
+          <p:cNvPr id="14" name="Text 12"/>
           <p:cNvSpPr txBox="1"/>
           <p:nvPr/>
         </p:nvSpPr>
@@ -11868,7 +11124,7 @@
       </p:sp>
       <p:sp>
         <p:nvSpPr>
-          <p:cNvPr id="22" name="Shape 20"/>
+          <p:cNvPr id="15" name="Shape 13"/>
           <p:cNvSpPr/>
           <p:nvPr/>
         </p:nvSpPr>
@@ -11891,7 +11147,7 @@
       </p:sp>
       <p:sp>
         <p:nvSpPr>
-          <p:cNvPr id="23" name="Text 21"/>
+          <p:cNvPr id="16" name="Text 14"/>
           <p:cNvSpPr txBox="1"/>
           <p:nvPr/>
         </p:nvSpPr>
@@ -11930,7 +11186,7 @@
       </p:sp>
       <p:sp>
         <p:nvSpPr>
-          <p:cNvPr id="24" name="Text 22"/>
+          <p:cNvPr id="17" name="Text 15"/>
           <p:cNvSpPr txBox="1"/>
           <p:nvPr/>
         </p:nvSpPr>
@@ -11966,7 +11222,7 @@
       </p:sp>
       <p:sp>
         <p:nvSpPr>
-          <p:cNvPr id="25" name="Shape 23"/>
+          <p:cNvPr id="18" name="Shape 16"/>
           <p:cNvSpPr/>
           <p:nvPr/>
         </p:nvSpPr>
@@ -11989,7 +11245,7 @@
       </p:sp>
       <p:sp>
         <p:nvSpPr>
-          <p:cNvPr id="26" name="Text 24"/>
+          <p:cNvPr id="19" name="Text 17"/>
           <p:cNvSpPr txBox="1"/>
           <p:nvPr/>
         </p:nvSpPr>
@@ -12028,7 +11284,7 @@
       </p:sp>
       <p:sp>
         <p:nvSpPr>
-          <p:cNvPr id="27" name="Text 25"/>
+          <p:cNvPr id="20" name="Text 18"/>
           <p:cNvSpPr txBox="1"/>
           <p:nvPr/>
         </p:nvSpPr>
@@ -12065,7 +11321,7 @@
       </p:sp>
       <p:sp>
         <p:nvSpPr>
-          <p:cNvPr id="28" name="Text 26"/>
+          <p:cNvPr id="21" name="Text 19"/>
           <p:cNvSpPr txBox="1"/>
           <p:nvPr/>
         </p:nvSpPr>
@@ -12102,7 +11358,7 @@
       </p:sp>
       <p:sp>
         <p:nvSpPr>
-          <p:cNvPr id="29" name="Text 27"/>
+          <p:cNvPr id="22" name="Text 20"/>
           <p:cNvSpPr txBox="1"/>
           <p:nvPr/>
         </p:nvSpPr>
@@ -12439,53 +11695,30 @@
       </p:sp>
       <p:sp>
         <p:nvSpPr>
-          <p:cNvPr id="8" name="Shape 6"/>
-          <p:cNvSpPr/>
-          <p:nvPr/>
-        </p:nvSpPr>
-        <p:spPr>
-          <a:xfrm>
-            <a:off x="457200" y="3931920"/>
-            <a:ext cx="3931920" cy="0"/>
-          </a:xfrm>
-          <a:prstGeom prst="line">
-            <a:avLst/>
-          </a:prstGeom>
-          <a:noFill/>
-          <a:ln w="12700">
-            <a:solidFill>
-              <a:srgbClr val="161616"/>
-            </a:solidFill>
-            <a:prstDash val="solid"/>
-          </a:ln>
-        </p:spPr>
-      </p:sp>
-      <p:sp>
-        <p:nvSpPr>
-          <p:cNvPr id="9" name="Text 7"/>
-          <p:cNvSpPr txBox="1"/>
-          <p:nvPr/>
-        </p:nvSpPr>
-        <p:spPr>
-          <a:xfrm>
-            <a:off x="457200" y="4005072"/>
-            <a:ext cx="1737360" cy="237744"/>
-          </a:xfrm>
-          <a:prstGeom prst="rect">
-            <a:avLst/>
-          </a:prstGeom>
-          <a:noFill/>
-          <a:ln/>
-        </p:spPr>
-        <p:txBody>
-          <a:bodyPr wrap="square" lIns="0" tIns="0" rIns="0" bIns="0" rtlCol="0" anchor="t"/>
-          <a:lstStyle/>
-          <a:p>
-            <a:pPr indent="0" marL="0">
-              <a:buNone/>
-            </a:pPr>
-            <a:r>
-              <a:rPr lang="en-US" sz="700" spc="100" kern="0" dirty="0">
+          <p:cNvPr id="8" name="Text 6"/>
+          <p:cNvSpPr txBox="1"/>
+          <p:nvPr/>
+        </p:nvSpPr>
+        <p:spPr>
+          <a:xfrm>
+            <a:off x="4754880" y="1325880"/>
+            <a:ext cx="3931920" cy="201168"/>
+          </a:xfrm>
+          <a:prstGeom prst="rect">
+            <a:avLst/>
+          </a:prstGeom>
+          <a:noFill/>
+          <a:ln/>
+        </p:spPr>
+        <p:txBody>
+          <a:bodyPr wrap="square" lIns="0" tIns="0" rIns="0" bIns="0" rtlCol="0" anchor="t"/>
+          <a:lstStyle/>
+          <a:p>
+            <a:pPr indent="0" marL="0">
+              <a:buNone/>
+            </a:pPr>
+            <a:r>
+              <a:rPr lang="en-US" sz="800" spc="200" kern="0" dirty="0">
                 <a:solidFill>
                   <a:schemeClr val="tx2"/>
                 </a:solidFill>
@@ -12493,231 +11726,6 @@
                 <a:ea typeface="Courier New" pitchFamily="34" charset="-122"/>
                 <a:cs typeface="Courier New" pitchFamily="34" charset="-120"/>
               </a:rPr>
-              <a:t>SYSTEMS CONTROLLED</a:t>
-            </a:r>
-            <a:endParaRPr lang="en-US" sz="700" dirty="0"/>
-          </a:p>
-        </p:txBody>
-      </p:sp>
-      <p:sp>
-        <p:nvSpPr>
-          <p:cNvPr id="10" name="Text 8"/>
-          <p:cNvSpPr txBox="1"/>
-          <p:nvPr/>
-        </p:nvSpPr>
-        <p:spPr>
-          <a:xfrm>
-            <a:off x="2240280" y="4005072"/>
-            <a:ext cx="2148840" cy="237744"/>
-          </a:xfrm>
-          <a:prstGeom prst="rect">
-            <a:avLst/>
-          </a:prstGeom>
-          <a:noFill/>
-          <a:ln/>
-        </p:spPr>
-        <p:txBody>
-          <a:bodyPr wrap="square" lIns="0" tIns="0" rIns="0" bIns="0" rtlCol="0" anchor="t"/>
-          <a:lstStyle/>
-          <a:p>
-            <a:pPr indent="0" marL="0">
-              <a:buNone/>
-            </a:pPr>
-            <a:r>
-              <a:rPr lang="en-US" sz="1000" b="1" dirty="0">
-                <a:solidFill>
-                  <a:schemeClr val="tx1"/>
-                </a:solidFill>
-              </a:rPr>
-              <a:t>Video, lights, sound</a:t>
-            </a:r>
-            <a:endParaRPr lang="en-US" sz="1000" dirty="0"/>
-          </a:p>
-        </p:txBody>
-      </p:sp>
-      <p:sp>
-        <p:nvSpPr>
-          <p:cNvPr id="11" name="Text 9"/>
-          <p:cNvSpPr txBox="1"/>
-          <p:nvPr/>
-        </p:nvSpPr>
-        <p:spPr>
-          <a:xfrm>
-            <a:off x="457200" y="4279392"/>
-            <a:ext cx="1737360" cy="237744"/>
-          </a:xfrm>
-          <a:prstGeom prst="rect">
-            <a:avLst/>
-          </a:prstGeom>
-          <a:noFill/>
-          <a:ln/>
-        </p:spPr>
-        <p:txBody>
-          <a:bodyPr wrap="square" lIns="0" tIns="0" rIns="0" bIns="0" rtlCol="0" anchor="t"/>
-          <a:lstStyle/>
-          <a:p>
-            <a:pPr indent="0" marL="0">
-              <a:buNone/>
-            </a:pPr>
-            <a:r>
-              <a:rPr lang="en-US" sz="700" spc="100" kern="0" dirty="0">
-                <a:solidFill>
-                  <a:schemeClr val="tx2"/>
-                </a:solidFill>
-                <a:latin typeface="Courier New" pitchFamily="34" charset="0"/>
-                <a:ea typeface="Courier New" pitchFamily="34" charset="-122"/>
-                <a:cs typeface="Courier New" pitchFamily="34" charset="-120"/>
-              </a:rPr>
-              <a:t>DECISION KPI</a:t>
-            </a:r>
-            <a:endParaRPr lang="en-US" sz="700" dirty="0"/>
-          </a:p>
-        </p:txBody>
-      </p:sp>
-      <p:sp>
-        <p:nvSpPr>
-          <p:cNvPr id="12" name="Text 10"/>
-          <p:cNvSpPr txBox="1"/>
-          <p:nvPr/>
-        </p:nvSpPr>
-        <p:spPr>
-          <a:xfrm>
-            <a:off x="2240280" y="4279392"/>
-            <a:ext cx="2148840" cy="237744"/>
-          </a:xfrm>
-          <a:prstGeom prst="rect">
-            <a:avLst/>
-          </a:prstGeom>
-          <a:noFill/>
-          <a:ln/>
-        </p:spPr>
-        <p:txBody>
-          <a:bodyPr wrap="square" lIns="0" tIns="0" rIns="0" bIns="0" rtlCol="0" anchor="t"/>
-          <a:lstStyle/>
-          <a:p>
-            <a:pPr indent="0" marL="0">
-              <a:buNone/>
-            </a:pPr>
-            <a:r>
-              <a:rPr lang="en-US" sz="1000" b="1" dirty="0">
-                <a:solidFill>
-                  <a:schemeClr val="tx1"/>
-                </a:solidFill>
-              </a:rPr>
-              <a:t>Rebooking within 14 days</a:t>
-            </a:r>
-            <a:endParaRPr lang="en-US" sz="1000" dirty="0"/>
-          </a:p>
-        </p:txBody>
-      </p:sp>
-      <p:sp>
-        <p:nvSpPr>
-          <p:cNvPr id="13" name="Text 11"/>
-          <p:cNvSpPr txBox="1"/>
-          <p:nvPr/>
-        </p:nvSpPr>
-        <p:spPr>
-          <a:xfrm>
-            <a:off x="457200" y="4553712"/>
-            <a:ext cx="1737360" cy="237744"/>
-          </a:xfrm>
-          <a:prstGeom prst="rect">
-            <a:avLst/>
-          </a:prstGeom>
-          <a:noFill/>
-          <a:ln/>
-        </p:spPr>
-        <p:txBody>
-          <a:bodyPr wrap="square" lIns="0" tIns="0" rIns="0" bIns="0" rtlCol="0" anchor="t"/>
-          <a:lstStyle/>
-          <a:p>
-            <a:pPr indent="0" marL="0">
-              <a:buNone/>
-            </a:pPr>
-            <a:r>
-              <a:rPr lang="en-US" sz="700" spc="100" kern="0" dirty="0">
-                <a:solidFill>
-                  <a:schemeClr val="tx2"/>
-                </a:solidFill>
-                <a:latin typeface="Courier New" pitchFamily="34" charset="0"/>
-                <a:ea typeface="Courier New" pitchFamily="34" charset="-122"/>
-                <a:cs typeface="Courier New" pitchFamily="34" charset="-120"/>
-              </a:rPr>
-              <a:t>PILOT ROUNDS</a:t>
-            </a:r>
-            <a:endParaRPr lang="en-US" sz="700" dirty="0"/>
-          </a:p>
-        </p:txBody>
-      </p:sp>
-      <p:sp>
-        <p:nvSpPr>
-          <p:cNvPr id="14" name="Text 12"/>
-          <p:cNvSpPr txBox="1"/>
-          <p:nvPr/>
-        </p:nvSpPr>
-        <p:spPr>
-          <a:xfrm>
-            <a:off x="2240280" y="4553712"/>
-            <a:ext cx="2148840" cy="237744"/>
-          </a:xfrm>
-          <a:prstGeom prst="rect">
-            <a:avLst/>
-          </a:prstGeom>
-          <a:noFill/>
-          <a:ln/>
-        </p:spPr>
-        <p:txBody>
-          <a:bodyPr wrap="square" lIns="0" tIns="0" rIns="0" bIns="0" rtlCol="0" anchor="t"/>
-          <a:lstStyle/>
-          <a:p>
-            <a:pPr indent="0" marL="0">
-              <a:buNone/>
-            </a:pPr>
-            <a:r>
-              <a:rPr lang="en-US" sz="1000" b="1" dirty="0">
-                <a:solidFill>
-                  <a:schemeClr val="tx1"/>
-                </a:solidFill>
-              </a:rPr>
-              <a:t>3</a:t>
-            </a:r>
-            <a:endParaRPr lang="en-US" sz="1000" dirty="0"/>
-          </a:p>
-        </p:txBody>
-      </p:sp>
-      <p:sp>
-        <p:nvSpPr>
-          <p:cNvPr id="15" name="Text 13"/>
-          <p:cNvSpPr txBox="1"/>
-          <p:nvPr/>
-        </p:nvSpPr>
-        <p:spPr>
-          <a:xfrm>
-            <a:off x="4754880" y="1325880"/>
-            <a:ext cx="3931920" cy="201168"/>
-          </a:xfrm>
-          <a:prstGeom prst="rect">
-            <a:avLst/>
-          </a:prstGeom>
-          <a:noFill/>
-          <a:ln/>
-        </p:spPr>
-        <p:txBody>
-          <a:bodyPr wrap="square" lIns="0" tIns="0" rIns="0" bIns="0" rtlCol="0" anchor="t"/>
-          <a:lstStyle/>
-          <a:p>
-            <a:pPr indent="0" marL="0">
-              <a:buNone/>
-            </a:pPr>
-            <a:r>
-              <a:rPr lang="en-US" sz="800" spc="200" kern="0" dirty="0">
-                <a:solidFill>
-                  <a:schemeClr val="tx2"/>
-                </a:solidFill>
-                <a:latin typeface="Courier New" pitchFamily="34" charset="0"/>
-                <a:ea typeface="Courier New" pitchFamily="34" charset="-122"/>
-                <a:cs typeface="Courier New" pitchFamily="34" charset="-120"/>
-              </a:rPr>
               <a:t>WHAT WAS BUILT</a:t>
             </a:r>
             <a:endParaRPr lang="en-US" sz="800" dirty="0"/>
@@ -12726,7 +11734,7 @@
       </p:sp>
       <p:sp>
         <p:nvSpPr>
-          <p:cNvPr id="16" name="Shape 14"/>
+          <p:cNvPr id="9" name="Shape 7"/>
           <p:cNvSpPr/>
           <p:nvPr/>
         </p:nvSpPr>
@@ -12749,7 +11757,7 @@
       </p:sp>
       <p:sp>
         <p:nvSpPr>
-          <p:cNvPr id="17" name="Text 15"/>
+          <p:cNvPr id="10" name="Text 8"/>
           <p:cNvSpPr txBox="1"/>
           <p:nvPr/>
         </p:nvSpPr>
@@ -12788,7 +11796,7 @@
       </p:sp>
       <p:sp>
         <p:nvSpPr>
-          <p:cNvPr id="18" name="Text 16"/>
+          <p:cNvPr id="11" name="Text 9"/>
           <p:cNvSpPr txBox="1"/>
           <p:nvPr/>
         </p:nvSpPr>
@@ -12824,7 +11832,7 @@
       </p:sp>
       <p:sp>
         <p:nvSpPr>
-          <p:cNvPr id="19" name="Shape 17"/>
+          <p:cNvPr id="12" name="Shape 10"/>
           <p:cNvSpPr/>
           <p:nvPr/>
         </p:nvSpPr>
@@ -12847,7 +11855,7 @@
       </p:sp>
       <p:sp>
         <p:nvSpPr>
-          <p:cNvPr id="20" name="Text 18"/>
+          <p:cNvPr id="13" name="Text 11"/>
           <p:cNvSpPr txBox="1"/>
           <p:nvPr/>
         </p:nvSpPr>
@@ -12886,7 +11894,7 @@
       </p:sp>
       <p:sp>
         <p:nvSpPr>
-          <p:cNvPr id="21" name="Text 19"/>
+          <p:cNvPr id="14" name="Text 12"/>
           <p:cNvSpPr txBox="1"/>
           <p:nvPr/>
         </p:nvSpPr>
@@ -12922,7 +11930,7 @@
       </p:sp>
       <p:sp>
         <p:nvSpPr>
-          <p:cNvPr id="22" name="Shape 20"/>
+          <p:cNvPr id="15" name="Shape 13"/>
           <p:cNvSpPr/>
           <p:nvPr/>
         </p:nvSpPr>
@@ -12945,7 +11953,7 @@
       </p:sp>
       <p:sp>
         <p:nvSpPr>
-          <p:cNvPr id="23" name="Text 21"/>
+          <p:cNvPr id="16" name="Text 14"/>
           <p:cNvSpPr txBox="1"/>
           <p:nvPr/>
         </p:nvSpPr>
@@ -12984,7 +11992,7 @@
       </p:sp>
       <p:sp>
         <p:nvSpPr>
-          <p:cNvPr id="24" name="Text 22"/>
+          <p:cNvPr id="17" name="Text 15"/>
           <p:cNvSpPr txBox="1"/>
           <p:nvPr/>
         </p:nvSpPr>
@@ -13020,7 +12028,7 @@
       </p:sp>
       <p:sp>
         <p:nvSpPr>
-          <p:cNvPr id="25" name="Shape 23"/>
+          <p:cNvPr id="18" name="Shape 16"/>
           <p:cNvSpPr/>
           <p:nvPr/>
         </p:nvSpPr>
@@ -13043,7 +12051,7 @@
       </p:sp>
       <p:sp>
         <p:nvSpPr>
-          <p:cNvPr id="26" name="Text 24"/>
+          <p:cNvPr id="19" name="Text 17"/>
           <p:cNvSpPr txBox="1"/>
           <p:nvPr/>
         </p:nvSpPr>
@@ -13082,7 +12090,7 @@
       </p:sp>
       <p:sp>
         <p:nvSpPr>
-          <p:cNvPr id="27" name="Text 25"/>
+          <p:cNvPr id="20" name="Text 18"/>
           <p:cNvSpPr txBox="1"/>
           <p:nvPr/>
         </p:nvSpPr>
@@ -13119,7 +12127,7 @@
       </p:sp>
       <p:sp>
         <p:nvSpPr>
-          <p:cNvPr id="28" name="Text 26"/>
+          <p:cNvPr id="21" name="Text 19"/>
           <p:cNvSpPr txBox="1"/>
           <p:nvPr/>
         </p:nvSpPr>
@@ -13156,7 +12164,7 @@
       </p:sp>
       <p:sp>
         <p:nvSpPr>
-          <p:cNvPr id="29" name="Text 27"/>
+          <p:cNvPr id="22" name="Text 20"/>
           <p:cNvSpPr txBox="1"/>
           <p:nvPr/>
         </p:nvSpPr>

</xml_diff>

<commit_message>
feat: three offerings (workshop, intensive, cohort) across site, FAQ, structured data, and PowerPoint
Co-Authored-By: Claude Fable 5.1 <noreply@anthropic.com>
</commit_message>
<xml_diff>
--- a/docs/deck/AI-Training-For-Companies.pptx
+++ b/docs/deck/AI-Training-For-Companies.pptx
@@ -116,52 +116,52 @@
   <p:extLst>
     <p:ext uri="{521415D9-36F7-43E2-AB2F-B90AF26B5E84}">
       <p14:sectionLst xmlns:p14="http://schemas.microsoft.com/office/powerpoint/2010/main">
-        <p14:section name="Open" id="{60b49c94-11be-576a-2b64-b39203df956b}">
+        <p14:section name="Open" id="{e565ed41-5a01-5701-7648-1b2d4db9d1b1}">
           <p14:sldIdLst>
             <p14:sldId id="256"/>
           </p14:sldIdLst>
         </p14:section>
-        <p14:section name="Problem" id="{d2770146-b0b7-0f91-b18e-0540b21ff752}">
+        <p14:section name="Problem" id="{2537da75-1d64-77c8-dd05-6c75af0b008e}">
           <p14:sldIdLst>
             <p14:sldId id="257"/>
           </p14:sldIdLst>
         </p14:section>
-        <p14:section name="Fix" id="{8acb7e49-3c04-de45-0653-060940c4ecba}">
+        <p14:section name="Fix" id="{74c602a3-fd19-0699-3678-702c151de74e}">
           <p14:sldIdLst>
             <p14:sldId id="258"/>
           </p14:sldIdLst>
         </p14:section>
-        <p14:section name="Program" id="{67e2f6ba-df0b-fc3a-f547-b09969fbf2e1}">
+        <p14:section name="Offerings" id="{d2ba94df-912d-2117-8de9-f25210956687}">
           <p14:sldIdLst>
             <p14:sldId id="259"/>
           </p14:sldIdLst>
         </p14:section>
-        <p14:section name="Outcomes" id="{fb07d3f6-2d3c-f098-954c-bed2edcf41f7}">
+        <p14:section name="Outcomes" id="{499913a0-4a2f-f768-3ee0-eea93a2f6a76}">
           <p14:sldIdLst>
             <p14:sldId id="260"/>
           </p14:sldIdLst>
         </p14:section>
-        <p14:section name="Proof" id="{4bf8485d-f2a3-a18a-c515-8564c1bc22eb}">
+        <p14:section name="Proof" id="{acb850b4-6f48-7d31-3dfe-c3896e4775be}">
           <p14:sldIdLst>
             <p14:sldId id="261"/>
           </p14:sldIdLst>
         </p14:section>
-        <p14:section name="Case 1" id="{ed92f946-d52b-a7fe-33c3-b1926f9071f0}">
+        <p14:section name="Case 1" id="{e852a56c-52bf-38a6-1ac7-88dac4090eaa}">
           <p14:sldIdLst>
             <p14:sldId id="262"/>
           </p14:sldIdLst>
         </p14:section>
-        <p14:section name="Case 2" id="{3492a7dd-d718-c3ed-9e2f-8152a9156e5b}">
+        <p14:section name="Case 2" id="{b4c75f12-9829-e5f0-e654-7a79e4ebd2f2}">
           <p14:sldIdLst>
             <p14:sldId id="263"/>
           </p14:sldIdLst>
         </p14:section>
-        <p14:section name="Case 3" id="{65d7ad71-1511-8bee-e2b5-4f348c494a15}">
+        <p14:section name="Case 3" id="{4def157e-1bda-621a-5e66-796aa0167930}">
           <p14:sldIdLst>
             <p14:sldId id="264"/>
           </p14:sldIdLst>
         </p14:section>
-        <p14:section name="Close" id="{e0a8404c-d882-971b-e261-30cf1220429b}">
+        <p14:section name="Close" id="{b10b26ce-d8c9-9c49-52a2-1da06836fc46}">
           <p14:sldIdLst>
             <p14:sldId id="265"/>
           </p14:sldIdLst>
@@ -2042,7 +2042,7 @@
                 <a:ea typeface="Courier New" pitchFamily="34" charset="-122"/>
                 <a:cs typeface="Courier New" pitchFamily="34" charset="-120"/>
               </a:rPr>
-              <a:t>8 weeks. 4 to 8 people. One system in production.</a:t>
+              <a:t>One day at your office. Three days over Zoom. Eight weeks to production.</a:t>
             </a:r>
             <a:endParaRPr lang="en-US" sz="1100" dirty="0"/>
           </a:p>
@@ -2103,7 +2103,7 @@
                   <a:srgbClr val="FFFFFF"/>
                 </a:solidFill>
               </a:rPr>
-              <a:t>One fee. One cohort. One system in production.</a:t>
+              <a:t>Fixed fees. No per-seat charges.</a:t>
             </a:r>
             <a:endParaRPr lang="en-US" sz="2200" dirty="0"/>
           </a:p>
@@ -2118,107 +2118,142 @@
         <p:spPr>
           <a:xfrm>
             <a:off x="548640" y="1280160"/>
-            <a:ext cx="3657600" cy="822960"/>
-          </a:xfrm>
-          <a:prstGeom prst="rect">
-            <a:avLst/>
-          </a:prstGeom>
-          <a:noFill/>
-          <a:ln/>
-        </p:spPr>
-        <p:txBody>
-          <a:bodyPr wrap="square" lIns="0" tIns="0" rIns="0" bIns="0" rtlCol="0" anchor="t"/>
-          <a:lstStyle/>
-          <a:p>
-            <a:pPr indent="0" marL="0">
-              <a:buNone/>
-            </a:pPr>
-            <a:r>
-              <a:rPr lang="en-US" sz="4400" dirty="0">
+            <a:ext cx="2560320" cy="320040"/>
+          </a:xfrm>
+          <a:prstGeom prst="rect">
+            <a:avLst/>
+          </a:prstGeom>
+          <a:noFill/>
+          <a:ln/>
+        </p:spPr>
+        <p:txBody>
+          <a:bodyPr wrap="square" lIns="0" tIns="0" rIns="0" bIns="0" rtlCol="0" anchor="t"/>
+          <a:lstStyle/>
+          <a:p>
+            <a:pPr indent="0" marL="0">
+              <a:buNone/>
+            </a:pPr>
+            <a:r>
+              <a:rPr lang="en-US" sz="1300" b="1" dirty="0">
                 <a:solidFill>
                   <a:srgbClr val="FFFFFF"/>
+                </a:solidFill>
+              </a:rPr>
+              <a:t>One-day workshop</a:t>
+            </a:r>
+            <a:endParaRPr lang="en-US" sz="1300" dirty="0"/>
+          </a:p>
+        </p:txBody>
+      </p:sp>
+      <p:sp>
+        <p:nvSpPr>
+          <p:cNvPr id="4" name="Text 2"/>
+          <p:cNvSpPr txBox="1"/>
+          <p:nvPr/>
+        </p:nvSpPr>
+        <p:spPr>
+          <a:xfrm>
+            <a:off x="548640" y="1600200"/>
+            <a:ext cx="2560320" cy="411480"/>
+          </a:xfrm>
+          <a:prstGeom prst="rect">
+            <a:avLst/>
+          </a:prstGeom>
+          <a:noFill/>
+          <a:ln/>
+        </p:spPr>
+        <p:txBody>
+          <a:bodyPr wrap="square" lIns="0" tIns="0" rIns="0" bIns="0" rtlCol="0" anchor="t"/>
+          <a:lstStyle/>
+          <a:p>
+            <a:pPr indent="0" marL="0">
+              <a:buNone/>
+            </a:pPr>
+            <a:r>
+              <a:rPr lang="en-US" sz="800" dirty="0">
+                <a:solidFill>
+                  <a:srgbClr val="B5B5B5"/>
                 </a:solidFill>
                 <a:latin typeface="Courier New" pitchFamily="34" charset="0"/>
                 <a:ea typeface="Courier New" pitchFamily="34" charset="-122"/>
                 <a:cs typeface="Courier New" pitchFamily="34" charset="-120"/>
               </a:rPr>
-              <a:t>$40,000</a:t>
-            </a:r>
-            <a:endParaRPr lang="en-US" sz="4400" dirty="0"/>
-          </a:p>
-        </p:txBody>
-      </p:sp>
-      <p:sp>
-        <p:nvSpPr>
-          <p:cNvPr id="4" name="Text 2"/>
-          <p:cNvSpPr txBox="1"/>
-          <p:nvPr/>
-        </p:nvSpPr>
-        <p:spPr>
-          <a:xfrm>
-            <a:off x="548640" y="2148840"/>
-            <a:ext cx="3657600" cy="274320"/>
-          </a:xfrm>
-          <a:prstGeom prst="rect">
-            <a:avLst/>
-          </a:prstGeom>
-          <a:noFill/>
-          <a:ln/>
-        </p:spPr>
-        <p:txBody>
-          <a:bodyPr wrap="square" lIns="0" tIns="0" rIns="0" bIns="0" rtlCol="0" anchor="t"/>
-          <a:lstStyle/>
-          <a:p>
-            <a:pPr indent="0" marL="0">
-              <a:buNone/>
-            </a:pPr>
-            <a:r>
-              <a:rPr lang="en-US" sz="1000" dirty="0">
-                <a:solidFill>
-                  <a:srgbClr val="B5B5B5"/>
+              <a:t>1 day · In person, at your office</a:t>
+            </a:r>
+            <a:endParaRPr lang="en-US" sz="800" dirty="0"/>
+          </a:p>
+        </p:txBody>
+      </p:sp>
+      <p:sp>
+        <p:nvSpPr>
+          <p:cNvPr id="5" name="Text 3"/>
+          <p:cNvSpPr txBox="1"/>
+          <p:nvPr/>
+        </p:nvSpPr>
+        <p:spPr>
+          <a:xfrm>
+            <a:off x="548640" y="2103120"/>
+            <a:ext cx="2560320" cy="548640"/>
+          </a:xfrm>
+          <a:prstGeom prst="rect">
+            <a:avLst/>
+          </a:prstGeom>
+          <a:noFill/>
+          <a:ln/>
+        </p:spPr>
+        <p:txBody>
+          <a:bodyPr wrap="square" lIns="0" tIns="0" rIns="0" bIns="0" rtlCol="0" anchor="t"/>
+          <a:lstStyle/>
+          <a:p>
+            <a:pPr indent="0" marL="0">
+              <a:buNone/>
+            </a:pPr>
+            <a:r>
+              <a:rPr lang="en-US" sz="2800" dirty="0">
+                <a:solidFill>
+                  <a:srgbClr val="FFFFFF"/>
                 </a:solidFill>
                 <a:latin typeface="Courier New" pitchFamily="34" charset="0"/>
                 <a:ea typeface="Courier New" pitchFamily="34" charset="-122"/>
                 <a:cs typeface="Courier New" pitchFamily="34" charset="-120"/>
               </a:rPr>
-              <a:t>8 weeks · 4 to 8 people</a:t>
-            </a:r>
-            <a:endParaRPr lang="en-US" sz="1000" dirty="0"/>
-          </a:p>
-        </p:txBody>
-      </p:sp>
-      <p:sp>
-        <p:nvSpPr>
-          <p:cNvPr id="5" name="Text 3"/>
-          <p:cNvSpPr txBox="1"/>
-          <p:nvPr/>
-        </p:nvSpPr>
-        <p:spPr>
-          <a:xfrm>
-            <a:off x="4572000" y="1325880"/>
-            <a:ext cx="4023360" cy="365760"/>
-          </a:xfrm>
-          <a:prstGeom prst="rect">
-            <a:avLst/>
-          </a:prstGeom>
-          <a:noFill/>
-          <a:ln/>
-        </p:spPr>
-        <p:txBody>
-          <a:bodyPr wrap="square" lIns="0" tIns="0" rIns="0" bIns="0" rtlCol="0" anchor="t"/>
-          <a:lstStyle/>
-          <a:p>
-            <a:pPr marL="342900" indent="-342900">
-              <a:buSzPct val="100000"/>
-              <a:buChar char="▪"/>
-            </a:pPr>
-            <a:r>
-              <a:rPr lang="en-US" sz="1300" dirty="0">
+              <a:t>$7,500</a:t>
+            </a:r>
+            <a:endParaRPr lang="en-US" sz="2800" dirty="0"/>
+          </a:p>
+        </p:txBody>
+      </p:sp>
+      <p:sp>
+        <p:nvSpPr>
+          <p:cNvPr id="6" name="Text 4"/>
+          <p:cNvSpPr txBox="1"/>
+          <p:nvPr/>
+        </p:nvSpPr>
+        <p:spPr>
+          <a:xfrm>
+            <a:off x="3291840" y="1280160"/>
+            <a:ext cx="2560320" cy="320040"/>
+          </a:xfrm>
+          <a:prstGeom prst="rect">
+            <a:avLst/>
+          </a:prstGeom>
+          <a:noFill/>
+          <a:ln/>
+        </p:spPr>
+        <p:txBody>
+          <a:bodyPr wrap="square" lIns="0" tIns="0" rIns="0" bIns="0" rtlCol="0" anchor="t"/>
+          <a:lstStyle/>
+          <a:p>
+            <a:pPr indent="0" marL="0">
+              <a:buNone/>
+            </a:pPr>
+            <a:r>
+              <a:rPr lang="en-US" sz="1300" b="1" dirty="0">
                 <a:solidFill>
                   <a:srgbClr val="FFFFFF"/>
                 </a:solidFill>
               </a:rPr>
-              <a:t>Eight weeks of instruction and working sessions</a:t>
+              <a:t>Three-day intensive</a:t>
             </a:r>
             <a:endParaRPr lang="en-US" sz="1300" dirty="0"/>
           </a:p>
@@ -2226,36 +2261,113 @@
       </p:sp>
       <p:sp>
         <p:nvSpPr>
-          <p:cNvPr id="6" name="Text 4"/>
-          <p:cNvSpPr txBox="1"/>
-          <p:nvPr/>
-        </p:nvSpPr>
-        <p:spPr>
-          <a:xfrm>
-            <a:off x="4572000" y="1709928"/>
-            <a:ext cx="4023360" cy="365760"/>
-          </a:xfrm>
-          <a:prstGeom prst="rect">
-            <a:avLst/>
-          </a:prstGeom>
-          <a:noFill/>
-          <a:ln/>
-        </p:spPr>
-        <p:txBody>
-          <a:bodyPr wrap="square" lIns="0" tIns="0" rIns="0" bIns="0" rtlCol="0" anchor="t"/>
-          <a:lstStyle/>
-          <a:p>
-            <a:pPr marL="342900" indent="-342900">
-              <a:buSzPct val="100000"/>
-              <a:buChar char="▪"/>
-            </a:pPr>
-            <a:r>
-              <a:rPr lang="en-US" sz="1300" dirty="0">
+          <p:cNvPr id="7" name="Text 5"/>
+          <p:cNvSpPr txBox="1"/>
+          <p:nvPr/>
+        </p:nvSpPr>
+        <p:spPr>
+          <a:xfrm>
+            <a:off x="3291840" y="1600200"/>
+            <a:ext cx="2560320" cy="411480"/>
+          </a:xfrm>
+          <a:prstGeom prst="rect">
+            <a:avLst/>
+          </a:prstGeom>
+          <a:noFill/>
+          <a:ln/>
+        </p:spPr>
+        <p:txBody>
+          <a:bodyPr wrap="square" lIns="0" tIns="0" rIns="0" bIns="0" rtlCol="0" anchor="t"/>
+          <a:lstStyle/>
+          <a:p>
+            <a:pPr indent="0" marL="0">
+              <a:buNone/>
+            </a:pPr>
+            <a:r>
+              <a:rPr lang="en-US" sz="800" dirty="0">
+                <a:solidFill>
+                  <a:srgbClr val="B5B5B5"/>
+                </a:solidFill>
+                <a:latin typeface="Courier New" pitchFamily="34" charset="0"/>
+                <a:ea typeface="Courier New" pitchFamily="34" charset="-122"/>
+                <a:cs typeface="Courier New" pitchFamily="34" charset="-120"/>
+              </a:rPr>
+              <a:t>3 days, 4 hours per day · Remote, over Zoom</a:t>
+            </a:r>
+            <a:endParaRPr lang="en-US" sz="800" dirty="0"/>
+          </a:p>
+        </p:txBody>
+      </p:sp>
+      <p:sp>
+        <p:nvSpPr>
+          <p:cNvPr id="8" name="Text 6"/>
+          <p:cNvSpPr txBox="1"/>
+          <p:nvPr/>
+        </p:nvSpPr>
+        <p:spPr>
+          <a:xfrm>
+            <a:off x="3291840" y="2103120"/>
+            <a:ext cx="2560320" cy="548640"/>
+          </a:xfrm>
+          <a:prstGeom prst="rect">
+            <a:avLst/>
+          </a:prstGeom>
+          <a:noFill/>
+          <a:ln/>
+        </p:spPr>
+        <p:txBody>
+          <a:bodyPr wrap="square" lIns="0" tIns="0" rIns="0" bIns="0" rtlCol="0" anchor="t"/>
+          <a:lstStyle/>
+          <a:p>
+            <a:pPr indent="0" marL="0">
+              <a:buNone/>
+            </a:pPr>
+            <a:r>
+              <a:rPr lang="en-US" sz="2800" dirty="0">
                 <a:solidFill>
                   <a:srgbClr val="FFFFFF"/>
                 </a:solidFill>
-              </a:rPr>
-              <a:t>Code and architecture review on your real project</a:t>
+                <a:latin typeface="Courier New" pitchFamily="34" charset="0"/>
+                <a:ea typeface="Courier New" pitchFamily="34" charset="-122"/>
+                <a:cs typeface="Courier New" pitchFamily="34" charset="-120"/>
+              </a:rPr>
+              <a:t>$15,000</a:t>
+            </a:r>
+            <a:endParaRPr lang="en-US" sz="2800" dirty="0"/>
+          </a:p>
+        </p:txBody>
+      </p:sp>
+      <p:sp>
+        <p:nvSpPr>
+          <p:cNvPr id="9" name="Text 7"/>
+          <p:cNvSpPr txBox="1"/>
+          <p:nvPr/>
+        </p:nvSpPr>
+        <p:spPr>
+          <a:xfrm>
+            <a:off x="6035040" y="1280160"/>
+            <a:ext cx="2560320" cy="320040"/>
+          </a:xfrm>
+          <a:prstGeom prst="rect">
+            <a:avLst/>
+          </a:prstGeom>
+          <a:noFill/>
+          <a:ln/>
+        </p:spPr>
+        <p:txBody>
+          <a:bodyPr wrap="square" lIns="0" tIns="0" rIns="0" bIns="0" rtlCol="0" anchor="t"/>
+          <a:lstStyle/>
+          <a:p>
+            <a:pPr indent="0" marL="0">
+              <a:buNone/>
+            </a:pPr>
+            <a:r>
+              <a:rPr lang="en-US" sz="1300" b="1" dirty="0">
+                <a:solidFill>
+                  <a:srgbClr val="FFFFFF"/>
+                </a:solidFill>
+              </a:rPr>
+              <a:t>Eight-week cohort</a:t>
             </a:r>
             <a:endParaRPr lang="en-US" sz="1300" dirty="0"/>
           </a:p>
@@ -2263,81 +2375,85 @@
       </p:sp>
       <p:sp>
         <p:nvSpPr>
-          <p:cNvPr id="7" name="Text 5"/>
-          <p:cNvSpPr txBox="1"/>
-          <p:nvPr/>
-        </p:nvSpPr>
-        <p:spPr>
-          <a:xfrm>
-            <a:off x="4572000" y="2093976"/>
-            <a:ext cx="4023360" cy="365760"/>
-          </a:xfrm>
-          <a:prstGeom prst="rect">
-            <a:avLst/>
-          </a:prstGeom>
-          <a:noFill/>
-          <a:ln/>
-        </p:spPr>
-        <p:txBody>
-          <a:bodyPr wrap="square" lIns="0" tIns="0" rIns="0" bIns="0" rtlCol="0" anchor="t"/>
-          <a:lstStyle/>
-          <a:p>
-            <a:pPr marL="342900" indent="-342900">
-              <a:buSzPct val="100000"/>
-              <a:buChar char="▪"/>
-            </a:pPr>
-            <a:r>
-              <a:rPr lang="en-US" sz="1300" dirty="0">
+          <p:cNvPr id="10" name="Text 8"/>
+          <p:cNvSpPr txBox="1"/>
+          <p:nvPr/>
+        </p:nvSpPr>
+        <p:spPr>
+          <a:xfrm>
+            <a:off x="6035040" y="1600200"/>
+            <a:ext cx="2560320" cy="411480"/>
+          </a:xfrm>
+          <a:prstGeom prst="rect">
+            <a:avLst/>
+          </a:prstGeom>
+          <a:noFill/>
+          <a:ln/>
+        </p:spPr>
+        <p:txBody>
+          <a:bodyPr wrap="square" lIns="0" tIns="0" rIns="0" bIns="0" rtlCol="0" anchor="t"/>
+          <a:lstStyle/>
+          <a:p>
+            <a:pPr indent="0" marL="0">
+              <a:buNone/>
+            </a:pPr>
+            <a:r>
+              <a:rPr lang="en-US" sz="800" dirty="0">
+                <a:solidFill>
+                  <a:srgbClr val="B5B5B5"/>
+                </a:solidFill>
+                <a:latin typeface="Courier New" pitchFamily="34" charset="0"/>
+                <a:ea typeface="Courier New" pitchFamily="34" charset="-122"/>
+                <a:cs typeface="Courier New" pitchFamily="34" charset="-120"/>
+              </a:rPr>
+              <a:t>8 weeks · On site or remote</a:t>
+            </a:r>
+            <a:endParaRPr lang="en-US" sz="800" dirty="0"/>
+          </a:p>
+        </p:txBody>
+      </p:sp>
+      <p:sp>
+        <p:nvSpPr>
+          <p:cNvPr id="11" name="Text 9"/>
+          <p:cNvSpPr txBox="1"/>
+          <p:nvPr/>
+        </p:nvSpPr>
+        <p:spPr>
+          <a:xfrm>
+            <a:off x="6035040" y="2103120"/>
+            <a:ext cx="2560320" cy="548640"/>
+          </a:xfrm>
+          <a:prstGeom prst="rect">
+            <a:avLst/>
+          </a:prstGeom>
+          <a:noFill/>
+          <a:ln/>
+        </p:spPr>
+        <p:txBody>
+          <a:bodyPr wrap="square" lIns="0" tIns="0" rIns="0" bIns="0" rtlCol="0" anchor="t"/>
+          <a:lstStyle/>
+          <a:p>
+            <a:pPr indent="0" marL="0">
+              <a:buNone/>
+            </a:pPr>
+            <a:r>
+              <a:rPr lang="en-US" sz="2800" dirty="0">
                 <a:solidFill>
                   <a:srgbClr val="FFFFFF"/>
                 </a:solidFill>
-              </a:rPr>
-              <a:t>Deployment, runbook, and monitoring</a:t>
-            </a:r>
-            <a:endParaRPr lang="en-US" sz="1300" dirty="0"/>
-          </a:p>
-        </p:txBody>
-      </p:sp>
-      <p:sp>
-        <p:nvSpPr>
-          <p:cNvPr id="8" name="Text 6"/>
-          <p:cNvSpPr txBox="1"/>
-          <p:nvPr/>
-        </p:nvSpPr>
-        <p:spPr>
-          <a:xfrm>
-            <a:off x="4572000" y="2478024"/>
-            <a:ext cx="4023360" cy="365760"/>
-          </a:xfrm>
-          <a:prstGeom prst="rect">
-            <a:avLst/>
-          </a:prstGeom>
-          <a:noFill/>
-          <a:ln/>
-        </p:spPr>
-        <p:txBody>
-          <a:bodyPr wrap="square" lIns="0" tIns="0" rIns="0" bIns="0" rtlCol="0" anchor="t"/>
-          <a:lstStyle/>
-          <a:p>
-            <a:pPr marL="342900" indent="-342900">
-              <a:buSzPct val="100000"/>
-              <a:buChar char="▪"/>
-            </a:pPr>
-            <a:r>
-              <a:rPr lang="en-US" sz="1300" dirty="0">
-                <a:solidFill>
-                  <a:srgbClr val="FFFFFF"/>
-                </a:solidFill>
-              </a:rPr>
-              <a:t>Thirty days of support after the cohort</a:t>
-            </a:r>
-            <a:endParaRPr lang="en-US" sz="1300" dirty="0"/>
-          </a:p>
-        </p:txBody>
-      </p:sp>
-      <p:sp>
-        <p:nvSpPr>
-          <p:cNvPr id="9" name="Shape 7"/>
+                <a:latin typeface="Courier New" pitchFamily="34" charset="0"/>
+                <a:ea typeface="Courier New" pitchFamily="34" charset="-122"/>
+                <a:cs typeface="Courier New" pitchFamily="34" charset="-120"/>
+              </a:rPr>
+              <a:t>$40,000</a:t>
+            </a:r>
+            <a:endParaRPr lang="en-US" sz="2800" dirty="0"/>
+          </a:p>
+        </p:txBody>
+      </p:sp>
+      <p:sp>
+        <p:nvSpPr>
+          <p:cNvPr id="12" name="Shape 10"/>
           <p:cNvSpPr/>
           <p:nvPr/>
         </p:nvSpPr>
@@ -2360,7 +2476,7 @@
       </p:sp>
       <p:sp>
         <p:nvSpPr>
-          <p:cNvPr id="10" name="Text 8"/>
+          <p:cNvPr id="13" name="Text 11"/>
           <p:cNvSpPr txBox="1"/>
           <p:nvPr/>
         </p:nvSpPr>
@@ -2396,7 +2512,7 @@
       </p:sp>
       <p:sp>
         <p:nvSpPr>
-          <p:cNvPr id="11" name="Text 9"/>
+          <p:cNvPr id="14" name="Text 12"/>
           <p:cNvSpPr txBox="1"/>
           <p:nvPr/>
         </p:nvSpPr>
@@ -2435,7 +2551,7 @@
       </p:sp>
       <p:sp>
         <p:nvSpPr>
-          <p:cNvPr id="12" name="Text 10"/>
+          <p:cNvPr id="15" name="Text 13"/>
           <p:cNvSpPr txBox="1"/>
           <p:nvPr/>
         </p:nvSpPr>
@@ -3080,7 +3196,7 @@
                   <a:srgbClr val="161616"/>
                 </a:solidFill>
               </a:rPr>
-              <a:t>Eight weeks. One system in production.</a:t>
+              <a:t>Three ways to work with us</a:t>
             </a:r>
             <a:endParaRPr lang="en-US" sz="2800" dirty="0"/>
           </a:p>
@@ -3116,7 +3232,7 @@
                   <a:schemeClr val="tx2"/>
                 </a:solidFill>
               </a:rPr>
-              <a:t>Your team builds it. We teach, review, and support it after.</a:t>
+              <a:t>Your team builds. We teach, review, and support it after.</a:t>
             </a:r>
             <a:endParaRPr lang="en-US" sz="1400" dirty="0"/>
           </a:p>
@@ -3130,8 +3246,8 @@
         </p:nvSpPr>
         <p:spPr>
           <a:xfrm>
-            <a:off x="548640" y="1874520"/>
-            <a:ext cx="1908810" cy="1051560"/>
+            <a:off x="548640" y="1828800"/>
+            <a:ext cx="2560320" cy="2651760"/>
           </a:xfrm>
           <a:prstGeom prst="rect">
             <a:avLst/>
@@ -3155,24 +3271,24 @@
         </p:nvSpPr>
         <p:spPr>
           <a:xfrm>
-            <a:off x="713232" y="2039112"/>
-            <a:ext cx="1579626" cy="201168"/>
-          </a:xfrm>
-          <a:prstGeom prst="rect">
-            <a:avLst/>
-          </a:prstGeom>
-          <a:noFill/>
-          <a:ln/>
-        </p:spPr>
-        <p:txBody>
-          <a:bodyPr wrap="square" lIns="0" tIns="0" rIns="0" bIns="0" rtlCol="0" anchor="t"/>
-          <a:lstStyle/>
-          <a:p>
-            <a:pPr indent="0" marL="0">
-              <a:buNone/>
-            </a:pPr>
-            <a:r>
-              <a:rPr lang="en-US" sz="800" dirty="0">
+            <a:off x="777240" y="2057400"/>
+            <a:ext cx="2103120" cy="201168"/>
+          </a:xfrm>
+          <a:prstGeom prst="rect">
+            <a:avLst/>
+          </a:prstGeom>
+          <a:noFill/>
+          <a:ln/>
+        </p:spPr>
+        <p:txBody>
+          <a:bodyPr wrap="square" lIns="0" tIns="0" rIns="0" bIns="0" rtlCol="0" anchor="t"/>
+          <a:lstStyle/>
+          <a:p>
+            <a:pPr indent="0" marL="0">
+              <a:buNone/>
+            </a:pPr>
+            <a:r>
+              <a:rPr lang="en-US" sz="800" spc="100" kern="0" dirty="0">
                 <a:solidFill>
                   <a:schemeClr val="tx2"/>
                 </a:solidFill>
@@ -3180,7 +3296,7 @@
                 <a:ea typeface="Courier New" pitchFamily="34" charset="-122"/>
                 <a:cs typeface="Courier New" pitchFamily="34" charset="-120"/>
               </a:rPr>
-              <a:t>WEEK 01</a:t>
+              <a:t>1 DAY</a:t>
             </a:r>
             <a:endParaRPr lang="en-US" sz="800" dirty="0"/>
           </a:p>
@@ -3194,44 +3310,158 @@
         </p:nvSpPr>
         <p:spPr>
           <a:xfrm>
-            <a:off x="713232" y="2313432"/>
-            <a:ext cx="1579626" cy="502920"/>
-          </a:xfrm>
-          <a:prstGeom prst="rect">
-            <a:avLst/>
-          </a:prstGeom>
-          <a:noFill/>
-          <a:ln/>
-        </p:spPr>
-        <p:txBody>
-          <a:bodyPr wrap="square" lIns="0" tIns="0" rIns="0" bIns="0" rtlCol="0" anchor="t"/>
-          <a:lstStyle/>
-          <a:p>
-            <a:pPr indent="0" marL="0">
-              <a:buNone/>
-            </a:pPr>
-            <a:r>
-              <a:rPr lang="en-US" sz="1300" b="1" dirty="0">
+            <a:off x="777240" y="2331720"/>
+            <a:ext cx="2103120" cy="365760"/>
+          </a:xfrm>
+          <a:prstGeom prst="rect">
+            <a:avLst/>
+          </a:prstGeom>
+          <a:noFill/>
+          <a:ln/>
+        </p:spPr>
+        <p:txBody>
+          <a:bodyPr wrap="square" lIns="0" tIns="0" rIns="0" bIns="0" rtlCol="0" anchor="t"/>
+          <a:lstStyle/>
+          <a:p>
+            <a:pPr indent="0" marL="0">
+              <a:buNone/>
+            </a:pPr>
+            <a:r>
+              <a:rPr lang="en-US" sz="1600" b="1" dirty="0">
                 <a:solidFill>
                   <a:schemeClr val="tx1"/>
                 </a:solidFill>
               </a:rPr>
-              <a:t>Foundations</a:t>
-            </a:r>
-            <a:endParaRPr lang="en-US" sz="1300" dirty="0"/>
-          </a:p>
-        </p:txBody>
-      </p:sp>
-      <p:sp>
-        <p:nvSpPr>
-          <p:cNvPr id="7" name="Shape 5"/>
+              <a:t>One-day workshop</a:t>
+            </a:r>
+            <a:endParaRPr lang="en-US" sz="1600" dirty="0"/>
+          </a:p>
+        </p:txBody>
+      </p:sp>
+      <p:sp>
+        <p:nvSpPr>
+          <p:cNvPr id="7" name="Text 5"/>
+          <p:cNvSpPr txBox="1"/>
+          <p:nvPr/>
+        </p:nvSpPr>
+        <p:spPr>
+          <a:xfrm>
+            <a:off x="777240" y="2697480"/>
+            <a:ext cx="2103120" cy="274320"/>
+          </a:xfrm>
+          <a:prstGeom prst="rect">
+            <a:avLst/>
+          </a:prstGeom>
+          <a:noFill/>
+          <a:ln/>
+        </p:spPr>
+        <p:txBody>
+          <a:bodyPr wrap="square" lIns="0" tIns="0" rIns="0" bIns="0" rtlCol="0" anchor="t"/>
+          <a:lstStyle/>
+          <a:p>
+            <a:pPr indent="0" marL="0">
+              <a:buNone/>
+            </a:pPr>
+            <a:r>
+              <a:rPr lang="en-US" sz="900" dirty="0">
+                <a:solidFill>
+                  <a:schemeClr val="tx2"/>
+                </a:solidFill>
+                <a:latin typeface="Courier New" pitchFamily="34" charset="0"/>
+                <a:ea typeface="Courier New" pitchFamily="34" charset="-122"/>
+                <a:cs typeface="Courier New" pitchFamily="34" charset="-120"/>
+              </a:rPr>
+              <a:t>In person, at your office</a:t>
+            </a:r>
+            <a:endParaRPr lang="en-US" sz="900" dirty="0"/>
+          </a:p>
+        </p:txBody>
+      </p:sp>
+      <p:sp>
+        <p:nvSpPr>
+          <p:cNvPr id="8" name="Text 6"/>
+          <p:cNvSpPr txBox="1"/>
+          <p:nvPr/>
+        </p:nvSpPr>
+        <p:spPr>
+          <a:xfrm>
+            <a:off x="777240" y="3063240"/>
+            <a:ext cx="2103120" cy="1005840"/>
+          </a:xfrm>
+          <a:prstGeom prst="rect">
+            <a:avLst/>
+          </a:prstGeom>
+          <a:noFill/>
+          <a:ln/>
+        </p:spPr>
+        <p:txBody>
+          <a:bodyPr wrap="square" lIns="0" tIns="0" rIns="0" bIns="0" rtlCol="0" anchor="t"/>
+          <a:lstStyle/>
+          <a:p>
+            <a:pPr indent="0" marL="0">
+              <a:buNone/>
+            </a:pPr>
+            <a:r>
+              <a:rPr lang="en-US" sz="1100" dirty="0">
+                <a:solidFill>
+                  <a:schemeClr val="tx1"/>
+                </a:solidFill>
+              </a:rPr>
+              <a:t>Map your operations, pick the first three systems worth building, and leave with a plan and a working prototype of one.</a:t>
+            </a:r>
+            <a:endParaRPr lang="en-US" sz="1100" dirty="0"/>
+          </a:p>
+        </p:txBody>
+      </p:sp>
+      <p:sp>
+        <p:nvSpPr>
+          <p:cNvPr id="9" name="Text 7"/>
+          <p:cNvSpPr txBox="1"/>
+          <p:nvPr/>
+        </p:nvSpPr>
+        <p:spPr>
+          <a:xfrm>
+            <a:off x="777240" y="3977640"/>
+            <a:ext cx="2103120" cy="365760"/>
+          </a:xfrm>
+          <a:prstGeom prst="rect">
+            <a:avLst/>
+          </a:prstGeom>
+          <a:noFill/>
+          <a:ln/>
+        </p:spPr>
+        <p:txBody>
+          <a:bodyPr wrap="square" lIns="0" tIns="0" rIns="0" bIns="0" rtlCol="0" anchor="t"/>
+          <a:lstStyle/>
+          <a:p>
+            <a:pPr indent="0" marL="0">
+              <a:buNone/>
+            </a:pPr>
+            <a:r>
+              <a:rPr lang="en-US" sz="1800" dirty="0">
+                <a:solidFill>
+                  <a:schemeClr val="tx1"/>
+                </a:solidFill>
+                <a:latin typeface="Courier New" pitchFamily="34" charset="0"/>
+                <a:ea typeface="Courier New" pitchFamily="34" charset="-122"/>
+                <a:cs typeface="Courier New" pitchFamily="34" charset="-120"/>
+              </a:rPr>
+              <a:t>$7,500</a:t>
+            </a:r>
+            <a:endParaRPr lang="en-US" sz="1800" dirty="0"/>
+          </a:p>
+        </p:txBody>
+      </p:sp>
+      <p:sp>
+        <p:nvSpPr>
+          <p:cNvPr id="10" name="Shape 8"/>
           <p:cNvSpPr/>
           <p:nvPr/>
         </p:nvSpPr>
         <p:spPr>
           <a:xfrm>
-            <a:off x="2594610" y="1874520"/>
-            <a:ext cx="1908810" cy="1051560"/>
+            <a:off x="3291840" y="1828800"/>
+            <a:ext cx="2560320" cy="2651760"/>
           </a:xfrm>
           <a:prstGeom prst="rect">
             <a:avLst/>
@@ -3249,30 +3479,30 @@
       </p:sp>
       <p:sp>
         <p:nvSpPr>
-          <p:cNvPr id="8" name="Text 6"/>
-          <p:cNvSpPr txBox="1"/>
-          <p:nvPr/>
-        </p:nvSpPr>
-        <p:spPr>
-          <a:xfrm>
-            <a:off x="2759202" y="2039112"/>
-            <a:ext cx="1579626" cy="201168"/>
-          </a:xfrm>
-          <a:prstGeom prst="rect">
-            <a:avLst/>
-          </a:prstGeom>
-          <a:noFill/>
-          <a:ln/>
-        </p:spPr>
-        <p:txBody>
-          <a:bodyPr wrap="square" lIns="0" tIns="0" rIns="0" bIns="0" rtlCol="0" anchor="t"/>
-          <a:lstStyle/>
-          <a:p>
-            <a:pPr indent="0" marL="0">
-              <a:buNone/>
-            </a:pPr>
-            <a:r>
-              <a:rPr lang="en-US" sz="800" dirty="0">
+          <p:cNvPr id="11" name="Text 9"/>
+          <p:cNvSpPr txBox="1"/>
+          <p:nvPr/>
+        </p:nvSpPr>
+        <p:spPr>
+          <a:xfrm>
+            <a:off x="3520440" y="2057400"/>
+            <a:ext cx="2103120" cy="201168"/>
+          </a:xfrm>
+          <a:prstGeom prst="rect">
+            <a:avLst/>
+          </a:prstGeom>
+          <a:noFill/>
+          <a:ln/>
+        </p:spPr>
+        <p:txBody>
+          <a:bodyPr wrap="square" lIns="0" tIns="0" rIns="0" bIns="0" rtlCol="0" anchor="t"/>
+          <a:lstStyle/>
+          <a:p>
+            <a:pPr indent="0" marL="0">
+              <a:buNone/>
+            </a:pPr>
+            <a:r>
+              <a:rPr lang="en-US" sz="800" spc="100" kern="0" dirty="0">
                 <a:solidFill>
                   <a:schemeClr val="tx2"/>
                 </a:solidFill>
@@ -3280,7 +3510,7 @@
                 <a:ea typeface="Courier New" pitchFamily="34" charset="-122"/>
                 <a:cs typeface="Courier New" pitchFamily="34" charset="-120"/>
               </a:rPr>
-              <a:t>WEEK 02</a:t>
+              <a:t>3 DAYS, 4 HOURS PER DAY</a:t>
             </a:r>
             <a:endParaRPr lang="en-US" sz="800" dirty="0"/>
           </a:p>
@@ -3288,50 +3518,164 @@
       </p:sp>
       <p:sp>
         <p:nvSpPr>
-          <p:cNvPr id="9" name="Text 7"/>
-          <p:cNvSpPr txBox="1"/>
-          <p:nvPr/>
-        </p:nvSpPr>
-        <p:spPr>
-          <a:xfrm>
-            <a:off x="2759202" y="2313432"/>
-            <a:ext cx="1579626" cy="502920"/>
-          </a:xfrm>
-          <a:prstGeom prst="rect">
-            <a:avLst/>
-          </a:prstGeom>
-          <a:noFill/>
-          <a:ln/>
-        </p:spPr>
-        <p:txBody>
-          <a:bodyPr wrap="square" lIns="0" tIns="0" rIns="0" bIns="0" rtlCol="0" anchor="t"/>
-          <a:lstStyle/>
-          <a:p>
-            <a:pPr indent="0" marL="0">
-              <a:buNone/>
-            </a:pPr>
-            <a:r>
-              <a:rPr lang="en-US" sz="1300" b="1" dirty="0">
+          <p:cNvPr id="12" name="Text 10"/>
+          <p:cNvSpPr txBox="1"/>
+          <p:nvPr/>
+        </p:nvSpPr>
+        <p:spPr>
+          <a:xfrm>
+            <a:off x="3520440" y="2331720"/>
+            <a:ext cx="2103120" cy="365760"/>
+          </a:xfrm>
+          <a:prstGeom prst="rect">
+            <a:avLst/>
+          </a:prstGeom>
+          <a:noFill/>
+          <a:ln/>
+        </p:spPr>
+        <p:txBody>
+          <a:bodyPr wrap="square" lIns="0" tIns="0" rIns="0" bIns="0" rtlCol="0" anchor="t"/>
+          <a:lstStyle/>
+          <a:p>
+            <a:pPr indent="0" marL="0">
+              <a:buNone/>
+            </a:pPr>
+            <a:r>
+              <a:rPr lang="en-US" sz="1600" b="1" dirty="0">
                 <a:solidFill>
                   <a:schemeClr val="tx1"/>
                 </a:solidFill>
               </a:rPr>
-              <a:t>Pick the system</a:t>
-            </a:r>
-            <a:endParaRPr lang="en-US" sz="1300" dirty="0"/>
-          </a:p>
-        </p:txBody>
-      </p:sp>
-      <p:sp>
-        <p:nvSpPr>
-          <p:cNvPr id="10" name="Shape 8"/>
+              <a:t>Three-day intensive</a:t>
+            </a:r>
+            <a:endParaRPr lang="en-US" sz="1600" dirty="0"/>
+          </a:p>
+        </p:txBody>
+      </p:sp>
+      <p:sp>
+        <p:nvSpPr>
+          <p:cNvPr id="13" name="Text 11"/>
+          <p:cNvSpPr txBox="1"/>
+          <p:nvPr/>
+        </p:nvSpPr>
+        <p:spPr>
+          <a:xfrm>
+            <a:off x="3520440" y="2697480"/>
+            <a:ext cx="2103120" cy="274320"/>
+          </a:xfrm>
+          <a:prstGeom prst="rect">
+            <a:avLst/>
+          </a:prstGeom>
+          <a:noFill/>
+          <a:ln/>
+        </p:spPr>
+        <p:txBody>
+          <a:bodyPr wrap="square" lIns="0" tIns="0" rIns="0" bIns="0" rtlCol="0" anchor="t"/>
+          <a:lstStyle/>
+          <a:p>
+            <a:pPr indent="0" marL="0">
+              <a:buNone/>
+            </a:pPr>
+            <a:r>
+              <a:rPr lang="en-US" sz="900" dirty="0">
+                <a:solidFill>
+                  <a:schemeClr val="tx2"/>
+                </a:solidFill>
+                <a:latin typeface="Courier New" pitchFamily="34" charset="0"/>
+                <a:ea typeface="Courier New" pitchFamily="34" charset="-122"/>
+                <a:cs typeface="Courier New" pitchFamily="34" charset="-120"/>
+              </a:rPr>
+              <a:t>Remote, over Zoom</a:t>
+            </a:r>
+            <a:endParaRPr lang="en-US" sz="900" dirty="0"/>
+          </a:p>
+        </p:txBody>
+      </p:sp>
+      <p:sp>
+        <p:nvSpPr>
+          <p:cNvPr id="14" name="Text 12"/>
+          <p:cNvSpPr txBox="1"/>
+          <p:nvPr/>
+        </p:nvSpPr>
+        <p:spPr>
+          <a:xfrm>
+            <a:off x="3520440" y="3063240"/>
+            <a:ext cx="2103120" cy="1005840"/>
+          </a:xfrm>
+          <a:prstGeom prst="rect">
+            <a:avLst/>
+          </a:prstGeom>
+          <a:noFill/>
+          <a:ln/>
+        </p:spPr>
+        <p:txBody>
+          <a:bodyPr wrap="square" lIns="0" tIns="0" rIns="0" bIns="0" rtlCol="0" anchor="t"/>
+          <a:lstStyle/>
+          <a:p>
+            <a:pPr indent="0" marL="0">
+              <a:buNone/>
+            </a:pPr>
+            <a:r>
+              <a:rPr lang="en-US" sz="1100" dirty="0">
+                <a:solidFill>
+                  <a:schemeClr val="tx1"/>
+                </a:solidFill>
+              </a:rPr>
+              <a:t>Build a working AI system against your real data: LLM APIs, integrations, human handoff, and deployment.</a:t>
+            </a:r>
+            <a:endParaRPr lang="en-US" sz="1100" dirty="0"/>
+          </a:p>
+        </p:txBody>
+      </p:sp>
+      <p:sp>
+        <p:nvSpPr>
+          <p:cNvPr id="15" name="Text 13"/>
+          <p:cNvSpPr txBox="1"/>
+          <p:nvPr/>
+        </p:nvSpPr>
+        <p:spPr>
+          <a:xfrm>
+            <a:off x="3520440" y="3977640"/>
+            <a:ext cx="2103120" cy="365760"/>
+          </a:xfrm>
+          <a:prstGeom prst="rect">
+            <a:avLst/>
+          </a:prstGeom>
+          <a:noFill/>
+          <a:ln/>
+        </p:spPr>
+        <p:txBody>
+          <a:bodyPr wrap="square" lIns="0" tIns="0" rIns="0" bIns="0" rtlCol="0" anchor="t"/>
+          <a:lstStyle/>
+          <a:p>
+            <a:pPr indent="0" marL="0">
+              <a:buNone/>
+            </a:pPr>
+            <a:r>
+              <a:rPr lang="en-US" sz="1800" dirty="0">
+                <a:solidFill>
+                  <a:schemeClr val="tx1"/>
+                </a:solidFill>
+                <a:latin typeface="Courier New" pitchFamily="34" charset="0"/>
+                <a:ea typeface="Courier New" pitchFamily="34" charset="-122"/>
+                <a:cs typeface="Courier New" pitchFamily="34" charset="-120"/>
+              </a:rPr>
+              <a:t>$15,000</a:t>
+            </a:r>
+            <a:endParaRPr lang="en-US" sz="1800" dirty="0"/>
+          </a:p>
+        </p:txBody>
+      </p:sp>
+      <p:sp>
+        <p:nvSpPr>
+          <p:cNvPr id="16" name="Shape 14"/>
           <p:cNvSpPr/>
           <p:nvPr/>
         </p:nvSpPr>
         <p:spPr>
           <a:xfrm>
-            <a:off x="4640580" y="1874520"/>
-            <a:ext cx="1908810" cy="1051560"/>
+            <a:off x="6035040" y="1828800"/>
+            <a:ext cx="2560320" cy="2651760"/>
           </a:xfrm>
           <a:prstGeom prst="rect">
             <a:avLst/>
@@ -3349,30 +3693,30 @@
       </p:sp>
       <p:sp>
         <p:nvSpPr>
-          <p:cNvPr id="11" name="Text 9"/>
-          <p:cNvSpPr txBox="1"/>
-          <p:nvPr/>
-        </p:nvSpPr>
-        <p:spPr>
-          <a:xfrm>
-            <a:off x="4805172" y="2039112"/>
-            <a:ext cx="1579626" cy="201168"/>
-          </a:xfrm>
-          <a:prstGeom prst="rect">
-            <a:avLst/>
-          </a:prstGeom>
-          <a:noFill/>
-          <a:ln/>
-        </p:spPr>
-        <p:txBody>
-          <a:bodyPr wrap="square" lIns="0" tIns="0" rIns="0" bIns="0" rtlCol="0" anchor="t"/>
-          <a:lstStyle/>
-          <a:p>
-            <a:pPr indent="0" marL="0">
-              <a:buNone/>
-            </a:pPr>
-            <a:r>
-              <a:rPr lang="en-US" sz="800" dirty="0">
+          <p:cNvPr id="17" name="Text 15"/>
+          <p:cNvSpPr txBox="1"/>
+          <p:nvPr/>
+        </p:nvSpPr>
+        <p:spPr>
+          <a:xfrm>
+            <a:off x="6263640" y="2057400"/>
+            <a:ext cx="2103120" cy="201168"/>
+          </a:xfrm>
+          <a:prstGeom prst="rect">
+            <a:avLst/>
+          </a:prstGeom>
+          <a:noFill/>
+          <a:ln/>
+        </p:spPr>
+        <p:txBody>
+          <a:bodyPr wrap="square" lIns="0" tIns="0" rIns="0" bIns="0" rtlCol="0" anchor="t"/>
+          <a:lstStyle/>
+          <a:p>
+            <a:pPr indent="0" marL="0">
+              <a:buNone/>
+            </a:pPr>
+            <a:r>
+              <a:rPr lang="en-US" sz="800" spc="100" kern="0" dirty="0">
                 <a:solidFill>
                   <a:schemeClr val="tx2"/>
                 </a:solidFill>
@@ -3380,7 +3724,7 @@
                 <a:ea typeface="Courier New" pitchFamily="34" charset="-122"/>
                 <a:cs typeface="Courier New" pitchFamily="34" charset="-120"/>
               </a:rPr>
-              <a:t>WEEK 03</a:t>
+              <a:t>8 WEEKS</a:t>
             </a:r>
             <a:endParaRPr lang="en-US" sz="800" dirty="0"/>
           </a:p>
@@ -3388,91 +3732,66 @@
       </p:sp>
       <p:sp>
         <p:nvSpPr>
-          <p:cNvPr id="12" name="Text 10"/>
-          <p:cNvSpPr txBox="1"/>
-          <p:nvPr/>
-        </p:nvSpPr>
-        <p:spPr>
-          <a:xfrm>
-            <a:off x="4805172" y="2313432"/>
-            <a:ext cx="1579626" cy="502920"/>
-          </a:xfrm>
-          <a:prstGeom prst="rect">
-            <a:avLst/>
-          </a:prstGeom>
-          <a:noFill/>
-          <a:ln/>
-        </p:spPr>
-        <p:txBody>
-          <a:bodyPr wrap="square" lIns="0" tIns="0" rIns="0" bIns="0" rtlCol="0" anchor="t"/>
-          <a:lstStyle/>
-          <a:p>
-            <a:pPr indent="0" marL="0">
-              <a:buNone/>
-            </a:pPr>
-            <a:r>
-              <a:rPr lang="en-US" sz="1300" b="1" dirty="0">
+          <p:cNvPr id="18" name="Text 16"/>
+          <p:cNvSpPr txBox="1"/>
+          <p:nvPr/>
+        </p:nvSpPr>
+        <p:spPr>
+          <a:xfrm>
+            <a:off x="6263640" y="2331720"/>
+            <a:ext cx="2103120" cy="365760"/>
+          </a:xfrm>
+          <a:prstGeom prst="rect">
+            <a:avLst/>
+          </a:prstGeom>
+          <a:noFill/>
+          <a:ln/>
+        </p:spPr>
+        <p:txBody>
+          <a:bodyPr wrap="square" lIns="0" tIns="0" rIns="0" bIns="0" rtlCol="0" anchor="t"/>
+          <a:lstStyle/>
+          <a:p>
+            <a:pPr indent="0" marL="0">
+              <a:buNone/>
+            </a:pPr>
+            <a:r>
+              <a:rPr lang="en-US" sz="1600" b="1" dirty="0">
                 <a:solidFill>
                   <a:schemeClr val="tx1"/>
                 </a:solidFill>
               </a:rPr>
-              <a:t>Integrations</a:t>
-            </a:r>
-            <a:endParaRPr lang="en-US" sz="1300" dirty="0"/>
-          </a:p>
-        </p:txBody>
-      </p:sp>
-      <p:sp>
-        <p:nvSpPr>
-          <p:cNvPr id="13" name="Shape 11"/>
-          <p:cNvSpPr/>
-          <p:nvPr/>
-        </p:nvSpPr>
-        <p:spPr>
-          <a:xfrm>
-            <a:off x="6686550" y="1874520"/>
-            <a:ext cx="1908810" cy="1051560"/>
-          </a:xfrm>
-          <a:prstGeom prst="rect">
-            <a:avLst/>
-          </a:prstGeom>
-          <a:solidFill>
-            <a:srgbClr val="F4F4F4"/>
-          </a:solidFill>
-          <a:ln w="12700">
-            <a:solidFill>
-              <a:srgbClr val="F4F4F4"/>
-            </a:solidFill>
-            <a:prstDash val="solid"/>
-          </a:ln>
-        </p:spPr>
-      </p:sp>
-      <p:sp>
-        <p:nvSpPr>
-          <p:cNvPr id="14" name="Text 12"/>
-          <p:cNvSpPr txBox="1"/>
-          <p:nvPr/>
-        </p:nvSpPr>
-        <p:spPr>
-          <a:xfrm>
-            <a:off x="6851142" y="2039112"/>
-            <a:ext cx="1579626" cy="201168"/>
-          </a:xfrm>
-          <a:prstGeom prst="rect">
-            <a:avLst/>
-          </a:prstGeom>
-          <a:noFill/>
-          <a:ln/>
-        </p:spPr>
-        <p:txBody>
-          <a:bodyPr wrap="square" lIns="0" tIns="0" rIns="0" bIns="0" rtlCol="0" anchor="t"/>
-          <a:lstStyle/>
-          <a:p>
-            <a:pPr indent="0" marL="0">
-              <a:buNone/>
-            </a:pPr>
-            <a:r>
-              <a:rPr lang="en-US" sz="800" dirty="0">
+              <a:t>Eight-week cohort</a:t>
+            </a:r>
+            <a:endParaRPr lang="en-US" sz="1600" dirty="0"/>
+          </a:p>
+        </p:txBody>
+      </p:sp>
+      <p:sp>
+        <p:nvSpPr>
+          <p:cNvPr id="19" name="Text 17"/>
+          <p:cNvSpPr txBox="1"/>
+          <p:nvPr/>
+        </p:nvSpPr>
+        <p:spPr>
+          <a:xfrm>
+            <a:off x="6263640" y="2697480"/>
+            <a:ext cx="2103120" cy="274320"/>
+          </a:xfrm>
+          <a:prstGeom prst="rect">
+            <a:avLst/>
+          </a:prstGeom>
+          <a:noFill/>
+          <a:ln/>
+        </p:spPr>
+        <p:txBody>
+          <a:bodyPr wrap="square" lIns="0" tIns="0" rIns="0" bIns="0" rtlCol="0" anchor="t"/>
+          <a:lstStyle/>
+          <a:p>
+            <a:pPr indent="0" marL="0">
+              <a:buNone/>
+            </a:pPr>
+            <a:r>
+              <a:rPr lang="en-US" sz="900" dirty="0">
                 <a:solidFill>
                   <a:schemeClr val="tx2"/>
                 </a:solidFill>
@@ -3480,445 +3799,84 @@
                 <a:ea typeface="Courier New" pitchFamily="34" charset="-122"/>
                 <a:cs typeface="Courier New" pitchFamily="34" charset="-120"/>
               </a:rPr>
-              <a:t>WEEK 04</a:t>
-            </a:r>
-            <a:endParaRPr lang="en-US" sz="800" dirty="0"/>
-          </a:p>
-        </p:txBody>
-      </p:sp>
-      <p:sp>
-        <p:nvSpPr>
-          <p:cNvPr id="15" name="Text 13"/>
-          <p:cNvSpPr txBox="1"/>
-          <p:nvPr/>
-        </p:nvSpPr>
-        <p:spPr>
-          <a:xfrm>
-            <a:off x="6851142" y="2313432"/>
-            <a:ext cx="1579626" cy="502920"/>
-          </a:xfrm>
-          <a:prstGeom prst="rect">
-            <a:avLst/>
-          </a:prstGeom>
-          <a:noFill/>
-          <a:ln/>
-        </p:spPr>
-        <p:txBody>
-          <a:bodyPr wrap="square" lIns="0" tIns="0" rIns="0" bIns="0" rtlCol="0" anchor="t"/>
-          <a:lstStyle/>
-          <a:p>
-            <a:pPr indent="0" marL="0">
-              <a:buNone/>
-            </a:pPr>
-            <a:r>
-              <a:rPr lang="en-US" sz="1300" b="1" dirty="0">
+              <a:t>On site or remote</a:t>
+            </a:r>
+            <a:endParaRPr lang="en-US" sz="900" dirty="0"/>
+          </a:p>
+        </p:txBody>
+      </p:sp>
+      <p:sp>
+        <p:nvSpPr>
+          <p:cNvPr id="20" name="Text 18"/>
+          <p:cNvSpPr txBox="1"/>
+          <p:nvPr/>
+        </p:nvSpPr>
+        <p:spPr>
+          <a:xfrm>
+            <a:off x="6263640" y="3063240"/>
+            <a:ext cx="2103120" cy="1005840"/>
+          </a:xfrm>
+          <a:prstGeom prst="rect">
+            <a:avLst/>
+          </a:prstGeom>
+          <a:noFill/>
+          <a:ln/>
+        </p:spPr>
+        <p:txBody>
+          <a:bodyPr wrap="square" lIns="0" tIns="0" rIns="0" bIns="0" rtlCol="0" anchor="t"/>
+          <a:lstStyle/>
+          <a:p>
+            <a:pPr indent="0" marL="0">
+              <a:buNone/>
+            </a:pPr>
+            <a:r>
+              <a:rPr lang="en-US" sz="1100" dirty="0">
                 <a:solidFill>
                   <a:schemeClr val="tx1"/>
                 </a:solidFill>
               </a:rPr>
-              <a:t>Agents and tools</a:t>
-            </a:r>
-            <a:endParaRPr lang="en-US" sz="1300" dirty="0"/>
-          </a:p>
-        </p:txBody>
-      </p:sp>
-      <p:sp>
-        <p:nvSpPr>
-          <p:cNvPr id="16" name="Shape 14"/>
-          <p:cNvSpPr/>
-          <p:nvPr/>
-        </p:nvSpPr>
-        <p:spPr>
-          <a:xfrm>
-            <a:off x="548640" y="3063240"/>
-            <a:ext cx="1908810" cy="1051560"/>
-          </a:xfrm>
-          <a:prstGeom prst="rect">
-            <a:avLst/>
-          </a:prstGeom>
-          <a:solidFill>
-            <a:srgbClr val="F4F4F4"/>
-          </a:solidFill>
-          <a:ln w="12700">
-            <a:solidFill>
-              <a:srgbClr val="F4F4F4"/>
-            </a:solidFill>
-            <a:prstDash val="solid"/>
-          </a:ln>
-        </p:spPr>
-      </p:sp>
-      <p:sp>
-        <p:nvSpPr>
-          <p:cNvPr id="17" name="Text 15"/>
-          <p:cNvSpPr txBox="1"/>
-          <p:nvPr/>
-        </p:nvSpPr>
-        <p:spPr>
-          <a:xfrm>
-            <a:off x="713232" y="3227832"/>
-            <a:ext cx="1579626" cy="201168"/>
-          </a:xfrm>
-          <a:prstGeom prst="rect">
-            <a:avLst/>
-          </a:prstGeom>
-          <a:noFill/>
-          <a:ln/>
-        </p:spPr>
-        <p:txBody>
-          <a:bodyPr wrap="square" lIns="0" tIns="0" rIns="0" bIns="0" rtlCol="0" anchor="t"/>
-          <a:lstStyle/>
-          <a:p>
-            <a:pPr indent="0" marL="0">
-              <a:buNone/>
-            </a:pPr>
-            <a:r>
-              <a:rPr lang="en-US" sz="800" dirty="0">
-                <a:solidFill>
-                  <a:schemeClr val="tx2"/>
+              <a:t>One system shipped to production inside your company, owned and understood by the people who built it.</a:t>
+            </a:r>
+            <a:endParaRPr lang="en-US" sz="1100" dirty="0"/>
+          </a:p>
+        </p:txBody>
+      </p:sp>
+      <p:sp>
+        <p:nvSpPr>
+          <p:cNvPr id="21" name="Text 19"/>
+          <p:cNvSpPr txBox="1"/>
+          <p:nvPr/>
+        </p:nvSpPr>
+        <p:spPr>
+          <a:xfrm>
+            <a:off x="6263640" y="3977640"/>
+            <a:ext cx="2103120" cy="365760"/>
+          </a:xfrm>
+          <a:prstGeom prst="rect">
+            <a:avLst/>
+          </a:prstGeom>
+          <a:noFill/>
+          <a:ln/>
+        </p:spPr>
+        <p:txBody>
+          <a:bodyPr wrap="square" lIns="0" tIns="0" rIns="0" bIns="0" rtlCol="0" anchor="t"/>
+          <a:lstStyle/>
+          <a:p>
+            <a:pPr indent="0" marL="0">
+              <a:buNone/>
+            </a:pPr>
+            <a:r>
+              <a:rPr lang="en-US" sz="1800" dirty="0">
+                <a:solidFill>
+                  <a:schemeClr val="tx1"/>
                 </a:solidFill>
                 <a:latin typeface="Courier New" pitchFamily="34" charset="0"/>
                 <a:ea typeface="Courier New" pitchFamily="34" charset="-122"/>
                 <a:cs typeface="Courier New" pitchFamily="34" charset="-120"/>
               </a:rPr>
-              <a:t>WEEK 05</a:t>
-            </a:r>
-            <a:endParaRPr lang="en-US" sz="800" dirty="0"/>
-          </a:p>
-        </p:txBody>
-      </p:sp>
-      <p:sp>
-        <p:nvSpPr>
-          <p:cNvPr id="18" name="Text 16"/>
-          <p:cNvSpPr txBox="1"/>
-          <p:nvPr/>
-        </p:nvSpPr>
-        <p:spPr>
-          <a:xfrm>
-            <a:off x="713232" y="3502152"/>
-            <a:ext cx="1579626" cy="502920"/>
-          </a:xfrm>
-          <a:prstGeom prst="rect">
-            <a:avLst/>
-          </a:prstGeom>
-          <a:noFill/>
-          <a:ln/>
-        </p:spPr>
-        <p:txBody>
-          <a:bodyPr wrap="square" lIns="0" tIns="0" rIns="0" bIns="0" rtlCol="0" anchor="t"/>
-          <a:lstStyle/>
-          <a:p>
-            <a:pPr indent="0" marL="0">
-              <a:buNone/>
-            </a:pPr>
-            <a:r>
-              <a:rPr lang="en-US" sz="1300" b="1" dirty="0">
-                <a:solidFill>
-                  <a:schemeClr val="tx1"/>
-                </a:solidFill>
-              </a:rPr>
-              <a:t>Human in the loop</a:t>
-            </a:r>
-            <a:endParaRPr lang="en-US" sz="1300" dirty="0"/>
-          </a:p>
-        </p:txBody>
-      </p:sp>
-      <p:sp>
-        <p:nvSpPr>
-          <p:cNvPr id="19" name="Shape 17"/>
-          <p:cNvSpPr/>
-          <p:nvPr/>
-        </p:nvSpPr>
-        <p:spPr>
-          <a:xfrm>
-            <a:off x="2594610" y="3063240"/>
-            <a:ext cx="1908810" cy="1051560"/>
-          </a:xfrm>
-          <a:prstGeom prst="rect">
-            <a:avLst/>
-          </a:prstGeom>
-          <a:solidFill>
-            <a:srgbClr val="F4F4F4"/>
-          </a:solidFill>
-          <a:ln w="12700">
-            <a:solidFill>
-              <a:srgbClr val="F4F4F4"/>
-            </a:solidFill>
-            <a:prstDash val="solid"/>
-          </a:ln>
-        </p:spPr>
-      </p:sp>
-      <p:sp>
-        <p:nvSpPr>
-          <p:cNvPr id="20" name="Text 18"/>
-          <p:cNvSpPr txBox="1"/>
-          <p:nvPr/>
-        </p:nvSpPr>
-        <p:spPr>
-          <a:xfrm>
-            <a:off x="2759202" y="3227832"/>
-            <a:ext cx="1579626" cy="201168"/>
-          </a:xfrm>
-          <a:prstGeom prst="rect">
-            <a:avLst/>
-          </a:prstGeom>
-          <a:noFill/>
-          <a:ln/>
-        </p:spPr>
-        <p:txBody>
-          <a:bodyPr wrap="square" lIns="0" tIns="0" rIns="0" bIns="0" rtlCol="0" anchor="t"/>
-          <a:lstStyle/>
-          <a:p>
-            <a:pPr indent="0" marL="0">
-              <a:buNone/>
-            </a:pPr>
-            <a:r>
-              <a:rPr lang="en-US" sz="800" dirty="0">
-                <a:solidFill>
-                  <a:schemeClr val="tx2"/>
-                </a:solidFill>
-                <a:latin typeface="Courier New" pitchFamily="34" charset="0"/>
-                <a:ea typeface="Courier New" pitchFamily="34" charset="-122"/>
-                <a:cs typeface="Courier New" pitchFamily="34" charset="-120"/>
-              </a:rPr>
-              <a:t>WEEK 06</a:t>
-            </a:r>
-            <a:endParaRPr lang="en-US" sz="800" dirty="0"/>
-          </a:p>
-        </p:txBody>
-      </p:sp>
-      <p:sp>
-        <p:nvSpPr>
-          <p:cNvPr id="21" name="Text 19"/>
-          <p:cNvSpPr txBox="1"/>
-          <p:nvPr/>
-        </p:nvSpPr>
-        <p:spPr>
-          <a:xfrm>
-            <a:off x="2759202" y="3502152"/>
-            <a:ext cx="1579626" cy="502920"/>
-          </a:xfrm>
-          <a:prstGeom prst="rect">
-            <a:avLst/>
-          </a:prstGeom>
-          <a:noFill/>
-          <a:ln/>
-        </p:spPr>
-        <p:txBody>
-          <a:bodyPr wrap="square" lIns="0" tIns="0" rIns="0" bIns="0" rtlCol="0" anchor="t"/>
-          <a:lstStyle/>
-          <a:p>
-            <a:pPr indent="0" marL="0">
-              <a:buNone/>
-            </a:pPr>
-            <a:r>
-              <a:rPr lang="en-US" sz="1300" b="1" dirty="0">
-                <a:solidFill>
-                  <a:schemeClr val="tx1"/>
-                </a:solidFill>
-              </a:rPr>
-              <a:t>Build week</a:t>
-            </a:r>
-            <a:endParaRPr lang="en-US" sz="1300" dirty="0"/>
-          </a:p>
-        </p:txBody>
-      </p:sp>
-      <p:sp>
-        <p:nvSpPr>
-          <p:cNvPr id="22" name="Shape 20"/>
-          <p:cNvSpPr/>
-          <p:nvPr/>
-        </p:nvSpPr>
-        <p:spPr>
-          <a:xfrm>
-            <a:off x="4640580" y="3063240"/>
-            <a:ext cx="1908810" cy="1051560"/>
-          </a:xfrm>
-          <a:prstGeom prst="rect">
-            <a:avLst/>
-          </a:prstGeom>
-          <a:solidFill>
-            <a:srgbClr val="F4F4F4"/>
-          </a:solidFill>
-          <a:ln w="12700">
-            <a:solidFill>
-              <a:srgbClr val="F4F4F4"/>
-            </a:solidFill>
-            <a:prstDash val="solid"/>
-          </a:ln>
-        </p:spPr>
-      </p:sp>
-      <p:sp>
-        <p:nvSpPr>
-          <p:cNvPr id="23" name="Text 21"/>
-          <p:cNvSpPr txBox="1"/>
-          <p:nvPr/>
-        </p:nvSpPr>
-        <p:spPr>
-          <a:xfrm>
-            <a:off x="4805172" y="3227832"/>
-            <a:ext cx="1579626" cy="201168"/>
-          </a:xfrm>
-          <a:prstGeom prst="rect">
-            <a:avLst/>
-          </a:prstGeom>
-          <a:noFill/>
-          <a:ln/>
-        </p:spPr>
-        <p:txBody>
-          <a:bodyPr wrap="square" lIns="0" tIns="0" rIns="0" bIns="0" rtlCol="0" anchor="t"/>
-          <a:lstStyle/>
-          <a:p>
-            <a:pPr indent="0" marL="0">
-              <a:buNone/>
-            </a:pPr>
-            <a:r>
-              <a:rPr lang="en-US" sz="800" dirty="0">
-                <a:solidFill>
-                  <a:schemeClr val="tx2"/>
-                </a:solidFill>
-                <a:latin typeface="Courier New" pitchFamily="34" charset="0"/>
-                <a:ea typeface="Courier New" pitchFamily="34" charset="-122"/>
-                <a:cs typeface="Courier New" pitchFamily="34" charset="-120"/>
-              </a:rPr>
-              <a:t>WEEK 07</a:t>
-            </a:r>
-            <a:endParaRPr lang="en-US" sz="800" dirty="0"/>
-          </a:p>
-        </p:txBody>
-      </p:sp>
-      <p:sp>
-        <p:nvSpPr>
-          <p:cNvPr id="24" name="Text 22"/>
-          <p:cNvSpPr txBox="1"/>
-          <p:nvPr/>
-        </p:nvSpPr>
-        <p:spPr>
-          <a:xfrm>
-            <a:off x="4805172" y="3502152"/>
-            <a:ext cx="1579626" cy="502920"/>
-          </a:xfrm>
-          <a:prstGeom prst="rect">
-            <a:avLst/>
-          </a:prstGeom>
-          <a:noFill/>
-          <a:ln/>
-        </p:spPr>
-        <p:txBody>
-          <a:bodyPr wrap="square" lIns="0" tIns="0" rIns="0" bIns="0" rtlCol="0" anchor="t"/>
-          <a:lstStyle/>
-          <a:p>
-            <a:pPr indent="0" marL="0">
-              <a:buNone/>
-            </a:pPr>
-            <a:r>
-              <a:rPr lang="en-US" sz="1300" b="1" dirty="0">
-                <a:solidFill>
-                  <a:schemeClr val="tx1"/>
-                </a:solidFill>
-              </a:rPr>
-              <a:t>Evaluate and harden</a:t>
-            </a:r>
-            <a:endParaRPr lang="en-US" sz="1300" dirty="0"/>
-          </a:p>
-        </p:txBody>
-      </p:sp>
-      <p:sp>
-        <p:nvSpPr>
-          <p:cNvPr id="25" name="Shape 23"/>
-          <p:cNvSpPr/>
-          <p:nvPr/>
-        </p:nvSpPr>
-        <p:spPr>
-          <a:xfrm>
-            <a:off x="6686550" y="3063240"/>
-            <a:ext cx="1908810" cy="1051560"/>
-          </a:xfrm>
-          <a:prstGeom prst="rect">
-            <a:avLst/>
-          </a:prstGeom>
-          <a:solidFill>
-            <a:srgbClr val="F4F4F4"/>
-          </a:solidFill>
-          <a:ln w="12700">
-            <a:solidFill>
-              <a:srgbClr val="F4F4F4"/>
-            </a:solidFill>
-            <a:prstDash val="solid"/>
-          </a:ln>
-        </p:spPr>
-      </p:sp>
-      <p:sp>
-        <p:nvSpPr>
-          <p:cNvPr id="26" name="Text 24"/>
-          <p:cNvSpPr txBox="1"/>
-          <p:nvPr/>
-        </p:nvSpPr>
-        <p:spPr>
-          <a:xfrm>
-            <a:off x="6851142" y="3227832"/>
-            <a:ext cx="1579626" cy="201168"/>
-          </a:xfrm>
-          <a:prstGeom prst="rect">
-            <a:avLst/>
-          </a:prstGeom>
-          <a:noFill/>
-          <a:ln/>
-        </p:spPr>
-        <p:txBody>
-          <a:bodyPr wrap="square" lIns="0" tIns="0" rIns="0" bIns="0" rtlCol="0" anchor="t"/>
-          <a:lstStyle/>
-          <a:p>
-            <a:pPr indent="0" marL="0">
-              <a:buNone/>
-            </a:pPr>
-            <a:r>
-              <a:rPr lang="en-US" sz="800" dirty="0">
-                <a:solidFill>
-                  <a:schemeClr val="tx2"/>
-                </a:solidFill>
-                <a:latin typeface="Courier New" pitchFamily="34" charset="0"/>
-                <a:ea typeface="Courier New" pitchFamily="34" charset="-122"/>
-                <a:cs typeface="Courier New" pitchFamily="34" charset="-120"/>
-              </a:rPr>
-              <a:t>WEEK 08</a:t>
-            </a:r>
-            <a:endParaRPr lang="en-US" sz="800" dirty="0"/>
-          </a:p>
-        </p:txBody>
-      </p:sp>
-      <p:sp>
-        <p:nvSpPr>
-          <p:cNvPr id="27" name="Text 25"/>
-          <p:cNvSpPr txBox="1"/>
-          <p:nvPr/>
-        </p:nvSpPr>
-        <p:spPr>
-          <a:xfrm>
-            <a:off x="6851142" y="3502152"/>
-            <a:ext cx="1579626" cy="502920"/>
-          </a:xfrm>
-          <a:prstGeom prst="rect">
-            <a:avLst/>
-          </a:prstGeom>
-          <a:noFill/>
-          <a:ln/>
-        </p:spPr>
-        <p:txBody>
-          <a:bodyPr wrap="square" lIns="0" tIns="0" rIns="0" bIns="0" rtlCol="0" anchor="t"/>
-          <a:lstStyle/>
-          <a:p>
-            <a:pPr indent="0" marL="0">
-              <a:buNone/>
-            </a:pPr>
-            <a:r>
-              <a:rPr lang="en-US" sz="1300" b="1" dirty="0">
-                <a:solidFill>
-                  <a:schemeClr val="tx1"/>
-                </a:solidFill>
-              </a:rPr>
-              <a:t>Deploy and own</a:t>
-            </a:r>
-            <a:endParaRPr lang="en-US" sz="1300" dirty="0"/>
+              <a:t>$40,000</a:t>
+            </a:r>
+            <a:endParaRPr lang="en-US" sz="1800" dirty="0"/>
           </a:p>
         </p:txBody>
       </p:sp>

</xml_diff>

<commit_message>
content: swap workshop and intensive pricing
Co-Authored-By: Claude Fable 5.1 <noreply@anthropic.com>
</commit_message>
<xml_diff>
--- a/docs/deck/AI-Training-For-Companies.pptx
+++ b/docs/deck/AI-Training-For-Companies.pptx
@@ -116,52 +116,52 @@
   <p:extLst>
     <p:ext uri="{521415D9-36F7-43E2-AB2F-B90AF26B5E84}">
       <p14:sectionLst xmlns:p14="http://schemas.microsoft.com/office/powerpoint/2010/main">
-        <p14:section name="Open" id="{e565ed41-5a01-5701-7648-1b2d4db9d1b1}">
+        <p14:section name="Open" id="{e85e272d-62fd-0e88-f1fa-7eab9f13f6f2}">
           <p14:sldIdLst>
             <p14:sldId id="256"/>
           </p14:sldIdLst>
         </p14:section>
-        <p14:section name="Problem" id="{2537da75-1d64-77c8-dd05-6c75af0b008e}">
+        <p14:section name="Problem" id="{7bbd2bc4-09f2-8811-62d1-0550eca42d13}">
           <p14:sldIdLst>
             <p14:sldId id="257"/>
           </p14:sldIdLst>
         </p14:section>
-        <p14:section name="Fix" id="{74c602a3-fd19-0699-3678-702c151de74e}">
+        <p14:section name="Fix" id="{cd462742-0257-67ec-0fc0-4a63c7b922f5}">
           <p14:sldIdLst>
             <p14:sldId id="258"/>
           </p14:sldIdLst>
         </p14:section>
-        <p14:section name="Offerings" id="{d2ba94df-912d-2117-8de9-f25210956687}">
+        <p14:section name="Offerings" id="{393a26a3-9448-a7c8-07b8-80192f2b6e7b}">
           <p14:sldIdLst>
             <p14:sldId id="259"/>
           </p14:sldIdLst>
         </p14:section>
-        <p14:section name="Outcomes" id="{499913a0-4a2f-f768-3ee0-eea93a2f6a76}">
+        <p14:section name="Outcomes" id="{3e3f3070-acbe-7850-a349-79ae62a7fe78}">
           <p14:sldIdLst>
             <p14:sldId id="260"/>
           </p14:sldIdLst>
         </p14:section>
-        <p14:section name="Proof" id="{acb850b4-6f48-7d31-3dfe-c3896e4775be}">
+        <p14:section name="Proof" id="{8a970592-6a3e-3049-9f40-00f809549da7}">
           <p14:sldIdLst>
             <p14:sldId id="261"/>
           </p14:sldIdLst>
         </p14:section>
-        <p14:section name="Case 1" id="{e852a56c-52bf-38a6-1ac7-88dac4090eaa}">
+        <p14:section name="Case 1" id="{466e5e4b-3b8a-a906-dba3-e1537a64003c}">
           <p14:sldIdLst>
             <p14:sldId id="262"/>
           </p14:sldIdLst>
         </p14:section>
-        <p14:section name="Case 2" id="{b4c75f12-9829-e5f0-e654-7a79e4ebd2f2}">
+        <p14:section name="Case 2" id="{bd071580-6e60-9ef9-00fa-9df1e1aa75ff}">
           <p14:sldIdLst>
             <p14:sldId id="263"/>
           </p14:sldIdLst>
         </p14:section>
-        <p14:section name="Case 3" id="{4def157e-1bda-621a-5e66-796aa0167930}">
+        <p14:section name="Case 3" id="{250d3523-a8ae-6608-c25a-74b1f25accfc}">
           <p14:sldIdLst>
             <p14:sldId id="264"/>
           </p14:sldIdLst>
         </p14:section>
-        <p14:section name="Close" id="{b10b26ce-d8c9-9c49-52a2-1da06836fc46}">
+        <p14:section name="Close" id="{a390515c-9a62-ba0c-ae51-2cd5ee4ce990}">
           <p14:sldIdLst>
             <p14:sldId id="265"/>
           </p14:sldIdLst>
@@ -2217,7 +2217,7 @@
                 <a:ea typeface="Courier New" pitchFamily="34" charset="-122"/>
                 <a:cs typeface="Courier New" pitchFamily="34" charset="-120"/>
               </a:rPr>
-              <a:t>$7,500</a:t>
+              <a:t>$15,000</a:t>
             </a:r>
             <a:endParaRPr lang="en-US" sz="2800" dirty="0"/>
           </a:p>
@@ -2331,7 +2331,7 @@
                 <a:ea typeface="Courier New" pitchFamily="34" charset="-122"/>
                 <a:cs typeface="Courier New" pitchFamily="34" charset="-120"/>
               </a:rPr>
-              <a:t>$15,000</a:t>
+              <a:t>$7,500</a:t>
             </a:r>
             <a:endParaRPr lang="en-US" sz="2800" dirty="0"/>
           </a:p>
@@ -3446,7 +3446,7 @@
                 <a:ea typeface="Courier New" pitchFamily="34" charset="-122"/>
                 <a:cs typeface="Courier New" pitchFamily="34" charset="-120"/>
               </a:rPr>
-              <a:t>$7,500</a:t>
+              <a:t>$15,000</a:t>
             </a:r>
             <a:endParaRPr lang="en-US" sz="1800" dirty="0"/>
           </a:p>
@@ -3660,7 +3660,7 @@
                 <a:ea typeface="Courier New" pitchFamily="34" charset="-122"/>
                 <a:cs typeface="Courier New" pitchFamily="34" charset="-120"/>
               </a:rPr>
-              <a:t>$15,000</a:t>
+              <a:t>$7,500</a:t>
             </a:r>
             <a:endParaRPr lang="en-US" sz="1800" dirty="0"/>
           </a:p>

</xml_diff>

<commit_message>
content: cohort price to $50,000
Co-Authored-By: Claude Fable 5.1 <noreply@anthropic.com>
</commit_message>
<xml_diff>
--- a/docs/deck/AI-Training-For-Companies.pptx
+++ b/docs/deck/AI-Training-For-Companies.pptx
@@ -116,52 +116,52 @@
   <p:extLst>
     <p:ext uri="{521415D9-36F7-43E2-AB2F-B90AF26B5E84}">
       <p14:sectionLst xmlns:p14="http://schemas.microsoft.com/office/powerpoint/2010/main">
-        <p14:section name="Open" id="{e85e272d-62fd-0e88-f1fa-7eab9f13f6f2}">
+        <p14:section name="Open" id="{ea687cc0-cac7-585d-7f3b-f019f29135f4}">
           <p14:sldIdLst>
             <p14:sldId id="256"/>
           </p14:sldIdLst>
         </p14:section>
-        <p14:section name="Problem" id="{7bbd2bc4-09f2-8811-62d1-0550eca42d13}">
+        <p14:section name="Problem" id="{b7aeab32-75b0-213f-62f5-d986e67c5db2}">
           <p14:sldIdLst>
             <p14:sldId id="257"/>
           </p14:sldIdLst>
         </p14:section>
-        <p14:section name="Fix" id="{cd462742-0257-67ec-0fc0-4a63c7b922f5}">
+        <p14:section name="Fix" id="{2c6db435-0e70-0d11-2bdd-8a099cac46bf}">
           <p14:sldIdLst>
             <p14:sldId id="258"/>
           </p14:sldIdLst>
         </p14:section>
-        <p14:section name="Offerings" id="{393a26a3-9448-a7c8-07b8-80192f2b6e7b}">
+        <p14:section name="Offerings" id="{f9e952b2-d5a6-c257-855b-af84d3118c54}">
           <p14:sldIdLst>
             <p14:sldId id="259"/>
           </p14:sldIdLst>
         </p14:section>
-        <p14:section name="Outcomes" id="{3e3f3070-acbe-7850-a349-79ae62a7fe78}">
+        <p14:section name="Outcomes" id="{dd997651-f488-70a2-b9ad-83832727c426}">
           <p14:sldIdLst>
             <p14:sldId id="260"/>
           </p14:sldIdLst>
         </p14:section>
-        <p14:section name="Proof" id="{8a970592-6a3e-3049-9f40-00f809549da7}">
+        <p14:section name="Proof" id="{612bd716-47f3-330e-ed36-82cae5ec9a91}">
           <p14:sldIdLst>
             <p14:sldId id="261"/>
           </p14:sldIdLst>
         </p14:section>
-        <p14:section name="Case 1" id="{466e5e4b-3b8a-a906-dba3-e1537a64003c}">
+        <p14:section name="Case 1" id="{039d1dda-bc66-c490-4553-bead5a46f803}">
           <p14:sldIdLst>
             <p14:sldId id="262"/>
           </p14:sldIdLst>
         </p14:section>
-        <p14:section name="Case 2" id="{bd071580-6e60-9ef9-00fa-9df1e1aa75ff}">
+        <p14:section name="Case 2" id="{8bcebf66-b935-afc7-270e-2b5853fee938}">
           <p14:sldIdLst>
             <p14:sldId id="263"/>
           </p14:sldIdLst>
         </p14:section>
-        <p14:section name="Case 3" id="{250d3523-a8ae-6608-c25a-74b1f25accfc}">
+        <p14:section name="Case 3" id="{8c03dd37-5419-beb5-0230-8d765cb0d9f9}">
           <p14:sldIdLst>
             <p14:sldId id="264"/>
           </p14:sldIdLst>
         </p14:section>
-        <p14:section name="Close" id="{a390515c-9a62-ba0c-ae51-2cd5ee4ce990}">
+        <p14:section name="Close" id="{63b2365d-42d7-335a-d148-fd6ab0707b28}">
           <p14:sldIdLst>
             <p14:sldId id="265"/>
           </p14:sldIdLst>
@@ -2445,7 +2445,7 @@
                 <a:ea typeface="Courier New" pitchFamily="34" charset="-122"/>
                 <a:cs typeface="Courier New" pitchFamily="34" charset="-120"/>
               </a:rPr>
-              <a:t>$40,000</a:t>
+              <a:t>$50,000</a:t>
             </a:r>
             <a:endParaRPr lang="en-US" sz="2800" dirty="0"/>
           </a:p>
@@ -3874,7 +3874,7 @@
                 <a:ea typeface="Courier New" pitchFamily="34" charset="-122"/>
                 <a:cs typeface="Courier New" pitchFamily="34" charset="-120"/>
               </a:rPr>
-              <a:t>$40,000</a:t>
+              <a:t>$50,000</a:t>
             </a:r>
             <a:endParaRPr lang="en-US" sz="1800" dirty="0"/>
           </a:p>

</xml_diff>

<commit_message>
content: lead pipeline work attributed to Applegate Ventures; merge with site case study
Co-Authored-By: Claude Fable 5.1 <noreply@anthropic.com>
</commit_message>
<xml_diff>
--- a/docs/deck/AI-Training-For-Companies.pptx
+++ b/docs/deck/AI-Training-For-Companies.pptx
@@ -116,52 +116,52 @@
   <p:extLst>
     <p:ext uri="{521415D9-36F7-43E2-AB2F-B90AF26B5E84}">
       <p14:sectionLst xmlns:p14="http://schemas.microsoft.com/office/powerpoint/2010/main">
-        <p14:section name="Open" id="{ea687cc0-cac7-585d-7f3b-f019f29135f4}">
+        <p14:section name="Open" id="{66c0b010-46a0-2492-90d9-05e81074303d}">
           <p14:sldIdLst>
             <p14:sldId id="256"/>
           </p14:sldIdLst>
         </p14:section>
-        <p14:section name="Problem" id="{b7aeab32-75b0-213f-62f5-d986e67c5db2}">
+        <p14:section name="Problem" id="{cd2a71e4-f0fd-76ba-1c3d-451c17ac1a0c}">
           <p14:sldIdLst>
             <p14:sldId id="257"/>
           </p14:sldIdLst>
         </p14:section>
-        <p14:section name="Fix" id="{2c6db435-0e70-0d11-2bdd-8a099cac46bf}">
+        <p14:section name="Fix" id="{d7d5635f-5b09-877b-6a2e-629861cd590f}">
           <p14:sldIdLst>
             <p14:sldId id="258"/>
           </p14:sldIdLst>
         </p14:section>
-        <p14:section name="Offerings" id="{f9e952b2-d5a6-c257-855b-af84d3118c54}">
+        <p14:section name="Offerings" id="{259130ab-fb2d-8380-08af-8a9960025a9b}">
           <p14:sldIdLst>
             <p14:sldId id="259"/>
           </p14:sldIdLst>
         </p14:section>
-        <p14:section name="Outcomes" id="{dd997651-f488-70a2-b9ad-83832727c426}">
+        <p14:section name="Outcomes" id="{956c0cd1-b321-25b3-ddca-263d2434f978}">
           <p14:sldIdLst>
             <p14:sldId id="260"/>
           </p14:sldIdLst>
         </p14:section>
-        <p14:section name="Proof" id="{612bd716-47f3-330e-ed36-82cae5ec9a91}">
+        <p14:section name="Proof" id="{92d558f5-c16c-ce54-070e-a6a6836574d0}">
           <p14:sldIdLst>
             <p14:sldId id="261"/>
           </p14:sldIdLst>
         </p14:section>
-        <p14:section name="Case 1" id="{039d1dda-bc66-c490-4553-bead5a46f803}">
+        <p14:section name="Case 1" id="{df039b25-5dcf-14f4-4f62-598676023392}">
           <p14:sldIdLst>
             <p14:sldId id="262"/>
           </p14:sldIdLst>
         </p14:section>
-        <p14:section name="Case 2" id="{8bcebf66-b935-afc7-270e-2b5853fee938}">
+        <p14:section name="Case 2" id="{386fa101-2e78-3d3e-92c9-87eda30959af}">
           <p14:sldIdLst>
             <p14:sldId id="263"/>
           </p14:sldIdLst>
         </p14:section>
-        <p14:section name="Case 3" id="{8c03dd37-5419-beb5-0230-8d765cb0d9f9}">
+        <p14:section name="Case 3" id="{62ad6e14-2433-60e0-ca38-75bb21bba149}">
           <p14:sldIdLst>
             <p14:sldId id="264"/>
           </p14:sldIdLst>
         </p14:section>
-        <p14:section name="Close" id="{63b2365d-42d7-335a-d148-fd6ab0707b28}">
+        <p14:section name="Close" id="{225d3a14-a483-7a04-4ca6-7ec72ec20fa4}">
           <p14:sldIdLst>
             <p14:sldId id="265"/>
           </p14:sldIdLst>
@@ -5000,7 +5000,7 @@
                   <a:schemeClr val="tx1"/>
                 </a:solidFill>
               </a:rPr>
-              <a:t>Wonderfly   ·   Windansea Coconuts   ·   WD Capital   ·   Hologram Pilates (Proto)   ·   Applegate Ventures</a:t>
+              <a:t>Wonderfly   ·   Windansea Coconuts   ·   Applegate Ventures   ·   Hologram Pilates (Proto)</a:t>
             </a:r>
             <a:endParaRPr lang="en-US" sz="1400" dirty="0"/>
           </a:p>
@@ -5940,7 +5940,7 @@
                 <a:ea typeface="Courier New" pitchFamily="34" charset="-122"/>
                 <a:cs typeface="Courier New" pitchFamily="34" charset="-120"/>
               </a:rPr>
-              <a:t>WD CAPITAL</a:t>
+              <a:t>APPLEGATE VENTURES</a:t>
             </a:r>
             <a:endParaRPr lang="en-US" sz="800" dirty="0"/>
           </a:p>

</xml_diff>

<commit_message>
feat: Nekter and SnapLogic case studies, demo video hero, simpler approach section, Snowflake labs
Co-Authored-By: Claude Fable 5.1 <noreply@anthropic.com>
</commit_message>
<xml_diff>
--- a/docs/deck/AI-Training-For-Companies.pptx
+++ b/docs/deck/AI-Training-For-Companies.pptx
@@ -15,9 +15,11 @@
     <p:sldId id="263" r:id="rId9"/>
     <p:sldId id="264" r:id="rId10"/>
     <p:sldId id="265" r:id="rId11"/>
+    <p:sldId id="266" r:id="rId12"/>
+    <p:sldId id="267" r:id="rId13"/>
   </p:sldIdLst>
   <p:notesMasterIdLst>
-    <p:notesMasterId r:id="rId12"/>
+    <p:notesMasterId r:id="rId14"/>
   </p:notesMasterIdLst>
   <p:sldSz cx="9144000" cy="5143500"/>
   <p:notesSz cx="5143500" cy="9144000"/>
@@ -116,54 +118,64 @@
   <p:extLst>
     <p:ext uri="{521415D9-36F7-43E2-AB2F-B90AF26B5E84}">
       <p14:sectionLst xmlns:p14="http://schemas.microsoft.com/office/powerpoint/2010/main">
-        <p14:section name="Open" id="{66c0b010-46a0-2492-90d9-05e81074303d}">
+        <p14:section name="Open" id="{64188c3a-9f88-6d9d-b5ea-445464e118d7}">
           <p14:sldIdLst>
             <p14:sldId id="256"/>
           </p14:sldIdLst>
         </p14:section>
-        <p14:section name="Problem" id="{cd2a71e4-f0fd-76ba-1c3d-451c17ac1a0c}">
+        <p14:section name="Problem" id="{5d141fc5-72ce-7317-0f7b-ef52a9737ad2}">
           <p14:sldIdLst>
             <p14:sldId id="257"/>
           </p14:sldIdLst>
         </p14:section>
-        <p14:section name="Fix" id="{d7d5635f-5b09-877b-6a2e-629861cd590f}">
+        <p14:section name="Fix" id="{a222acc7-2df3-4b72-b5ad-6924b71fcbda}">
           <p14:sldIdLst>
             <p14:sldId id="258"/>
           </p14:sldIdLst>
         </p14:section>
-        <p14:section name="Offerings" id="{259130ab-fb2d-8380-08af-8a9960025a9b}">
+        <p14:section name="Offerings" id="{c263d120-a290-36e1-1ddc-14fcf694a09f}">
           <p14:sldIdLst>
             <p14:sldId id="259"/>
           </p14:sldIdLst>
         </p14:section>
-        <p14:section name="Outcomes" id="{956c0cd1-b321-25b3-ddca-263d2434f978}">
+        <p14:section name="Outcomes" id="{a696c511-8976-493f-ff85-6bdcbdc19ea7}">
           <p14:sldIdLst>
             <p14:sldId id="260"/>
           </p14:sldIdLst>
         </p14:section>
-        <p14:section name="Proof" id="{92d558f5-c16c-ce54-070e-a6a6836574d0}">
+        <p14:section name="Proof" id="{b15ec4ec-e8f7-8fe2-8e64-71914b11002c}">
           <p14:sldIdLst>
             <p14:sldId id="261"/>
           </p14:sldIdLst>
         </p14:section>
-        <p14:section name="Case 1" id="{df039b25-5dcf-14f4-4f62-598676023392}">
+        <p14:section name="Case 1" id="{ed5dd9b8-3b0d-b6cf-adcd-f732a4f84094}">
           <p14:sldIdLst>
             <p14:sldId id="262"/>
           </p14:sldIdLst>
         </p14:section>
-        <p14:section name="Case 2" id="{386fa101-2e78-3d3e-92c9-87eda30959af}">
+        <p14:section name="Case 2" id="{00165f22-a8dc-0e81-fb38-c87f4b3bf999}">
           <p14:sldIdLst>
             <p14:sldId id="263"/>
           </p14:sldIdLst>
         </p14:section>
-        <p14:section name="Case 3" id="{62ad6e14-2433-60e0-ca38-75bb21bba149}">
+        <p14:section name="Case 3" id="{94341c54-e2fc-4d88-2fb7-5c6a897b2df5}">
           <p14:sldIdLst>
             <p14:sldId id="264"/>
           </p14:sldIdLst>
         </p14:section>
-        <p14:section name="Close" id="{225d3a14-a483-7a04-4ca6-7ec72ec20fa4}">
+        <p14:section name="Case 4" id="{50cb6a97-cfc6-f279-6538-e754f4e4223f}">
           <p14:sldIdLst>
             <p14:sldId id="265"/>
+          </p14:sldIdLst>
+        </p14:section>
+        <p14:section name="Case 5" id="{70b79541-fb0b-f520-0b17-e1ab5bb6081e}">
+          <p14:sldIdLst>
+            <p14:sldId id="266"/>
+          </p14:sldIdLst>
+        </p14:section>
+        <p14:section name="Close" id="{cf4f6a22-e0b6-53a2-b1d1-9d26f1533f3e}">
+          <p14:sldIdLst>
+            <p14:sldId id="267"/>
           </p14:sldIdLst>
         </p14:section>
       </p14:sectionLst>
@@ -682,6 +694,182 @@
             <a:fld id="{F7021451-1387-4CA6-816F-3879F97B5CBC}" type="slidenum">
               <a:rPr lang="en-US"/>
               <a:t>10</a:t>
+            </a:fld>
+            <a:endParaRPr lang="en-US"/>
+          </a:p>
+        </p:txBody>
+      </p:sp>
+    </p:spTree>
+    <p:extLst>
+      <p:ext uri="{BB962C8B-B14F-4D97-AF65-F5344CB8AC3E}">
+        <p14:creationId xmlns:p14="http://schemas.microsoft.com/office/powerpoint/2010/main" val="1024086991"/>
+      </p:ext>
+    </p:extLst>
+  </p:cSld>
+  <p:clrMapOvr>
+    <a:masterClrMapping/>
+  </p:clrMapOvr>
+</p:notes>
+</file>
+
+<file path=ppt/notesSlides/notesSlide11.xml><?xml version="1.0" encoding="utf-8"?>
+<p:notes xmlns:a="http://schemas.openxmlformats.org/drawingml/2006/main" xmlns:r="http://schemas.openxmlformats.org/officeDocument/2006/relationships" xmlns:p="http://schemas.openxmlformats.org/presentationml/2006/main">
+  <p:cSld>
+    <p:spTree>
+      <p:nvGrpSpPr>
+        <p:cNvPr id="1" name=""/>
+        <p:cNvGrpSpPr/>
+        <p:nvPr/>
+      </p:nvGrpSpPr>
+      <p:grpSpPr>
+        <a:xfrm>
+          <a:off x="0" y="0"/>
+          <a:ext cx="0" cy="0"/>
+          <a:chOff x="0" y="0"/>
+          <a:chExt cx="0" cy="0"/>
+        </a:xfrm>
+      </p:grpSpPr>
+      <p:sp>
+        <p:nvSpPr>
+          <p:cNvPr id="2" name="Slide Image Placeholder 1"/>
+          <p:cNvSpPr>
+            <a:spLocks noGrp="1" noRot="1" noChangeAspect="1"/>
+          </p:cNvSpPr>
+          <p:nvPr>
+            <p:ph type="sldImg"/>
+          </p:nvPr>
+        </p:nvSpPr>
+        <p:spPr/>
+      </p:sp>
+      <p:sp>
+        <p:nvSpPr>
+          <p:cNvPr id="3" name="Notes Placeholder 2"/>
+          <p:cNvSpPr>
+            <a:spLocks noGrp="1"/>
+          </p:cNvSpPr>
+          <p:nvPr>
+            <p:ph type="body" idx="1"/>
+          </p:nvPr>
+        </p:nvSpPr>
+        <p:spPr/>
+        <p:txBody>
+          <a:bodyPr/>
+          <a:lstStyle/>
+          <a:p>
+            <a:r>
+              <a:rPr lang="en-US" dirty="0"/>
+              <a:t/>
+            </a:r>
+            <a:endParaRPr lang="en-US" dirty="0"/>
+          </a:p>
+        </p:txBody>
+      </p:sp>
+      <p:sp>
+        <p:nvSpPr>
+          <p:cNvPr id="4" name="Slide Number Placeholder 3"/>
+          <p:cNvSpPr>
+            <a:spLocks noGrp="1"/>
+          </p:cNvSpPr>
+          <p:nvPr>
+            <p:ph type="sldNum" sz="quarter" idx="10"/>
+          </p:nvPr>
+        </p:nvSpPr>
+        <p:spPr/>
+        <p:txBody>
+          <a:bodyPr/>
+          <a:lstStyle/>
+          <a:p>
+            <a:fld id="{F7021451-1387-4CA6-816F-3879F97B5CBC}" type="slidenum">
+              <a:rPr lang="en-US"/>
+              <a:t>11</a:t>
+            </a:fld>
+            <a:endParaRPr lang="en-US"/>
+          </a:p>
+        </p:txBody>
+      </p:sp>
+    </p:spTree>
+    <p:extLst>
+      <p:ext uri="{BB962C8B-B14F-4D97-AF65-F5344CB8AC3E}">
+        <p14:creationId xmlns:p14="http://schemas.microsoft.com/office/powerpoint/2010/main" val="1024086991"/>
+      </p:ext>
+    </p:extLst>
+  </p:cSld>
+  <p:clrMapOvr>
+    <a:masterClrMapping/>
+  </p:clrMapOvr>
+</p:notes>
+</file>
+
+<file path=ppt/notesSlides/notesSlide12.xml><?xml version="1.0" encoding="utf-8"?>
+<p:notes xmlns:a="http://schemas.openxmlformats.org/drawingml/2006/main" xmlns:r="http://schemas.openxmlformats.org/officeDocument/2006/relationships" xmlns:p="http://schemas.openxmlformats.org/presentationml/2006/main">
+  <p:cSld>
+    <p:spTree>
+      <p:nvGrpSpPr>
+        <p:cNvPr id="1" name=""/>
+        <p:cNvGrpSpPr/>
+        <p:nvPr/>
+      </p:nvGrpSpPr>
+      <p:grpSpPr>
+        <a:xfrm>
+          <a:off x="0" y="0"/>
+          <a:ext cx="0" cy="0"/>
+          <a:chOff x="0" y="0"/>
+          <a:chExt cx="0" cy="0"/>
+        </a:xfrm>
+      </p:grpSpPr>
+      <p:sp>
+        <p:nvSpPr>
+          <p:cNvPr id="2" name="Slide Image Placeholder 1"/>
+          <p:cNvSpPr>
+            <a:spLocks noGrp="1" noRot="1" noChangeAspect="1"/>
+          </p:cNvSpPr>
+          <p:nvPr>
+            <p:ph type="sldImg"/>
+          </p:nvPr>
+        </p:nvSpPr>
+        <p:spPr/>
+      </p:sp>
+      <p:sp>
+        <p:nvSpPr>
+          <p:cNvPr id="3" name="Notes Placeholder 2"/>
+          <p:cNvSpPr>
+            <a:spLocks noGrp="1"/>
+          </p:cNvSpPr>
+          <p:nvPr>
+            <p:ph type="body" idx="1"/>
+          </p:nvPr>
+        </p:nvSpPr>
+        <p:spPr/>
+        <p:txBody>
+          <a:bodyPr/>
+          <a:lstStyle/>
+          <a:p>
+            <a:r>
+              <a:rPr lang="en-US" dirty="0"/>
+              <a:t/>
+            </a:r>
+            <a:endParaRPr lang="en-US" dirty="0"/>
+          </a:p>
+        </p:txBody>
+      </p:sp>
+      <p:sp>
+        <p:nvSpPr>
+          <p:cNvPr id="4" name="Slide Number Placeholder 3"/>
+          <p:cNvSpPr>
+            <a:spLocks noGrp="1"/>
+          </p:cNvSpPr>
+          <p:nvPr>
+            <p:ph type="sldNum" sz="quarter" idx="10"/>
+          </p:nvPr>
+        </p:nvSpPr>
+        <p:spPr/>
+        <p:txBody>
+          <a:bodyPr/>
+          <a:lstStyle/>
+          <a:p>
+            <a:fld id="{F7021451-1387-4CA6-816F-3879F97B5CBC}" type="slidenum">
+              <a:rPr lang="en-US"/>
+              <a:t>12</a:t>
             </a:fld>
             <a:endParaRPr lang="en-US"/>
           </a:p>
@@ -2076,6 +2264,844 @@
       <p:sp>
         <p:nvSpPr>
           <p:cNvPr id="2" name="Text 0"/>
+          <p:cNvSpPr/>
+          <p:nvPr>
+            <p:ph idx="100" type="title" hasCustomPrompt="1"/>
+          </p:nvPr>
+        </p:nvSpPr>
+        <p:spPr>
+          <a:xfrm>
+            <a:off x="548640" y="502920"/>
+            <a:ext cx="8046720" cy="822960"/>
+          </a:xfrm>
+          <a:prstGeom prst="rect">
+            <a:avLst/>
+          </a:prstGeom>
+          <a:noFill/>
+          <a:ln/>
+        </p:spPr>
+        <p:txBody>
+          <a:bodyPr wrap="square" lIns="0" tIns="0" rIns="0" bIns="0" rtlCol="0" anchor="t"/>
+          <a:lstStyle/>
+          <a:p>
+            <a:pPr indent="0" marL="0">
+              <a:buNone/>
+            </a:pPr>
+            <a:r>
+              <a:rPr lang="en-US" sz="2800" b="1" dirty="0">
+                <a:solidFill>
+                  <a:srgbClr val="161616"/>
+                </a:solidFill>
+              </a:rPr>
+              <a:t>Event operations with no retyping</a:t>
+            </a:r>
+            <a:endParaRPr lang="en-US" sz="2800" dirty="0"/>
+          </a:p>
+        </p:txBody>
+      </p:sp>
+      <p:sp>
+        <p:nvSpPr>
+          <p:cNvPr id="3" name="Text 1"/>
+          <p:cNvSpPr txBox="1"/>
+          <p:nvPr/>
+        </p:nvSpPr>
+        <p:spPr>
+          <a:xfrm>
+            <a:off x="548640" y="274320"/>
+            <a:ext cx="8046720" cy="201168"/>
+          </a:xfrm>
+          <a:prstGeom prst="rect">
+            <a:avLst/>
+          </a:prstGeom>
+          <a:noFill/>
+          <a:ln/>
+        </p:spPr>
+        <p:txBody>
+          <a:bodyPr wrap="square" lIns="0" tIns="0" rIns="0" bIns="0" rtlCol="0" anchor="t"/>
+          <a:lstStyle/>
+          <a:p>
+            <a:pPr indent="0" marL="0">
+              <a:buNone/>
+            </a:pPr>
+            <a:r>
+              <a:rPr lang="en-US" sz="800" spc="200" kern="0" dirty="0">
+                <a:solidFill>
+                  <a:schemeClr val="tx2"/>
+                </a:solidFill>
+                <a:latin typeface="Courier New" pitchFamily="34" charset="0"/>
+                <a:ea typeface="Courier New" pitchFamily="34" charset="-122"/>
+                <a:cs typeface="Courier New" pitchFamily="34" charset="-120"/>
+              </a:rPr>
+              <a:t>WINDANSEA COCONUTS</a:t>
+            </a:r>
+            <a:endParaRPr lang="en-US" sz="800" dirty="0"/>
+          </a:p>
+        </p:txBody>
+      </p:sp>
+      <p:sp>
+        <p:nvSpPr>
+          <p:cNvPr id="4" name="Shape 2"/>
+          <p:cNvSpPr/>
+          <p:nvPr/>
+        </p:nvSpPr>
+        <p:spPr>
+          <a:xfrm>
+            <a:off x="548640" y="1600200"/>
+            <a:ext cx="8046720" cy="0"/>
+          </a:xfrm>
+          <a:prstGeom prst="line">
+            <a:avLst/>
+          </a:prstGeom>
+          <a:noFill/>
+          <a:ln w="12700">
+            <a:solidFill>
+              <a:srgbClr val="161616"/>
+            </a:solidFill>
+            <a:prstDash val="solid"/>
+          </a:ln>
+        </p:spPr>
+      </p:sp>
+      <p:sp>
+        <p:nvSpPr>
+          <p:cNvPr id="5" name="Text 3"/>
+          <p:cNvSpPr txBox="1"/>
+          <p:nvPr/>
+        </p:nvSpPr>
+        <p:spPr>
+          <a:xfrm>
+            <a:off x="548640" y="1737360"/>
+            <a:ext cx="1828800" cy="201168"/>
+          </a:xfrm>
+          <a:prstGeom prst="rect">
+            <a:avLst/>
+          </a:prstGeom>
+          <a:noFill/>
+          <a:ln/>
+        </p:spPr>
+        <p:txBody>
+          <a:bodyPr wrap="square" lIns="0" tIns="0" rIns="0" bIns="0" rtlCol="0" anchor="t"/>
+          <a:lstStyle/>
+          <a:p>
+            <a:pPr indent="0" marL="0">
+              <a:buNone/>
+            </a:pPr>
+            <a:r>
+              <a:rPr lang="en-US" sz="800" spc="200" kern="0" dirty="0">
+                <a:solidFill>
+                  <a:schemeClr val="tx2"/>
+                </a:solidFill>
+                <a:latin typeface="Courier New" pitchFamily="34" charset="0"/>
+                <a:ea typeface="Courier New" pitchFamily="34" charset="-122"/>
+                <a:cs typeface="Courier New" pitchFamily="34" charset="-120"/>
+              </a:rPr>
+              <a:t>PROBLEM</a:t>
+            </a:r>
+            <a:endParaRPr lang="en-US" sz="800" dirty="0"/>
+          </a:p>
+        </p:txBody>
+      </p:sp>
+      <p:sp>
+        <p:nvSpPr>
+          <p:cNvPr id="6" name="Text 4"/>
+          <p:cNvSpPr txBox="1"/>
+          <p:nvPr/>
+        </p:nvSpPr>
+        <p:spPr>
+          <a:xfrm>
+            <a:off x="2560320" y="1709928"/>
+            <a:ext cx="6035040" cy="731520"/>
+          </a:xfrm>
+          <a:prstGeom prst="rect">
+            <a:avLst/>
+          </a:prstGeom>
+          <a:noFill/>
+          <a:ln/>
+        </p:spPr>
+        <p:txBody>
+          <a:bodyPr wrap="square" lIns="0" tIns="0" rIns="0" bIns="0" rtlCol="0" anchor="t"/>
+          <a:lstStyle/>
+          <a:p>
+            <a:pPr indent="0" marL="0">
+              <a:buNone/>
+            </a:pPr>
+            <a:r>
+              <a:rPr lang="en-US" sz="1500" dirty="0">
+                <a:solidFill>
+                  <a:schemeClr val="tx1"/>
+                </a:solidFill>
+              </a:rPr>
+              <a:t>Every closed deal was copied by hand into tasks, intake forms, and crew run sheets.</a:t>
+            </a:r>
+            <a:endParaRPr lang="en-US" sz="1500" dirty="0"/>
+          </a:p>
+        </p:txBody>
+      </p:sp>
+      <p:sp>
+        <p:nvSpPr>
+          <p:cNvPr id="7" name="Shape 5"/>
+          <p:cNvSpPr/>
+          <p:nvPr/>
+        </p:nvSpPr>
+        <p:spPr>
+          <a:xfrm>
+            <a:off x="548640" y="2514600"/>
+            <a:ext cx="8046720" cy="0"/>
+          </a:xfrm>
+          <a:prstGeom prst="line">
+            <a:avLst/>
+          </a:prstGeom>
+          <a:noFill/>
+          <a:ln w="9525">
+            <a:solidFill>
+              <a:srgbClr val="E2E2E2"/>
+            </a:solidFill>
+            <a:prstDash val="solid"/>
+          </a:ln>
+        </p:spPr>
+      </p:sp>
+      <p:sp>
+        <p:nvSpPr>
+          <p:cNvPr id="8" name="Text 6"/>
+          <p:cNvSpPr txBox="1"/>
+          <p:nvPr/>
+        </p:nvSpPr>
+        <p:spPr>
+          <a:xfrm>
+            <a:off x="548640" y="2651760"/>
+            <a:ext cx="1828800" cy="201168"/>
+          </a:xfrm>
+          <a:prstGeom prst="rect">
+            <a:avLst/>
+          </a:prstGeom>
+          <a:noFill/>
+          <a:ln/>
+        </p:spPr>
+        <p:txBody>
+          <a:bodyPr wrap="square" lIns="0" tIns="0" rIns="0" bIns="0" rtlCol="0" anchor="t"/>
+          <a:lstStyle/>
+          <a:p>
+            <a:pPr indent="0" marL="0">
+              <a:buNone/>
+            </a:pPr>
+            <a:r>
+              <a:rPr lang="en-US" sz="800" spc="200" kern="0" dirty="0">
+                <a:solidFill>
+                  <a:schemeClr val="tx2"/>
+                </a:solidFill>
+                <a:latin typeface="Courier New" pitchFamily="34" charset="0"/>
+                <a:ea typeface="Courier New" pitchFamily="34" charset="-122"/>
+                <a:cs typeface="Courier New" pitchFamily="34" charset="-120"/>
+              </a:rPr>
+              <a:t>WHAT WE BUILT</a:t>
+            </a:r>
+            <a:endParaRPr lang="en-US" sz="800" dirty="0"/>
+          </a:p>
+        </p:txBody>
+      </p:sp>
+      <p:sp>
+        <p:nvSpPr>
+          <p:cNvPr id="9" name="Text 7"/>
+          <p:cNvSpPr txBox="1"/>
+          <p:nvPr/>
+        </p:nvSpPr>
+        <p:spPr>
+          <a:xfrm>
+            <a:off x="2560320" y="2624328"/>
+            <a:ext cx="6035040" cy="731520"/>
+          </a:xfrm>
+          <a:prstGeom prst="rect">
+            <a:avLst/>
+          </a:prstGeom>
+          <a:noFill/>
+          <a:ln/>
+        </p:spPr>
+        <p:txBody>
+          <a:bodyPr wrap="square" lIns="0" tIns="0" rIns="0" bIns="0" rtlCol="0" anchor="t"/>
+          <a:lstStyle/>
+          <a:p>
+            <a:pPr indent="0" marL="0">
+              <a:buNone/>
+            </a:pPr>
+            <a:r>
+              <a:rPr lang="en-US" sz="1500" dirty="0">
+                <a:solidFill>
+                  <a:schemeClr val="tx1"/>
+                </a:solidFill>
+              </a:rPr>
+              <a:t>Webhooks from the CRM create the event, send the intake, and write a daily Run of Show with Claude.</a:t>
+            </a:r>
+            <a:endParaRPr lang="en-US" sz="1500" dirty="0"/>
+          </a:p>
+        </p:txBody>
+      </p:sp>
+      <p:sp>
+        <p:nvSpPr>
+          <p:cNvPr id="10" name="Shape 8"/>
+          <p:cNvSpPr/>
+          <p:nvPr/>
+        </p:nvSpPr>
+        <p:spPr>
+          <a:xfrm>
+            <a:off x="548640" y="3429000"/>
+            <a:ext cx="8046720" cy="0"/>
+          </a:xfrm>
+          <a:prstGeom prst="line">
+            <a:avLst/>
+          </a:prstGeom>
+          <a:noFill/>
+          <a:ln w="9525">
+            <a:solidFill>
+              <a:srgbClr val="E2E2E2"/>
+            </a:solidFill>
+            <a:prstDash val="solid"/>
+          </a:ln>
+        </p:spPr>
+      </p:sp>
+      <p:sp>
+        <p:nvSpPr>
+          <p:cNvPr id="11" name="Text 9"/>
+          <p:cNvSpPr txBox="1"/>
+          <p:nvPr/>
+        </p:nvSpPr>
+        <p:spPr>
+          <a:xfrm>
+            <a:off x="548640" y="3566160"/>
+            <a:ext cx="1828800" cy="201168"/>
+          </a:xfrm>
+          <a:prstGeom prst="rect">
+            <a:avLst/>
+          </a:prstGeom>
+          <a:noFill/>
+          <a:ln/>
+        </p:spPr>
+        <p:txBody>
+          <a:bodyPr wrap="square" lIns="0" tIns="0" rIns="0" bIns="0" rtlCol="0" anchor="t"/>
+          <a:lstStyle/>
+          <a:p>
+            <a:pPr indent="0" marL="0">
+              <a:buNone/>
+            </a:pPr>
+            <a:r>
+              <a:rPr lang="en-US" sz="800" spc="200" kern="0" dirty="0">
+                <a:solidFill>
+                  <a:schemeClr val="tx2"/>
+                </a:solidFill>
+                <a:latin typeface="Courier New" pitchFamily="34" charset="0"/>
+                <a:ea typeface="Courier New" pitchFamily="34" charset="-122"/>
+                <a:cs typeface="Courier New" pitchFamily="34" charset="-120"/>
+              </a:rPr>
+              <a:t>RESULT</a:t>
+            </a:r>
+            <a:endParaRPr lang="en-US" sz="800" dirty="0"/>
+          </a:p>
+        </p:txBody>
+      </p:sp>
+      <p:sp>
+        <p:nvSpPr>
+          <p:cNvPr id="12" name="Text 10"/>
+          <p:cNvSpPr txBox="1"/>
+          <p:nvPr/>
+        </p:nvSpPr>
+        <p:spPr>
+          <a:xfrm>
+            <a:off x="2560320" y="3538728"/>
+            <a:ext cx="6035040" cy="731520"/>
+          </a:xfrm>
+          <a:prstGeom prst="rect">
+            <a:avLst/>
+          </a:prstGeom>
+          <a:noFill/>
+          <a:ln/>
+        </p:spPr>
+        <p:txBody>
+          <a:bodyPr wrap="square" lIns="0" tIns="0" rIns="0" bIns="0" rtlCol="0" anchor="t"/>
+          <a:lstStyle/>
+          <a:p>
+            <a:pPr indent="0" marL="0">
+              <a:buNone/>
+            </a:pPr>
+            <a:r>
+              <a:rPr lang="en-US" sz="1500" dirty="0">
+                <a:solidFill>
+                  <a:schemeClr val="tx1"/>
+                </a:solidFill>
+              </a:rPr>
+              <a:t>A closed deal becomes a staffed event with a current run sheet, with nobody retyping it.</a:t>
+            </a:r>
+            <a:endParaRPr lang="en-US" sz="1500" dirty="0"/>
+          </a:p>
+        </p:txBody>
+      </p:sp>
+      <p:sp>
+        <p:nvSpPr>
+          <p:cNvPr id="13" name="Shape 11"/>
+          <p:cNvSpPr/>
+          <p:nvPr/>
+        </p:nvSpPr>
+        <p:spPr>
+          <a:xfrm>
+            <a:off x="548640" y="4343400"/>
+            <a:ext cx="8046720" cy="0"/>
+          </a:xfrm>
+          <a:prstGeom prst="line">
+            <a:avLst/>
+          </a:prstGeom>
+          <a:noFill/>
+          <a:ln w="9525">
+            <a:solidFill>
+              <a:srgbClr val="E2E2E2"/>
+            </a:solidFill>
+            <a:prstDash val="solid"/>
+          </a:ln>
+        </p:spPr>
+      </p:sp>
+    </p:spTree>
+  </p:cSld>
+  <p:clrMapOvr>
+    <a:masterClrMapping/>
+  </p:clrMapOvr>
+</p:sld>
+</file>
+
+<file path=ppt/slides/slide11.xml><?xml version="1.0" encoding="utf-8"?>
+<p:sld xmlns:a="http://schemas.openxmlformats.org/drawingml/2006/main" xmlns:r="http://schemas.openxmlformats.org/officeDocument/2006/relationships" xmlns:p="http://schemas.openxmlformats.org/presentationml/2006/main">
+  <p:cSld name="Slide 11">
+    <p:spTree>
+      <p:nvGrpSpPr>
+        <p:cNvPr id="1" name=""/>
+        <p:cNvGrpSpPr/>
+        <p:nvPr/>
+      </p:nvGrpSpPr>
+      <p:grpSpPr>
+        <a:xfrm>
+          <a:off x="0" y="0"/>
+          <a:ext cx="0" cy="0"/>
+          <a:chOff x="0" y="0"/>
+          <a:chExt cx="0" cy="0"/>
+        </a:xfrm>
+      </p:grpSpPr>
+      <p:sp>
+        <p:nvSpPr>
+          <p:cNvPr id="2" name="Text 0"/>
+          <p:cNvSpPr/>
+          <p:nvPr>
+            <p:ph idx="100" type="title" hasCustomPrompt="1"/>
+          </p:nvPr>
+        </p:nvSpPr>
+        <p:spPr>
+          <a:xfrm>
+            <a:off x="548640" y="502920"/>
+            <a:ext cx="8046720" cy="822960"/>
+          </a:xfrm>
+          <a:prstGeom prst="rect">
+            <a:avLst/>
+          </a:prstGeom>
+          <a:noFill/>
+          <a:ln/>
+        </p:spPr>
+        <p:txBody>
+          <a:bodyPr wrap="square" lIns="0" tIns="0" rIns="0" bIns="0" rtlCol="0" anchor="t"/>
+          <a:lstStyle/>
+          <a:p>
+            <a:pPr indent="0" marL="0">
+              <a:buNone/>
+            </a:pPr>
+            <a:r>
+              <a:rPr lang="en-US" sz="2800" b="1" dirty="0">
+                <a:solidFill>
+                  <a:srgbClr val="161616"/>
+                </a:solidFill>
+              </a:rPr>
+              <a:t>A lead pipeline that replaced Zapier</a:t>
+            </a:r>
+            <a:endParaRPr lang="en-US" sz="2800" dirty="0"/>
+          </a:p>
+        </p:txBody>
+      </p:sp>
+      <p:sp>
+        <p:nvSpPr>
+          <p:cNvPr id="3" name="Text 1"/>
+          <p:cNvSpPr txBox="1"/>
+          <p:nvPr/>
+        </p:nvSpPr>
+        <p:spPr>
+          <a:xfrm>
+            <a:off x="548640" y="274320"/>
+            <a:ext cx="8046720" cy="201168"/>
+          </a:xfrm>
+          <a:prstGeom prst="rect">
+            <a:avLst/>
+          </a:prstGeom>
+          <a:noFill/>
+          <a:ln/>
+        </p:spPr>
+        <p:txBody>
+          <a:bodyPr wrap="square" lIns="0" tIns="0" rIns="0" bIns="0" rtlCol="0" anchor="t"/>
+          <a:lstStyle/>
+          <a:p>
+            <a:pPr indent="0" marL="0">
+              <a:buNone/>
+            </a:pPr>
+            <a:r>
+              <a:rPr lang="en-US" sz="800" spc="200" kern="0" dirty="0">
+                <a:solidFill>
+                  <a:schemeClr val="tx2"/>
+                </a:solidFill>
+                <a:latin typeface="Courier New" pitchFamily="34" charset="0"/>
+                <a:ea typeface="Courier New" pitchFamily="34" charset="-122"/>
+                <a:cs typeface="Courier New" pitchFamily="34" charset="-120"/>
+              </a:rPr>
+              <a:t>APPLEGATE VENTURES</a:t>
+            </a:r>
+            <a:endParaRPr lang="en-US" sz="800" dirty="0"/>
+          </a:p>
+        </p:txBody>
+      </p:sp>
+      <p:sp>
+        <p:nvSpPr>
+          <p:cNvPr id="4" name="Shape 2"/>
+          <p:cNvSpPr/>
+          <p:nvPr/>
+        </p:nvSpPr>
+        <p:spPr>
+          <a:xfrm>
+            <a:off x="548640" y="1600200"/>
+            <a:ext cx="8046720" cy="0"/>
+          </a:xfrm>
+          <a:prstGeom prst="line">
+            <a:avLst/>
+          </a:prstGeom>
+          <a:noFill/>
+          <a:ln w="12700">
+            <a:solidFill>
+              <a:srgbClr val="161616"/>
+            </a:solidFill>
+            <a:prstDash val="solid"/>
+          </a:ln>
+        </p:spPr>
+      </p:sp>
+      <p:sp>
+        <p:nvSpPr>
+          <p:cNvPr id="5" name="Text 3"/>
+          <p:cNvSpPr txBox="1"/>
+          <p:nvPr/>
+        </p:nvSpPr>
+        <p:spPr>
+          <a:xfrm>
+            <a:off x="548640" y="1737360"/>
+            <a:ext cx="1828800" cy="201168"/>
+          </a:xfrm>
+          <a:prstGeom prst="rect">
+            <a:avLst/>
+          </a:prstGeom>
+          <a:noFill/>
+          <a:ln/>
+        </p:spPr>
+        <p:txBody>
+          <a:bodyPr wrap="square" lIns="0" tIns="0" rIns="0" bIns="0" rtlCol="0" anchor="t"/>
+          <a:lstStyle/>
+          <a:p>
+            <a:pPr indent="0" marL="0">
+              <a:buNone/>
+            </a:pPr>
+            <a:r>
+              <a:rPr lang="en-US" sz="800" spc="200" kern="0" dirty="0">
+                <a:solidFill>
+                  <a:schemeClr val="tx2"/>
+                </a:solidFill>
+                <a:latin typeface="Courier New" pitchFamily="34" charset="0"/>
+                <a:ea typeface="Courier New" pitchFamily="34" charset="-122"/>
+                <a:cs typeface="Courier New" pitchFamily="34" charset="-120"/>
+              </a:rPr>
+              <a:t>PROBLEM</a:t>
+            </a:r>
+            <a:endParaRPr lang="en-US" sz="800" dirty="0"/>
+          </a:p>
+        </p:txBody>
+      </p:sp>
+      <p:sp>
+        <p:nvSpPr>
+          <p:cNvPr id="6" name="Text 4"/>
+          <p:cNvSpPr txBox="1"/>
+          <p:nvPr/>
+        </p:nvSpPr>
+        <p:spPr>
+          <a:xfrm>
+            <a:off x="2560320" y="1709928"/>
+            <a:ext cx="6035040" cy="731520"/>
+          </a:xfrm>
+          <a:prstGeom prst="rect">
+            <a:avLst/>
+          </a:prstGeom>
+          <a:noFill/>
+          <a:ln/>
+        </p:spPr>
+        <p:txBody>
+          <a:bodyPr wrap="square" lIns="0" tIns="0" rIns="0" bIns="0" rtlCol="0" anchor="t"/>
+          <a:lstStyle/>
+          <a:p>
+            <a:pPr indent="0" marL="0">
+              <a:buNone/>
+            </a:pPr>
+            <a:r>
+              <a:rPr lang="en-US" sz="1500" dirty="0">
+                <a:solidFill>
+                  <a:schemeClr val="tx1"/>
+                </a:solidFill>
+              </a:rPr>
+              <a:t>Property leads arrived through a chain of Zapier steps that duplicated records and failed silently.</a:t>
+            </a:r>
+            <a:endParaRPr lang="en-US" sz="1500" dirty="0"/>
+          </a:p>
+        </p:txBody>
+      </p:sp>
+      <p:sp>
+        <p:nvSpPr>
+          <p:cNvPr id="7" name="Shape 5"/>
+          <p:cNvSpPr/>
+          <p:nvPr/>
+        </p:nvSpPr>
+        <p:spPr>
+          <a:xfrm>
+            <a:off x="548640" y="2514600"/>
+            <a:ext cx="8046720" cy="0"/>
+          </a:xfrm>
+          <a:prstGeom prst="line">
+            <a:avLst/>
+          </a:prstGeom>
+          <a:noFill/>
+          <a:ln w="9525">
+            <a:solidFill>
+              <a:srgbClr val="E2E2E2"/>
+            </a:solidFill>
+            <a:prstDash val="solid"/>
+          </a:ln>
+        </p:spPr>
+      </p:sp>
+      <p:sp>
+        <p:nvSpPr>
+          <p:cNvPr id="8" name="Text 6"/>
+          <p:cNvSpPr txBox="1"/>
+          <p:nvPr/>
+        </p:nvSpPr>
+        <p:spPr>
+          <a:xfrm>
+            <a:off x="548640" y="2651760"/>
+            <a:ext cx="1828800" cy="201168"/>
+          </a:xfrm>
+          <a:prstGeom prst="rect">
+            <a:avLst/>
+          </a:prstGeom>
+          <a:noFill/>
+          <a:ln/>
+        </p:spPr>
+        <p:txBody>
+          <a:bodyPr wrap="square" lIns="0" tIns="0" rIns="0" bIns="0" rtlCol="0" anchor="t"/>
+          <a:lstStyle/>
+          <a:p>
+            <a:pPr indent="0" marL="0">
+              <a:buNone/>
+            </a:pPr>
+            <a:r>
+              <a:rPr lang="en-US" sz="800" spc="200" kern="0" dirty="0">
+                <a:solidFill>
+                  <a:schemeClr val="tx2"/>
+                </a:solidFill>
+                <a:latin typeface="Courier New" pitchFamily="34" charset="0"/>
+                <a:ea typeface="Courier New" pitchFamily="34" charset="-122"/>
+                <a:cs typeface="Courier New" pitchFamily="34" charset="-120"/>
+              </a:rPr>
+              <a:t>WHAT WE BUILT</a:t>
+            </a:r>
+            <a:endParaRPr lang="en-US" sz="800" dirty="0"/>
+          </a:p>
+        </p:txBody>
+      </p:sp>
+      <p:sp>
+        <p:nvSpPr>
+          <p:cNvPr id="9" name="Text 7"/>
+          <p:cNvSpPr txBox="1"/>
+          <p:nvPr/>
+        </p:nvSpPr>
+        <p:spPr>
+          <a:xfrm>
+            <a:off x="2560320" y="2624328"/>
+            <a:ext cx="6035040" cy="731520"/>
+          </a:xfrm>
+          <a:prstGeom prst="rect">
+            <a:avLst/>
+          </a:prstGeom>
+          <a:noFill/>
+          <a:ln/>
+        </p:spPr>
+        <p:txBody>
+          <a:bodyPr wrap="square" lIns="0" tIns="0" rIns="0" bIns="0" rtlCol="0" anchor="t"/>
+          <a:lstStyle/>
+          <a:p>
+            <a:pPr indent="0" marL="0">
+              <a:buNone/>
+            </a:pPr>
+            <a:r>
+              <a:rPr lang="en-US" sz="1500" dirty="0">
+                <a:solidFill>
+                  <a:schemeClr val="tx1"/>
+                </a:solidFill>
+              </a:rPr>
+              <a:t>One pipeline that scores, dedupes, and pushes leads to HubSpot, with a dashboard and replay.</a:t>
+            </a:r>
+            <a:endParaRPr lang="en-US" sz="1500" dirty="0"/>
+          </a:p>
+        </p:txBody>
+      </p:sp>
+      <p:sp>
+        <p:nvSpPr>
+          <p:cNvPr id="10" name="Shape 8"/>
+          <p:cNvSpPr/>
+          <p:nvPr/>
+        </p:nvSpPr>
+        <p:spPr>
+          <a:xfrm>
+            <a:off x="548640" y="3429000"/>
+            <a:ext cx="8046720" cy="0"/>
+          </a:xfrm>
+          <a:prstGeom prst="line">
+            <a:avLst/>
+          </a:prstGeom>
+          <a:noFill/>
+          <a:ln w="9525">
+            <a:solidFill>
+              <a:srgbClr val="E2E2E2"/>
+            </a:solidFill>
+            <a:prstDash val="solid"/>
+          </a:ln>
+        </p:spPr>
+      </p:sp>
+      <p:sp>
+        <p:nvSpPr>
+          <p:cNvPr id="11" name="Text 9"/>
+          <p:cNvSpPr txBox="1"/>
+          <p:nvPr/>
+        </p:nvSpPr>
+        <p:spPr>
+          <a:xfrm>
+            <a:off x="548640" y="3566160"/>
+            <a:ext cx="1828800" cy="201168"/>
+          </a:xfrm>
+          <a:prstGeom prst="rect">
+            <a:avLst/>
+          </a:prstGeom>
+          <a:noFill/>
+          <a:ln/>
+        </p:spPr>
+        <p:txBody>
+          <a:bodyPr wrap="square" lIns="0" tIns="0" rIns="0" bIns="0" rtlCol="0" anchor="t"/>
+          <a:lstStyle/>
+          <a:p>
+            <a:pPr indent="0" marL="0">
+              <a:buNone/>
+            </a:pPr>
+            <a:r>
+              <a:rPr lang="en-US" sz="800" spc="200" kern="0" dirty="0">
+                <a:solidFill>
+                  <a:schemeClr val="tx2"/>
+                </a:solidFill>
+                <a:latin typeface="Courier New" pitchFamily="34" charset="0"/>
+                <a:ea typeface="Courier New" pitchFamily="34" charset="-122"/>
+                <a:cs typeface="Courier New" pitchFamily="34" charset="-120"/>
+              </a:rPr>
+              <a:t>RESULT</a:t>
+            </a:r>
+            <a:endParaRPr lang="en-US" sz="800" dirty="0"/>
+          </a:p>
+        </p:txBody>
+      </p:sp>
+      <p:sp>
+        <p:nvSpPr>
+          <p:cNvPr id="12" name="Text 10"/>
+          <p:cNvSpPr txBox="1"/>
+          <p:nvPr/>
+        </p:nvSpPr>
+        <p:spPr>
+          <a:xfrm>
+            <a:off x="2560320" y="3538728"/>
+            <a:ext cx="6035040" cy="731520"/>
+          </a:xfrm>
+          <a:prstGeom prst="rect">
+            <a:avLst/>
+          </a:prstGeom>
+          <a:noFill/>
+          <a:ln/>
+        </p:spPr>
+        <p:txBody>
+          <a:bodyPr wrap="square" lIns="0" tIns="0" rIns="0" bIns="0" rtlCol="0" anchor="t"/>
+          <a:lstStyle/>
+          <a:p>
+            <a:pPr indent="0" marL="0">
+              <a:buNone/>
+            </a:pPr>
+            <a:r>
+              <a:rPr lang="en-US" sz="1500" dirty="0">
+                <a:solidFill>
+                  <a:schemeClr val="tx1"/>
+                </a:solidFill>
+              </a:rPr>
+              <a:t>Zapier is gone. Every lead has an audit trail. Million-dollar transactions run on it.</a:t>
+            </a:r>
+            <a:endParaRPr lang="en-US" sz="1500" dirty="0"/>
+          </a:p>
+        </p:txBody>
+      </p:sp>
+      <p:sp>
+        <p:nvSpPr>
+          <p:cNvPr id="13" name="Shape 11"/>
+          <p:cNvSpPr/>
+          <p:nvPr/>
+        </p:nvSpPr>
+        <p:spPr>
+          <a:xfrm>
+            <a:off x="548640" y="4343400"/>
+            <a:ext cx="8046720" cy="0"/>
+          </a:xfrm>
+          <a:prstGeom prst="line">
+            <a:avLst/>
+          </a:prstGeom>
+          <a:noFill/>
+          <a:ln w="9525">
+            <a:solidFill>
+              <a:srgbClr val="E2E2E2"/>
+            </a:solidFill>
+            <a:prstDash val="solid"/>
+          </a:ln>
+        </p:spPr>
+      </p:sp>
+    </p:spTree>
+  </p:cSld>
+  <p:clrMapOvr>
+    <a:masterClrMapping/>
+  </p:clrMapOvr>
+</p:sld>
+</file>
+
+<file path=ppt/slides/slide12.xml><?xml version="1.0" encoding="utf-8"?>
+<p:sld xmlns:a="http://schemas.openxmlformats.org/drawingml/2006/main" xmlns:r="http://schemas.openxmlformats.org/officeDocument/2006/relationships" xmlns:p="http://schemas.openxmlformats.org/presentationml/2006/main">
+  <p:cSld name="Slide 12">
+    <p:spTree>
+      <p:nvGrpSpPr>
+        <p:cNvPr id="1" name=""/>
+        <p:cNvGrpSpPr/>
+        <p:nvPr/>
+      </p:nvGrpSpPr>
+      <p:grpSpPr>
+        <a:xfrm>
+          <a:off x="0" y="0"/>
+          <a:ext cx="0" cy="0"/>
+          <a:chOff x="0" y="0"/>
+          <a:chExt cx="0" cy="0"/>
+        </a:xfrm>
+      </p:grpSpPr>
+      <p:sp>
+        <p:nvSpPr>
+          <p:cNvPr id="2" name="Text 0"/>
           <p:cNvSpPr txBox="1"/>
           <p:nvPr/>
         </p:nvSpPr>
@@ -5000,7 +6026,7 @@
                   <a:schemeClr val="tx1"/>
                 </a:solidFill>
               </a:rPr>
-              <a:t>Wonderfly   ·   Windansea Coconuts   ·   Applegate Ventures   ·   Hologram Pilates (Proto)</a:t>
+              <a:t>Nekter   ·   SnapLogic   ·   Wonderfly   ·   Windansea Coconuts   ·   Applegate Ventures   ·   Hologram Pilates (Proto)</a:t>
             </a:r>
             <a:endParaRPr lang="en-US" sz="1400" dirty="0"/>
           </a:p>
@@ -5063,7 +6089,7 @@
                   <a:srgbClr val="161616"/>
                 </a:solidFill>
               </a:rPr>
-              <a:t>A customer service agent that answers texts around the clock</a:t>
+              <a:t>The company's first GTM sales agent</a:t>
             </a:r>
             <a:endParaRPr lang="en-US" sz="2800" dirty="0"/>
           </a:p>
@@ -5102,7 +6128,7 @@
                 <a:ea typeface="Courier New" pitchFamily="34" charset="-122"/>
                 <a:cs typeface="Courier New" pitchFamily="34" charset="-120"/>
               </a:rPr>
-              <a:t>WONDERFLY</a:t>
+              <a:t>SNAPLOGIC</a:t>
             </a:r>
             <a:endParaRPr lang="en-US" sz="800" dirty="0"/>
           </a:p>
@@ -5200,7 +6226,7 @@
                   <a:schemeClr val="tx1"/>
                 </a:solidFill>
               </a:rPr>
-              <a:t>Customers text evenings and weekends. Staff replied Monday. Bookings were lost.</a:t>
+              <a:t>Reps prepped for calls by pulling account history from separate systems. Prep took longer than the call.</a:t>
             </a:r>
             <a:endParaRPr lang="en-US" sz="1500" dirty="0"/>
           </a:p>
@@ -5298,7 +6324,7 @@
                   <a:schemeClr val="tx1"/>
                 </a:solidFill>
               </a:rPr>
-              <a:t>An SMS agent on the venue's phone lines that answers from live data and hands off to a human when unsure.</a:t>
+              <a:t>An agent on SnapLogic AgentCreator that pulls account context and answers reps' questions on demand.</a:t>
             </a:r>
             <a:endParaRPr lang="en-US" sz="1500" dirty="0"/>
           </a:p>
@@ -5396,7 +6422,7 @@
                   <a:schemeClr val="tx1"/>
                 </a:solidFill>
               </a:rPr>
-              <a:t>Replies in seconds, any hour. Staff only touch the conversations it flags.</a:t>
+              <a:t>Account briefs in seconds. The build became the teaching example for customer bootcamps.</a:t>
             </a:r>
             <a:endParaRPr lang="en-US" sz="1500" dirty="0"/>
           </a:p>
@@ -5482,7 +6508,7 @@
                   <a:srgbClr val="161616"/>
                 </a:solidFill>
               </a:rPr>
-              <a:t>Event operations with no retyping</a:t>
+              <a:t>A customer success platform that surfaces churn risk early</a:t>
             </a:r>
             <a:endParaRPr lang="en-US" sz="2800" dirty="0"/>
           </a:p>
@@ -5521,7 +6547,7 @@
                 <a:ea typeface="Courier New" pitchFamily="34" charset="-122"/>
                 <a:cs typeface="Courier New" pitchFamily="34" charset="-120"/>
               </a:rPr>
-              <a:t>WINDANSEA COCONUTS</a:t>
+              <a:t>NEKTER</a:t>
             </a:r>
             <a:endParaRPr lang="en-US" sz="800" dirty="0"/>
           </a:p>
@@ -5619,7 +6645,7 @@
                   <a:schemeClr val="tx1"/>
                 </a:solidFill>
               </a:rPr>
-              <a:t>Every closed deal was copied by hand into tasks, intake forms, and crew run sheets.</a:t>
+              <a:t>CSMs juggled Salesforce, Zendesk, call recordings, and email. Health drops were noticed after the renewal was lost.</a:t>
             </a:r>
             <a:endParaRPr lang="en-US" sz="1500" dirty="0"/>
           </a:p>
@@ -5717,7 +6743,7 @@
                   <a:schemeClr val="tx1"/>
                 </a:solidFill>
               </a:rPr>
-              <a:t>Webhooks from the CRM create the event, send the intake, and write a daily Run of Show with Claude.</a:t>
+              <a:t>One account view with health scores, AI insights on every interaction, Slack alerts, and a natural-language assistant over the data.</a:t>
             </a:r>
             <a:endParaRPr lang="en-US" sz="1500" dirty="0"/>
           </a:p>
@@ -5815,7 +6841,7 @@
                   <a:schemeClr val="tx1"/>
                 </a:solidFill>
               </a:rPr>
-              <a:t>A closed deal becomes a staffed event with a current run sheet, with nobody retyping it.</a:t>
+              <a:t>Risk reaches Slack before the renewal call. A CSM asks a question in plain English and gets the answer from the actual call.</a:t>
             </a:r>
             <a:endParaRPr lang="en-US" sz="1500" dirty="0"/>
           </a:p>
@@ -5901,7 +6927,7 @@
                   <a:srgbClr val="161616"/>
                 </a:solidFill>
               </a:rPr>
-              <a:t>A lead pipeline that replaced Zapier</a:t>
+              <a:t>A customer service agent that answers texts around the clock</a:t>
             </a:r>
             <a:endParaRPr lang="en-US" sz="2800" dirty="0"/>
           </a:p>
@@ -5940,7 +6966,7 @@
                 <a:ea typeface="Courier New" pitchFamily="34" charset="-122"/>
                 <a:cs typeface="Courier New" pitchFamily="34" charset="-120"/>
               </a:rPr>
-              <a:t>APPLEGATE VENTURES</a:t>
+              <a:t>WONDERFLY</a:t>
             </a:r>
             <a:endParaRPr lang="en-US" sz="800" dirty="0"/>
           </a:p>
@@ -6038,7 +7064,7 @@
                   <a:schemeClr val="tx1"/>
                 </a:solidFill>
               </a:rPr>
-              <a:t>Property leads arrived through a chain of Zapier steps that duplicated records and failed silently.</a:t>
+              <a:t>Customers text evenings and weekends. Staff replied Monday. Bookings were lost.</a:t>
             </a:r>
             <a:endParaRPr lang="en-US" sz="1500" dirty="0"/>
           </a:p>
@@ -6136,7 +7162,7 @@
                   <a:schemeClr val="tx1"/>
                 </a:solidFill>
               </a:rPr>
-              <a:t>One pipeline that scores, dedupes, and pushes leads to HubSpot, with a dashboard and replay.</a:t>
+              <a:t>An SMS agent on the venue's phone lines that answers from live data and hands off to a human when unsure.</a:t>
             </a:r>
             <a:endParaRPr lang="en-US" sz="1500" dirty="0"/>
           </a:p>
@@ -6234,7 +7260,7 @@
                   <a:schemeClr val="tx1"/>
                 </a:solidFill>
               </a:rPr>
-              <a:t>Zapier is gone. Every lead has an audit trail. Million-dollar transactions run on it.</a:t>
+              <a:t>Replies in seconds, any hour. Staff only touch the conversations it flags.</a:t>
             </a:r>
             <a:endParaRPr lang="en-US" sz="1500" dirty="0"/>
           </a:p>

</xml_diff>

<commit_message>
content: remove Hologram Pilates; SnapLogic as internal GTM sales assistant
Co-Authored-By: Claude Fable 5.1 <noreply@anthropic.com>
</commit_message>
<xml_diff>
--- a/docs/deck/AI-Training-For-Companies.pptx
+++ b/docs/deck/AI-Training-For-Companies.pptx
@@ -118,62 +118,62 @@
   <p:extLst>
     <p:ext uri="{521415D9-36F7-43E2-AB2F-B90AF26B5E84}">
       <p14:sectionLst xmlns:p14="http://schemas.microsoft.com/office/powerpoint/2010/main">
-        <p14:section name="Open" id="{64188c3a-9f88-6d9d-b5ea-445464e118d7}">
+        <p14:section name="Open" id="{c4aa99bc-17f4-0808-bcf9-a522c06ae920}">
           <p14:sldIdLst>
             <p14:sldId id="256"/>
           </p14:sldIdLst>
         </p14:section>
-        <p14:section name="Problem" id="{5d141fc5-72ce-7317-0f7b-ef52a9737ad2}">
+        <p14:section name="Problem" id="{f53ebad8-d28d-20f5-e3bb-7ce0b88d0c80}">
           <p14:sldIdLst>
             <p14:sldId id="257"/>
           </p14:sldIdLst>
         </p14:section>
-        <p14:section name="Fix" id="{a222acc7-2df3-4b72-b5ad-6924b71fcbda}">
+        <p14:section name="Fix" id="{c9340b94-9de6-eae7-6c46-8deb158e83f3}">
           <p14:sldIdLst>
             <p14:sldId id="258"/>
           </p14:sldIdLst>
         </p14:section>
-        <p14:section name="Offerings" id="{c263d120-a290-36e1-1ddc-14fcf694a09f}">
+        <p14:section name="Offerings" id="{de59309a-e6be-bff9-8abb-a186a0506c58}">
           <p14:sldIdLst>
             <p14:sldId id="259"/>
           </p14:sldIdLst>
         </p14:section>
-        <p14:section name="Outcomes" id="{a696c511-8976-493f-ff85-6bdcbdc19ea7}">
+        <p14:section name="Outcomes" id="{57249b64-8ce0-0c5f-e0d6-7475182b662d}">
           <p14:sldIdLst>
             <p14:sldId id="260"/>
           </p14:sldIdLst>
         </p14:section>
-        <p14:section name="Proof" id="{b15ec4ec-e8f7-8fe2-8e64-71914b11002c}">
+        <p14:section name="Proof" id="{cbd50716-6828-a6d3-1324-fd2c8e23ae7d}">
           <p14:sldIdLst>
             <p14:sldId id="261"/>
           </p14:sldIdLst>
         </p14:section>
-        <p14:section name="Case 1" id="{ed5dd9b8-3b0d-b6cf-adcd-f732a4f84094}">
+        <p14:section name="Case 1" id="{13339175-e200-0360-d0a8-eb0d196cb4c0}">
           <p14:sldIdLst>
             <p14:sldId id="262"/>
           </p14:sldIdLst>
         </p14:section>
-        <p14:section name="Case 2" id="{00165f22-a8dc-0e81-fb38-c87f4b3bf999}">
+        <p14:section name="Case 2" id="{27f88750-0544-f7fd-5c59-17a0a8dc4acd}">
           <p14:sldIdLst>
             <p14:sldId id="263"/>
           </p14:sldIdLst>
         </p14:section>
-        <p14:section name="Case 3" id="{94341c54-e2fc-4d88-2fb7-5c6a897b2df5}">
+        <p14:section name="Case 3" id="{29ad1519-9ec9-2f0b-6e9e-6bc39a26172e}">
           <p14:sldIdLst>
             <p14:sldId id="264"/>
           </p14:sldIdLst>
         </p14:section>
-        <p14:section name="Case 4" id="{50cb6a97-cfc6-f279-6538-e754f4e4223f}">
+        <p14:section name="Case 4" id="{037eb17b-971e-466a-6c8a-23f150b93ae5}">
           <p14:sldIdLst>
             <p14:sldId id="265"/>
           </p14:sldIdLst>
         </p14:section>
-        <p14:section name="Case 5" id="{70b79541-fb0b-f520-0b17-e1ab5bb6081e}">
+        <p14:section name="Case 5" id="{3dee9d90-37cb-ec30-a682-d6d03eb1e70e}">
           <p14:sldIdLst>
             <p14:sldId id="266"/>
           </p14:sldIdLst>
         </p14:section>
-        <p14:section name="Close" id="{cf4f6a22-e0b6-53a2-b1d1-9d26f1533f3e}">
+        <p14:section name="Close" id="{6b27ffde-2370-ebba-ace2-2e4aeefc8598}">
           <p14:sldIdLst>
             <p14:sldId id="267"/>
           </p14:sldIdLst>
@@ -6026,7 +6026,7 @@
                   <a:schemeClr val="tx1"/>
                 </a:solidFill>
               </a:rPr>
-              <a:t>Nekter   ·   SnapLogic   ·   Wonderfly   ·   Windansea Coconuts   ·   Applegate Ventures   ·   Hologram Pilates (Proto)</a:t>
+              <a:t>Nekter   ·   SnapLogic   ·   Wonderfly   ·   Windansea Coconuts   ·   Applegate Ventures</a:t>
             </a:r>
             <a:endParaRPr lang="en-US" sz="1400" dirty="0"/>
           </a:p>
@@ -6089,7 +6089,7 @@
                   <a:srgbClr val="161616"/>
                 </a:solidFill>
               </a:rPr>
-              <a:t>The company's first GTM sales agent</a:t>
+              <a:t>GTM sales assistant, an internal build</a:t>
             </a:r>
             <a:endParaRPr lang="en-US" sz="2800" dirty="0"/>
           </a:p>

</xml_diff>

<commit_message>
feat: AI fluency angle, offering detail pages with agenda and outcomes, FAQ, deck slide
Co-Authored-By: Claude Fable 5.1 <noreply@anthropic.com>
</commit_message>
<xml_diff>
--- a/docs/deck/AI-Training-For-Companies.pptx
+++ b/docs/deck/AI-Training-For-Companies.pptx
@@ -17,9 +17,10 @@
     <p:sldId id="265" r:id="rId11"/>
     <p:sldId id="266" r:id="rId12"/>
     <p:sldId id="267" r:id="rId13"/>
+    <p:sldId id="268" r:id="rId14"/>
   </p:sldIdLst>
   <p:notesMasterIdLst>
-    <p:notesMasterId r:id="rId14"/>
+    <p:notesMasterId r:id="rId15"/>
   </p:notesMasterIdLst>
   <p:sldSz cx="9144000" cy="5143500"/>
   <p:notesSz cx="5143500" cy="9144000"/>
@@ -118,64 +119,69 @@
   <p:extLst>
     <p:ext uri="{521415D9-36F7-43E2-AB2F-B90AF26B5E84}">
       <p14:sectionLst xmlns:p14="http://schemas.microsoft.com/office/powerpoint/2010/main">
-        <p14:section name="Open" id="{c4aa99bc-17f4-0808-bcf9-a522c06ae920}">
+        <p14:section name="Open" id="{1d4a15e7-e03c-7a6a-1f39-fbf838dd715b}">
           <p14:sldIdLst>
             <p14:sldId id="256"/>
           </p14:sldIdLst>
         </p14:section>
-        <p14:section name="Problem" id="{f53ebad8-d28d-20f5-e3bb-7ce0b88d0c80}">
+        <p14:section name="Problem" id="{102546a4-ceff-c4dd-8fcc-2f660e4ca94c}">
           <p14:sldIdLst>
             <p14:sldId id="257"/>
           </p14:sldIdLst>
         </p14:section>
-        <p14:section name="Fix" id="{c9340b94-9de6-eae7-6c46-8deb158e83f3}">
+        <p14:section name="Fix" id="{44ff3c79-ad76-16d2-6c2c-48507c9807c6}">
           <p14:sldIdLst>
             <p14:sldId id="258"/>
           </p14:sldIdLst>
         </p14:section>
-        <p14:section name="Offerings" id="{de59309a-e6be-bff9-8abb-a186a0506c58}">
+        <p14:section name="Fluency" id="{0c28a855-6411-9f14-8c1f-2645a72eec71}">
           <p14:sldIdLst>
             <p14:sldId id="259"/>
           </p14:sldIdLst>
         </p14:section>
-        <p14:section name="Outcomes" id="{57249b64-8ce0-0c5f-e0d6-7475182b662d}">
+        <p14:section name="Offerings" id="{6a9a3a96-826c-84c5-1d04-df93330d45eb}">
           <p14:sldIdLst>
             <p14:sldId id="260"/>
           </p14:sldIdLst>
         </p14:section>
-        <p14:section name="Proof" id="{cbd50716-6828-a6d3-1324-fd2c8e23ae7d}">
+        <p14:section name="Outcomes" id="{fbee6944-771e-2992-757b-7b24fa62dc97}">
           <p14:sldIdLst>
             <p14:sldId id="261"/>
           </p14:sldIdLst>
         </p14:section>
-        <p14:section name="Case 1" id="{13339175-e200-0360-d0a8-eb0d196cb4c0}">
+        <p14:section name="Proof" id="{ab151388-f0ce-f944-69e9-8cb5bf1acd4b}">
           <p14:sldIdLst>
             <p14:sldId id="262"/>
           </p14:sldIdLst>
         </p14:section>
-        <p14:section name="Case 2" id="{27f88750-0544-f7fd-5c59-17a0a8dc4acd}">
+        <p14:section name="Case 1" id="{5e8d8789-4332-1194-f572-b3336cedd34e}">
           <p14:sldIdLst>
             <p14:sldId id="263"/>
           </p14:sldIdLst>
         </p14:section>
-        <p14:section name="Case 3" id="{29ad1519-9ec9-2f0b-6e9e-6bc39a26172e}">
+        <p14:section name="Case 2" id="{16f0f81f-3917-43f9-b5ac-a258455330ba}">
           <p14:sldIdLst>
             <p14:sldId id="264"/>
           </p14:sldIdLst>
         </p14:section>
-        <p14:section name="Case 4" id="{037eb17b-971e-466a-6c8a-23f150b93ae5}">
+        <p14:section name="Case 3" id="{55e3d9df-b85d-b97c-1c32-d59d41982d65}">
           <p14:sldIdLst>
             <p14:sldId id="265"/>
           </p14:sldIdLst>
         </p14:section>
-        <p14:section name="Case 5" id="{3dee9d90-37cb-ec30-a682-d6d03eb1e70e}">
+        <p14:section name="Case 4" id="{ebfda554-fee3-4b5b-aec9-44bad8b4dcaa}">
           <p14:sldIdLst>
             <p14:sldId id="266"/>
           </p14:sldIdLst>
         </p14:section>
-        <p14:section name="Close" id="{6b27ffde-2370-ebba-ace2-2e4aeefc8598}">
+        <p14:section name="Case 5" id="{d6206bff-8619-8109-cffb-2270a395623f}">
           <p14:sldIdLst>
             <p14:sldId id="267"/>
+          </p14:sldIdLst>
+        </p14:section>
+        <p14:section name="Close" id="{cb76c8b8-f766-59df-73e9-8023fbebc809}">
+          <p14:sldIdLst>
+            <p14:sldId id="268"/>
           </p14:sldIdLst>
         </p14:section>
       </p14:sectionLst>
@@ -870,6 +876,94 @@
             <a:fld id="{F7021451-1387-4CA6-816F-3879F97B5CBC}" type="slidenum">
               <a:rPr lang="en-US"/>
               <a:t>12</a:t>
+            </a:fld>
+            <a:endParaRPr lang="en-US"/>
+          </a:p>
+        </p:txBody>
+      </p:sp>
+    </p:spTree>
+    <p:extLst>
+      <p:ext uri="{BB962C8B-B14F-4D97-AF65-F5344CB8AC3E}">
+        <p14:creationId xmlns:p14="http://schemas.microsoft.com/office/powerpoint/2010/main" val="1024086991"/>
+      </p:ext>
+    </p:extLst>
+  </p:cSld>
+  <p:clrMapOvr>
+    <a:masterClrMapping/>
+  </p:clrMapOvr>
+</p:notes>
+</file>
+
+<file path=ppt/notesSlides/notesSlide13.xml><?xml version="1.0" encoding="utf-8"?>
+<p:notes xmlns:a="http://schemas.openxmlformats.org/drawingml/2006/main" xmlns:r="http://schemas.openxmlformats.org/officeDocument/2006/relationships" xmlns:p="http://schemas.openxmlformats.org/presentationml/2006/main">
+  <p:cSld>
+    <p:spTree>
+      <p:nvGrpSpPr>
+        <p:cNvPr id="1" name=""/>
+        <p:cNvGrpSpPr/>
+        <p:nvPr/>
+      </p:nvGrpSpPr>
+      <p:grpSpPr>
+        <a:xfrm>
+          <a:off x="0" y="0"/>
+          <a:ext cx="0" cy="0"/>
+          <a:chOff x="0" y="0"/>
+          <a:chExt cx="0" cy="0"/>
+        </a:xfrm>
+      </p:grpSpPr>
+      <p:sp>
+        <p:nvSpPr>
+          <p:cNvPr id="2" name="Slide Image Placeholder 1"/>
+          <p:cNvSpPr>
+            <a:spLocks noGrp="1" noRot="1" noChangeAspect="1"/>
+          </p:cNvSpPr>
+          <p:nvPr>
+            <p:ph type="sldImg"/>
+          </p:nvPr>
+        </p:nvSpPr>
+        <p:spPr/>
+      </p:sp>
+      <p:sp>
+        <p:nvSpPr>
+          <p:cNvPr id="3" name="Notes Placeholder 2"/>
+          <p:cNvSpPr>
+            <a:spLocks noGrp="1"/>
+          </p:cNvSpPr>
+          <p:nvPr>
+            <p:ph type="body" idx="1"/>
+          </p:nvPr>
+        </p:nvSpPr>
+        <p:spPr/>
+        <p:txBody>
+          <a:bodyPr/>
+          <a:lstStyle/>
+          <a:p>
+            <a:r>
+              <a:rPr lang="en-US" dirty="0"/>
+              <a:t/>
+            </a:r>
+            <a:endParaRPr lang="en-US" dirty="0"/>
+          </a:p>
+        </p:txBody>
+      </p:sp>
+      <p:sp>
+        <p:nvSpPr>
+          <p:cNvPr id="4" name="Slide Number Placeholder 3"/>
+          <p:cNvSpPr>
+            <a:spLocks noGrp="1"/>
+          </p:cNvSpPr>
+          <p:nvPr>
+            <p:ph type="sldNum" sz="quarter" idx="10"/>
+          </p:nvPr>
+        </p:nvSpPr>
+        <p:spPr/>
+        <p:txBody>
+          <a:bodyPr/>
+          <a:lstStyle/>
+          <a:p>
+            <a:fld id="{F7021451-1387-4CA6-816F-3879F97B5CBC}" type="slidenum">
+              <a:rPr lang="en-US"/>
+              <a:t>13</a:t>
             </a:fld>
             <a:endParaRPr lang="en-US"/>
           </a:p>
@@ -2293,7 +2387,7 @@
                   <a:srgbClr val="161616"/>
                 </a:solidFill>
               </a:rPr>
-              <a:t>Event operations with no retyping</a:t>
+              <a:t>A customer service agent that answers texts around the clock</a:t>
             </a:r>
             <a:endParaRPr lang="en-US" sz="2800" dirty="0"/>
           </a:p>
@@ -2332,7 +2426,7 @@
                 <a:ea typeface="Courier New" pitchFamily="34" charset="-122"/>
                 <a:cs typeface="Courier New" pitchFamily="34" charset="-120"/>
               </a:rPr>
-              <a:t>WINDANSEA COCONUTS</a:t>
+              <a:t>WONDERFLY</a:t>
             </a:r>
             <a:endParaRPr lang="en-US" sz="800" dirty="0"/>
           </a:p>
@@ -2430,7 +2524,7 @@
                   <a:schemeClr val="tx1"/>
                 </a:solidFill>
               </a:rPr>
-              <a:t>Every closed deal was copied by hand into tasks, intake forms, and crew run sheets.</a:t>
+              <a:t>Customers text evenings and weekends. Staff replied Monday. Bookings were lost.</a:t>
             </a:r>
             <a:endParaRPr lang="en-US" sz="1500" dirty="0"/>
           </a:p>
@@ -2528,7 +2622,7 @@
                   <a:schemeClr val="tx1"/>
                 </a:solidFill>
               </a:rPr>
-              <a:t>Webhooks from the CRM create the event, send the intake, and write a daily Run of Show with Claude.</a:t>
+              <a:t>An SMS agent on the venue's phone lines that answers from live data and hands off to a human when unsure.</a:t>
             </a:r>
             <a:endParaRPr lang="en-US" sz="1500" dirty="0"/>
           </a:p>
@@ -2626,7 +2720,7 @@
                   <a:schemeClr val="tx1"/>
                 </a:solidFill>
               </a:rPr>
-              <a:t>A closed deal becomes a staffed event with a current run sheet, with nobody retyping it.</a:t>
+              <a:t>Replies in seconds, any hour. Staff only touch the conversations it flags.</a:t>
             </a:r>
             <a:endParaRPr lang="en-US" sz="1500" dirty="0"/>
           </a:p>
@@ -2712,7 +2806,7 @@
                   <a:srgbClr val="161616"/>
                 </a:solidFill>
               </a:rPr>
-              <a:t>A lead pipeline that replaced Zapier</a:t>
+              <a:t>Event operations with no retyping</a:t>
             </a:r>
             <a:endParaRPr lang="en-US" sz="2800" dirty="0"/>
           </a:p>
@@ -2751,7 +2845,7 @@
                 <a:ea typeface="Courier New" pitchFamily="34" charset="-122"/>
                 <a:cs typeface="Courier New" pitchFamily="34" charset="-120"/>
               </a:rPr>
-              <a:t>APPLEGATE VENTURES</a:t>
+              <a:t>WINDANSEA COCONUTS</a:t>
             </a:r>
             <a:endParaRPr lang="en-US" sz="800" dirty="0"/>
           </a:p>
@@ -2849,7 +2943,7 @@
                   <a:schemeClr val="tx1"/>
                 </a:solidFill>
               </a:rPr>
-              <a:t>Property leads arrived through a chain of Zapier steps that duplicated records and failed silently.</a:t>
+              <a:t>Every closed deal was copied by hand into tasks, intake forms, and crew run sheets.</a:t>
             </a:r>
             <a:endParaRPr lang="en-US" sz="1500" dirty="0"/>
           </a:p>
@@ -2947,7 +3041,7 @@
                   <a:schemeClr val="tx1"/>
                 </a:solidFill>
               </a:rPr>
-              <a:t>One pipeline that scores, dedupes, and pushes leads to HubSpot, with a dashboard and replay.</a:t>
+              <a:t>Webhooks from the CRM create the event, send the intake, and write a daily Run of Show with Claude.</a:t>
             </a:r>
             <a:endParaRPr lang="en-US" sz="1500" dirty="0"/>
           </a:p>
@@ -3045,7 +3139,7 @@
                   <a:schemeClr val="tx1"/>
                 </a:solidFill>
               </a:rPr>
-              <a:t>Zapier is gone. Every lead has an audit trail. Million-dollar transactions run on it.</a:t>
+              <a:t>A closed deal becomes a staffed event with a current run sheet, with nobody retyping it.</a:t>
             </a:r>
             <a:endParaRPr lang="en-US" sz="1500" dirty="0"/>
           </a:p>
@@ -3102,6 +3196,425 @@
       <p:sp>
         <p:nvSpPr>
           <p:cNvPr id="2" name="Text 0"/>
+          <p:cNvSpPr/>
+          <p:nvPr>
+            <p:ph idx="100" type="title" hasCustomPrompt="1"/>
+          </p:nvPr>
+        </p:nvSpPr>
+        <p:spPr>
+          <a:xfrm>
+            <a:off x="548640" y="502920"/>
+            <a:ext cx="8046720" cy="822960"/>
+          </a:xfrm>
+          <a:prstGeom prst="rect">
+            <a:avLst/>
+          </a:prstGeom>
+          <a:noFill/>
+          <a:ln/>
+        </p:spPr>
+        <p:txBody>
+          <a:bodyPr wrap="square" lIns="0" tIns="0" rIns="0" bIns="0" rtlCol="0" anchor="t"/>
+          <a:lstStyle/>
+          <a:p>
+            <a:pPr indent="0" marL="0">
+              <a:buNone/>
+            </a:pPr>
+            <a:r>
+              <a:rPr lang="en-US" sz="2800" b="1" dirty="0">
+                <a:solidFill>
+                  <a:srgbClr val="161616"/>
+                </a:solidFill>
+              </a:rPr>
+              <a:t>A lead pipeline that replaced Zapier</a:t>
+            </a:r>
+            <a:endParaRPr lang="en-US" sz="2800" dirty="0"/>
+          </a:p>
+        </p:txBody>
+      </p:sp>
+      <p:sp>
+        <p:nvSpPr>
+          <p:cNvPr id="3" name="Text 1"/>
+          <p:cNvSpPr txBox="1"/>
+          <p:nvPr/>
+        </p:nvSpPr>
+        <p:spPr>
+          <a:xfrm>
+            <a:off x="548640" y="274320"/>
+            <a:ext cx="8046720" cy="201168"/>
+          </a:xfrm>
+          <a:prstGeom prst="rect">
+            <a:avLst/>
+          </a:prstGeom>
+          <a:noFill/>
+          <a:ln/>
+        </p:spPr>
+        <p:txBody>
+          <a:bodyPr wrap="square" lIns="0" tIns="0" rIns="0" bIns="0" rtlCol="0" anchor="t"/>
+          <a:lstStyle/>
+          <a:p>
+            <a:pPr indent="0" marL="0">
+              <a:buNone/>
+            </a:pPr>
+            <a:r>
+              <a:rPr lang="en-US" sz="800" spc="200" kern="0" dirty="0">
+                <a:solidFill>
+                  <a:schemeClr val="tx2"/>
+                </a:solidFill>
+                <a:latin typeface="Courier New" pitchFamily="34" charset="0"/>
+                <a:ea typeface="Courier New" pitchFamily="34" charset="-122"/>
+                <a:cs typeface="Courier New" pitchFamily="34" charset="-120"/>
+              </a:rPr>
+              <a:t>APPLEGATE VENTURES</a:t>
+            </a:r>
+            <a:endParaRPr lang="en-US" sz="800" dirty="0"/>
+          </a:p>
+        </p:txBody>
+      </p:sp>
+      <p:sp>
+        <p:nvSpPr>
+          <p:cNvPr id="4" name="Shape 2"/>
+          <p:cNvSpPr/>
+          <p:nvPr/>
+        </p:nvSpPr>
+        <p:spPr>
+          <a:xfrm>
+            <a:off x="548640" y="1600200"/>
+            <a:ext cx="8046720" cy="0"/>
+          </a:xfrm>
+          <a:prstGeom prst="line">
+            <a:avLst/>
+          </a:prstGeom>
+          <a:noFill/>
+          <a:ln w="12700">
+            <a:solidFill>
+              <a:srgbClr val="161616"/>
+            </a:solidFill>
+            <a:prstDash val="solid"/>
+          </a:ln>
+        </p:spPr>
+      </p:sp>
+      <p:sp>
+        <p:nvSpPr>
+          <p:cNvPr id="5" name="Text 3"/>
+          <p:cNvSpPr txBox="1"/>
+          <p:nvPr/>
+        </p:nvSpPr>
+        <p:spPr>
+          <a:xfrm>
+            <a:off x="548640" y="1737360"/>
+            <a:ext cx="1828800" cy="201168"/>
+          </a:xfrm>
+          <a:prstGeom prst="rect">
+            <a:avLst/>
+          </a:prstGeom>
+          <a:noFill/>
+          <a:ln/>
+        </p:spPr>
+        <p:txBody>
+          <a:bodyPr wrap="square" lIns="0" tIns="0" rIns="0" bIns="0" rtlCol="0" anchor="t"/>
+          <a:lstStyle/>
+          <a:p>
+            <a:pPr indent="0" marL="0">
+              <a:buNone/>
+            </a:pPr>
+            <a:r>
+              <a:rPr lang="en-US" sz="800" spc="200" kern="0" dirty="0">
+                <a:solidFill>
+                  <a:schemeClr val="tx2"/>
+                </a:solidFill>
+                <a:latin typeface="Courier New" pitchFamily="34" charset="0"/>
+                <a:ea typeface="Courier New" pitchFamily="34" charset="-122"/>
+                <a:cs typeface="Courier New" pitchFamily="34" charset="-120"/>
+              </a:rPr>
+              <a:t>PROBLEM</a:t>
+            </a:r>
+            <a:endParaRPr lang="en-US" sz="800" dirty="0"/>
+          </a:p>
+        </p:txBody>
+      </p:sp>
+      <p:sp>
+        <p:nvSpPr>
+          <p:cNvPr id="6" name="Text 4"/>
+          <p:cNvSpPr txBox="1"/>
+          <p:nvPr/>
+        </p:nvSpPr>
+        <p:spPr>
+          <a:xfrm>
+            <a:off x="2560320" y="1709928"/>
+            <a:ext cx="6035040" cy="731520"/>
+          </a:xfrm>
+          <a:prstGeom prst="rect">
+            <a:avLst/>
+          </a:prstGeom>
+          <a:noFill/>
+          <a:ln/>
+        </p:spPr>
+        <p:txBody>
+          <a:bodyPr wrap="square" lIns="0" tIns="0" rIns="0" bIns="0" rtlCol="0" anchor="t"/>
+          <a:lstStyle/>
+          <a:p>
+            <a:pPr indent="0" marL="0">
+              <a:buNone/>
+            </a:pPr>
+            <a:r>
+              <a:rPr lang="en-US" sz="1500" dirty="0">
+                <a:solidFill>
+                  <a:schemeClr val="tx1"/>
+                </a:solidFill>
+              </a:rPr>
+              <a:t>Property leads arrived through a chain of Zapier steps that duplicated records and failed silently.</a:t>
+            </a:r>
+            <a:endParaRPr lang="en-US" sz="1500" dirty="0"/>
+          </a:p>
+        </p:txBody>
+      </p:sp>
+      <p:sp>
+        <p:nvSpPr>
+          <p:cNvPr id="7" name="Shape 5"/>
+          <p:cNvSpPr/>
+          <p:nvPr/>
+        </p:nvSpPr>
+        <p:spPr>
+          <a:xfrm>
+            <a:off x="548640" y="2514600"/>
+            <a:ext cx="8046720" cy="0"/>
+          </a:xfrm>
+          <a:prstGeom prst="line">
+            <a:avLst/>
+          </a:prstGeom>
+          <a:noFill/>
+          <a:ln w="9525">
+            <a:solidFill>
+              <a:srgbClr val="E2E2E2"/>
+            </a:solidFill>
+            <a:prstDash val="solid"/>
+          </a:ln>
+        </p:spPr>
+      </p:sp>
+      <p:sp>
+        <p:nvSpPr>
+          <p:cNvPr id="8" name="Text 6"/>
+          <p:cNvSpPr txBox="1"/>
+          <p:nvPr/>
+        </p:nvSpPr>
+        <p:spPr>
+          <a:xfrm>
+            <a:off x="548640" y="2651760"/>
+            <a:ext cx="1828800" cy="201168"/>
+          </a:xfrm>
+          <a:prstGeom prst="rect">
+            <a:avLst/>
+          </a:prstGeom>
+          <a:noFill/>
+          <a:ln/>
+        </p:spPr>
+        <p:txBody>
+          <a:bodyPr wrap="square" lIns="0" tIns="0" rIns="0" bIns="0" rtlCol="0" anchor="t"/>
+          <a:lstStyle/>
+          <a:p>
+            <a:pPr indent="0" marL="0">
+              <a:buNone/>
+            </a:pPr>
+            <a:r>
+              <a:rPr lang="en-US" sz="800" spc="200" kern="0" dirty="0">
+                <a:solidFill>
+                  <a:schemeClr val="tx2"/>
+                </a:solidFill>
+                <a:latin typeface="Courier New" pitchFamily="34" charset="0"/>
+                <a:ea typeface="Courier New" pitchFamily="34" charset="-122"/>
+                <a:cs typeface="Courier New" pitchFamily="34" charset="-120"/>
+              </a:rPr>
+              <a:t>WHAT WE BUILT</a:t>
+            </a:r>
+            <a:endParaRPr lang="en-US" sz="800" dirty="0"/>
+          </a:p>
+        </p:txBody>
+      </p:sp>
+      <p:sp>
+        <p:nvSpPr>
+          <p:cNvPr id="9" name="Text 7"/>
+          <p:cNvSpPr txBox="1"/>
+          <p:nvPr/>
+        </p:nvSpPr>
+        <p:spPr>
+          <a:xfrm>
+            <a:off x="2560320" y="2624328"/>
+            <a:ext cx="6035040" cy="731520"/>
+          </a:xfrm>
+          <a:prstGeom prst="rect">
+            <a:avLst/>
+          </a:prstGeom>
+          <a:noFill/>
+          <a:ln/>
+        </p:spPr>
+        <p:txBody>
+          <a:bodyPr wrap="square" lIns="0" tIns="0" rIns="0" bIns="0" rtlCol="0" anchor="t"/>
+          <a:lstStyle/>
+          <a:p>
+            <a:pPr indent="0" marL="0">
+              <a:buNone/>
+            </a:pPr>
+            <a:r>
+              <a:rPr lang="en-US" sz="1500" dirty="0">
+                <a:solidFill>
+                  <a:schemeClr val="tx1"/>
+                </a:solidFill>
+              </a:rPr>
+              <a:t>One pipeline that scores, dedupes, and pushes leads to HubSpot, with a dashboard and replay.</a:t>
+            </a:r>
+            <a:endParaRPr lang="en-US" sz="1500" dirty="0"/>
+          </a:p>
+        </p:txBody>
+      </p:sp>
+      <p:sp>
+        <p:nvSpPr>
+          <p:cNvPr id="10" name="Shape 8"/>
+          <p:cNvSpPr/>
+          <p:nvPr/>
+        </p:nvSpPr>
+        <p:spPr>
+          <a:xfrm>
+            <a:off x="548640" y="3429000"/>
+            <a:ext cx="8046720" cy="0"/>
+          </a:xfrm>
+          <a:prstGeom prst="line">
+            <a:avLst/>
+          </a:prstGeom>
+          <a:noFill/>
+          <a:ln w="9525">
+            <a:solidFill>
+              <a:srgbClr val="E2E2E2"/>
+            </a:solidFill>
+            <a:prstDash val="solid"/>
+          </a:ln>
+        </p:spPr>
+      </p:sp>
+      <p:sp>
+        <p:nvSpPr>
+          <p:cNvPr id="11" name="Text 9"/>
+          <p:cNvSpPr txBox="1"/>
+          <p:nvPr/>
+        </p:nvSpPr>
+        <p:spPr>
+          <a:xfrm>
+            <a:off x="548640" y="3566160"/>
+            <a:ext cx="1828800" cy="201168"/>
+          </a:xfrm>
+          <a:prstGeom prst="rect">
+            <a:avLst/>
+          </a:prstGeom>
+          <a:noFill/>
+          <a:ln/>
+        </p:spPr>
+        <p:txBody>
+          <a:bodyPr wrap="square" lIns="0" tIns="0" rIns="0" bIns="0" rtlCol="0" anchor="t"/>
+          <a:lstStyle/>
+          <a:p>
+            <a:pPr indent="0" marL="0">
+              <a:buNone/>
+            </a:pPr>
+            <a:r>
+              <a:rPr lang="en-US" sz="800" spc="200" kern="0" dirty="0">
+                <a:solidFill>
+                  <a:schemeClr val="tx2"/>
+                </a:solidFill>
+                <a:latin typeface="Courier New" pitchFamily="34" charset="0"/>
+                <a:ea typeface="Courier New" pitchFamily="34" charset="-122"/>
+                <a:cs typeface="Courier New" pitchFamily="34" charset="-120"/>
+              </a:rPr>
+              <a:t>RESULT</a:t>
+            </a:r>
+            <a:endParaRPr lang="en-US" sz="800" dirty="0"/>
+          </a:p>
+        </p:txBody>
+      </p:sp>
+      <p:sp>
+        <p:nvSpPr>
+          <p:cNvPr id="12" name="Text 10"/>
+          <p:cNvSpPr txBox="1"/>
+          <p:nvPr/>
+        </p:nvSpPr>
+        <p:spPr>
+          <a:xfrm>
+            <a:off x="2560320" y="3538728"/>
+            <a:ext cx="6035040" cy="731520"/>
+          </a:xfrm>
+          <a:prstGeom prst="rect">
+            <a:avLst/>
+          </a:prstGeom>
+          <a:noFill/>
+          <a:ln/>
+        </p:spPr>
+        <p:txBody>
+          <a:bodyPr wrap="square" lIns="0" tIns="0" rIns="0" bIns="0" rtlCol="0" anchor="t"/>
+          <a:lstStyle/>
+          <a:p>
+            <a:pPr indent="0" marL="0">
+              <a:buNone/>
+            </a:pPr>
+            <a:r>
+              <a:rPr lang="en-US" sz="1500" dirty="0">
+                <a:solidFill>
+                  <a:schemeClr val="tx1"/>
+                </a:solidFill>
+              </a:rPr>
+              <a:t>Zapier is gone. Every lead has an audit trail. Million-dollar transactions run on it.</a:t>
+            </a:r>
+            <a:endParaRPr lang="en-US" sz="1500" dirty="0"/>
+          </a:p>
+        </p:txBody>
+      </p:sp>
+      <p:sp>
+        <p:nvSpPr>
+          <p:cNvPr id="13" name="Shape 11"/>
+          <p:cNvSpPr/>
+          <p:nvPr/>
+        </p:nvSpPr>
+        <p:spPr>
+          <a:xfrm>
+            <a:off x="548640" y="4343400"/>
+            <a:ext cx="8046720" cy="0"/>
+          </a:xfrm>
+          <a:prstGeom prst="line">
+            <a:avLst/>
+          </a:prstGeom>
+          <a:noFill/>
+          <a:ln w="9525">
+            <a:solidFill>
+              <a:srgbClr val="E2E2E2"/>
+            </a:solidFill>
+            <a:prstDash val="solid"/>
+          </a:ln>
+        </p:spPr>
+      </p:sp>
+    </p:spTree>
+  </p:cSld>
+  <p:clrMapOvr>
+    <a:masterClrMapping/>
+  </p:clrMapOvr>
+</p:sld>
+</file>
+
+<file path=ppt/slides/slide13.xml><?xml version="1.0" encoding="utf-8"?>
+<p:sld xmlns:a="http://schemas.openxmlformats.org/drawingml/2006/main" xmlns:r="http://schemas.openxmlformats.org/officeDocument/2006/relationships" xmlns:p="http://schemas.openxmlformats.org/presentationml/2006/main">
+  <p:cSld name="Slide 13">
+    <p:spTree>
+      <p:nvGrpSpPr>
+        <p:cNvPr id="1" name=""/>
+        <p:cNvGrpSpPr/>
+        <p:nvPr/>
+      </p:nvGrpSpPr>
+      <p:grpSpPr>
+        <a:xfrm>
+          <a:off x="0" y="0"/>
+          <a:ext cx="0" cy="0"/>
+          <a:chOff x="0" y="0"/>
+          <a:chExt cx="0" cy="0"/>
+        </a:xfrm>
+      </p:grpSpPr>
+      <p:sp>
+        <p:nvSpPr>
+          <p:cNvPr id="2" name="Text 0"/>
           <p:cNvSpPr txBox="1"/>
           <p:nvPr/>
         </p:nvSpPr>
@@ -4222,7 +4735,7 @@
                   <a:srgbClr val="161616"/>
                 </a:solidFill>
               </a:rPr>
-              <a:t>Three ways to work with us</a:t>
+              <a:t>Your team has ChatGPT. The best AI users work differently.</a:t>
             </a:r>
             <a:endParaRPr lang="en-US" sz="2800" dirty="0"/>
           </a:p>
@@ -4236,58 +4749,69 @@
         </p:nvSpPr>
         <p:spPr>
           <a:xfrm>
-            <a:off x="548640" y="1280160"/>
-            <a:ext cx="8046720" cy="365760"/>
-          </a:xfrm>
-          <a:prstGeom prst="rect">
-            <a:avLst/>
-          </a:prstGeom>
-          <a:noFill/>
-          <a:ln/>
-        </p:spPr>
-        <p:txBody>
-          <a:bodyPr wrap="square" lIns="0" tIns="0" rIns="0" bIns="0" rtlCol="0" anchor="t"/>
-          <a:lstStyle/>
-          <a:p>
-            <a:pPr indent="0" marL="0">
-              <a:buNone/>
-            </a:pPr>
-            <a:r>
-              <a:rPr lang="en-US" sz="1400" dirty="0">
+            <a:off x="548640" y="1600200"/>
+            <a:ext cx="8046720" cy="731520"/>
+          </a:xfrm>
+          <a:prstGeom prst="rect">
+            <a:avLst/>
+          </a:prstGeom>
+          <a:noFill/>
+          <a:ln/>
+        </p:spPr>
+        <p:txBody>
+          <a:bodyPr wrap="square" lIns="0" tIns="0" rIns="0" bIns="0" rtlCol="0" anchor="t"/>
+          <a:lstStyle/>
+          <a:p>
+            <a:pPr indent="0" marL="0">
+              <a:buNone/>
+            </a:pPr>
+            <a:r>
+              <a:rPr lang="en-US" sz="2200" dirty="0">
                 <a:solidFill>
                   <a:schemeClr val="tx2"/>
                 </a:solidFill>
               </a:rPr>
-              <a:t>Your team builds. We teach, review, and support it after.</a:t>
-            </a:r>
-            <a:endParaRPr lang="en-US" sz="1400" dirty="0"/>
-          </a:p>
-        </p:txBody>
-      </p:sp>
-      <p:sp>
-        <p:nvSpPr>
-          <p:cNvPr id="4" name="Shape 2"/>
-          <p:cNvSpPr/>
-          <p:nvPr/>
-        </p:nvSpPr>
-        <p:spPr>
-          <a:xfrm>
-            <a:off x="548640" y="1828800"/>
-            <a:ext cx="2560320" cy="2651760"/>
-          </a:xfrm>
-          <a:prstGeom prst="rect">
-            <a:avLst/>
-          </a:prstGeom>
-          <a:solidFill>
-            <a:srgbClr val="F4F4F4"/>
-          </a:solidFill>
-          <a:ln w="12700">
-            <a:solidFill>
-              <a:srgbClr val="F4F4F4"/>
-            </a:solidFill>
-            <a:prstDash val="solid"/>
-          </a:ln>
-        </p:spPr>
+              <a:t>Most teams use AI like a search box.</a:t>
+            </a:r>
+            <a:endParaRPr lang="en-US" sz="2200" dirty="0"/>
+          </a:p>
+        </p:txBody>
+      </p:sp>
+      <p:sp>
+        <p:nvSpPr>
+          <p:cNvPr id="4" name="Text 2"/>
+          <p:cNvSpPr txBox="1"/>
+          <p:nvPr/>
+        </p:nvSpPr>
+        <p:spPr>
+          <a:xfrm>
+            <a:off x="548640" y="2468880"/>
+            <a:ext cx="8046720" cy="731520"/>
+          </a:xfrm>
+          <a:prstGeom prst="rect">
+            <a:avLst/>
+          </a:prstGeom>
+          <a:noFill/>
+          <a:ln/>
+        </p:spPr>
+        <p:txBody>
+          <a:bodyPr wrap="square" lIns="0" tIns="0" rIns="0" bIns="0" rtlCol="0" anchor="t"/>
+          <a:lstStyle/>
+          <a:p>
+            <a:pPr indent="0" marL="0">
+              <a:buNone/>
+            </a:pPr>
+            <a:r>
+              <a:rPr lang="en-US" sz="2200" dirty="0">
+                <a:solidFill>
+                  <a:schemeClr val="tx2"/>
+                </a:solidFill>
+              </a:rPr>
+              <a:t>The best users run Claude Code and Codex, hand work to agents, and script the rest.</a:t>
+            </a:r>
+            <a:endParaRPr lang="en-US" sz="2200" dirty="0"/>
+          </a:p>
+        </p:txBody>
       </p:sp>
       <p:sp>
         <p:nvSpPr>
@@ -4297,612 +4821,31 @@
         </p:nvSpPr>
         <p:spPr>
           <a:xfrm>
-            <a:off x="777240" y="2057400"/>
-            <a:ext cx="2103120" cy="201168"/>
-          </a:xfrm>
-          <a:prstGeom prst="rect">
-            <a:avLst/>
-          </a:prstGeom>
-          <a:noFill/>
-          <a:ln/>
-        </p:spPr>
-        <p:txBody>
-          <a:bodyPr wrap="square" lIns="0" tIns="0" rIns="0" bIns="0" rtlCol="0" anchor="t"/>
-          <a:lstStyle/>
-          <a:p>
-            <a:pPr indent="0" marL="0">
-              <a:buNone/>
-            </a:pPr>
-            <a:r>
-              <a:rPr lang="en-US" sz="800" spc="100" kern="0" dirty="0">
-                <a:solidFill>
-                  <a:schemeClr val="tx2"/>
-                </a:solidFill>
-                <a:latin typeface="Courier New" pitchFamily="34" charset="0"/>
-                <a:ea typeface="Courier New" pitchFamily="34" charset="-122"/>
-                <a:cs typeface="Courier New" pitchFamily="34" charset="-120"/>
-              </a:rPr>
-              <a:t>1 DAY</a:t>
-            </a:r>
-            <a:endParaRPr lang="en-US" sz="800" dirty="0"/>
-          </a:p>
-        </p:txBody>
-      </p:sp>
-      <p:sp>
-        <p:nvSpPr>
-          <p:cNvPr id="6" name="Text 4"/>
-          <p:cNvSpPr txBox="1"/>
-          <p:nvPr/>
-        </p:nvSpPr>
-        <p:spPr>
-          <a:xfrm>
-            <a:off x="777240" y="2331720"/>
-            <a:ext cx="2103120" cy="365760"/>
-          </a:xfrm>
-          <a:prstGeom prst="rect">
-            <a:avLst/>
-          </a:prstGeom>
-          <a:noFill/>
-          <a:ln/>
-        </p:spPr>
-        <p:txBody>
-          <a:bodyPr wrap="square" lIns="0" tIns="0" rIns="0" bIns="0" rtlCol="0" anchor="t"/>
-          <a:lstStyle/>
-          <a:p>
-            <a:pPr indent="0" marL="0">
-              <a:buNone/>
-            </a:pPr>
-            <a:r>
-              <a:rPr lang="en-US" sz="1600" b="1" dirty="0">
+            <a:off x="548640" y="3337560"/>
+            <a:ext cx="8046720" cy="731520"/>
+          </a:xfrm>
+          <a:prstGeom prst="rect">
+            <a:avLst/>
+          </a:prstGeom>
+          <a:noFill/>
+          <a:ln/>
+        </p:spPr>
+        <p:txBody>
+          <a:bodyPr wrap="square" lIns="0" tIns="0" rIns="0" bIns="0" rtlCol="0" anchor="t"/>
+          <a:lstStyle/>
+          <a:p>
+            <a:pPr indent="0" marL="0">
+              <a:buNone/>
+            </a:pPr>
+            <a:r>
+              <a:rPr lang="en-US" sz="2200" dirty="0">
                 <a:solidFill>
                   <a:schemeClr val="tx1"/>
                 </a:solidFill>
               </a:rPr>
-              <a:t>One-day workshop</a:t>
-            </a:r>
-            <a:endParaRPr lang="en-US" sz="1600" dirty="0"/>
-          </a:p>
-        </p:txBody>
-      </p:sp>
-      <p:sp>
-        <p:nvSpPr>
-          <p:cNvPr id="7" name="Text 5"/>
-          <p:cNvSpPr txBox="1"/>
-          <p:nvPr/>
-        </p:nvSpPr>
-        <p:spPr>
-          <a:xfrm>
-            <a:off x="777240" y="2697480"/>
-            <a:ext cx="2103120" cy="274320"/>
-          </a:xfrm>
-          <a:prstGeom prst="rect">
-            <a:avLst/>
-          </a:prstGeom>
-          <a:noFill/>
-          <a:ln/>
-        </p:spPr>
-        <p:txBody>
-          <a:bodyPr wrap="square" lIns="0" tIns="0" rIns="0" bIns="0" rtlCol="0" anchor="t"/>
-          <a:lstStyle/>
-          <a:p>
-            <a:pPr indent="0" marL="0">
-              <a:buNone/>
-            </a:pPr>
-            <a:r>
-              <a:rPr lang="en-US" sz="900" dirty="0">
-                <a:solidFill>
-                  <a:schemeClr val="tx2"/>
-                </a:solidFill>
-                <a:latin typeface="Courier New" pitchFamily="34" charset="0"/>
-                <a:ea typeface="Courier New" pitchFamily="34" charset="-122"/>
-                <a:cs typeface="Courier New" pitchFamily="34" charset="-120"/>
-              </a:rPr>
-              <a:t>In person, at your office</a:t>
-            </a:r>
-            <a:endParaRPr lang="en-US" sz="900" dirty="0"/>
-          </a:p>
-        </p:txBody>
-      </p:sp>
-      <p:sp>
-        <p:nvSpPr>
-          <p:cNvPr id="8" name="Text 6"/>
-          <p:cNvSpPr txBox="1"/>
-          <p:nvPr/>
-        </p:nvSpPr>
-        <p:spPr>
-          <a:xfrm>
-            <a:off x="777240" y="3063240"/>
-            <a:ext cx="2103120" cy="1005840"/>
-          </a:xfrm>
-          <a:prstGeom prst="rect">
-            <a:avLst/>
-          </a:prstGeom>
-          <a:noFill/>
-          <a:ln/>
-        </p:spPr>
-        <p:txBody>
-          <a:bodyPr wrap="square" lIns="0" tIns="0" rIns="0" bIns="0" rtlCol="0" anchor="t"/>
-          <a:lstStyle/>
-          <a:p>
-            <a:pPr indent="0" marL="0">
-              <a:buNone/>
-            </a:pPr>
-            <a:r>
-              <a:rPr lang="en-US" sz="1100" dirty="0">
-                <a:solidFill>
-                  <a:schemeClr val="tx1"/>
-                </a:solidFill>
-              </a:rPr>
-              <a:t>Map your operations, pick the first three systems worth building, and leave with a plan and a working prototype of one.</a:t>
-            </a:r>
-            <a:endParaRPr lang="en-US" sz="1100" dirty="0"/>
-          </a:p>
-        </p:txBody>
-      </p:sp>
-      <p:sp>
-        <p:nvSpPr>
-          <p:cNvPr id="9" name="Text 7"/>
-          <p:cNvSpPr txBox="1"/>
-          <p:nvPr/>
-        </p:nvSpPr>
-        <p:spPr>
-          <a:xfrm>
-            <a:off x="777240" y="3977640"/>
-            <a:ext cx="2103120" cy="365760"/>
-          </a:xfrm>
-          <a:prstGeom prst="rect">
-            <a:avLst/>
-          </a:prstGeom>
-          <a:noFill/>
-          <a:ln/>
-        </p:spPr>
-        <p:txBody>
-          <a:bodyPr wrap="square" lIns="0" tIns="0" rIns="0" bIns="0" rtlCol="0" anchor="t"/>
-          <a:lstStyle/>
-          <a:p>
-            <a:pPr indent="0" marL="0">
-              <a:buNone/>
-            </a:pPr>
-            <a:r>
-              <a:rPr lang="en-US" sz="1800" dirty="0">
-                <a:solidFill>
-                  <a:schemeClr val="tx1"/>
-                </a:solidFill>
-                <a:latin typeface="Courier New" pitchFamily="34" charset="0"/>
-                <a:ea typeface="Courier New" pitchFamily="34" charset="-122"/>
-                <a:cs typeface="Courier New" pitchFamily="34" charset="-120"/>
-              </a:rPr>
-              <a:t>$15,000</a:t>
-            </a:r>
-            <a:endParaRPr lang="en-US" sz="1800" dirty="0"/>
-          </a:p>
-        </p:txBody>
-      </p:sp>
-      <p:sp>
-        <p:nvSpPr>
-          <p:cNvPr id="10" name="Shape 8"/>
-          <p:cNvSpPr/>
-          <p:nvPr/>
-        </p:nvSpPr>
-        <p:spPr>
-          <a:xfrm>
-            <a:off x="3291840" y="1828800"/>
-            <a:ext cx="2560320" cy="2651760"/>
-          </a:xfrm>
-          <a:prstGeom prst="rect">
-            <a:avLst/>
-          </a:prstGeom>
-          <a:solidFill>
-            <a:srgbClr val="F4F4F4"/>
-          </a:solidFill>
-          <a:ln w="12700">
-            <a:solidFill>
-              <a:srgbClr val="F4F4F4"/>
-            </a:solidFill>
-            <a:prstDash val="solid"/>
-          </a:ln>
-        </p:spPr>
-      </p:sp>
-      <p:sp>
-        <p:nvSpPr>
-          <p:cNvPr id="11" name="Text 9"/>
-          <p:cNvSpPr txBox="1"/>
-          <p:nvPr/>
-        </p:nvSpPr>
-        <p:spPr>
-          <a:xfrm>
-            <a:off x="3520440" y="2057400"/>
-            <a:ext cx="2103120" cy="201168"/>
-          </a:xfrm>
-          <a:prstGeom prst="rect">
-            <a:avLst/>
-          </a:prstGeom>
-          <a:noFill/>
-          <a:ln/>
-        </p:spPr>
-        <p:txBody>
-          <a:bodyPr wrap="square" lIns="0" tIns="0" rIns="0" bIns="0" rtlCol="0" anchor="t"/>
-          <a:lstStyle/>
-          <a:p>
-            <a:pPr indent="0" marL="0">
-              <a:buNone/>
-            </a:pPr>
-            <a:r>
-              <a:rPr lang="en-US" sz="800" spc="100" kern="0" dirty="0">
-                <a:solidFill>
-                  <a:schemeClr val="tx2"/>
-                </a:solidFill>
-                <a:latin typeface="Courier New" pitchFamily="34" charset="0"/>
-                <a:ea typeface="Courier New" pitchFamily="34" charset="-122"/>
-                <a:cs typeface="Courier New" pitchFamily="34" charset="-120"/>
-              </a:rPr>
-              <a:t>3 DAYS, 4 HOURS PER DAY</a:t>
-            </a:r>
-            <a:endParaRPr lang="en-US" sz="800" dirty="0"/>
-          </a:p>
-        </p:txBody>
-      </p:sp>
-      <p:sp>
-        <p:nvSpPr>
-          <p:cNvPr id="12" name="Text 10"/>
-          <p:cNvSpPr txBox="1"/>
-          <p:nvPr/>
-        </p:nvSpPr>
-        <p:spPr>
-          <a:xfrm>
-            <a:off x="3520440" y="2331720"/>
-            <a:ext cx="2103120" cy="365760"/>
-          </a:xfrm>
-          <a:prstGeom prst="rect">
-            <a:avLst/>
-          </a:prstGeom>
-          <a:noFill/>
-          <a:ln/>
-        </p:spPr>
-        <p:txBody>
-          <a:bodyPr wrap="square" lIns="0" tIns="0" rIns="0" bIns="0" rtlCol="0" anchor="t"/>
-          <a:lstStyle/>
-          <a:p>
-            <a:pPr indent="0" marL="0">
-              <a:buNone/>
-            </a:pPr>
-            <a:r>
-              <a:rPr lang="en-US" sz="1600" b="1" dirty="0">
-                <a:solidFill>
-                  <a:schemeClr val="tx1"/>
-                </a:solidFill>
-              </a:rPr>
-              <a:t>Three-day intensive</a:t>
-            </a:r>
-            <a:endParaRPr lang="en-US" sz="1600" dirty="0"/>
-          </a:p>
-        </p:txBody>
-      </p:sp>
-      <p:sp>
-        <p:nvSpPr>
-          <p:cNvPr id="13" name="Text 11"/>
-          <p:cNvSpPr txBox="1"/>
-          <p:nvPr/>
-        </p:nvSpPr>
-        <p:spPr>
-          <a:xfrm>
-            <a:off x="3520440" y="2697480"/>
-            <a:ext cx="2103120" cy="274320"/>
-          </a:xfrm>
-          <a:prstGeom prst="rect">
-            <a:avLst/>
-          </a:prstGeom>
-          <a:noFill/>
-          <a:ln/>
-        </p:spPr>
-        <p:txBody>
-          <a:bodyPr wrap="square" lIns="0" tIns="0" rIns="0" bIns="0" rtlCol="0" anchor="t"/>
-          <a:lstStyle/>
-          <a:p>
-            <a:pPr indent="0" marL="0">
-              <a:buNone/>
-            </a:pPr>
-            <a:r>
-              <a:rPr lang="en-US" sz="900" dirty="0">
-                <a:solidFill>
-                  <a:schemeClr val="tx2"/>
-                </a:solidFill>
-                <a:latin typeface="Courier New" pitchFamily="34" charset="0"/>
-                <a:ea typeface="Courier New" pitchFamily="34" charset="-122"/>
-                <a:cs typeface="Courier New" pitchFamily="34" charset="-120"/>
-              </a:rPr>
-              <a:t>Remote, over Zoom</a:t>
-            </a:r>
-            <a:endParaRPr lang="en-US" sz="900" dirty="0"/>
-          </a:p>
-        </p:txBody>
-      </p:sp>
-      <p:sp>
-        <p:nvSpPr>
-          <p:cNvPr id="14" name="Text 12"/>
-          <p:cNvSpPr txBox="1"/>
-          <p:nvPr/>
-        </p:nvSpPr>
-        <p:spPr>
-          <a:xfrm>
-            <a:off x="3520440" y="3063240"/>
-            <a:ext cx="2103120" cy="1005840"/>
-          </a:xfrm>
-          <a:prstGeom prst="rect">
-            <a:avLst/>
-          </a:prstGeom>
-          <a:noFill/>
-          <a:ln/>
-        </p:spPr>
-        <p:txBody>
-          <a:bodyPr wrap="square" lIns="0" tIns="0" rIns="0" bIns="0" rtlCol="0" anchor="t"/>
-          <a:lstStyle/>
-          <a:p>
-            <a:pPr indent="0" marL="0">
-              <a:buNone/>
-            </a:pPr>
-            <a:r>
-              <a:rPr lang="en-US" sz="1100" dirty="0">
-                <a:solidFill>
-                  <a:schemeClr val="tx1"/>
-                </a:solidFill>
-              </a:rPr>
-              <a:t>Build a working AI system against your real data: LLM APIs, integrations, human handoff, and deployment.</a:t>
-            </a:r>
-            <a:endParaRPr lang="en-US" sz="1100" dirty="0"/>
-          </a:p>
-        </p:txBody>
-      </p:sp>
-      <p:sp>
-        <p:nvSpPr>
-          <p:cNvPr id="15" name="Text 13"/>
-          <p:cNvSpPr txBox="1"/>
-          <p:nvPr/>
-        </p:nvSpPr>
-        <p:spPr>
-          <a:xfrm>
-            <a:off x="3520440" y="3977640"/>
-            <a:ext cx="2103120" cy="365760"/>
-          </a:xfrm>
-          <a:prstGeom prst="rect">
-            <a:avLst/>
-          </a:prstGeom>
-          <a:noFill/>
-          <a:ln/>
-        </p:spPr>
-        <p:txBody>
-          <a:bodyPr wrap="square" lIns="0" tIns="0" rIns="0" bIns="0" rtlCol="0" anchor="t"/>
-          <a:lstStyle/>
-          <a:p>
-            <a:pPr indent="0" marL="0">
-              <a:buNone/>
-            </a:pPr>
-            <a:r>
-              <a:rPr lang="en-US" sz="1800" dirty="0">
-                <a:solidFill>
-                  <a:schemeClr val="tx1"/>
-                </a:solidFill>
-                <a:latin typeface="Courier New" pitchFamily="34" charset="0"/>
-                <a:ea typeface="Courier New" pitchFamily="34" charset="-122"/>
-                <a:cs typeface="Courier New" pitchFamily="34" charset="-120"/>
-              </a:rPr>
-              <a:t>$7,500</a:t>
-            </a:r>
-            <a:endParaRPr lang="en-US" sz="1800" dirty="0"/>
-          </a:p>
-        </p:txBody>
-      </p:sp>
-      <p:sp>
-        <p:nvSpPr>
-          <p:cNvPr id="16" name="Shape 14"/>
-          <p:cNvSpPr/>
-          <p:nvPr/>
-        </p:nvSpPr>
-        <p:spPr>
-          <a:xfrm>
-            <a:off x="6035040" y="1828800"/>
-            <a:ext cx="2560320" cy="2651760"/>
-          </a:xfrm>
-          <a:prstGeom prst="rect">
-            <a:avLst/>
-          </a:prstGeom>
-          <a:solidFill>
-            <a:srgbClr val="F4F4F4"/>
-          </a:solidFill>
-          <a:ln w="12700">
-            <a:solidFill>
-              <a:srgbClr val="F4F4F4"/>
-            </a:solidFill>
-            <a:prstDash val="solid"/>
-          </a:ln>
-        </p:spPr>
-      </p:sp>
-      <p:sp>
-        <p:nvSpPr>
-          <p:cNvPr id="17" name="Text 15"/>
-          <p:cNvSpPr txBox="1"/>
-          <p:nvPr/>
-        </p:nvSpPr>
-        <p:spPr>
-          <a:xfrm>
-            <a:off x="6263640" y="2057400"/>
-            <a:ext cx="2103120" cy="201168"/>
-          </a:xfrm>
-          <a:prstGeom prst="rect">
-            <a:avLst/>
-          </a:prstGeom>
-          <a:noFill/>
-          <a:ln/>
-        </p:spPr>
-        <p:txBody>
-          <a:bodyPr wrap="square" lIns="0" tIns="0" rIns="0" bIns="0" rtlCol="0" anchor="t"/>
-          <a:lstStyle/>
-          <a:p>
-            <a:pPr indent="0" marL="0">
-              <a:buNone/>
-            </a:pPr>
-            <a:r>
-              <a:rPr lang="en-US" sz="800" spc="100" kern="0" dirty="0">
-                <a:solidFill>
-                  <a:schemeClr val="tx2"/>
-                </a:solidFill>
-                <a:latin typeface="Courier New" pitchFamily="34" charset="0"/>
-                <a:ea typeface="Courier New" pitchFamily="34" charset="-122"/>
-                <a:cs typeface="Courier New" pitchFamily="34" charset="-120"/>
-              </a:rPr>
-              <a:t>8 WEEKS</a:t>
-            </a:r>
-            <a:endParaRPr lang="en-US" sz="800" dirty="0"/>
-          </a:p>
-        </p:txBody>
-      </p:sp>
-      <p:sp>
-        <p:nvSpPr>
-          <p:cNvPr id="18" name="Text 16"/>
-          <p:cNvSpPr txBox="1"/>
-          <p:nvPr/>
-        </p:nvSpPr>
-        <p:spPr>
-          <a:xfrm>
-            <a:off x="6263640" y="2331720"/>
-            <a:ext cx="2103120" cy="365760"/>
-          </a:xfrm>
-          <a:prstGeom prst="rect">
-            <a:avLst/>
-          </a:prstGeom>
-          <a:noFill/>
-          <a:ln/>
-        </p:spPr>
-        <p:txBody>
-          <a:bodyPr wrap="square" lIns="0" tIns="0" rIns="0" bIns="0" rtlCol="0" anchor="t"/>
-          <a:lstStyle/>
-          <a:p>
-            <a:pPr indent="0" marL="0">
-              <a:buNone/>
-            </a:pPr>
-            <a:r>
-              <a:rPr lang="en-US" sz="1600" b="1" dirty="0">
-                <a:solidFill>
-                  <a:schemeClr val="tx1"/>
-                </a:solidFill>
-              </a:rPr>
-              <a:t>Eight-week cohort</a:t>
-            </a:r>
-            <a:endParaRPr lang="en-US" sz="1600" dirty="0"/>
-          </a:p>
-        </p:txBody>
-      </p:sp>
-      <p:sp>
-        <p:nvSpPr>
-          <p:cNvPr id="19" name="Text 17"/>
-          <p:cNvSpPr txBox="1"/>
-          <p:nvPr/>
-        </p:nvSpPr>
-        <p:spPr>
-          <a:xfrm>
-            <a:off x="6263640" y="2697480"/>
-            <a:ext cx="2103120" cy="274320"/>
-          </a:xfrm>
-          <a:prstGeom prst="rect">
-            <a:avLst/>
-          </a:prstGeom>
-          <a:noFill/>
-          <a:ln/>
-        </p:spPr>
-        <p:txBody>
-          <a:bodyPr wrap="square" lIns="0" tIns="0" rIns="0" bIns="0" rtlCol="0" anchor="t"/>
-          <a:lstStyle/>
-          <a:p>
-            <a:pPr indent="0" marL="0">
-              <a:buNone/>
-            </a:pPr>
-            <a:r>
-              <a:rPr lang="en-US" sz="900" dirty="0">
-                <a:solidFill>
-                  <a:schemeClr val="tx2"/>
-                </a:solidFill>
-                <a:latin typeface="Courier New" pitchFamily="34" charset="0"/>
-                <a:ea typeface="Courier New" pitchFamily="34" charset="-122"/>
-                <a:cs typeface="Courier New" pitchFamily="34" charset="-120"/>
-              </a:rPr>
-              <a:t>On site or remote</a:t>
-            </a:r>
-            <a:endParaRPr lang="en-US" sz="900" dirty="0"/>
-          </a:p>
-        </p:txBody>
-      </p:sp>
-      <p:sp>
-        <p:nvSpPr>
-          <p:cNvPr id="20" name="Text 18"/>
-          <p:cNvSpPr txBox="1"/>
-          <p:nvPr/>
-        </p:nvSpPr>
-        <p:spPr>
-          <a:xfrm>
-            <a:off x="6263640" y="3063240"/>
-            <a:ext cx="2103120" cy="1005840"/>
-          </a:xfrm>
-          <a:prstGeom prst="rect">
-            <a:avLst/>
-          </a:prstGeom>
-          <a:noFill/>
-          <a:ln/>
-        </p:spPr>
-        <p:txBody>
-          <a:bodyPr wrap="square" lIns="0" tIns="0" rIns="0" bIns="0" rtlCol="0" anchor="t"/>
-          <a:lstStyle/>
-          <a:p>
-            <a:pPr indent="0" marL="0">
-              <a:buNone/>
-            </a:pPr>
-            <a:r>
-              <a:rPr lang="en-US" sz="1100" dirty="0">
-                <a:solidFill>
-                  <a:schemeClr val="tx1"/>
-                </a:solidFill>
-              </a:rPr>
-              <a:t>One system shipped to production inside your company, owned and understood by the people who built it.</a:t>
-            </a:r>
-            <a:endParaRPr lang="en-US" sz="1100" dirty="0"/>
-          </a:p>
-        </p:txBody>
-      </p:sp>
-      <p:sp>
-        <p:nvSpPr>
-          <p:cNvPr id="21" name="Text 19"/>
-          <p:cNvSpPr txBox="1"/>
-          <p:nvPr/>
-        </p:nvSpPr>
-        <p:spPr>
-          <a:xfrm>
-            <a:off x="6263640" y="3977640"/>
-            <a:ext cx="2103120" cy="365760"/>
-          </a:xfrm>
-          <a:prstGeom prst="rect">
-            <a:avLst/>
-          </a:prstGeom>
-          <a:noFill/>
-          <a:ln/>
-        </p:spPr>
-        <p:txBody>
-          <a:bodyPr wrap="square" lIns="0" tIns="0" rIns="0" bIns="0" rtlCol="0" anchor="t"/>
-          <a:lstStyle/>
-          <a:p>
-            <a:pPr indent="0" marL="0">
-              <a:buNone/>
-            </a:pPr>
-            <a:r>
-              <a:rPr lang="en-US" sz="1800" dirty="0">
-                <a:solidFill>
-                  <a:schemeClr val="tx1"/>
-                </a:solidFill>
-                <a:latin typeface="Courier New" pitchFamily="34" charset="0"/>
-                <a:ea typeface="Courier New" pitchFamily="34" charset="-122"/>
-                <a:cs typeface="Courier New" pitchFamily="34" charset="-120"/>
-              </a:rPr>
-              <a:t>$50,000</a:t>
-            </a:r>
-            <a:endParaRPr lang="en-US" sz="1800" dirty="0"/>
+              <a:t>We teach that way of working on your team’s real tasks.</a:t>
+            </a:r>
+            <a:endParaRPr lang="en-US" sz="2200" dirty="0"/>
           </a:p>
         </p:txBody>
       </p:sp>
@@ -4963,7 +4906,7 @@
                   <a:srgbClr val="161616"/>
                 </a:solidFill>
               </a:rPr>
-              <a:t>What your team can do after</a:t>
+              <a:t>Three ways to work with us</a:t>
             </a:r>
             <a:endParaRPr lang="en-US" sz="2800" dirty="0"/>
           </a:p>
@@ -4971,22 +4914,60 @@
       </p:sp>
       <p:sp>
         <p:nvSpPr>
-          <p:cNvPr id="3" name="Shape 1"/>
+          <p:cNvPr id="3" name="Text 1"/>
+          <p:cNvSpPr txBox="1"/>
+          <p:nvPr/>
+        </p:nvSpPr>
+        <p:spPr>
+          <a:xfrm>
+            <a:off x="548640" y="1280160"/>
+            <a:ext cx="8046720" cy="365760"/>
+          </a:xfrm>
+          <a:prstGeom prst="rect">
+            <a:avLst/>
+          </a:prstGeom>
+          <a:noFill/>
+          <a:ln/>
+        </p:spPr>
+        <p:txBody>
+          <a:bodyPr wrap="square" lIns="0" tIns="0" rIns="0" bIns="0" rtlCol="0" anchor="t"/>
+          <a:lstStyle/>
+          <a:p>
+            <a:pPr indent="0" marL="0">
+              <a:buNone/>
+            </a:pPr>
+            <a:r>
+              <a:rPr lang="en-US" sz="1400" dirty="0">
+                <a:solidFill>
+                  <a:schemeClr val="tx2"/>
+                </a:solidFill>
+              </a:rPr>
+              <a:t>Your team builds. We teach, review, and support it after.</a:t>
+            </a:r>
+            <a:endParaRPr lang="en-US" sz="1400" dirty="0"/>
+          </a:p>
+        </p:txBody>
+      </p:sp>
+      <p:sp>
+        <p:nvSpPr>
+          <p:cNvPr id="4" name="Shape 2"/>
           <p:cNvSpPr/>
           <p:nvPr/>
         </p:nvSpPr>
         <p:spPr>
           <a:xfrm>
-            <a:off x="548640" y="1554480"/>
-            <a:ext cx="8046720" cy="0"/>
-          </a:xfrm>
-          <a:prstGeom prst="line">
-            <a:avLst/>
-          </a:prstGeom>
-          <a:noFill/>
+            <a:off x="548640" y="1828800"/>
+            <a:ext cx="2560320" cy="2651760"/>
+          </a:xfrm>
+          <a:prstGeom prst="rect">
+            <a:avLst/>
+          </a:prstGeom>
+          <a:solidFill>
+            <a:srgbClr val="F4F4F4"/>
+          </a:solidFill>
           <a:ln w="12700">
             <a:solidFill>
-              <a:srgbClr val="161616"/>
+              <a:srgbClr val="F4F4F4"/>
             </a:solidFill>
             <a:prstDash val="solid"/>
           </a:ln>
@@ -4994,30 +4975,30 @@
       </p:sp>
       <p:sp>
         <p:nvSpPr>
-          <p:cNvPr id="4" name="Text 2"/>
-          <p:cNvSpPr txBox="1"/>
-          <p:nvPr/>
-        </p:nvSpPr>
-        <p:spPr>
-          <a:xfrm>
-            <a:off x="548640" y="1664208"/>
-            <a:ext cx="365760" cy="411480"/>
-          </a:xfrm>
-          <a:prstGeom prst="rect">
-            <a:avLst/>
-          </a:prstGeom>
-          <a:noFill/>
-          <a:ln/>
-        </p:spPr>
-        <p:txBody>
-          <a:bodyPr wrap="square" lIns="0" tIns="0" rIns="0" bIns="0" rtlCol="0" anchor="t"/>
-          <a:lstStyle/>
-          <a:p>
-            <a:pPr indent="0" marL="0">
-              <a:buNone/>
-            </a:pPr>
-            <a:r>
-              <a:rPr lang="en-US" sz="900" dirty="0">
+          <p:cNvPr id="5" name="Text 3"/>
+          <p:cNvSpPr txBox="1"/>
+          <p:nvPr/>
+        </p:nvSpPr>
+        <p:spPr>
+          <a:xfrm>
+            <a:off x="777240" y="2057400"/>
+            <a:ext cx="2103120" cy="201168"/>
+          </a:xfrm>
+          <a:prstGeom prst="rect">
+            <a:avLst/>
+          </a:prstGeom>
+          <a:noFill/>
+          <a:ln/>
+        </p:spPr>
+        <p:txBody>
+          <a:bodyPr wrap="square" lIns="0" tIns="0" rIns="0" bIns="0" rtlCol="0" anchor="t"/>
+          <a:lstStyle/>
+          <a:p>
+            <a:pPr indent="0" marL="0">
+              <a:buNone/>
+            </a:pPr>
+            <a:r>
+              <a:rPr lang="en-US" sz="800" spc="100" kern="0" dirty="0">
                 <a:solidFill>
                   <a:schemeClr val="tx2"/>
                 </a:solidFill>
@@ -5025,7 +5006,82 @@
                 <a:ea typeface="Courier New" pitchFamily="34" charset="-122"/>
                 <a:cs typeface="Courier New" pitchFamily="34" charset="-120"/>
               </a:rPr>
-              <a:t>01</a:t>
+              <a:t>1 DAY</a:t>
+            </a:r>
+            <a:endParaRPr lang="en-US" sz="800" dirty="0"/>
+          </a:p>
+        </p:txBody>
+      </p:sp>
+      <p:sp>
+        <p:nvSpPr>
+          <p:cNvPr id="6" name="Text 4"/>
+          <p:cNvSpPr txBox="1"/>
+          <p:nvPr/>
+        </p:nvSpPr>
+        <p:spPr>
+          <a:xfrm>
+            <a:off x="777240" y="2331720"/>
+            <a:ext cx="2103120" cy="365760"/>
+          </a:xfrm>
+          <a:prstGeom prst="rect">
+            <a:avLst/>
+          </a:prstGeom>
+          <a:noFill/>
+          <a:ln/>
+        </p:spPr>
+        <p:txBody>
+          <a:bodyPr wrap="square" lIns="0" tIns="0" rIns="0" bIns="0" rtlCol="0" anchor="t"/>
+          <a:lstStyle/>
+          <a:p>
+            <a:pPr indent="0" marL="0">
+              <a:buNone/>
+            </a:pPr>
+            <a:r>
+              <a:rPr lang="en-US" sz="1600" b="1" dirty="0">
+                <a:solidFill>
+                  <a:schemeClr val="tx1"/>
+                </a:solidFill>
+              </a:rPr>
+              <a:t>One-day workshop</a:t>
+            </a:r>
+            <a:endParaRPr lang="en-US" sz="1600" dirty="0"/>
+          </a:p>
+        </p:txBody>
+      </p:sp>
+      <p:sp>
+        <p:nvSpPr>
+          <p:cNvPr id="7" name="Text 5"/>
+          <p:cNvSpPr txBox="1"/>
+          <p:nvPr/>
+        </p:nvSpPr>
+        <p:spPr>
+          <a:xfrm>
+            <a:off x="777240" y="2697480"/>
+            <a:ext cx="2103120" cy="274320"/>
+          </a:xfrm>
+          <a:prstGeom prst="rect">
+            <a:avLst/>
+          </a:prstGeom>
+          <a:noFill/>
+          <a:ln/>
+        </p:spPr>
+        <p:txBody>
+          <a:bodyPr wrap="square" lIns="0" tIns="0" rIns="0" bIns="0" rtlCol="0" anchor="t"/>
+          <a:lstStyle/>
+          <a:p>
+            <a:pPr indent="0" marL="0">
+              <a:buNone/>
+            </a:pPr>
+            <a:r>
+              <a:rPr lang="en-US" sz="900" dirty="0">
+                <a:solidFill>
+                  <a:schemeClr val="tx2"/>
+                </a:solidFill>
+                <a:latin typeface="Courier New" pitchFamily="34" charset="0"/>
+                <a:ea typeface="Courier New" pitchFamily="34" charset="-122"/>
+                <a:cs typeface="Courier New" pitchFamily="34" charset="-120"/>
+              </a:rPr>
+              <a:t>In person, at your office</a:t>
             </a:r>
             <a:endParaRPr lang="en-US" sz="900" dirty="0"/>
           </a:p>
@@ -5033,58 +5089,99 @@
       </p:sp>
       <p:sp>
         <p:nvSpPr>
-          <p:cNvPr id="5" name="Text 3"/>
-          <p:cNvSpPr txBox="1"/>
-          <p:nvPr/>
-        </p:nvSpPr>
-        <p:spPr>
-          <a:xfrm>
-            <a:off x="1005840" y="1645920"/>
-            <a:ext cx="7589520" cy="411480"/>
-          </a:xfrm>
-          <a:prstGeom prst="rect">
-            <a:avLst/>
-          </a:prstGeom>
-          <a:noFill/>
-          <a:ln/>
-        </p:spPr>
-        <p:txBody>
-          <a:bodyPr wrap="square" lIns="0" tIns="0" rIns="0" bIns="0" rtlCol="0" anchor="t"/>
-          <a:lstStyle/>
-          <a:p>
-            <a:pPr indent="0" marL="0">
-              <a:buNone/>
-            </a:pPr>
-            <a:r>
-              <a:rPr lang="en-US" sz="1400" dirty="0">
+          <p:cNvPr id="8" name="Text 6"/>
+          <p:cNvSpPr txBox="1"/>
+          <p:nvPr/>
+        </p:nvSpPr>
+        <p:spPr>
+          <a:xfrm>
+            <a:off x="777240" y="3063240"/>
+            <a:ext cx="2103120" cy="1005840"/>
+          </a:xfrm>
+          <a:prstGeom prst="rect">
+            <a:avLst/>
+          </a:prstGeom>
+          <a:noFill/>
+          <a:ln/>
+        </p:spPr>
+        <p:txBody>
+          <a:bodyPr wrap="square" lIns="0" tIns="0" rIns="0" bIns="0" rtlCol="0" anchor="t"/>
+          <a:lstStyle/>
+          <a:p>
+            <a:pPr indent="0" marL="0">
+              <a:buNone/>
+            </a:pPr>
+            <a:r>
+              <a:rPr lang="en-US" sz="1100" dirty="0">
                 <a:solidFill>
                   <a:schemeClr val="tx1"/>
                 </a:solidFill>
               </a:rPr>
-              <a:t>Build on LLM APIs with structured outputs and tool use</a:t>
-            </a:r>
-            <a:endParaRPr lang="en-US" sz="1400" dirty="0"/>
-          </a:p>
-        </p:txBody>
-      </p:sp>
-      <p:sp>
-        <p:nvSpPr>
-          <p:cNvPr id="6" name="Shape 4"/>
+              <a:t>Map your operations, see how the best AI users actually work, and leave with a plan and a working prototype of your first system.</a:t>
+            </a:r>
+            <a:endParaRPr lang="en-US" sz="1100" dirty="0"/>
+          </a:p>
+        </p:txBody>
+      </p:sp>
+      <p:sp>
+        <p:nvSpPr>
+          <p:cNvPr id="9" name="Text 7"/>
+          <p:cNvSpPr txBox="1"/>
+          <p:nvPr/>
+        </p:nvSpPr>
+        <p:spPr>
+          <a:xfrm>
+            <a:off x="777240" y="3977640"/>
+            <a:ext cx="2103120" cy="365760"/>
+          </a:xfrm>
+          <a:prstGeom prst="rect">
+            <a:avLst/>
+          </a:prstGeom>
+          <a:noFill/>
+          <a:ln/>
+        </p:spPr>
+        <p:txBody>
+          <a:bodyPr wrap="square" lIns="0" tIns="0" rIns="0" bIns="0" rtlCol="0" anchor="t"/>
+          <a:lstStyle/>
+          <a:p>
+            <a:pPr indent="0" marL="0">
+              <a:buNone/>
+            </a:pPr>
+            <a:r>
+              <a:rPr lang="en-US" sz="1800" dirty="0">
+                <a:solidFill>
+                  <a:schemeClr val="tx1"/>
+                </a:solidFill>
+                <a:latin typeface="Courier New" pitchFamily="34" charset="0"/>
+                <a:ea typeface="Courier New" pitchFamily="34" charset="-122"/>
+                <a:cs typeface="Courier New" pitchFamily="34" charset="-120"/>
+              </a:rPr>
+              <a:t>$15,000</a:t>
+            </a:r>
+            <a:endParaRPr lang="en-US" sz="1800" dirty="0"/>
+          </a:p>
+        </p:txBody>
+      </p:sp>
+      <p:sp>
+        <p:nvSpPr>
+          <p:cNvPr id="10" name="Shape 8"/>
           <p:cNvSpPr/>
           <p:nvPr/>
         </p:nvSpPr>
         <p:spPr>
           <a:xfrm>
-            <a:off x="548640" y="2103120"/>
-            <a:ext cx="8046720" cy="0"/>
-          </a:xfrm>
-          <a:prstGeom prst="line">
-            <a:avLst/>
-          </a:prstGeom>
-          <a:noFill/>
-          <a:ln w="9525">
+            <a:off x="3291840" y="1828800"/>
+            <a:ext cx="2560320" cy="2651760"/>
+          </a:xfrm>
+          <a:prstGeom prst="rect">
+            <a:avLst/>
+          </a:prstGeom>
+          <a:solidFill>
+            <a:srgbClr val="F4F4F4"/>
+          </a:solidFill>
+          <a:ln w="12700">
             <a:solidFill>
-              <a:srgbClr val="E2E2E2"/>
+              <a:srgbClr val="F4F4F4"/>
             </a:solidFill>
             <a:prstDash val="solid"/>
           </a:ln>
@@ -5092,30 +5189,30 @@
       </p:sp>
       <p:sp>
         <p:nvSpPr>
-          <p:cNvPr id="7" name="Text 5"/>
-          <p:cNvSpPr txBox="1"/>
-          <p:nvPr/>
-        </p:nvSpPr>
-        <p:spPr>
-          <a:xfrm>
-            <a:off x="548640" y="2212848"/>
-            <a:ext cx="365760" cy="411480"/>
-          </a:xfrm>
-          <a:prstGeom prst="rect">
-            <a:avLst/>
-          </a:prstGeom>
-          <a:noFill/>
-          <a:ln/>
-        </p:spPr>
-        <p:txBody>
-          <a:bodyPr wrap="square" lIns="0" tIns="0" rIns="0" bIns="0" rtlCol="0" anchor="t"/>
-          <a:lstStyle/>
-          <a:p>
-            <a:pPr indent="0" marL="0">
-              <a:buNone/>
-            </a:pPr>
-            <a:r>
-              <a:rPr lang="en-US" sz="900" dirty="0">
+          <p:cNvPr id="11" name="Text 9"/>
+          <p:cNvSpPr txBox="1"/>
+          <p:nvPr/>
+        </p:nvSpPr>
+        <p:spPr>
+          <a:xfrm>
+            <a:off x="3520440" y="2057400"/>
+            <a:ext cx="2103120" cy="201168"/>
+          </a:xfrm>
+          <a:prstGeom prst="rect">
+            <a:avLst/>
+          </a:prstGeom>
+          <a:noFill/>
+          <a:ln/>
+        </p:spPr>
+        <p:txBody>
+          <a:bodyPr wrap="square" lIns="0" tIns="0" rIns="0" bIns="0" rtlCol="0" anchor="t"/>
+          <a:lstStyle/>
+          <a:p>
+            <a:pPr indent="0" marL="0">
+              <a:buNone/>
+            </a:pPr>
+            <a:r>
+              <a:rPr lang="en-US" sz="800" spc="100" kern="0" dirty="0">
                 <a:solidFill>
                   <a:schemeClr val="tx2"/>
                 </a:solidFill>
@@ -5123,7 +5220,82 @@
                 <a:ea typeface="Courier New" pitchFamily="34" charset="-122"/>
                 <a:cs typeface="Courier New" pitchFamily="34" charset="-120"/>
               </a:rPr>
-              <a:t>02</a:t>
+              <a:t>3 DAYS, 4 HOURS PER DAY</a:t>
+            </a:r>
+            <a:endParaRPr lang="en-US" sz="800" dirty="0"/>
+          </a:p>
+        </p:txBody>
+      </p:sp>
+      <p:sp>
+        <p:nvSpPr>
+          <p:cNvPr id="12" name="Text 10"/>
+          <p:cNvSpPr txBox="1"/>
+          <p:nvPr/>
+        </p:nvSpPr>
+        <p:spPr>
+          <a:xfrm>
+            <a:off x="3520440" y="2331720"/>
+            <a:ext cx="2103120" cy="365760"/>
+          </a:xfrm>
+          <a:prstGeom prst="rect">
+            <a:avLst/>
+          </a:prstGeom>
+          <a:noFill/>
+          <a:ln/>
+        </p:spPr>
+        <p:txBody>
+          <a:bodyPr wrap="square" lIns="0" tIns="0" rIns="0" bIns="0" rtlCol="0" anchor="t"/>
+          <a:lstStyle/>
+          <a:p>
+            <a:pPr indent="0" marL="0">
+              <a:buNone/>
+            </a:pPr>
+            <a:r>
+              <a:rPr lang="en-US" sz="1600" b="1" dirty="0">
+                <a:solidFill>
+                  <a:schemeClr val="tx1"/>
+                </a:solidFill>
+              </a:rPr>
+              <a:t>Three-day intensive</a:t>
+            </a:r>
+            <a:endParaRPr lang="en-US" sz="1600" dirty="0"/>
+          </a:p>
+        </p:txBody>
+      </p:sp>
+      <p:sp>
+        <p:nvSpPr>
+          <p:cNvPr id="13" name="Text 11"/>
+          <p:cNvSpPr txBox="1"/>
+          <p:nvPr/>
+        </p:nvSpPr>
+        <p:spPr>
+          <a:xfrm>
+            <a:off x="3520440" y="2697480"/>
+            <a:ext cx="2103120" cy="274320"/>
+          </a:xfrm>
+          <a:prstGeom prst="rect">
+            <a:avLst/>
+          </a:prstGeom>
+          <a:noFill/>
+          <a:ln/>
+        </p:spPr>
+        <p:txBody>
+          <a:bodyPr wrap="square" lIns="0" tIns="0" rIns="0" bIns="0" rtlCol="0" anchor="t"/>
+          <a:lstStyle/>
+          <a:p>
+            <a:pPr indent="0" marL="0">
+              <a:buNone/>
+            </a:pPr>
+            <a:r>
+              <a:rPr lang="en-US" sz="900" dirty="0">
+                <a:solidFill>
+                  <a:schemeClr val="tx2"/>
+                </a:solidFill>
+                <a:latin typeface="Courier New" pitchFamily="34" charset="0"/>
+                <a:ea typeface="Courier New" pitchFamily="34" charset="-122"/>
+                <a:cs typeface="Courier New" pitchFamily="34" charset="-120"/>
+              </a:rPr>
+              <a:t>Remote, over Zoom</a:t>
             </a:r>
             <a:endParaRPr lang="en-US" sz="900" dirty="0"/>
           </a:p>
@@ -5131,58 +5303,99 @@
       </p:sp>
       <p:sp>
         <p:nvSpPr>
-          <p:cNvPr id="8" name="Text 6"/>
-          <p:cNvSpPr txBox="1"/>
-          <p:nvPr/>
-        </p:nvSpPr>
-        <p:spPr>
-          <a:xfrm>
-            <a:off x="1005840" y="2194560"/>
-            <a:ext cx="7589520" cy="411480"/>
-          </a:xfrm>
-          <a:prstGeom prst="rect">
-            <a:avLst/>
-          </a:prstGeom>
-          <a:noFill/>
-          <a:ln/>
-        </p:spPr>
-        <p:txBody>
-          <a:bodyPr wrap="square" lIns="0" tIns="0" rIns="0" bIns="0" rtlCol="0" anchor="t"/>
-          <a:lstStyle/>
-          <a:p>
-            <a:pPr indent="0" marL="0">
-              <a:buNone/>
-            </a:pPr>
-            <a:r>
-              <a:rPr lang="en-US" sz="1400" dirty="0">
+          <p:cNvPr id="14" name="Text 12"/>
+          <p:cNvSpPr txBox="1"/>
+          <p:nvPr/>
+        </p:nvSpPr>
+        <p:spPr>
+          <a:xfrm>
+            <a:off x="3520440" y="3063240"/>
+            <a:ext cx="2103120" cy="1005840"/>
+          </a:xfrm>
+          <a:prstGeom prst="rect">
+            <a:avLst/>
+          </a:prstGeom>
+          <a:noFill/>
+          <a:ln/>
+        </p:spPr>
+        <p:txBody>
+          <a:bodyPr wrap="square" lIns="0" tIns="0" rIns="0" bIns="0" rtlCol="0" anchor="t"/>
+          <a:lstStyle/>
+          <a:p>
+            <a:pPr indent="0" marL="0">
+              <a:buNone/>
+            </a:pPr>
+            <a:r>
+              <a:rPr lang="en-US" sz="1100" dirty="0">
                 <a:solidFill>
                   <a:schemeClr val="tx1"/>
                 </a:solidFill>
               </a:rPr>
-              <a:t>Connect AI to your CRM, email, and operations systems</a:t>
-            </a:r>
-            <a:endParaRPr lang="en-US" sz="1400" dirty="0"/>
-          </a:p>
-        </p:txBody>
-      </p:sp>
-      <p:sp>
-        <p:nvSpPr>
-          <p:cNvPr id="9" name="Shape 7"/>
+              <a:t>Build a working AI system against your real data, and learn to work with AI the way the people getting ten times the output do.</a:t>
+            </a:r>
+            <a:endParaRPr lang="en-US" sz="1100" dirty="0"/>
+          </a:p>
+        </p:txBody>
+      </p:sp>
+      <p:sp>
+        <p:nvSpPr>
+          <p:cNvPr id="15" name="Text 13"/>
+          <p:cNvSpPr txBox="1"/>
+          <p:nvPr/>
+        </p:nvSpPr>
+        <p:spPr>
+          <a:xfrm>
+            <a:off x="3520440" y="3977640"/>
+            <a:ext cx="2103120" cy="365760"/>
+          </a:xfrm>
+          <a:prstGeom prst="rect">
+            <a:avLst/>
+          </a:prstGeom>
+          <a:noFill/>
+          <a:ln/>
+        </p:spPr>
+        <p:txBody>
+          <a:bodyPr wrap="square" lIns="0" tIns="0" rIns="0" bIns="0" rtlCol="0" anchor="t"/>
+          <a:lstStyle/>
+          <a:p>
+            <a:pPr indent="0" marL="0">
+              <a:buNone/>
+            </a:pPr>
+            <a:r>
+              <a:rPr lang="en-US" sz="1800" dirty="0">
+                <a:solidFill>
+                  <a:schemeClr val="tx1"/>
+                </a:solidFill>
+                <a:latin typeface="Courier New" pitchFamily="34" charset="0"/>
+                <a:ea typeface="Courier New" pitchFamily="34" charset="-122"/>
+                <a:cs typeface="Courier New" pitchFamily="34" charset="-120"/>
+              </a:rPr>
+              <a:t>$7,500</a:t>
+            </a:r>
+            <a:endParaRPr lang="en-US" sz="1800" dirty="0"/>
+          </a:p>
+        </p:txBody>
+      </p:sp>
+      <p:sp>
+        <p:nvSpPr>
+          <p:cNvPr id="16" name="Shape 14"/>
           <p:cNvSpPr/>
           <p:nvPr/>
         </p:nvSpPr>
         <p:spPr>
           <a:xfrm>
-            <a:off x="548640" y="2651760"/>
-            <a:ext cx="8046720" cy="0"/>
-          </a:xfrm>
-          <a:prstGeom prst="line">
-            <a:avLst/>
-          </a:prstGeom>
-          <a:noFill/>
-          <a:ln w="9525">
+            <a:off x="6035040" y="1828800"/>
+            <a:ext cx="2560320" cy="2651760"/>
+          </a:xfrm>
+          <a:prstGeom prst="rect">
+            <a:avLst/>
+          </a:prstGeom>
+          <a:solidFill>
+            <a:srgbClr val="F4F4F4"/>
+          </a:solidFill>
+          <a:ln w="12700">
             <a:solidFill>
-              <a:srgbClr val="E2E2E2"/>
+              <a:srgbClr val="F4F4F4"/>
             </a:solidFill>
             <a:prstDash val="solid"/>
           </a:ln>
@@ -5190,30 +5403,30 @@
       </p:sp>
       <p:sp>
         <p:nvSpPr>
-          <p:cNvPr id="10" name="Text 8"/>
-          <p:cNvSpPr txBox="1"/>
-          <p:nvPr/>
-        </p:nvSpPr>
-        <p:spPr>
-          <a:xfrm>
-            <a:off x="548640" y="2761488"/>
-            <a:ext cx="365760" cy="411480"/>
-          </a:xfrm>
-          <a:prstGeom prst="rect">
-            <a:avLst/>
-          </a:prstGeom>
-          <a:noFill/>
-          <a:ln/>
-        </p:spPr>
-        <p:txBody>
-          <a:bodyPr wrap="square" lIns="0" tIns="0" rIns="0" bIns="0" rtlCol="0" anchor="t"/>
-          <a:lstStyle/>
-          <a:p>
-            <a:pPr indent="0" marL="0">
-              <a:buNone/>
-            </a:pPr>
-            <a:r>
-              <a:rPr lang="en-US" sz="900" dirty="0">
+          <p:cNvPr id="17" name="Text 15"/>
+          <p:cNvSpPr txBox="1"/>
+          <p:nvPr/>
+        </p:nvSpPr>
+        <p:spPr>
+          <a:xfrm>
+            <a:off x="6263640" y="2057400"/>
+            <a:ext cx="2103120" cy="201168"/>
+          </a:xfrm>
+          <a:prstGeom prst="rect">
+            <a:avLst/>
+          </a:prstGeom>
+          <a:noFill/>
+          <a:ln/>
+        </p:spPr>
+        <p:txBody>
+          <a:bodyPr wrap="square" lIns="0" tIns="0" rIns="0" bIns="0" rtlCol="0" anchor="t"/>
+          <a:lstStyle/>
+          <a:p>
+            <a:pPr indent="0" marL="0">
+              <a:buNone/>
+            </a:pPr>
+            <a:r>
+              <a:rPr lang="en-US" sz="800" spc="100" kern="0" dirty="0">
                 <a:solidFill>
                   <a:schemeClr val="tx2"/>
                 </a:solidFill>
@@ -5221,81 +5434,58 @@
                 <a:ea typeface="Courier New" pitchFamily="34" charset="-122"/>
                 <a:cs typeface="Courier New" pitchFamily="34" charset="-120"/>
               </a:rPr>
-              <a:t>03</a:t>
-            </a:r>
-            <a:endParaRPr lang="en-US" sz="900" dirty="0"/>
-          </a:p>
-        </p:txBody>
-      </p:sp>
-      <p:sp>
-        <p:nvSpPr>
-          <p:cNvPr id="11" name="Text 9"/>
-          <p:cNvSpPr txBox="1"/>
-          <p:nvPr/>
-        </p:nvSpPr>
-        <p:spPr>
-          <a:xfrm>
-            <a:off x="1005840" y="2743200"/>
-            <a:ext cx="7589520" cy="411480"/>
-          </a:xfrm>
-          <a:prstGeom prst="rect">
-            <a:avLst/>
-          </a:prstGeom>
-          <a:noFill/>
-          <a:ln/>
-        </p:spPr>
-        <p:txBody>
-          <a:bodyPr wrap="square" lIns="0" tIns="0" rIns="0" bIns="0" rtlCol="0" anchor="t"/>
-          <a:lstStyle/>
-          <a:p>
-            <a:pPr indent="0" marL="0">
-              <a:buNone/>
-            </a:pPr>
-            <a:r>
-              <a:rPr lang="en-US" sz="1400" dirty="0">
+              <a:t>8 WEEKS</a:t>
+            </a:r>
+            <a:endParaRPr lang="en-US" sz="800" dirty="0"/>
+          </a:p>
+        </p:txBody>
+      </p:sp>
+      <p:sp>
+        <p:nvSpPr>
+          <p:cNvPr id="18" name="Text 16"/>
+          <p:cNvSpPr txBox="1"/>
+          <p:nvPr/>
+        </p:nvSpPr>
+        <p:spPr>
+          <a:xfrm>
+            <a:off x="6263640" y="2331720"/>
+            <a:ext cx="2103120" cy="365760"/>
+          </a:xfrm>
+          <a:prstGeom prst="rect">
+            <a:avLst/>
+          </a:prstGeom>
+          <a:noFill/>
+          <a:ln/>
+        </p:spPr>
+        <p:txBody>
+          <a:bodyPr wrap="square" lIns="0" tIns="0" rIns="0" bIns="0" rtlCol="0" anchor="t"/>
+          <a:lstStyle/>
+          <a:p>
+            <a:pPr indent="0" marL="0">
+              <a:buNone/>
+            </a:pPr>
+            <a:r>
+              <a:rPr lang="en-US" sz="1600" b="1" dirty="0">
                 <a:solidFill>
                   <a:schemeClr val="tx1"/>
                 </a:solidFill>
               </a:rPr>
-              <a:t>Design human handoff, alerts, and audit trails</a:t>
-            </a:r>
-            <a:endParaRPr lang="en-US" sz="1400" dirty="0"/>
-          </a:p>
-        </p:txBody>
-      </p:sp>
-      <p:sp>
-        <p:nvSpPr>
-          <p:cNvPr id="12" name="Shape 10"/>
-          <p:cNvSpPr/>
-          <p:nvPr/>
-        </p:nvSpPr>
-        <p:spPr>
-          <a:xfrm>
-            <a:off x="548640" y="3200400"/>
-            <a:ext cx="8046720" cy="0"/>
-          </a:xfrm>
-          <a:prstGeom prst="line">
-            <a:avLst/>
-          </a:prstGeom>
-          <a:noFill/>
-          <a:ln w="9525">
-            <a:solidFill>
-              <a:srgbClr val="E2E2E2"/>
-            </a:solidFill>
-            <a:prstDash val="solid"/>
-          </a:ln>
-        </p:spPr>
-      </p:sp>
-      <p:sp>
-        <p:nvSpPr>
-          <p:cNvPr id="13" name="Text 11"/>
-          <p:cNvSpPr txBox="1"/>
-          <p:nvPr/>
-        </p:nvSpPr>
-        <p:spPr>
-          <a:xfrm>
-            <a:off x="548640" y="3310128"/>
-            <a:ext cx="365760" cy="411480"/>
+              <a:t>Eight-week cohort</a:t>
+            </a:r>
+            <a:endParaRPr lang="en-US" sz="1600" dirty="0"/>
+          </a:p>
+        </p:txBody>
+      </p:sp>
+      <p:sp>
+        <p:nvSpPr>
+          <p:cNvPr id="19" name="Text 17"/>
+          <p:cNvSpPr txBox="1"/>
+          <p:nvPr/>
+        </p:nvSpPr>
+        <p:spPr>
+          <a:xfrm>
+            <a:off x="6263640" y="2697480"/>
+            <a:ext cx="2103120" cy="274320"/>
           </a:xfrm>
           <a:prstGeom prst="rect">
             <a:avLst/>
@@ -5319,7 +5509,7 @@
                 <a:ea typeface="Courier New" pitchFamily="34" charset="-122"/>
                 <a:cs typeface="Courier New" pitchFamily="34" charset="-120"/>
               </a:rPr>
-              <a:t>04</a:t>
+              <a:t>On site or remote</a:t>
             </a:r>
             <a:endParaRPr lang="en-US" sz="900" dirty="0"/>
           </a:p>
@@ -5327,160 +5517,78 @@
       </p:sp>
       <p:sp>
         <p:nvSpPr>
-          <p:cNvPr id="14" name="Text 12"/>
-          <p:cNvSpPr txBox="1"/>
-          <p:nvPr/>
-        </p:nvSpPr>
-        <p:spPr>
-          <a:xfrm>
-            <a:off x="1005840" y="3291840"/>
-            <a:ext cx="7589520" cy="411480"/>
-          </a:xfrm>
-          <a:prstGeom prst="rect">
-            <a:avLst/>
-          </a:prstGeom>
-          <a:noFill/>
-          <a:ln/>
-        </p:spPr>
-        <p:txBody>
-          <a:bodyPr wrap="square" lIns="0" tIns="0" rIns="0" bIns="0" rtlCol="0" anchor="t"/>
-          <a:lstStyle/>
-          <a:p>
-            <a:pPr indent="0" marL="0">
-              <a:buNone/>
-            </a:pPr>
-            <a:r>
-              <a:rPr lang="en-US" sz="1400" dirty="0">
+          <p:cNvPr id="20" name="Text 18"/>
+          <p:cNvSpPr txBox="1"/>
+          <p:nvPr/>
+        </p:nvSpPr>
+        <p:spPr>
+          <a:xfrm>
+            <a:off x="6263640" y="3063240"/>
+            <a:ext cx="2103120" cy="1005840"/>
+          </a:xfrm>
+          <a:prstGeom prst="rect">
+            <a:avLst/>
+          </a:prstGeom>
+          <a:noFill/>
+          <a:ln/>
+        </p:spPr>
+        <p:txBody>
+          <a:bodyPr wrap="square" lIns="0" tIns="0" rIns="0" bIns="0" rtlCol="0" anchor="t"/>
+          <a:lstStyle/>
+          <a:p>
+            <a:pPr indent="0" marL="0">
+              <a:buNone/>
+            </a:pPr>
+            <a:r>
+              <a:rPr lang="en-US" sz="1100" dirty="0">
                 <a:solidFill>
                   <a:schemeClr val="tx1"/>
                 </a:solidFill>
               </a:rPr>
-              <a:t>Test, monitor, and track the cost of a system in production</a:t>
-            </a:r>
-            <a:endParaRPr lang="en-US" sz="1400" dirty="0"/>
-          </a:p>
-        </p:txBody>
-      </p:sp>
-      <p:sp>
-        <p:nvSpPr>
-          <p:cNvPr id="15" name="Shape 13"/>
-          <p:cNvSpPr/>
-          <p:nvPr/>
-        </p:nvSpPr>
-        <p:spPr>
-          <a:xfrm>
-            <a:off x="548640" y="3749040"/>
-            <a:ext cx="8046720" cy="0"/>
-          </a:xfrm>
-          <a:prstGeom prst="line">
-            <a:avLst/>
-          </a:prstGeom>
-          <a:noFill/>
-          <a:ln w="9525">
-            <a:solidFill>
-              <a:srgbClr val="E2E2E2"/>
-            </a:solidFill>
-            <a:prstDash val="solid"/>
-          </a:ln>
-        </p:spPr>
-      </p:sp>
-      <p:sp>
-        <p:nvSpPr>
-          <p:cNvPr id="16" name="Text 14"/>
-          <p:cNvSpPr txBox="1"/>
-          <p:nvPr/>
-        </p:nvSpPr>
-        <p:spPr>
-          <a:xfrm>
-            <a:off x="548640" y="3858768"/>
-            <a:ext cx="365760" cy="411480"/>
-          </a:xfrm>
-          <a:prstGeom prst="rect">
-            <a:avLst/>
-          </a:prstGeom>
-          <a:noFill/>
-          <a:ln/>
-        </p:spPr>
-        <p:txBody>
-          <a:bodyPr wrap="square" lIns="0" tIns="0" rIns="0" bIns="0" rtlCol="0" anchor="t"/>
-          <a:lstStyle/>
-          <a:p>
-            <a:pPr indent="0" marL="0">
-              <a:buNone/>
-            </a:pPr>
-            <a:r>
-              <a:rPr lang="en-US" sz="900" dirty="0">
-                <a:solidFill>
-                  <a:schemeClr val="tx2"/>
+              <a:t>One system shipped to production inside your company, owned and understood by the people who built it, and a team that works with AI differently from here on.</a:t>
+            </a:r>
+            <a:endParaRPr lang="en-US" sz="1100" dirty="0"/>
+          </a:p>
+        </p:txBody>
+      </p:sp>
+      <p:sp>
+        <p:nvSpPr>
+          <p:cNvPr id="21" name="Text 19"/>
+          <p:cNvSpPr txBox="1"/>
+          <p:nvPr/>
+        </p:nvSpPr>
+        <p:spPr>
+          <a:xfrm>
+            <a:off x="6263640" y="3977640"/>
+            <a:ext cx="2103120" cy="365760"/>
+          </a:xfrm>
+          <a:prstGeom prst="rect">
+            <a:avLst/>
+          </a:prstGeom>
+          <a:noFill/>
+          <a:ln/>
+        </p:spPr>
+        <p:txBody>
+          <a:bodyPr wrap="square" lIns="0" tIns="0" rIns="0" bIns="0" rtlCol="0" anchor="t"/>
+          <a:lstStyle/>
+          <a:p>
+            <a:pPr indent="0" marL="0">
+              <a:buNone/>
+            </a:pPr>
+            <a:r>
+              <a:rPr lang="en-US" sz="1800" dirty="0">
+                <a:solidFill>
+                  <a:schemeClr val="tx1"/>
                 </a:solidFill>
                 <a:latin typeface="Courier New" pitchFamily="34" charset="0"/>
                 <a:ea typeface="Courier New" pitchFamily="34" charset="-122"/>
                 <a:cs typeface="Courier New" pitchFamily="34" charset="-120"/>
               </a:rPr>
-              <a:t>05</a:t>
-            </a:r>
-            <a:endParaRPr lang="en-US" sz="900" dirty="0"/>
-          </a:p>
-        </p:txBody>
-      </p:sp>
-      <p:sp>
-        <p:nvSpPr>
-          <p:cNvPr id="17" name="Text 15"/>
-          <p:cNvSpPr txBox="1"/>
-          <p:nvPr/>
-        </p:nvSpPr>
-        <p:spPr>
-          <a:xfrm>
-            <a:off x="1005840" y="3840480"/>
-            <a:ext cx="7589520" cy="411480"/>
-          </a:xfrm>
-          <a:prstGeom prst="rect">
-            <a:avLst/>
-          </a:prstGeom>
-          <a:noFill/>
-          <a:ln/>
-        </p:spPr>
-        <p:txBody>
-          <a:bodyPr wrap="square" lIns="0" tIns="0" rIns="0" bIns="0" rtlCol="0" anchor="t"/>
-          <a:lstStyle/>
-          <a:p>
-            <a:pPr indent="0" marL="0">
-              <a:buNone/>
-            </a:pPr>
-            <a:r>
-              <a:rPr lang="en-US" sz="1400" dirty="0">
-                <a:solidFill>
-                  <a:schemeClr val="tx1"/>
-                </a:solidFill>
-              </a:rPr>
-              <a:t>Scope and ship the next project without outside help</a:t>
-            </a:r>
-            <a:endParaRPr lang="en-US" sz="1400" dirty="0"/>
-          </a:p>
-        </p:txBody>
-      </p:sp>
-      <p:sp>
-        <p:nvSpPr>
-          <p:cNvPr id="18" name="Shape 16"/>
-          <p:cNvSpPr/>
-          <p:nvPr/>
-        </p:nvSpPr>
-        <p:spPr>
-          <a:xfrm>
-            <a:off x="548640" y="4297680"/>
-            <a:ext cx="8046720" cy="0"/>
-          </a:xfrm>
-          <a:prstGeom prst="line">
-            <a:avLst/>
-          </a:prstGeom>
-          <a:noFill/>
-          <a:ln w="9525">
-            <a:solidFill>
-              <a:srgbClr val="E2E2E2"/>
-            </a:solidFill>
-            <a:prstDash val="solid"/>
-          </a:ln>
-        </p:spPr>
+              <a:t>$50,000</a:t>
+            </a:r>
+            <a:endParaRPr lang="en-US" sz="1800" dirty="0"/>
+          </a:p>
+        </p:txBody>
       </p:sp>
     </p:spTree>
   </p:cSld>
@@ -5539,7 +5647,7 @@
                   <a:srgbClr val="161616"/>
                 </a:solidFill>
               </a:rPr>
-              <a:t>Built for clients, running today</a:t>
+              <a:t>What your team can do after</a:t>
             </a:r>
             <a:endParaRPr lang="en-US" sz="2800" dirty="0"/>
           </a:p>
@@ -5554,17 +5662,15 @@
         <p:spPr>
           <a:xfrm>
             <a:off x="548640" y="1554480"/>
-            <a:ext cx="1908810" cy="1371600"/>
-          </a:xfrm>
-          <a:prstGeom prst="rect">
-            <a:avLst/>
-          </a:prstGeom>
-          <a:solidFill>
-            <a:srgbClr val="F4F4F4"/>
-          </a:solidFill>
+            <a:ext cx="8046720" cy="0"/>
+          </a:xfrm>
+          <a:prstGeom prst="line">
+            <a:avLst/>
+          </a:prstGeom>
+          <a:noFill/>
           <a:ln w="12700">
             <a:solidFill>
-              <a:srgbClr val="F4F4F4"/>
+              <a:srgbClr val="161616"/>
             </a:solidFill>
             <a:prstDash val="solid"/>
           </a:ln>
@@ -5578,34 +5684,34 @@
         </p:nvSpPr>
         <p:spPr>
           <a:xfrm>
-            <a:off x="731520" y="1737360"/>
-            <a:ext cx="1543050" cy="548640"/>
-          </a:xfrm>
-          <a:prstGeom prst="rect">
-            <a:avLst/>
-          </a:prstGeom>
-          <a:noFill/>
-          <a:ln/>
-        </p:spPr>
-        <p:txBody>
-          <a:bodyPr wrap="square" lIns="0" tIns="0" rIns="0" bIns="0" rtlCol="0" anchor="t"/>
-          <a:lstStyle/>
-          <a:p>
-            <a:pPr indent="0" marL="0">
-              <a:buNone/>
-            </a:pPr>
-            <a:r>
-              <a:rPr lang="en-US" sz="2800" dirty="0">
-                <a:solidFill>
-                  <a:schemeClr val="tx1"/>
+            <a:off x="548640" y="1664208"/>
+            <a:ext cx="365760" cy="411480"/>
+          </a:xfrm>
+          <a:prstGeom prst="rect">
+            <a:avLst/>
+          </a:prstGeom>
+          <a:noFill/>
+          <a:ln/>
+        </p:spPr>
+        <p:txBody>
+          <a:bodyPr wrap="square" lIns="0" tIns="0" rIns="0" bIns="0" rtlCol="0" anchor="t"/>
+          <a:lstStyle/>
+          <a:p>
+            <a:pPr indent="0" marL="0">
+              <a:buNone/>
+            </a:pPr>
+            <a:r>
+              <a:rPr lang="en-US" sz="900" dirty="0">
+                <a:solidFill>
+                  <a:schemeClr val="tx2"/>
                 </a:solidFill>
                 <a:latin typeface="Courier New" pitchFamily="34" charset="0"/>
                 <a:ea typeface="Courier New" pitchFamily="34" charset="-122"/>
                 <a:cs typeface="Courier New" pitchFamily="34" charset="-120"/>
               </a:rPr>
-              <a:t>$6M+</a:t>
-            </a:r>
-            <a:endParaRPr lang="en-US" sz="2800" dirty="0"/>
+              <a:t>01</a:t>
+            </a:r>
+            <a:endParaRPr lang="en-US" sz="900" dirty="0"/>
           </a:p>
         </p:txBody>
       </p:sp>
@@ -5617,24 +5723,83 @@
         </p:nvSpPr>
         <p:spPr>
           <a:xfrm>
-            <a:off x="731520" y="2331720"/>
-            <a:ext cx="1543050" cy="548640"/>
-          </a:xfrm>
-          <a:prstGeom prst="rect">
-            <a:avLst/>
-          </a:prstGeom>
-          <a:noFill/>
-          <a:ln/>
-        </p:spPr>
-        <p:txBody>
-          <a:bodyPr wrap="square" lIns="0" tIns="0" rIns="0" bIns="0" rtlCol="0" anchor="t"/>
-          <a:lstStyle/>
-          <a:p>
-            <a:pPr indent="0" marL="0">
-              <a:buNone/>
-            </a:pPr>
-            <a:r>
-              <a:rPr lang="en-US" sz="800" dirty="0">
+            <a:off x="1005840" y="1645920"/>
+            <a:ext cx="7589520" cy="411480"/>
+          </a:xfrm>
+          <a:prstGeom prst="rect">
+            <a:avLst/>
+          </a:prstGeom>
+          <a:noFill/>
+          <a:ln/>
+        </p:spPr>
+        <p:txBody>
+          <a:bodyPr wrap="square" lIns="0" tIns="0" rIns="0" bIns="0" rtlCol="0" anchor="t"/>
+          <a:lstStyle/>
+          <a:p>
+            <a:pPr indent="0" marL="0">
+              <a:buNone/>
+            </a:pPr>
+            <a:r>
+              <a:rPr lang="en-US" sz="1400" dirty="0">
+                <a:solidFill>
+                  <a:schemeClr val="tx1"/>
+                </a:solidFill>
+              </a:rPr>
+              <a:t>Build on LLM APIs with structured outputs and tool use</a:t>
+            </a:r>
+            <a:endParaRPr lang="en-US" sz="1400" dirty="0"/>
+          </a:p>
+        </p:txBody>
+      </p:sp>
+      <p:sp>
+        <p:nvSpPr>
+          <p:cNvPr id="6" name="Shape 4"/>
+          <p:cNvSpPr/>
+          <p:nvPr/>
+        </p:nvSpPr>
+        <p:spPr>
+          <a:xfrm>
+            <a:off x="548640" y="2103120"/>
+            <a:ext cx="8046720" cy="0"/>
+          </a:xfrm>
+          <a:prstGeom prst="line">
+            <a:avLst/>
+          </a:prstGeom>
+          <a:noFill/>
+          <a:ln w="9525">
+            <a:solidFill>
+              <a:srgbClr val="E2E2E2"/>
+            </a:solidFill>
+            <a:prstDash val="solid"/>
+          </a:ln>
+        </p:spPr>
+      </p:sp>
+      <p:sp>
+        <p:nvSpPr>
+          <p:cNvPr id="7" name="Text 5"/>
+          <p:cNvSpPr txBox="1"/>
+          <p:nvPr/>
+        </p:nvSpPr>
+        <p:spPr>
+          <a:xfrm>
+            <a:off x="548640" y="2212848"/>
+            <a:ext cx="365760" cy="411480"/>
+          </a:xfrm>
+          <a:prstGeom prst="rect">
+            <a:avLst/>
+          </a:prstGeom>
+          <a:noFill/>
+          <a:ln/>
+        </p:spPr>
+        <p:txBody>
+          <a:bodyPr wrap="square" lIns="0" tIns="0" rIns="0" bIns="0" rtlCol="0" anchor="t"/>
+          <a:lstStyle/>
+          <a:p>
+            <a:pPr indent="0" marL="0">
+              <a:buNone/>
+            </a:pPr>
+            <a:r>
+              <a:rPr lang="en-US" sz="900" dirty="0">
                 <a:solidFill>
                   <a:schemeClr val="tx2"/>
                 </a:solidFill>
@@ -5642,32 +5807,66 @@
                 <a:ea typeface="Courier New" pitchFamily="34" charset="-122"/>
                 <a:cs typeface="Courier New" pitchFamily="34" charset="-120"/>
               </a:rPr>
-              <a:t>Client revenue supported by systems we built</a:t>
-            </a:r>
-            <a:endParaRPr lang="en-US" sz="800" dirty="0"/>
-          </a:p>
-        </p:txBody>
-      </p:sp>
-      <p:sp>
-        <p:nvSpPr>
-          <p:cNvPr id="6" name="Shape 4"/>
+              <a:t>02</a:t>
+            </a:r>
+            <a:endParaRPr lang="en-US" sz="900" dirty="0"/>
+          </a:p>
+        </p:txBody>
+      </p:sp>
+      <p:sp>
+        <p:nvSpPr>
+          <p:cNvPr id="8" name="Text 6"/>
+          <p:cNvSpPr txBox="1"/>
+          <p:nvPr/>
+        </p:nvSpPr>
+        <p:spPr>
+          <a:xfrm>
+            <a:off x="1005840" y="2194560"/>
+            <a:ext cx="7589520" cy="411480"/>
+          </a:xfrm>
+          <a:prstGeom prst="rect">
+            <a:avLst/>
+          </a:prstGeom>
+          <a:noFill/>
+          <a:ln/>
+        </p:spPr>
+        <p:txBody>
+          <a:bodyPr wrap="square" lIns="0" tIns="0" rIns="0" bIns="0" rtlCol="0" anchor="t"/>
+          <a:lstStyle/>
+          <a:p>
+            <a:pPr indent="0" marL="0">
+              <a:buNone/>
+            </a:pPr>
+            <a:r>
+              <a:rPr lang="en-US" sz="1400" dirty="0">
+                <a:solidFill>
+                  <a:schemeClr val="tx1"/>
+                </a:solidFill>
+              </a:rPr>
+              <a:t>Connect AI to your CRM, email, and operations systems</a:t>
+            </a:r>
+            <a:endParaRPr lang="en-US" sz="1400" dirty="0"/>
+          </a:p>
+        </p:txBody>
+      </p:sp>
+      <p:sp>
+        <p:nvSpPr>
+          <p:cNvPr id="9" name="Shape 7"/>
           <p:cNvSpPr/>
           <p:nvPr/>
         </p:nvSpPr>
         <p:spPr>
           <a:xfrm>
-            <a:off x="2594610" y="1554480"/>
-            <a:ext cx="1908810" cy="1371600"/>
-          </a:xfrm>
-          <a:prstGeom prst="rect">
-            <a:avLst/>
-          </a:prstGeom>
-          <a:solidFill>
-            <a:srgbClr val="F4F4F4"/>
-          </a:solidFill>
-          <a:ln w="12700">
+            <a:off x="548640" y="2651760"/>
+            <a:ext cx="8046720" cy="0"/>
+          </a:xfrm>
+          <a:prstGeom prst="line">
+            <a:avLst/>
+          </a:prstGeom>
+          <a:noFill/>
+          <a:ln w="9525">
             <a:solidFill>
-              <a:srgbClr val="F4F4F4"/>
+              <a:srgbClr val="E2E2E2"/>
             </a:solidFill>
             <a:prstDash val="solid"/>
           </a:ln>
@@ -5675,69 +5874,128 @@
       </p:sp>
       <p:sp>
         <p:nvSpPr>
-          <p:cNvPr id="7" name="Text 5"/>
-          <p:cNvSpPr txBox="1"/>
-          <p:nvPr/>
-        </p:nvSpPr>
-        <p:spPr>
-          <a:xfrm>
-            <a:off x="2777490" y="1737360"/>
-            <a:ext cx="1543050" cy="548640"/>
-          </a:xfrm>
-          <a:prstGeom prst="rect">
-            <a:avLst/>
-          </a:prstGeom>
-          <a:noFill/>
-          <a:ln/>
-        </p:spPr>
-        <p:txBody>
-          <a:bodyPr wrap="square" lIns="0" tIns="0" rIns="0" bIns="0" rtlCol="0" anchor="t"/>
-          <a:lstStyle/>
-          <a:p>
-            <a:pPr indent="0" marL="0">
-              <a:buNone/>
-            </a:pPr>
-            <a:r>
-              <a:rPr lang="en-US" sz="2800" dirty="0">
-                <a:solidFill>
-                  <a:schemeClr val="tx1"/>
+          <p:cNvPr id="10" name="Text 8"/>
+          <p:cNvSpPr txBox="1"/>
+          <p:nvPr/>
+        </p:nvSpPr>
+        <p:spPr>
+          <a:xfrm>
+            <a:off x="548640" y="2761488"/>
+            <a:ext cx="365760" cy="411480"/>
+          </a:xfrm>
+          <a:prstGeom prst="rect">
+            <a:avLst/>
+          </a:prstGeom>
+          <a:noFill/>
+          <a:ln/>
+        </p:spPr>
+        <p:txBody>
+          <a:bodyPr wrap="square" lIns="0" tIns="0" rIns="0" bIns="0" rtlCol="0" anchor="t"/>
+          <a:lstStyle/>
+          <a:p>
+            <a:pPr indent="0" marL="0">
+              <a:buNone/>
+            </a:pPr>
+            <a:r>
+              <a:rPr lang="en-US" sz="900" dirty="0">
+                <a:solidFill>
+                  <a:schemeClr val="tx2"/>
                 </a:solidFill>
                 <a:latin typeface="Courier New" pitchFamily="34" charset="0"/>
                 <a:ea typeface="Courier New" pitchFamily="34" charset="-122"/>
                 <a:cs typeface="Courier New" pitchFamily="34" charset="-120"/>
               </a:rPr>
-              <a:t>10</a:t>
-            </a:r>
-            <a:endParaRPr lang="en-US" sz="2800" dirty="0"/>
-          </a:p>
-        </p:txBody>
-      </p:sp>
-      <p:sp>
-        <p:nvSpPr>
-          <p:cNvPr id="8" name="Text 6"/>
-          <p:cNvSpPr txBox="1"/>
-          <p:nvPr/>
-        </p:nvSpPr>
-        <p:spPr>
-          <a:xfrm>
-            <a:off x="2777490" y="2331720"/>
-            <a:ext cx="1543050" cy="548640"/>
-          </a:xfrm>
-          <a:prstGeom prst="rect">
-            <a:avLst/>
-          </a:prstGeom>
-          <a:noFill/>
-          <a:ln/>
-        </p:spPr>
-        <p:txBody>
-          <a:bodyPr wrap="square" lIns="0" tIns="0" rIns="0" bIns="0" rtlCol="0" anchor="t"/>
-          <a:lstStyle/>
-          <a:p>
-            <a:pPr indent="0" marL="0">
-              <a:buNone/>
-            </a:pPr>
-            <a:r>
-              <a:rPr lang="en-US" sz="800" dirty="0">
+              <a:t>03</a:t>
+            </a:r>
+            <a:endParaRPr lang="en-US" sz="900" dirty="0"/>
+          </a:p>
+        </p:txBody>
+      </p:sp>
+      <p:sp>
+        <p:nvSpPr>
+          <p:cNvPr id="11" name="Text 9"/>
+          <p:cNvSpPr txBox="1"/>
+          <p:nvPr/>
+        </p:nvSpPr>
+        <p:spPr>
+          <a:xfrm>
+            <a:off x="1005840" y="2743200"/>
+            <a:ext cx="7589520" cy="411480"/>
+          </a:xfrm>
+          <a:prstGeom prst="rect">
+            <a:avLst/>
+          </a:prstGeom>
+          <a:noFill/>
+          <a:ln/>
+        </p:spPr>
+        <p:txBody>
+          <a:bodyPr wrap="square" lIns="0" tIns="0" rIns="0" bIns="0" rtlCol="0" anchor="t"/>
+          <a:lstStyle/>
+          <a:p>
+            <a:pPr indent="0" marL="0">
+              <a:buNone/>
+            </a:pPr>
+            <a:r>
+              <a:rPr lang="en-US" sz="1400" dirty="0">
+                <a:solidFill>
+                  <a:schemeClr val="tx1"/>
+                </a:solidFill>
+              </a:rPr>
+              <a:t>Design human handoff, alerts, and audit trails</a:t>
+            </a:r>
+            <a:endParaRPr lang="en-US" sz="1400" dirty="0"/>
+          </a:p>
+        </p:txBody>
+      </p:sp>
+      <p:sp>
+        <p:nvSpPr>
+          <p:cNvPr id="12" name="Shape 10"/>
+          <p:cNvSpPr/>
+          <p:nvPr/>
+        </p:nvSpPr>
+        <p:spPr>
+          <a:xfrm>
+            <a:off x="548640" y="3200400"/>
+            <a:ext cx="8046720" cy="0"/>
+          </a:xfrm>
+          <a:prstGeom prst="line">
+            <a:avLst/>
+          </a:prstGeom>
+          <a:noFill/>
+          <a:ln w="9525">
+            <a:solidFill>
+              <a:srgbClr val="E2E2E2"/>
+            </a:solidFill>
+            <a:prstDash val="solid"/>
+          </a:ln>
+        </p:spPr>
+      </p:sp>
+      <p:sp>
+        <p:nvSpPr>
+          <p:cNvPr id="13" name="Text 11"/>
+          <p:cNvSpPr txBox="1"/>
+          <p:nvPr/>
+        </p:nvSpPr>
+        <p:spPr>
+          <a:xfrm>
+            <a:off x="548640" y="3310128"/>
+            <a:ext cx="365760" cy="411480"/>
+          </a:xfrm>
+          <a:prstGeom prst="rect">
+            <a:avLst/>
+          </a:prstGeom>
+          <a:noFill/>
+          <a:ln/>
+        </p:spPr>
+        <p:txBody>
+          <a:bodyPr wrap="square" lIns="0" tIns="0" rIns="0" bIns="0" rtlCol="0" anchor="t"/>
+          <a:lstStyle/>
+          <a:p>
+            <a:pPr indent="0" marL="0">
+              <a:buNone/>
+            </a:pPr>
+            <a:r>
+              <a:rPr lang="en-US" sz="900" dirty="0">
                 <a:solidFill>
                   <a:schemeClr val="tx2"/>
                 </a:solidFill>
@@ -5745,32 +6003,66 @@
                 <a:ea typeface="Courier New" pitchFamily="34" charset="-122"/>
                 <a:cs typeface="Courier New" pitchFamily="34" charset="-120"/>
               </a:rPr>
-              <a:t>Client systems in production</a:t>
-            </a:r>
-            <a:endParaRPr lang="en-US" sz="800" dirty="0"/>
-          </a:p>
-        </p:txBody>
-      </p:sp>
-      <p:sp>
-        <p:nvSpPr>
-          <p:cNvPr id="9" name="Shape 7"/>
+              <a:t>04</a:t>
+            </a:r>
+            <a:endParaRPr lang="en-US" sz="900" dirty="0"/>
+          </a:p>
+        </p:txBody>
+      </p:sp>
+      <p:sp>
+        <p:nvSpPr>
+          <p:cNvPr id="14" name="Text 12"/>
+          <p:cNvSpPr txBox="1"/>
+          <p:nvPr/>
+        </p:nvSpPr>
+        <p:spPr>
+          <a:xfrm>
+            <a:off x="1005840" y="3291840"/>
+            <a:ext cx="7589520" cy="411480"/>
+          </a:xfrm>
+          <a:prstGeom prst="rect">
+            <a:avLst/>
+          </a:prstGeom>
+          <a:noFill/>
+          <a:ln/>
+        </p:spPr>
+        <p:txBody>
+          <a:bodyPr wrap="square" lIns="0" tIns="0" rIns="0" bIns="0" rtlCol="0" anchor="t"/>
+          <a:lstStyle/>
+          <a:p>
+            <a:pPr indent="0" marL="0">
+              <a:buNone/>
+            </a:pPr>
+            <a:r>
+              <a:rPr lang="en-US" sz="1400" dirty="0">
+                <a:solidFill>
+                  <a:schemeClr val="tx1"/>
+                </a:solidFill>
+              </a:rPr>
+              <a:t>Test, monitor, and track the cost of a system in production</a:t>
+            </a:r>
+            <a:endParaRPr lang="en-US" sz="1400" dirty="0"/>
+          </a:p>
+        </p:txBody>
+      </p:sp>
+      <p:sp>
+        <p:nvSpPr>
+          <p:cNvPr id="15" name="Shape 13"/>
           <p:cNvSpPr/>
           <p:nvPr/>
         </p:nvSpPr>
         <p:spPr>
           <a:xfrm>
-            <a:off x="4640580" y="1554480"/>
-            <a:ext cx="1908810" cy="1371600"/>
-          </a:xfrm>
-          <a:prstGeom prst="rect">
-            <a:avLst/>
-          </a:prstGeom>
-          <a:solidFill>
-            <a:srgbClr val="F4F4F4"/>
-          </a:solidFill>
-          <a:ln w="12700">
+            <a:off x="548640" y="3749040"/>
+            <a:ext cx="8046720" cy="0"/>
+          </a:xfrm>
+          <a:prstGeom prst="line">
+            <a:avLst/>
+          </a:prstGeom>
+          <a:noFill/>
+          <a:ln w="9525">
             <a:solidFill>
-              <a:srgbClr val="F4F4F4"/>
+              <a:srgbClr val="E2E2E2"/>
             </a:solidFill>
             <a:prstDash val="solid"/>
           </a:ln>
@@ -5778,259 +6070,101 @@
       </p:sp>
       <p:sp>
         <p:nvSpPr>
-          <p:cNvPr id="10" name="Text 8"/>
-          <p:cNvSpPr txBox="1"/>
-          <p:nvPr/>
-        </p:nvSpPr>
-        <p:spPr>
-          <a:xfrm>
-            <a:off x="4823460" y="1737360"/>
-            <a:ext cx="1543050" cy="548640"/>
-          </a:xfrm>
-          <a:prstGeom prst="rect">
-            <a:avLst/>
-          </a:prstGeom>
-          <a:noFill/>
-          <a:ln/>
-        </p:spPr>
-        <p:txBody>
-          <a:bodyPr wrap="square" lIns="0" tIns="0" rIns="0" bIns="0" rtlCol="0" anchor="t"/>
-          <a:lstStyle/>
-          <a:p>
-            <a:pPr indent="0" marL="0">
-              <a:buNone/>
-            </a:pPr>
-            <a:r>
-              <a:rPr lang="en-US" sz="2800" dirty="0">
-                <a:solidFill>
-                  <a:schemeClr val="tx1"/>
+          <p:cNvPr id="16" name="Text 14"/>
+          <p:cNvSpPr txBox="1"/>
+          <p:nvPr/>
+        </p:nvSpPr>
+        <p:spPr>
+          <a:xfrm>
+            <a:off x="548640" y="3858768"/>
+            <a:ext cx="365760" cy="411480"/>
+          </a:xfrm>
+          <a:prstGeom prst="rect">
+            <a:avLst/>
+          </a:prstGeom>
+          <a:noFill/>
+          <a:ln/>
+        </p:spPr>
+        <p:txBody>
+          <a:bodyPr wrap="square" lIns="0" tIns="0" rIns="0" bIns="0" rtlCol="0" anchor="t"/>
+          <a:lstStyle/>
+          <a:p>
+            <a:pPr indent="0" marL="0">
+              <a:buNone/>
+            </a:pPr>
+            <a:r>
+              <a:rPr lang="en-US" sz="900" dirty="0">
+                <a:solidFill>
+                  <a:schemeClr val="tx2"/>
                 </a:solidFill>
                 <a:latin typeface="Courier New" pitchFamily="34" charset="0"/>
                 <a:ea typeface="Courier New" pitchFamily="34" charset="-122"/>
                 <a:cs typeface="Courier New" pitchFamily="34" charset="-120"/>
               </a:rPr>
-              <a:t>10K+</a:t>
-            </a:r>
-            <a:endParaRPr lang="en-US" sz="2800" dirty="0"/>
-          </a:p>
-        </p:txBody>
-      </p:sp>
-      <p:sp>
-        <p:nvSpPr>
-          <p:cNvPr id="11" name="Text 9"/>
-          <p:cNvSpPr txBox="1"/>
-          <p:nvPr/>
-        </p:nvSpPr>
-        <p:spPr>
-          <a:xfrm>
-            <a:off x="4823460" y="2331720"/>
-            <a:ext cx="1543050" cy="548640"/>
-          </a:xfrm>
-          <a:prstGeom prst="rect">
-            <a:avLst/>
-          </a:prstGeom>
-          <a:noFill/>
-          <a:ln/>
-        </p:spPr>
-        <p:txBody>
-          <a:bodyPr wrap="square" lIns="0" tIns="0" rIns="0" bIns="0" rtlCol="0" anchor="t"/>
-          <a:lstStyle/>
-          <a:p>
-            <a:pPr indent="0" marL="0">
-              <a:buNone/>
-            </a:pPr>
-            <a:r>
-              <a:rPr lang="en-US" sz="800" dirty="0">
-                <a:solidFill>
-                  <a:schemeClr val="tx2"/>
-                </a:solidFill>
-                <a:latin typeface="Courier New" pitchFamily="34" charset="0"/>
-                <a:ea typeface="Courier New" pitchFamily="34" charset="-122"/>
-                <a:cs typeface="Courier New" pitchFamily="34" charset="-120"/>
-              </a:rPr>
-              <a:t>Customer conversations handled by AI agents we deployed</a:t>
-            </a:r>
-            <a:endParaRPr lang="en-US" sz="800" dirty="0"/>
-          </a:p>
-        </p:txBody>
-      </p:sp>
-      <p:sp>
-        <p:nvSpPr>
-          <p:cNvPr id="12" name="Shape 10"/>
+              <a:t>05</a:t>
+            </a:r>
+            <a:endParaRPr lang="en-US" sz="900" dirty="0"/>
+          </a:p>
+        </p:txBody>
+      </p:sp>
+      <p:sp>
+        <p:nvSpPr>
+          <p:cNvPr id="17" name="Text 15"/>
+          <p:cNvSpPr txBox="1"/>
+          <p:nvPr/>
+        </p:nvSpPr>
+        <p:spPr>
+          <a:xfrm>
+            <a:off x="1005840" y="3840480"/>
+            <a:ext cx="7589520" cy="411480"/>
+          </a:xfrm>
+          <a:prstGeom prst="rect">
+            <a:avLst/>
+          </a:prstGeom>
+          <a:noFill/>
+          <a:ln/>
+        </p:spPr>
+        <p:txBody>
+          <a:bodyPr wrap="square" lIns="0" tIns="0" rIns="0" bIns="0" rtlCol="0" anchor="t"/>
+          <a:lstStyle/>
+          <a:p>
+            <a:pPr indent="0" marL="0">
+              <a:buNone/>
+            </a:pPr>
+            <a:r>
+              <a:rPr lang="en-US" sz="1400" dirty="0">
+                <a:solidFill>
+                  <a:schemeClr val="tx1"/>
+                </a:solidFill>
+              </a:rPr>
+              <a:t>Scope and ship the next project without outside help</a:t>
+            </a:r>
+            <a:endParaRPr lang="en-US" sz="1400" dirty="0"/>
+          </a:p>
+        </p:txBody>
+      </p:sp>
+      <p:sp>
+        <p:nvSpPr>
+          <p:cNvPr id="18" name="Shape 16"/>
           <p:cNvSpPr/>
           <p:nvPr/>
         </p:nvSpPr>
         <p:spPr>
           <a:xfrm>
-            <a:off x="6686550" y="1554480"/>
-            <a:ext cx="1908810" cy="1371600"/>
-          </a:xfrm>
-          <a:prstGeom prst="rect">
-            <a:avLst/>
-          </a:prstGeom>
-          <a:solidFill>
-            <a:srgbClr val="F4F4F4"/>
-          </a:solidFill>
-          <a:ln w="12700">
+            <a:off x="548640" y="4297680"/>
+            <a:ext cx="8046720" cy="0"/>
+          </a:xfrm>
+          <a:prstGeom prst="line">
+            <a:avLst/>
+          </a:prstGeom>
+          <a:noFill/>
+          <a:ln w="9525">
             <a:solidFill>
-              <a:srgbClr val="F4F4F4"/>
+              <a:srgbClr val="E2E2E2"/>
             </a:solidFill>
             <a:prstDash val="solid"/>
           </a:ln>
         </p:spPr>
-      </p:sp>
-      <p:sp>
-        <p:nvSpPr>
-          <p:cNvPr id="13" name="Text 11"/>
-          <p:cNvSpPr txBox="1"/>
-          <p:nvPr/>
-        </p:nvSpPr>
-        <p:spPr>
-          <a:xfrm>
-            <a:off x="6869430" y="1737360"/>
-            <a:ext cx="1543050" cy="548640"/>
-          </a:xfrm>
-          <a:prstGeom prst="rect">
-            <a:avLst/>
-          </a:prstGeom>
-          <a:noFill/>
-          <a:ln/>
-        </p:spPr>
-        <p:txBody>
-          <a:bodyPr wrap="square" lIns="0" tIns="0" rIns="0" bIns="0" rtlCol="0" anchor="t"/>
-          <a:lstStyle/>
-          <a:p>
-            <a:pPr indent="0" marL="0">
-              <a:buNone/>
-            </a:pPr>
-            <a:r>
-              <a:rPr lang="en-US" sz="2800" dirty="0">
-                <a:solidFill>
-                  <a:schemeClr val="tx1"/>
-                </a:solidFill>
-                <a:latin typeface="Courier New" pitchFamily="34" charset="0"/>
-                <a:ea typeface="Courier New" pitchFamily="34" charset="-122"/>
-                <a:cs typeface="Courier New" pitchFamily="34" charset="-120"/>
-              </a:rPr>
-              <a:t>200+</a:t>
-            </a:r>
-            <a:endParaRPr lang="en-US" sz="2800" dirty="0"/>
-          </a:p>
-        </p:txBody>
-      </p:sp>
-      <p:sp>
-        <p:nvSpPr>
-          <p:cNvPr id="14" name="Text 12"/>
-          <p:cNvSpPr txBox="1"/>
-          <p:nvPr/>
-        </p:nvSpPr>
-        <p:spPr>
-          <a:xfrm>
-            <a:off x="6869430" y="2331720"/>
-            <a:ext cx="1543050" cy="548640"/>
-          </a:xfrm>
-          <a:prstGeom prst="rect">
-            <a:avLst/>
-          </a:prstGeom>
-          <a:noFill/>
-          <a:ln/>
-        </p:spPr>
-        <p:txBody>
-          <a:bodyPr wrap="square" lIns="0" tIns="0" rIns="0" bIns="0" rtlCol="0" anchor="t"/>
-          <a:lstStyle/>
-          <a:p>
-            <a:pPr indent="0" marL="0">
-              <a:buNone/>
-            </a:pPr>
-            <a:r>
-              <a:rPr lang="en-US" sz="800" dirty="0">
-                <a:solidFill>
-                  <a:schemeClr val="tx2"/>
-                </a:solidFill>
-                <a:latin typeface="Courier New" pitchFamily="34" charset="0"/>
-                <a:ea typeface="Courier New" pitchFamily="34" charset="-122"/>
-                <a:cs typeface="Courier New" pitchFamily="34" charset="-120"/>
-              </a:rPr>
-              <a:t>Hours of manual work removed per month across clients</a:t>
-            </a:r>
-            <a:endParaRPr lang="en-US" sz="800" dirty="0"/>
-          </a:p>
-        </p:txBody>
-      </p:sp>
-      <p:sp>
-        <p:nvSpPr>
-          <p:cNvPr id="15" name="Text 13"/>
-          <p:cNvSpPr txBox="1"/>
-          <p:nvPr/>
-        </p:nvSpPr>
-        <p:spPr>
-          <a:xfrm>
-            <a:off x="548640" y="3246120"/>
-            <a:ext cx="8046720" cy="201168"/>
-          </a:xfrm>
-          <a:prstGeom prst="rect">
-            <a:avLst/>
-          </a:prstGeom>
-          <a:noFill/>
-          <a:ln/>
-        </p:spPr>
-        <p:txBody>
-          <a:bodyPr wrap="square" lIns="0" tIns="0" rIns="0" bIns="0" rtlCol="0" anchor="t"/>
-          <a:lstStyle/>
-          <a:p>
-            <a:pPr indent="0" marL="0">
-              <a:buNone/>
-            </a:pPr>
-            <a:r>
-              <a:rPr lang="en-US" sz="800" spc="200" kern="0" dirty="0">
-                <a:solidFill>
-                  <a:schemeClr val="tx2"/>
-                </a:solidFill>
-                <a:latin typeface="Courier New" pitchFamily="34" charset="0"/>
-                <a:ea typeface="Courier New" pitchFamily="34" charset="-122"/>
-                <a:cs typeface="Courier New" pitchFamily="34" charset="-120"/>
-              </a:rPr>
-              <a:t>CLIENTS</a:t>
-            </a:r>
-            <a:endParaRPr lang="en-US" sz="800" dirty="0"/>
-          </a:p>
-        </p:txBody>
-      </p:sp>
-      <p:sp>
-        <p:nvSpPr>
-          <p:cNvPr id="16" name="Text 14"/>
-          <p:cNvSpPr txBox="1"/>
-          <p:nvPr/>
-        </p:nvSpPr>
-        <p:spPr>
-          <a:xfrm>
-            <a:off x="548640" y="3520440"/>
-            <a:ext cx="8046720" cy="365760"/>
-          </a:xfrm>
-          <a:prstGeom prst="rect">
-            <a:avLst/>
-          </a:prstGeom>
-          <a:noFill/>
-          <a:ln/>
-        </p:spPr>
-        <p:txBody>
-          <a:bodyPr wrap="square" lIns="0" tIns="0" rIns="0" bIns="0" rtlCol="0" anchor="t"/>
-          <a:lstStyle/>
-          <a:p>
-            <a:pPr indent="0" marL="0">
-              <a:buNone/>
-            </a:pPr>
-            <a:r>
-              <a:rPr lang="en-US" sz="1400" b="1" dirty="0">
-                <a:solidFill>
-                  <a:schemeClr val="tx1"/>
-                </a:solidFill>
-              </a:rPr>
-              <a:t>Nekter   ·   SnapLogic   ·   Wonderfly   ·   Windansea Coconuts   ·   Applegate Ventures</a:t>
-            </a:r>
-            <a:endParaRPr lang="en-US" sz="1400" dirty="0"/>
-          </a:p>
-        </p:txBody>
       </p:sp>
     </p:spTree>
   </p:cSld>
@@ -6089,7 +6223,7 @@
                   <a:srgbClr val="161616"/>
                 </a:solidFill>
               </a:rPr>
-              <a:t>GTM sales assistant, an internal build</a:t>
+              <a:t>Built for clients, running today</a:t>
             </a:r>
             <a:endParaRPr lang="en-US" sz="2800" dirty="0"/>
           </a:p>
@@ -6097,38 +6231,102 @@
       </p:sp>
       <p:sp>
         <p:nvSpPr>
-          <p:cNvPr id="3" name="Text 1"/>
-          <p:cNvSpPr txBox="1"/>
-          <p:nvPr/>
-        </p:nvSpPr>
-        <p:spPr>
-          <a:xfrm>
-            <a:off x="548640" y="274320"/>
-            <a:ext cx="8046720" cy="201168"/>
-          </a:xfrm>
-          <a:prstGeom prst="rect">
-            <a:avLst/>
-          </a:prstGeom>
-          <a:noFill/>
-          <a:ln/>
-        </p:spPr>
-        <p:txBody>
-          <a:bodyPr wrap="square" lIns="0" tIns="0" rIns="0" bIns="0" rtlCol="0" anchor="t"/>
-          <a:lstStyle/>
-          <a:p>
-            <a:pPr indent="0" marL="0">
-              <a:buNone/>
-            </a:pPr>
-            <a:r>
-              <a:rPr lang="en-US" sz="800" spc="200" kern="0" dirty="0">
-                <a:solidFill>
-                  <a:schemeClr val="tx2"/>
+          <p:cNvPr id="3" name="Shape 1"/>
+          <p:cNvSpPr/>
+          <p:nvPr/>
+        </p:nvSpPr>
+        <p:spPr>
+          <a:xfrm>
+            <a:off x="548640" y="1554480"/>
+            <a:ext cx="1908810" cy="1371600"/>
+          </a:xfrm>
+          <a:prstGeom prst="rect">
+            <a:avLst/>
+          </a:prstGeom>
+          <a:solidFill>
+            <a:srgbClr val="F4F4F4"/>
+          </a:solidFill>
+          <a:ln w="12700">
+            <a:solidFill>
+              <a:srgbClr val="F4F4F4"/>
+            </a:solidFill>
+            <a:prstDash val="solid"/>
+          </a:ln>
+        </p:spPr>
+      </p:sp>
+      <p:sp>
+        <p:nvSpPr>
+          <p:cNvPr id="4" name="Text 2"/>
+          <p:cNvSpPr txBox="1"/>
+          <p:nvPr/>
+        </p:nvSpPr>
+        <p:spPr>
+          <a:xfrm>
+            <a:off x="731520" y="1737360"/>
+            <a:ext cx="1543050" cy="548640"/>
+          </a:xfrm>
+          <a:prstGeom prst="rect">
+            <a:avLst/>
+          </a:prstGeom>
+          <a:noFill/>
+          <a:ln/>
+        </p:spPr>
+        <p:txBody>
+          <a:bodyPr wrap="square" lIns="0" tIns="0" rIns="0" bIns="0" rtlCol="0" anchor="t"/>
+          <a:lstStyle/>
+          <a:p>
+            <a:pPr indent="0" marL="0">
+              <a:buNone/>
+            </a:pPr>
+            <a:r>
+              <a:rPr lang="en-US" sz="2800" dirty="0">
+                <a:solidFill>
+                  <a:schemeClr val="tx1"/>
                 </a:solidFill>
                 <a:latin typeface="Courier New" pitchFamily="34" charset="0"/>
                 <a:ea typeface="Courier New" pitchFamily="34" charset="-122"/>
                 <a:cs typeface="Courier New" pitchFamily="34" charset="-120"/>
               </a:rPr>
-              <a:t>SNAPLOGIC</a:t>
+              <a:t>$6M+</a:t>
+            </a:r>
+            <a:endParaRPr lang="en-US" sz="2800" dirty="0"/>
+          </a:p>
+        </p:txBody>
+      </p:sp>
+      <p:sp>
+        <p:nvSpPr>
+          <p:cNvPr id="5" name="Text 3"/>
+          <p:cNvSpPr txBox="1"/>
+          <p:nvPr/>
+        </p:nvSpPr>
+        <p:spPr>
+          <a:xfrm>
+            <a:off x="731520" y="2331720"/>
+            <a:ext cx="1543050" cy="548640"/>
+          </a:xfrm>
+          <a:prstGeom prst="rect">
+            <a:avLst/>
+          </a:prstGeom>
+          <a:noFill/>
+          <a:ln/>
+        </p:spPr>
+        <p:txBody>
+          <a:bodyPr wrap="square" lIns="0" tIns="0" rIns="0" bIns="0" rtlCol="0" anchor="t"/>
+          <a:lstStyle/>
+          <a:p>
+            <a:pPr indent="0" marL="0">
+              <a:buNone/>
+            </a:pPr>
+            <a:r>
+              <a:rPr lang="en-US" sz="800" dirty="0">
+                <a:solidFill>
+                  <a:schemeClr val="tx2"/>
+                </a:solidFill>
+                <a:latin typeface="Courier New" pitchFamily="34" charset="0"/>
+                <a:ea typeface="Courier New" pitchFamily="34" charset="-122"/>
+                <a:cs typeface="Courier New" pitchFamily="34" charset="-120"/>
+              </a:rPr>
+              <a:t>Client revenue supported by systems we built</a:t>
             </a:r>
             <a:endParaRPr lang="en-US" sz="800" dirty="0"/>
           </a:p>
@@ -6136,22 +6334,24 @@
       </p:sp>
       <p:sp>
         <p:nvSpPr>
-          <p:cNvPr id="4" name="Shape 2"/>
+          <p:cNvPr id="6" name="Shape 4"/>
           <p:cNvSpPr/>
           <p:nvPr/>
         </p:nvSpPr>
         <p:spPr>
           <a:xfrm>
-            <a:off x="548640" y="1600200"/>
-            <a:ext cx="8046720" cy="0"/>
-          </a:xfrm>
-          <a:prstGeom prst="line">
-            <a:avLst/>
-          </a:prstGeom>
-          <a:noFill/>
+            <a:off x="2594610" y="1554480"/>
+            <a:ext cx="1908810" cy="1371600"/>
+          </a:xfrm>
+          <a:prstGeom prst="rect">
+            <a:avLst/>
+          </a:prstGeom>
+          <a:solidFill>
+            <a:srgbClr val="F4F4F4"/>
+          </a:solidFill>
           <a:ln w="12700">
             <a:solidFill>
-              <a:srgbClr val="161616"/>
+              <a:srgbClr val="F4F4F4"/>
             </a:solidFill>
             <a:prstDash val="solid"/>
           </a:ln>
@@ -6159,38 +6359,77 @@
       </p:sp>
       <p:sp>
         <p:nvSpPr>
-          <p:cNvPr id="5" name="Text 3"/>
-          <p:cNvSpPr txBox="1"/>
-          <p:nvPr/>
-        </p:nvSpPr>
-        <p:spPr>
-          <a:xfrm>
-            <a:off x="548640" y="1737360"/>
-            <a:ext cx="1828800" cy="201168"/>
-          </a:xfrm>
-          <a:prstGeom prst="rect">
-            <a:avLst/>
-          </a:prstGeom>
-          <a:noFill/>
-          <a:ln/>
-        </p:spPr>
-        <p:txBody>
-          <a:bodyPr wrap="square" lIns="0" tIns="0" rIns="0" bIns="0" rtlCol="0" anchor="t"/>
-          <a:lstStyle/>
-          <a:p>
-            <a:pPr indent="0" marL="0">
-              <a:buNone/>
-            </a:pPr>
-            <a:r>
-              <a:rPr lang="en-US" sz="800" spc="200" kern="0" dirty="0">
-                <a:solidFill>
-                  <a:schemeClr val="tx2"/>
+          <p:cNvPr id="7" name="Text 5"/>
+          <p:cNvSpPr txBox="1"/>
+          <p:nvPr/>
+        </p:nvSpPr>
+        <p:spPr>
+          <a:xfrm>
+            <a:off x="2777490" y="1737360"/>
+            <a:ext cx="1543050" cy="548640"/>
+          </a:xfrm>
+          <a:prstGeom prst="rect">
+            <a:avLst/>
+          </a:prstGeom>
+          <a:noFill/>
+          <a:ln/>
+        </p:spPr>
+        <p:txBody>
+          <a:bodyPr wrap="square" lIns="0" tIns="0" rIns="0" bIns="0" rtlCol="0" anchor="t"/>
+          <a:lstStyle/>
+          <a:p>
+            <a:pPr indent="0" marL="0">
+              <a:buNone/>
+            </a:pPr>
+            <a:r>
+              <a:rPr lang="en-US" sz="2800" dirty="0">
+                <a:solidFill>
+                  <a:schemeClr val="tx1"/>
                 </a:solidFill>
                 <a:latin typeface="Courier New" pitchFamily="34" charset="0"/>
                 <a:ea typeface="Courier New" pitchFamily="34" charset="-122"/>
                 <a:cs typeface="Courier New" pitchFamily="34" charset="-120"/>
               </a:rPr>
-              <a:t>PROBLEM</a:t>
+              <a:t>10</a:t>
+            </a:r>
+            <a:endParaRPr lang="en-US" sz="2800" dirty="0"/>
+          </a:p>
+        </p:txBody>
+      </p:sp>
+      <p:sp>
+        <p:nvSpPr>
+          <p:cNvPr id="8" name="Text 6"/>
+          <p:cNvSpPr txBox="1"/>
+          <p:nvPr/>
+        </p:nvSpPr>
+        <p:spPr>
+          <a:xfrm>
+            <a:off x="2777490" y="2331720"/>
+            <a:ext cx="1543050" cy="548640"/>
+          </a:xfrm>
+          <a:prstGeom prst="rect">
+            <a:avLst/>
+          </a:prstGeom>
+          <a:noFill/>
+          <a:ln/>
+        </p:spPr>
+        <p:txBody>
+          <a:bodyPr wrap="square" lIns="0" tIns="0" rIns="0" bIns="0" rtlCol="0" anchor="t"/>
+          <a:lstStyle/>
+          <a:p>
+            <a:pPr indent="0" marL="0">
+              <a:buNone/>
+            </a:pPr>
+            <a:r>
+              <a:rPr lang="en-US" sz="800" dirty="0">
+                <a:solidFill>
+                  <a:schemeClr val="tx2"/>
+                </a:solidFill>
+                <a:latin typeface="Courier New" pitchFamily="34" charset="0"/>
+                <a:ea typeface="Courier New" pitchFamily="34" charset="-122"/>
+                <a:cs typeface="Courier New" pitchFamily="34" charset="-120"/>
+              </a:rPr>
+              <a:t>Client systems in production</a:t>
             </a:r>
             <a:endParaRPr lang="en-US" sz="800" dirty="0"/>
           </a:p>
@@ -6198,58 +6437,24 @@
       </p:sp>
       <p:sp>
         <p:nvSpPr>
-          <p:cNvPr id="6" name="Text 4"/>
-          <p:cNvSpPr txBox="1"/>
-          <p:nvPr/>
-        </p:nvSpPr>
-        <p:spPr>
-          <a:xfrm>
-            <a:off x="2560320" y="1709928"/>
-            <a:ext cx="6035040" cy="731520"/>
-          </a:xfrm>
-          <a:prstGeom prst="rect">
-            <a:avLst/>
-          </a:prstGeom>
-          <a:noFill/>
-          <a:ln/>
-        </p:spPr>
-        <p:txBody>
-          <a:bodyPr wrap="square" lIns="0" tIns="0" rIns="0" bIns="0" rtlCol="0" anchor="t"/>
-          <a:lstStyle/>
-          <a:p>
-            <a:pPr indent="0" marL="0">
-              <a:buNone/>
-            </a:pPr>
-            <a:r>
-              <a:rPr lang="en-US" sz="1500" dirty="0">
-                <a:solidFill>
-                  <a:schemeClr val="tx1"/>
-                </a:solidFill>
-              </a:rPr>
-              <a:t>Reps prepped for calls by pulling account history from separate systems. Prep took longer than the call.</a:t>
-            </a:r>
-            <a:endParaRPr lang="en-US" sz="1500" dirty="0"/>
-          </a:p>
-        </p:txBody>
-      </p:sp>
-      <p:sp>
-        <p:nvSpPr>
-          <p:cNvPr id="7" name="Shape 5"/>
+          <p:cNvPr id="9" name="Shape 7"/>
           <p:cNvSpPr/>
           <p:nvPr/>
         </p:nvSpPr>
         <p:spPr>
           <a:xfrm>
-            <a:off x="548640" y="2514600"/>
-            <a:ext cx="8046720" cy="0"/>
-          </a:xfrm>
-          <a:prstGeom prst="line">
-            <a:avLst/>
-          </a:prstGeom>
-          <a:noFill/>
-          <a:ln w="9525">
+            <a:off x="4640580" y="1554480"/>
+            <a:ext cx="1908810" cy="1371600"/>
+          </a:xfrm>
+          <a:prstGeom prst="rect">
+            <a:avLst/>
+          </a:prstGeom>
+          <a:solidFill>
+            <a:srgbClr val="F4F4F4"/>
+          </a:solidFill>
+          <a:ln w="12700">
             <a:solidFill>
-              <a:srgbClr val="E2E2E2"/>
+              <a:srgbClr val="F4F4F4"/>
             </a:solidFill>
             <a:prstDash val="solid"/>
           </a:ln>
@@ -6257,38 +6462,77 @@
       </p:sp>
       <p:sp>
         <p:nvSpPr>
-          <p:cNvPr id="8" name="Text 6"/>
-          <p:cNvSpPr txBox="1"/>
-          <p:nvPr/>
-        </p:nvSpPr>
-        <p:spPr>
-          <a:xfrm>
-            <a:off x="548640" y="2651760"/>
-            <a:ext cx="1828800" cy="201168"/>
-          </a:xfrm>
-          <a:prstGeom prst="rect">
-            <a:avLst/>
-          </a:prstGeom>
-          <a:noFill/>
-          <a:ln/>
-        </p:spPr>
-        <p:txBody>
-          <a:bodyPr wrap="square" lIns="0" tIns="0" rIns="0" bIns="0" rtlCol="0" anchor="t"/>
-          <a:lstStyle/>
-          <a:p>
-            <a:pPr indent="0" marL="0">
-              <a:buNone/>
-            </a:pPr>
-            <a:r>
-              <a:rPr lang="en-US" sz="800" spc="200" kern="0" dirty="0">
-                <a:solidFill>
-                  <a:schemeClr val="tx2"/>
+          <p:cNvPr id="10" name="Text 8"/>
+          <p:cNvSpPr txBox="1"/>
+          <p:nvPr/>
+        </p:nvSpPr>
+        <p:spPr>
+          <a:xfrm>
+            <a:off x="4823460" y="1737360"/>
+            <a:ext cx="1543050" cy="548640"/>
+          </a:xfrm>
+          <a:prstGeom prst="rect">
+            <a:avLst/>
+          </a:prstGeom>
+          <a:noFill/>
+          <a:ln/>
+        </p:spPr>
+        <p:txBody>
+          <a:bodyPr wrap="square" lIns="0" tIns="0" rIns="0" bIns="0" rtlCol="0" anchor="t"/>
+          <a:lstStyle/>
+          <a:p>
+            <a:pPr indent="0" marL="0">
+              <a:buNone/>
+            </a:pPr>
+            <a:r>
+              <a:rPr lang="en-US" sz="2800" dirty="0">
+                <a:solidFill>
+                  <a:schemeClr val="tx1"/>
                 </a:solidFill>
                 <a:latin typeface="Courier New" pitchFamily="34" charset="0"/>
                 <a:ea typeface="Courier New" pitchFamily="34" charset="-122"/>
                 <a:cs typeface="Courier New" pitchFamily="34" charset="-120"/>
               </a:rPr>
-              <a:t>WHAT WE BUILT</a:t>
+              <a:t>10K+</a:t>
+            </a:r>
+            <a:endParaRPr lang="en-US" sz="2800" dirty="0"/>
+          </a:p>
+        </p:txBody>
+      </p:sp>
+      <p:sp>
+        <p:nvSpPr>
+          <p:cNvPr id="11" name="Text 9"/>
+          <p:cNvSpPr txBox="1"/>
+          <p:nvPr/>
+        </p:nvSpPr>
+        <p:spPr>
+          <a:xfrm>
+            <a:off x="4823460" y="2331720"/>
+            <a:ext cx="1543050" cy="548640"/>
+          </a:xfrm>
+          <a:prstGeom prst="rect">
+            <a:avLst/>
+          </a:prstGeom>
+          <a:noFill/>
+          <a:ln/>
+        </p:spPr>
+        <p:txBody>
+          <a:bodyPr wrap="square" lIns="0" tIns="0" rIns="0" bIns="0" rtlCol="0" anchor="t"/>
+          <a:lstStyle/>
+          <a:p>
+            <a:pPr indent="0" marL="0">
+              <a:buNone/>
+            </a:pPr>
+            <a:r>
+              <a:rPr lang="en-US" sz="800" dirty="0">
+                <a:solidFill>
+                  <a:schemeClr val="tx2"/>
+                </a:solidFill>
+                <a:latin typeface="Courier New" pitchFamily="34" charset="0"/>
+                <a:ea typeface="Courier New" pitchFamily="34" charset="-122"/>
+                <a:cs typeface="Courier New" pitchFamily="34" charset="-120"/>
+              </a:rPr>
+              <a:t>Customer conversations handled by AI agents we deployed</a:t>
             </a:r>
             <a:endParaRPr lang="en-US" sz="800" dirty="0"/>
           </a:p>
@@ -6296,58 +6540,24 @@
       </p:sp>
       <p:sp>
         <p:nvSpPr>
-          <p:cNvPr id="9" name="Text 7"/>
-          <p:cNvSpPr txBox="1"/>
-          <p:nvPr/>
-        </p:nvSpPr>
-        <p:spPr>
-          <a:xfrm>
-            <a:off x="2560320" y="2624328"/>
-            <a:ext cx="6035040" cy="731520"/>
-          </a:xfrm>
-          <a:prstGeom prst="rect">
-            <a:avLst/>
-          </a:prstGeom>
-          <a:noFill/>
-          <a:ln/>
-        </p:spPr>
-        <p:txBody>
-          <a:bodyPr wrap="square" lIns="0" tIns="0" rIns="0" bIns="0" rtlCol="0" anchor="t"/>
-          <a:lstStyle/>
-          <a:p>
-            <a:pPr indent="0" marL="0">
-              <a:buNone/>
-            </a:pPr>
-            <a:r>
-              <a:rPr lang="en-US" sz="1500" dirty="0">
-                <a:solidFill>
-                  <a:schemeClr val="tx1"/>
-                </a:solidFill>
-              </a:rPr>
-              <a:t>An agent on SnapLogic AgentCreator that pulls account context and answers reps' questions on demand.</a:t>
-            </a:r>
-            <a:endParaRPr lang="en-US" sz="1500" dirty="0"/>
-          </a:p>
-        </p:txBody>
-      </p:sp>
-      <p:sp>
-        <p:nvSpPr>
-          <p:cNvPr id="10" name="Shape 8"/>
+          <p:cNvPr id="12" name="Shape 10"/>
           <p:cNvSpPr/>
           <p:nvPr/>
         </p:nvSpPr>
         <p:spPr>
           <a:xfrm>
-            <a:off x="548640" y="3429000"/>
-            <a:ext cx="8046720" cy="0"/>
-          </a:xfrm>
-          <a:prstGeom prst="line">
-            <a:avLst/>
-          </a:prstGeom>
-          <a:noFill/>
-          <a:ln w="9525">
+            <a:off x="6686550" y="1554480"/>
+            <a:ext cx="1908810" cy="1371600"/>
+          </a:xfrm>
+          <a:prstGeom prst="rect">
+            <a:avLst/>
+          </a:prstGeom>
+          <a:solidFill>
+            <a:srgbClr val="F4F4F4"/>
+          </a:solidFill>
+          <a:ln w="12700">
             <a:solidFill>
-              <a:srgbClr val="E2E2E2"/>
+              <a:srgbClr val="F4F4F4"/>
             </a:solidFill>
             <a:prstDash val="solid"/>
           </a:ln>
@@ -6355,38 +6565,77 @@
       </p:sp>
       <p:sp>
         <p:nvSpPr>
-          <p:cNvPr id="11" name="Text 9"/>
-          <p:cNvSpPr txBox="1"/>
-          <p:nvPr/>
-        </p:nvSpPr>
-        <p:spPr>
-          <a:xfrm>
-            <a:off x="548640" y="3566160"/>
-            <a:ext cx="1828800" cy="201168"/>
-          </a:xfrm>
-          <a:prstGeom prst="rect">
-            <a:avLst/>
-          </a:prstGeom>
-          <a:noFill/>
-          <a:ln/>
-        </p:spPr>
-        <p:txBody>
-          <a:bodyPr wrap="square" lIns="0" tIns="0" rIns="0" bIns="0" rtlCol="0" anchor="t"/>
-          <a:lstStyle/>
-          <a:p>
-            <a:pPr indent="0" marL="0">
-              <a:buNone/>
-            </a:pPr>
-            <a:r>
-              <a:rPr lang="en-US" sz="800" spc="200" kern="0" dirty="0">
-                <a:solidFill>
-                  <a:schemeClr val="tx2"/>
+          <p:cNvPr id="13" name="Text 11"/>
+          <p:cNvSpPr txBox="1"/>
+          <p:nvPr/>
+        </p:nvSpPr>
+        <p:spPr>
+          <a:xfrm>
+            <a:off x="6869430" y="1737360"/>
+            <a:ext cx="1543050" cy="548640"/>
+          </a:xfrm>
+          <a:prstGeom prst="rect">
+            <a:avLst/>
+          </a:prstGeom>
+          <a:noFill/>
+          <a:ln/>
+        </p:spPr>
+        <p:txBody>
+          <a:bodyPr wrap="square" lIns="0" tIns="0" rIns="0" bIns="0" rtlCol="0" anchor="t"/>
+          <a:lstStyle/>
+          <a:p>
+            <a:pPr indent="0" marL="0">
+              <a:buNone/>
+            </a:pPr>
+            <a:r>
+              <a:rPr lang="en-US" sz="2800" dirty="0">
+                <a:solidFill>
+                  <a:schemeClr val="tx1"/>
                 </a:solidFill>
                 <a:latin typeface="Courier New" pitchFamily="34" charset="0"/>
                 <a:ea typeface="Courier New" pitchFamily="34" charset="-122"/>
                 <a:cs typeface="Courier New" pitchFamily="34" charset="-120"/>
               </a:rPr>
-              <a:t>RESULT</a:t>
+              <a:t>200+</a:t>
+            </a:r>
+            <a:endParaRPr lang="en-US" sz="2800" dirty="0"/>
+          </a:p>
+        </p:txBody>
+      </p:sp>
+      <p:sp>
+        <p:nvSpPr>
+          <p:cNvPr id="14" name="Text 12"/>
+          <p:cNvSpPr txBox="1"/>
+          <p:nvPr/>
+        </p:nvSpPr>
+        <p:spPr>
+          <a:xfrm>
+            <a:off x="6869430" y="2331720"/>
+            <a:ext cx="1543050" cy="548640"/>
+          </a:xfrm>
+          <a:prstGeom prst="rect">
+            <a:avLst/>
+          </a:prstGeom>
+          <a:noFill/>
+          <a:ln/>
+        </p:spPr>
+        <p:txBody>
+          <a:bodyPr wrap="square" lIns="0" tIns="0" rIns="0" bIns="0" rtlCol="0" anchor="t"/>
+          <a:lstStyle/>
+          <a:p>
+            <a:pPr indent="0" marL="0">
+              <a:buNone/>
+            </a:pPr>
+            <a:r>
+              <a:rPr lang="en-US" sz="800" dirty="0">
+                <a:solidFill>
+                  <a:schemeClr val="tx2"/>
+                </a:solidFill>
+                <a:latin typeface="Courier New" pitchFamily="34" charset="0"/>
+                <a:ea typeface="Courier New" pitchFamily="34" charset="-122"/>
+                <a:cs typeface="Courier New" pitchFamily="34" charset="-120"/>
+              </a:rPr>
+              <a:t>Hours of manual work removed per month across clients</a:t>
             </a:r>
             <a:endParaRPr lang="en-US" sz="800" dirty="0"/>
           </a:p>
@@ -6394,62 +6643,78 @@
       </p:sp>
       <p:sp>
         <p:nvSpPr>
-          <p:cNvPr id="12" name="Text 10"/>
-          <p:cNvSpPr txBox="1"/>
-          <p:nvPr/>
-        </p:nvSpPr>
-        <p:spPr>
-          <a:xfrm>
-            <a:off x="2560320" y="3538728"/>
-            <a:ext cx="6035040" cy="731520"/>
-          </a:xfrm>
-          <a:prstGeom prst="rect">
-            <a:avLst/>
-          </a:prstGeom>
-          <a:noFill/>
-          <a:ln/>
-        </p:spPr>
-        <p:txBody>
-          <a:bodyPr wrap="square" lIns="0" tIns="0" rIns="0" bIns="0" rtlCol="0" anchor="t"/>
-          <a:lstStyle/>
-          <a:p>
-            <a:pPr indent="0" marL="0">
-              <a:buNone/>
-            </a:pPr>
-            <a:r>
-              <a:rPr lang="en-US" sz="1500" dirty="0">
+          <p:cNvPr id="15" name="Text 13"/>
+          <p:cNvSpPr txBox="1"/>
+          <p:nvPr/>
+        </p:nvSpPr>
+        <p:spPr>
+          <a:xfrm>
+            <a:off x="548640" y="3246120"/>
+            <a:ext cx="8046720" cy="201168"/>
+          </a:xfrm>
+          <a:prstGeom prst="rect">
+            <a:avLst/>
+          </a:prstGeom>
+          <a:noFill/>
+          <a:ln/>
+        </p:spPr>
+        <p:txBody>
+          <a:bodyPr wrap="square" lIns="0" tIns="0" rIns="0" bIns="0" rtlCol="0" anchor="t"/>
+          <a:lstStyle/>
+          <a:p>
+            <a:pPr indent="0" marL="0">
+              <a:buNone/>
+            </a:pPr>
+            <a:r>
+              <a:rPr lang="en-US" sz="800" spc="200" kern="0" dirty="0">
+                <a:solidFill>
+                  <a:schemeClr val="tx2"/>
+                </a:solidFill>
+                <a:latin typeface="Courier New" pitchFamily="34" charset="0"/>
+                <a:ea typeface="Courier New" pitchFamily="34" charset="-122"/>
+                <a:cs typeface="Courier New" pitchFamily="34" charset="-120"/>
+              </a:rPr>
+              <a:t>CLIENTS</a:t>
+            </a:r>
+            <a:endParaRPr lang="en-US" sz="800" dirty="0"/>
+          </a:p>
+        </p:txBody>
+      </p:sp>
+      <p:sp>
+        <p:nvSpPr>
+          <p:cNvPr id="16" name="Text 14"/>
+          <p:cNvSpPr txBox="1"/>
+          <p:nvPr/>
+        </p:nvSpPr>
+        <p:spPr>
+          <a:xfrm>
+            <a:off x="548640" y="3520440"/>
+            <a:ext cx="8046720" cy="365760"/>
+          </a:xfrm>
+          <a:prstGeom prst="rect">
+            <a:avLst/>
+          </a:prstGeom>
+          <a:noFill/>
+          <a:ln/>
+        </p:spPr>
+        <p:txBody>
+          <a:bodyPr wrap="square" lIns="0" tIns="0" rIns="0" bIns="0" rtlCol="0" anchor="t"/>
+          <a:lstStyle/>
+          <a:p>
+            <a:pPr indent="0" marL="0">
+              <a:buNone/>
+            </a:pPr>
+            <a:r>
+              <a:rPr lang="en-US" sz="1400" b="1" dirty="0">
                 <a:solidFill>
                   <a:schemeClr val="tx1"/>
                 </a:solidFill>
               </a:rPr>
-              <a:t>Account briefs in seconds. The build became the teaching example for customer bootcamps.</a:t>
-            </a:r>
-            <a:endParaRPr lang="en-US" sz="1500" dirty="0"/>
-          </a:p>
-        </p:txBody>
-      </p:sp>
-      <p:sp>
-        <p:nvSpPr>
-          <p:cNvPr id="13" name="Shape 11"/>
-          <p:cNvSpPr/>
-          <p:nvPr/>
-        </p:nvSpPr>
-        <p:spPr>
-          <a:xfrm>
-            <a:off x="548640" y="4343400"/>
-            <a:ext cx="8046720" cy="0"/>
-          </a:xfrm>
-          <a:prstGeom prst="line">
-            <a:avLst/>
-          </a:prstGeom>
-          <a:noFill/>
-          <a:ln w="9525">
-            <a:solidFill>
-              <a:srgbClr val="E2E2E2"/>
-            </a:solidFill>
-            <a:prstDash val="solid"/>
-          </a:ln>
-        </p:spPr>
+              <a:t>Nekter   ·   SnapLogic   ·   Wonderfly   ·   Windansea Coconuts   ·   Applegate Ventures</a:t>
+            </a:r>
+            <a:endParaRPr lang="en-US" sz="1400" dirty="0"/>
+          </a:p>
+        </p:txBody>
       </p:sp>
     </p:spTree>
   </p:cSld>
@@ -6508,7 +6773,7 @@
                   <a:srgbClr val="161616"/>
                 </a:solidFill>
               </a:rPr>
-              <a:t>A customer success platform that surfaces churn risk early</a:t>
+              <a:t>GTM sales assistant, an internal build</a:t>
             </a:r>
             <a:endParaRPr lang="en-US" sz="2800" dirty="0"/>
           </a:p>
@@ -6547,7 +6812,7 @@
                 <a:ea typeface="Courier New" pitchFamily="34" charset="-122"/>
                 <a:cs typeface="Courier New" pitchFamily="34" charset="-120"/>
               </a:rPr>
-              <a:t>NEKTER</a:t>
+              <a:t>SNAPLOGIC</a:t>
             </a:r>
             <a:endParaRPr lang="en-US" sz="800" dirty="0"/>
           </a:p>
@@ -6645,7 +6910,7 @@
                   <a:schemeClr val="tx1"/>
                 </a:solidFill>
               </a:rPr>
-              <a:t>CSMs juggled Salesforce, Zendesk, call recordings, and email. Health drops were noticed after the renewal was lost.</a:t>
+              <a:t>Reps prepped for calls by pulling account history from separate systems. Prep took longer than the call.</a:t>
             </a:r>
             <a:endParaRPr lang="en-US" sz="1500" dirty="0"/>
           </a:p>
@@ -6743,7 +7008,7 @@
                   <a:schemeClr val="tx1"/>
                 </a:solidFill>
               </a:rPr>
-              <a:t>One account view with health scores, AI insights on every interaction, Slack alerts, and a natural-language assistant over the data.</a:t>
+              <a:t>An agent on SnapLogic AgentCreator that pulls account context and answers reps' questions on demand.</a:t>
             </a:r>
             <a:endParaRPr lang="en-US" sz="1500" dirty="0"/>
           </a:p>
@@ -6841,7 +7106,7 @@
                   <a:schemeClr val="tx1"/>
                 </a:solidFill>
               </a:rPr>
-              <a:t>Risk reaches Slack before the renewal call. A CSM asks a question in plain English and gets the answer from the actual call.</a:t>
+              <a:t>Account briefs in seconds. The build became the teaching example for customer bootcamps.</a:t>
             </a:r>
             <a:endParaRPr lang="en-US" sz="1500" dirty="0"/>
           </a:p>
@@ -6927,7 +7192,7 @@
                   <a:srgbClr val="161616"/>
                 </a:solidFill>
               </a:rPr>
-              <a:t>A customer service agent that answers texts around the clock</a:t>
+              <a:t>A customer success platform that surfaces churn risk early</a:t>
             </a:r>
             <a:endParaRPr lang="en-US" sz="2800" dirty="0"/>
           </a:p>
@@ -6966,7 +7231,7 @@
                 <a:ea typeface="Courier New" pitchFamily="34" charset="-122"/>
                 <a:cs typeface="Courier New" pitchFamily="34" charset="-120"/>
               </a:rPr>
-              <a:t>WONDERFLY</a:t>
+              <a:t>NEKTER</a:t>
             </a:r>
             <a:endParaRPr lang="en-US" sz="800" dirty="0"/>
           </a:p>
@@ -7064,7 +7329,7 @@
                   <a:schemeClr val="tx1"/>
                 </a:solidFill>
               </a:rPr>
-              <a:t>Customers text evenings and weekends. Staff replied Monday. Bookings were lost.</a:t>
+              <a:t>CSMs juggled Salesforce, Zendesk, call recordings, and email. Health drops were noticed after the renewal was lost.</a:t>
             </a:r>
             <a:endParaRPr lang="en-US" sz="1500" dirty="0"/>
           </a:p>
@@ -7162,7 +7427,7 @@
                   <a:schemeClr val="tx1"/>
                 </a:solidFill>
               </a:rPr>
-              <a:t>An SMS agent on the venue's phone lines that answers from live data and hands off to a human when unsure.</a:t>
+              <a:t>One account view with health scores, AI insights on every interaction, Slack alerts, and a natural-language assistant over the data.</a:t>
             </a:r>
             <a:endParaRPr lang="en-US" sz="1500" dirty="0"/>
           </a:p>
@@ -7260,7 +7525,7 @@
                   <a:schemeClr val="tx1"/>
                 </a:solidFill>
               </a:rPr>
-              <a:t>Replies in seconds, any hour. Staff only touch the conversations it flags.</a:t>
+              <a:t>Risk reaches Slack before the renewal call. A CSM asks a question in plain English and gets the answer from the actual call.</a:t>
             </a:r>
             <a:endParaRPr lang="en-US" sz="1500" dirty="0"/>
           </a:p>

</xml_diff>